<commit_message>
Add required A.A.W.S. copyright notice slide and page 142 MUSTS slide
A.A.W.S. granted permission to screen-share A.A. literature during a meeting on
the condition that its copyright disclaimer is displayed. The disclaimer now
opens the deck on a dedicated title slide and repeats as a short footer on every
content slide.

Adds slide 3 from p. 142 - the three highlighted passages for checking out a
newcomer, cited to chapter 10 where the page actually falls. Preview renderer
now draws slide backgrounds so dark slides can be inspected.

Co-Authored-By: Claude Opus 5 <noreply@anthropic.com>
Claude-Session: https://claude.ai/code/session_01NuCgD3Z7aWvkQrsSvAUX4h
</commit_message>
<xml_diff>
--- a/aa-slideshow/aa-big-book-study.pptx
+++ b/aa-slideshow/aa-big-book-study.pptx
@@ -6,9 +6,11 @@
   </p:sldMasterIdLst>
   <p:sldIdLst>
     <p:sldId id="256" r:id="rId2"/>
+    <p:sldId id="257" r:id="rId3"/>
+    <p:sldId id="258" r:id="rId4"/>
   </p:sldIdLst>
   <p:notesMasterIdLst>
-    <p:notesMasterId r:id="rId3"/>
+    <p:notesMasterId r:id="rId5"/>
   </p:notesMasterIdLst>
   <p:sldSz cx="12192000" cy="6858000"/>
   <p:notesSz cx="6858000" cy="12192000"/>
@@ -502,12 +504,10 @@
           <a:p>
             <a:r>
               <a:rPr lang="en-US" dirty="0"/>
-              <a:t>Roadmap slide. The Big Book is built in three movements.
-Doctor's Opinion + Bill's Story = Step 1. The Problem. We are powerless.
-Chapters 2-4 = Step 2. The Solution. There is a Power.
-Chapters 5-7 = Steps 3 through 12. The action necessary for recovery.
-Chapters 8 and 9 speak to the family - read today as Al-Anon and Alateen.
-The "MUSTS" exercise begins on page 142.</a:t>
+              <a:t>Leave this slide up while people are settling in.
+A.A.W.S. granted permission by email (Drew Deetz, Intellectual Property Administrator,
+General Service Office) on the condition that this copyright notice is displayed when
+A.A. literature is screen-shared during a meeting.</a:t>
             </a:r>
             <a:endParaRPr lang="en-US" dirty="0"/>
           </a:p>
@@ -531,6 +531,193 @@
             <a:fld id="{F7021451-1387-4CA6-816F-3879F97B5CBC}" type="slidenum">
               <a:rPr lang="en-US"/>
               <a:t>1</a:t>
+            </a:fld>
+            <a:endParaRPr lang="en-US"/>
+          </a:p>
+        </p:txBody>
+      </p:sp>
+    </p:spTree>
+    <p:extLst>
+      <p:ext uri="{BB962C8B-B14F-4D97-AF65-F5344CB8AC3E}">
+        <p14:creationId xmlns:p14="http://schemas.microsoft.com/office/powerpoint/2010/main" val="1024086991"/>
+      </p:ext>
+    </p:extLst>
+  </p:cSld>
+  <p:clrMapOvr>
+    <a:masterClrMapping/>
+  </p:clrMapOvr>
+</p:notes>
+</file>
+
+<file path=ppt/notesSlides/notesSlide2.xml><?xml version="1.0" encoding="utf-8"?>
+<p:notes xmlns:a="http://schemas.openxmlformats.org/drawingml/2006/main" xmlns:r="http://schemas.openxmlformats.org/officeDocument/2006/relationships" xmlns:p="http://schemas.openxmlformats.org/presentationml/2006/main">
+  <p:cSld>
+    <p:spTree>
+      <p:nvGrpSpPr>
+        <p:cNvPr id="1" name=""/>
+        <p:cNvGrpSpPr/>
+        <p:nvPr/>
+      </p:nvGrpSpPr>
+      <p:grpSpPr>
+        <a:xfrm>
+          <a:off x="0" y="0"/>
+          <a:ext cx="0" cy="0"/>
+          <a:chOff x="0" y="0"/>
+          <a:chExt cx="0" cy="0"/>
+        </a:xfrm>
+      </p:grpSpPr>
+      <p:sp>
+        <p:nvSpPr>
+          <p:cNvPr id="2" name="Slide Image Placeholder 1"/>
+          <p:cNvSpPr>
+            <a:spLocks noGrp="1" noRot="1" noChangeAspect="1"/>
+          </p:cNvSpPr>
+          <p:nvPr>
+            <p:ph type="sldImg"/>
+          </p:nvPr>
+        </p:nvSpPr>
+        <p:spPr/>
+      </p:sp>
+      <p:sp>
+        <p:nvSpPr>
+          <p:cNvPr id="3" name="Notes Placeholder 2"/>
+          <p:cNvSpPr>
+            <a:spLocks noGrp="1"/>
+          </p:cNvSpPr>
+          <p:nvPr>
+            <p:ph type="body" idx="1"/>
+          </p:nvPr>
+        </p:nvSpPr>
+        <p:spPr/>
+        <p:txBody>
+          <a:bodyPr/>
+          <a:lstStyle/>
+          <a:p>
+            <a:r>
+              <a:rPr lang="en-US" dirty="0"/>
+              <a:t>Roadmap slide. The Big Book is built in three movements.
+Doctor's Opinion + Bill's Story = Step 1. The Problem. We are powerless.
+Chapters 2-4 = Step 2. The Solution. There is a Power.
+Chapters 5-7 = Steps 3 through 12. The action necessary for recovery.
+Chapters 8 and 9 speak to the family - read today as Al-Anon and Alateen.
+The "MUSTS" exercise begins on page 142.</a:t>
+            </a:r>
+            <a:endParaRPr lang="en-US" dirty="0"/>
+          </a:p>
+        </p:txBody>
+      </p:sp>
+      <p:sp>
+        <p:nvSpPr>
+          <p:cNvPr id="4" name="Slide Number Placeholder 3"/>
+          <p:cNvSpPr>
+            <a:spLocks noGrp="1"/>
+          </p:cNvSpPr>
+          <p:nvPr>
+            <p:ph type="sldNum" sz="quarter" idx="10"/>
+          </p:nvPr>
+        </p:nvSpPr>
+        <p:spPr/>
+        <p:txBody>
+          <a:bodyPr/>
+          <a:lstStyle/>
+          <a:p>
+            <a:fld id="{F7021451-1387-4CA6-816F-3879F97B5CBC}" type="slidenum">
+              <a:rPr lang="en-US"/>
+              <a:t>2</a:t>
+            </a:fld>
+            <a:endParaRPr lang="en-US"/>
+          </a:p>
+        </p:txBody>
+      </p:sp>
+    </p:spTree>
+    <p:extLst>
+      <p:ext uri="{BB962C8B-B14F-4D97-AF65-F5344CB8AC3E}">
+        <p14:creationId xmlns:p14="http://schemas.microsoft.com/office/powerpoint/2010/main" val="1024086991"/>
+      </p:ext>
+    </p:extLst>
+  </p:cSld>
+  <p:clrMapOvr>
+    <a:masterClrMapping/>
+  </p:clrMapOvr>
+</p:notes>
+</file>
+
+<file path=ppt/notesSlides/notesSlide3.xml><?xml version="1.0" encoding="utf-8"?>
+<p:notes xmlns:a="http://schemas.openxmlformats.org/drawingml/2006/main" xmlns:r="http://schemas.openxmlformats.org/officeDocument/2006/relationships" xmlns:p="http://schemas.openxmlformats.org/presentationml/2006/main">
+  <p:cSld>
+    <p:spTree>
+      <p:nvGrpSpPr>
+        <p:cNvPr id="1" name=""/>
+        <p:cNvGrpSpPr/>
+        <p:nvPr/>
+      </p:nvGrpSpPr>
+      <p:grpSpPr>
+        <a:xfrm>
+          <a:off x="0" y="0"/>
+          <a:ext cx="0" cy="0"/>
+          <a:chOff x="0" y="0"/>
+          <a:chExt cx="0" cy="0"/>
+        </a:xfrm>
+      </p:grpSpPr>
+      <p:sp>
+        <p:nvSpPr>
+          <p:cNvPr id="2" name="Slide Image Placeholder 1"/>
+          <p:cNvSpPr>
+            <a:spLocks noGrp="1" noRot="1" noChangeAspect="1"/>
+          </p:cNvSpPr>
+          <p:nvPr>
+            <p:ph type="sldImg"/>
+          </p:nvPr>
+        </p:nvSpPr>
+        <p:spPr/>
+      </p:sp>
+      <p:sp>
+        <p:nvSpPr>
+          <p:cNvPr id="3" name="Notes Placeholder 2"/>
+          <p:cNvSpPr>
+            <a:spLocks noGrp="1"/>
+          </p:cNvSpPr>
+          <p:nvPr>
+            <p:ph type="body" idx="1"/>
+          </p:nvPr>
+        </p:nvSpPr>
+        <p:spPr/>
+        <p:txBody>
+          <a:bodyPr/>
+          <a:lstStyle/>
+          <a:p>
+            <a:r>
+              <a:rPr lang="en-US" dirty="0"/>
+              <a:t>Page 142. Start here with the newcomer - this is where we check him out.
+Three questions, and they are not rhetorical:
+1. Will he take every necessary step? Submit to anything? Stop drinking forever?
+2. Or does he think he can get away with a few drinks later? Probe this one thoroughly.
+3. He either can and will get well, or he will not. If not, why waste the time?
+Note for the room: this passage sits in the chapter To Employers, but the test applies
+to anyone carrying the message to a newcomer.</a:t>
+            </a:r>
+            <a:endParaRPr lang="en-US" dirty="0"/>
+          </a:p>
+        </p:txBody>
+      </p:sp>
+      <p:sp>
+        <p:nvSpPr>
+          <p:cNvPr id="4" name="Slide Number Placeholder 3"/>
+          <p:cNvSpPr>
+            <a:spLocks noGrp="1"/>
+          </p:cNvSpPr>
+          <p:nvPr>
+            <p:ph type="sldNum" sz="quarter" idx="10"/>
+          </p:nvPr>
+        </p:nvSpPr>
+        <p:spPr/>
+        <p:txBody>
+          <a:bodyPr/>
+          <a:lstStyle/>
+          <a:p>
+            <a:fld id="{F7021451-1387-4CA6-816F-3879F97B5CBC}" type="slidenum">
+              <a:rPr lang="en-US"/>
+              <a:t>3</a:t>
             </a:fld>
             <a:endParaRPr lang="en-US"/>
           </a:p>
@@ -862,6 +1049,261 @@
     <p:bg>
       <p:bgPr>
         <a:solidFill>
+          <a:srgbClr val="1B2A41"/>
+        </a:solidFill>
+      </p:bgPr>
+    </p:bg>
+    <p:spTree>
+      <p:nvGrpSpPr>
+        <p:cNvPr id="1" name=""/>
+        <p:cNvGrpSpPr/>
+        <p:nvPr/>
+      </p:nvGrpSpPr>
+      <p:grpSpPr>
+        <a:xfrm>
+          <a:off x="0" y="0"/>
+          <a:ext cx="0" cy="0"/>
+          <a:chOff x="0" y="0"/>
+          <a:chExt cx="0" cy="0"/>
+        </a:xfrm>
+      </p:grpSpPr>
+      <p:sp>
+        <p:nvSpPr>
+          <p:cNvPr id="2" name="Text 0"/>
+          <p:cNvSpPr/>
+          <p:nvPr/>
+        </p:nvSpPr>
+        <p:spPr>
+          <a:xfrm>
+            <a:off x="822960" y="914400"/>
+            <a:ext cx="10543032" cy="777240"/>
+          </a:xfrm>
+          <a:prstGeom prst="rect">
+            <a:avLst/>
+          </a:prstGeom>
+          <a:noFill/>
+          <a:ln/>
+        </p:spPr>
+        <p:txBody>
+          <a:bodyPr wrap="square" lIns="0" tIns="0" rIns="0" bIns="0" rtlCol="0" anchor="ctr"/>
+          <a:lstStyle/>
+          <a:p>
+            <a:pPr indent="0" marL="0">
+              <a:buNone/>
+            </a:pPr>
+            <a:r>
+              <a:rPr lang="en-US" sz="4400" b="1" dirty="0">
+                <a:solidFill>
+                  <a:srgbClr val="FFFFFF"/>
+                </a:solidFill>
+                <a:latin typeface="Cambria" pitchFamily="34" charset="0"/>
+                <a:ea typeface="Cambria" pitchFamily="34" charset="-122"/>
+                <a:cs typeface="Cambria" pitchFamily="34" charset="-120"/>
+              </a:rPr>
+              <a:t>The Big Book Study</a:t>
+            </a:r>
+            <a:endParaRPr lang="en-US" sz="4400" dirty="0"/>
+          </a:p>
+        </p:txBody>
+      </p:sp>
+      <p:sp>
+        <p:nvSpPr>
+          <p:cNvPr id="3" name="Text 1"/>
+          <p:cNvSpPr/>
+          <p:nvPr/>
+        </p:nvSpPr>
+        <p:spPr>
+          <a:xfrm>
+            <a:off x="822960" y="1737360"/>
+            <a:ext cx="10543032" cy="365760"/>
+          </a:xfrm>
+          <a:prstGeom prst="rect">
+            <a:avLst/>
+          </a:prstGeom>
+          <a:noFill/>
+          <a:ln/>
+        </p:spPr>
+        <p:txBody>
+          <a:bodyPr wrap="square" lIns="0" tIns="0" rIns="0" bIns="0" rtlCol="0" anchor="ctr"/>
+          <a:lstStyle/>
+          <a:p>
+            <a:pPr indent="0" marL="0">
+              <a:buNone/>
+            </a:pPr>
+            <a:r>
+              <a:rPr lang="en-US" sz="1800" spc="200" kern="0" dirty="0">
+                <a:solidFill>
+                  <a:srgbClr val="A9B8CC"/>
+                </a:solidFill>
+                <a:latin typeface="Calibri" pitchFamily="34" charset="0"/>
+                <a:ea typeface="Calibri" pitchFamily="34" charset="-122"/>
+                <a:cs typeface="Calibri" pitchFamily="34" charset="-120"/>
+              </a:rPr>
+              <a:t>Alcoholics Anonymous   ·   Fourth Edition</a:t>
+            </a:r>
+            <a:endParaRPr lang="en-US" sz="1800" dirty="0"/>
+          </a:p>
+        </p:txBody>
+      </p:sp>
+      <p:sp>
+        <p:nvSpPr>
+          <p:cNvPr id="4" name="Shape 2"/>
+          <p:cNvSpPr/>
+          <p:nvPr/>
+        </p:nvSpPr>
+        <p:spPr>
+          <a:xfrm>
+            <a:off x="822960" y="2651760"/>
+            <a:ext cx="10543032" cy="2011680"/>
+          </a:xfrm>
+          <a:prstGeom prst="roundRect">
+            <a:avLst>
+              <a:gd name="adj" fmla="val 4545"/>
+            </a:avLst>
+          </a:prstGeom>
+          <a:solidFill>
+            <a:srgbClr val="FFFFFF"/>
+          </a:solidFill>
+          <a:ln/>
+        </p:spPr>
+      </p:sp>
+      <p:sp>
+        <p:nvSpPr>
+          <p:cNvPr id="5" name="Text 3"/>
+          <p:cNvSpPr/>
+          <p:nvPr/>
+        </p:nvSpPr>
+        <p:spPr>
+          <a:xfrm>
+            <a:off x="1115568" y="2788920"/>
+            <a:ext cx="9966960" cy="292608"/>
+          </a:xfrm>
+          <a:prstGeom prst="rect">
+            <a:avLst/>
+          </a:prstGeom>
+          <a:noFill/>
+          <a:ln/>
+        </p:spPr>
+        <p:txBody>
+          <a:bodyPr wrap="square" lIns="0" tIns="0" rIns="0" bIns="0" rtlCol="0" anchor="ctr"/>
+          <a:lstStyle/>
+          <a:p>
+            <a:pPr indent="0" marL="0">
+              <a:buNone/>
+            </a:pPr>
+            <a:r>
+              <a:rPr lang="en-US" sz="1200" b="1" spc="200" kern="0" dirty="0">
+                <a:solidFill>
+                  <a:srgbClr val="9E1B60"/>
+                </a:solidFill>
+                <a:latin typeface="Calibri" pitchFamily="34" charset="0"/>
+                <a:ea typeface="Calibri" pitchFamily="34" charset="-122"/>
+                <a:cs typeface="Calibri" pitchFamily="34" charset="-120"/>
+              </a:rPr>
+              <a:t>COPYRIGHT NOTICE</a:t>
+            </a:r>
+            <a:endParaRPr lang="en-US" sz="1200" dirty="0"/>
+          </a:p>
+        </p:txBody>
+      </p:sp>
+      <p:sp>
+        <p:nvSpPr>
+          <p:cNvPr id="6" name="Text 4"/>
+          <p:cNvSpPr/>
+          <p:nvPr/>
+        </p:nvSpPr>
+        <p:spPr>
+          <a:xfrm>
+            <a:off x="1115568" y="3127248"/>
+            <a:ext cx="9966960" cy="1371600"/>
+          </a:xfrm>
+          <a:prstGeom prst="rect">
+            <a:avLst/>
+          </a:prstGeom>
+          <a:noFill/>
+          <a:ln/>
+        </p:spPr>
+        <p:txBody>
+          <a:bodyPr wrap="square" lIns="0" tIns="0" rIns="0" bIns="0" rtlCol="0" anchor="t"/>
+          <a:lstStyle/>
+          <a:p>
+            <a:pPr indent="0" marL="0">
+              <a:lnSpc>
+                <a:spcPct val="120000"/>
+              </a:lnSpc>
+              <a:buNone/>
+            </a:pPr>
+            <a:r>
+              <a:rPr lang="en-US" sz="1700" i="1" dirty="0">
+                <a:solidFill>
+                  <a:srgbClr val="1B2A41"/>
+                </a:solidFill>
+                <a:latin typeface="Calibri" pitchFamily="34" charset="0"/>
+                <a:ea typeface="Calibri" pitchFamily="34" charset="-122"/>
+                <a:cs typeface="Calibri" pitchFamily="34" charset="-120"/>
+              </a:rPr>
+              <a:t>“These materials are copyright © by Alcoholics Anonymous World Services, Inc. ("A.A.W.S."). All rights reserved. Individual printing or photocopying of a single copy is permitted. Intended for personal use only, and not to be reproduced further or distributed for resale.”</a:t>
+            </a:r>
+            <a:endParaRPr lang="en-US" sz="1700" dirty="0"/>
+          </a:p>
+        </p:txBody>
+      </p:sp>
+      <p:sp>
+        <p:nvSpPr>
+          <p:cNvPr id="7" name="Text 5"/>
+          <p:cNvSpPr/>
+          <p:nvPr/>
+        </p:nvSpPr>
+        <p:spPr>
+          <a:xfrm>
+            <a:off x="822960" y="4892040"/>
+            <a:ext cx="10543032" cy="731520"/>
+          </a:xfrm>
+          <a:prstGeom prst="rect">
+            <a:avLst/>
+          </a:prstGeom>
+          <a:noFill/>
+          <a:ln/>
+        </p:spPr>
+        <p:txBody>
+          <a:bodyPr wrap="square" lIns="0" tIns="0" rIns="0" bIns="0" rtlCol="0" anchor="t"/>
+          <a:lstStyle/>
+          <a:p>
+            <a:pPr indent="0" marL="0">
+              <a:lnSpc>
+                <a:spcPct val="120000"/>
+              </a:lnSpc>
+              <a:buNone/>
+            </a:pPr>
+            <a:r>
+              <a:rPr lang="en-US" sz="1300" dirty="0">
+                <a:solidFill>
+                  <a:srgbClr val="A9B8CC"/>
+                </a:solidFill>
+                <a:latin typeface="Calibri" pitchFamily="34" charset="0"/>
+                <a:ea typeface="Calibri" pitchFamily="34" charset="-122"/>
+                <a:cs typeface="Calibri" pitchFamily="34" charset="-120"/>
+              </a:rPr>
+              <a:t>Displayed at the request of A.A. World Services, Inc. A.A.W.S. has advised that it has no objection to screen-sharing A.A. literature from aa.org or from authorized e-books during an A.A. meeting, provided this notice is also displayed.</a:t>
+            </a:r>
+            <a:endParaRPr lang="en-US" sz="1300" dirty="0"/>
+          </a:p>
+        </p:txBody>
+      </p:sp>
+    </p:spTree>
+  </p:cSld>
+  <p:clrMapOvr>
+    <a:masterClrMapping/>
+  </p:clrMapOvr>
+</p:sld>
+</file>
+
+<file path=ppt/slides/slide2.xml><?xml version="1.0" encoding="utf-8"?>
+<p:sld xmlns:a="http://schemas.openxmlformats.org/drawingml/2006/main" xmlns:r="http://schemas.openxmlformats.org/officeDocument/2006/relationships" xmlns:p="http://schemas.openxmlformats.org/presentationml/2006/main">
+  <p:cSld name="Slide 2">
+    <p:bg>
+      <p:bgPr>
+        <a:solidFill>
           <a:srgbClr val="FFFFFF"/>
         </a:solidFill>
       </p:bgPr>
@@ -1044,12 +1486,12 @@
         </p:nvSpPr>
         <p:spPr>
           <a:xfrm>
-            <a:off x="548640" y="1417320"/>
-            <a:ext cx="11091672" cy="1097280"/>
+            <a:off x="548640" y="1371600"/>
+            <a:ext cx="11091672" cy="1051560"/>
           </a:xfrm>
           <a:prstGeom prst="roundRect">
             <a:avLst>
-              <a:gd name="adj" fmla="val 6667"/>
+              <a:gd name="adj" fmla="val 6957"/>
             </a:avLst>
           </a:prstGeom>
           <a:solidFill>
@@ -1066,12 +1508,12 @@
         </p:nvSpPr>
         <p:spPr>
           <a:xfrm>
-            <a:off x="548640" y="1417320"/>
-            <a:ext cx="3017520" cy="1097280"/>
+            <a:off x="548640" y="1371600"/>
+            <a:ext cx="3017520" cy="1051560"/>
           </a:xfrm>
           <a:prstGeom prst="roundRect">
             <a:avLst>
-              <a:gd name="adj" fmla="val 6667"/>
+              <a:gd name="adj" fmla="val 6957"/>
             </a:avLst>
           </a:prstGeom>
           <a:solidFill>
@@ -1088,8 +1530,8 @@
         </p:nvSpPr>
         <p:spPr>
           <a:xfrm>
-            <a:off x="777240" y="1417320"/>
-            <a:ext cx="2560320" cy="1097280"/>
+            <a:off x="777240" y="1371600"/>
+            <a:ext cx="2560320" cy="1051560"/>
           </a:xfrm>
           <a:prstGeom prst="rect">
             <a:avLst/>
@@ -1150,8 +1592,8 @@
         </p:nvSpPr>
         <p:spPr>
           <a:xfrm>
-            <a:off x="3794760" y="1600200"/>
-            <a:ext cx="457200" cy="347472"/>
+            <a:off x="3794760" y="1549908"/>
+            <a:ext cx="457200" cy="329184"/>
           </a:xfrm>
           <a:prstGeom prst="rect">
             <a:avLst/>
@@ -1178,8 +1620,8 @@
         </p:nvSpPr>
         <p:spPr>
           <a:xfrm>
-            <a:off x="4370832" y="1600200"/>
-            <a:ext cx="5669280" cy="347472"/>
+            <a:off x="4370832" y="1549908"/>
+            <a:ext cx="5669280" cy="329184"/>
           </a:xfrm>
           <a:prstGeom prst="rect">
             <a:avLst/>
@@ -1217,8 +1659,8 @@
         </p:nvSpPr>
         <p:spPr>
           <a:xfrm>
-            <a:off x="10195560" y="1600200"/>
-            <a:ext cx="1280160" cy="347472"/>
+            <a:off x="10195560" y="1549908"/>
+            <a:ext cx="1280160" cy="329184"/>
           </a:xfrm>
           <a:prstGeom prst="rect">
             <a:avLst/>
@@ -1256,8 +1698,8 @@
         </p:nvSpPr>
         <p:spPr>
           <a:xfrm>
-            <a:off x="3794760" y="1984248"/>
-            <a:ext cx="457200" cy="347472"/>
+            <a:off x="3794760" y="1915668"/>
+            <a:ext cx="457200" cy="329184"/>
           </a:xfrm>
           <a:prstGeom prst="rect">
             <a:avLst/>
@@ -1295,8 +1737,8 @@
         </p:nvSpPr>
         <p:spPr>
           <a:xfrm>
-            <a:off x="4370832" y="1984248"/>
-            <a:ext cx="5669280" cy="347472"/>
+            <a:off x="4370832" y="1915668"/>
+            <a:ext cx="5669280" cy="329184"/>
           </a:xfrm>
           <a:prstGeom prst="rect">
             <a:avLst/>
@@ -1334,8 +1776,8 @@
         </p:nvSpPr>
         <p:spPr>
           <a:xfrm>
-            <a:off x="10195560" y="1984248"/>
-            <a:ext cx="1280160" cy="347472"/>
+            <a:off x="10195560" y="1915668"/>
+            <a:ext cx="1280160" cy="329184"/>
           </a:xfrm>
           <a:prstGeom prst="rect">
             <a:avLst/>
@@ -1373,12 +1815,12 @@
         </p:nvSpPr>
         <p:spPr>
           <a:xfrm>
-            <a:off x="548640" y="2697480"/>
-            <a:ext cx="11091672" cy="1371600"/>
+            <a:off x="548640" y="2560320"/>
+            <a:ext cx="11091672" cy="1325880"/>
           </a:xfrm>
           <a:prstGeom prst="roundRect">
             <a:avLst>
-              <a:gd name="adj" fmla="val 5333"/>
+              <a:gd name="adj" fmla="val 5517"/>
             </a:avLst>
           </a:prstGeom>
           <a:solidFill>
@@ -1395,12 +1837,12 @@
         </p:nvSpPr>
         <p:spPr>
           <a:xfrm>
-            <a:off x="548640" y="2697480"/>
-            <a:ext cx="3017520" cy="1371600"/>
+            <a:off x="548640" y="2560320"/>
+            <a:ext cx="3017520" cy="1325880"/>
           </a:xfrm>
           <a:prstGeom prst="roundRect">
             <a:avLst>
-              <a:gd name="adj" fmla="val 5333"/>
+              <a:gd name="adj" fmla="val 5517"/>
             </a:avLst>
           </a:prstGeom>
           <a:solidFill>
@@ -1417,8 +1859,8 @@
         </p:nvSpPr>
         <p:spPr>
           <a:xfrm>
-            <a:off x="777240" y="2697480"/>
-            <a:ext cx="2560320" cy="1371600"/>
+            <a:off x="777240" y="2560320"/>
+            <a:ext cx="2560320" cy="1325880"/>
           </a:xfrm>
           <a:prstGeom prst="rect">
             <a:avLst/>
@@ -1479,8 +1921,8 @@
         </p:nvSpPr>
         <p:spPr>
           <a:xfrm>
-            <a:off x="3794760" y="2825496"/>
-            <a:ext cx="457200" cy="347472"/>
+            <a:off x="3794760" y="2692908"/>
+            <a:ext cx="457200" cy="329184"/>
           </a:xfrm>
           <a:prstGeom prst="rect">
             <a:avLst/>
@@ -1518,8 +1960,8 @@
         </p:nvSpPr>
         <p:spPr>
           <a:xfrm>
-            <a:off x="4370832" y="2825496"/>
-            <a:ext cx="5669280" cy="347472"/>
+            <a:off x="4370832" y="2692908"/>
+            <a:ext cx="5669280" cy="329184"/>
           </a:xfrm>
           <a:prstGeom prst="rect">
             <a:avLst/>
@@ -1557,8 +1999,8 @@
         </p:nvSpPr>
         <p:spPr>
           <a:xfrm>
-            <a:off x="10195560" y="2825496"/>
-            <a:ext cx="1280160" cy="347472"/>
+            <a:off x="10195560" y="2692908"/>
+            <a:ext cx="1280160" cy="329184"/>
           </a:xfrm>
           <a:prstGeom prst="rect">
             <a:avLst/>
@@ -1596,8 +2038,8 @@
         </p:nvSpPr>
         <p:spPr>
           <a:xfrm>
-            <a:off x="3794760" y="3209544"/>
-            <a:ext cx="457200" cy="347472"/>
+            <a:off x="3794760" y="3058668"/>
+            <a:ext cx="457200" cy="329184"/>
           </a:xfrm>
           <a:prstGeom prst="rect">
             <a:avLst/>
@@ -1635,8 +2077,8 @@
         </p:nvSpPr>
         <p:spPr>
           <a:xfrm>
-            <a:off x="4370832" y="3209544"/>
-            <a:ext cx="5669280" cy="347472"/>
+            <a:off x="4370832" y="3058668"/>
+            <a:ext cx="5669280" cy="329184"/>
           </a:xfrm>
           <a:prstGeom prst="rect">
             <a:avLst/>
@@ -1674,8 +2116,8 @@
         </p:nvSpPr>
         <p:spPr>
           <a:xfrm>
-            <a:off x="10195560" y="3209544"/>
-            <a:ext cx="1280160" cy="347472"/>
+            <a:off x="10195560" y="3058668"/>
+            <a:ext cx="1280160" cy="329184"/>
           </a:xfrm>
           <a:prstGeom prst="rect">
             <a:avLst/>
@@ -1713,8 +2155,8 @@
         </p:nvSpPr>
         <p:spPr>
           <a:xfrm>
-            <a:off x="3794760" y="3593592"/>
-            <a:ext cx="457200" cy="347472"/>
+            <a:off x="3794760" y="3424428"/>
+            <a:ext cx="457200" cy="329184"/>
           </a:xfrm>
           <a:prstGeom prst="rect">
             <a:avLst/>
@@ -1752,8 +2194,8 @@
         </p:nvSpPr>
         <p:spPr>
           <a:xfrm>
-            <a:off x="4370832" y="3593592"/>
-            <a:ext cx="5669280" cy="347472"/>
+            <a:off x="4370832" y="3424428"/>
+            <a:ext cx="5669280" cy="329184"/>
           </a:xfrm>
           <a:prstGeom prst="rect">
             <a:avLst/>
@@ -1791,8 +2233,8 @@
         </p:nvSpPr>
         <p:spPr>
           <a:xfrm>
-            <a:off x="10195560" y="3593592"/>
-            <a:ext cx="1280160" cy="347472"/>
+            <a:off x="10195560" y="3424428"/>
+            <a:ext cx="1280160" cy="329184"/>
           </a:xfrm>
           <a:prstGeom prst="rect">
             <a:avLst/>
@@ -1830,12 +2272,12 @@
         </p:nvSpPr>
         <p:spPr>
           <a:xfrm>
-            <a:off x="548640" y="4251960"/>
-            <a:ext cx="11091672" cy="1371600"/>
+            <a:off x="548640" y="4023360"/>
+            <a:ext cx="11091672" cy="1325880"/>
           </a:xfrm>
           <a:prstGeom prst="roundRect">
             <a:avLst>
-              <a:gd name="adj" fmla="val 5333"/>
+              <a:gd name="adj" fmla="val 5517"/>
             </a:avLst>
           </a:prstGeom>
           <a:solidFill>
@@ -1852,12 +2294,12 @@
         </p:nvSpPr>
         <p:spPr>
           <a:xfrm>
-            <a:off x="548640" y="4251960"/>
-            <a:ext cx="3017520" cy="1371600"/>
+            <a:off x="548640" y="4023360"/>
+            <a:ext cx="3017520" cy="1325880"/>
           </a:xfrm>
           <a:prstGeom prst="roundRect">
             <a:avLst>
-              <a:gd name="adj" fmla="val 5333"/>
+              <a:gd name="adj" fmla="val 5517"/>
             </a:avLst>
           </a:prstGeom>
           <a:solidFill>
@@ -1874,8 +2316,8 @@
         </p:nvSpPr>
         <p:spPr>
           <a:xfrm>
-            <a:off x="777240" y="4251960"/>
-            <a:ext cx="2560320" cy="1371600"/>
+            <a:off x="777240" y="4023360"/>
+            <a:ext cx="2560320" cy="1325880"/>
           </a:xfrm>
           <a:prstGeom prst="rect">
             <a:avLst/>
@@ -1936,8 +2378,8 @@
         </p:nvSpPr>
         <p:spPr>
           <a:xfrm>
-            <a:off x="3794760" y="4379976"/>
-            <a:ext cx="457200" cy="347472"/>
+            <a:off x="3794760" y="4155948"/>
+            <a:ext cx="457200" cy="329184"/>
           </a:xfrm>
           <a:prstGeom prst="rect">
             <a:avLst/>
@@ -1975,8 +2417,8 @@
         </p:nvSpPr>
         <p:spPr>
           <a:xfrm>
-            <a:off x="4370832" y="4379976"/>
-            <a:ext cx="5669280" cy="347472"/>
+            <a:off x="4370832" y="4155948"/>
+            <a:ext cx="5669280" cy="329184"/>
           </a:xfrm>
           <a:prstGeom prst="rect">
             <a:avLst/>
@@ -2014,8 +2456,8 @@
         </p:nvSpPr>
         <p:spPr>
           <a:xfrm>
-            <a:off x="10195560" y="4379976"/>
-            <a:ext cx="1280160" cy="347472"/>
+            <a:off x="10195560" y="4155948"/>
+            <a:ext cx="1280160" cy="329184"/>
           </a:xfrm>
           <a:prstGeom prst="rect">
             <a:avLst/>
@@ -2053,8 +2495,8 @@
         </p:nvSpPr>
         <p:spPr>
           <a:xfrm>
-            <a:off x="3794760" y="4764024"/>
-            <a:ext cx="457200" cy="347472"/>
+            <a:off x="3794760" y="4521708"/>
+            <a:ext cx="457200" cy="329184"/>
           </a:xfrm>
           <a:prstGeom prst="rect">
             <a:avLst/>
@@ -2092,8 +2534,8 @@
         </p:nvSpPr>
         <p:spPr>
           <a:xfrm>
-            <a:off x="4370832" y="4764024"/>
-            <a:ext cx="5669280" cy="347472"/>
+            <a:off x="4370832" y="4521708"/>
+            <a:ext cx="5669280" cy="329184"/>
           </a:xfrm>
           <a:prstGeom prst="rect">
             <a:avLst/>
@@ -2131,8 +2573,8 @@
         </p:nvSpPr>
         <p:spPr>
           <a:xfrm>
-            <a:off x="10195560" y="4764024"/>
-            <a:ext cx="1280160" cy="347472"/>
+            <a:off x="10195560" y="4521708"/>
+            <a:ext cx="1280160" cy="329184"/>
           </a:xfrm>
           <a:prstGeom prst="rect">
             <a:avLst/>
@@ -2170,8 +2612,8 @@
         </p:nvSpPr>
         <p:spPr>
           <a:xfrm>
-            <a:off x="3794760" y="5148072"/>
-            <a:ext cx="457200" cy="347472"/>
+            <a:off x="3794760" y="4887468"/>
+            <a:ext cx="457200" cy="329184"/>
           </a:xfrm>
           <a:prstGeom prst="rect">
             <a:avLst/>
@@ -2209,8 +2651,8 @@
         </p:nvSpPr>
         <p:spPr>
           <a:xfrm>
-            <a:off x="4370832" y="5148072"/>
-            <a:ext cx="5669280" cy="347472"/>
+            <a:off x="4370832" y="4887468"/>
+            <a:ext cx="5669280" cy="329184"/>
           </a:xfrm>
           <a:prstGeom prst="rect">
             <a:avLst/>
@@ -2248,8 +2690,8 @@
         </p:nvSpPr>
         <p:spPr>
           <a:xfrm>
-            <a:off x="10195560" y="5148072"/>
-            <a:ext cx="1280160" cy="347472"/>
+            <a:off x="10195560" y="4887468"/>
+            <a:ext cx="1280160" cy="329184"/>
           </a:xfrm>
           <a:prstGeom prst="rect">
             <a:avLst/>
@@ -2287,12 +2729,12 @@
         </p:nvSpPr>
         <p:spPr>
           <a:xfrm>
-            <a:off x="548640" y="5852160"/>
-            <a:ext cx="11091672" cy="548640"/>
+            <a:off x="548640" y="5532120"/>
+            <a:ext cx="11091672" cy="502920"/>
           </a:xfrm>
           <a:prstGeom prst="roundRect">
             <a:avLst>
-              <a:gd name="adj" fmla="val 13333"/>
+              <a:gd name="adj" fmla="val 14545"/>
             </a:avLst>
           </a:prstGeom>
           <a:solidFill>
@@ -2309,8 +2751,8 @@
         </p:nvSpPr>
         <p:spPr>
           <a:xfrm>
-            <a:off x="868680" y="5852160"/>
-            <a:ext cx="5029200" cy="548640"/>
+            <a:off x="868680" y="5532120"/>
+            <a:ext cx="5029200" cy="502920"/>
           </a:xfrm>
           <a:prstGeom prst="rect">
             <a:avLst/>
@@ -2362,7 +2804,7 @@
                 <a:ea typeface="Calibri" pitchFamily="34" charset="-122"/>
                 <a:cs typeface="Calibri" pitchFamily="34" charset="-120"/>
               </a:rPr>
-              <a:t>  →  </a:t>
+              <a:t>   →   </a:t>
             </a:r>
             <a:pPr indent="0" marL="0">
               <a:buNone/>
@@ -2390,7 +2832,7 @@
                 <a:ea typeface="Calibri" pitchFamily="34" charset="-122"/>
                 <a:cs typeface="Calibri" pitchFamily="34" charset="-120"/>
               </a:rPr>
-              <a:t>   p. 104</a:t>
+              <a:t>     p. 104</a:t>
             </a:r>
             <a:endParaRPr lang="en-US" sz="1400" dirty="0"/>
           </a:p>
@@ -2404,8 +2846,8 @@
         </p:nvSpPr>
         <p:spPr>
           <a:xfrm>
-            <a:off x="6309360" y="5852160"/>
-            <a:ext cx="5029200" cy="548640"/>
+            <a:off x="6309360" y="5532120"/>
+            <a:ext cx="5029200" cy="502920"/>
           </a:xfrm>
           <a:prstGeom prst="rect">
             <a:avLst/>
@@ -2457,7 +2899,7 @@
                 <a:ea typeface="Calibri" pitchFamily="34" charset="-122"/>
                 <a:cs typeface="Calibri" pitchFamily="34" charset="-120"/>
               </a:rPr>
-              <a:t>  →  </a:t>
+              <a:t>   →   </a:t>
             </a:r>
             <a:pPr indent="0" marL="0">
               <a:buNone/>
@@ -2485,9 +2927,697 @@
                 <a:ea typeface="Calibri" pitchFamily="34" charset="-122"/>
                 <a:cs typeface="Calibri" pitchFamily="34" charset="-120"/>
               </a:rPr>
-              <a:t>   p. 122</a:t>
+              <a:t>     p. 122</a:t>
             </a:r>
             <a:endParaRPr lang="en-US" sz="1400" dirty="0"/>
+          </a:p>
+        </p:txBody>
+      </p:sp>
+      <p:sp>
+        <p:nvSpPr>
+          <p:cNvPr id="42" name="Text 40"/>
+          <p:cNvSpPr/>
+          <p:nvPr/>
+        </p:nvSpPr>
+        <p:spPr>
+          <a:xfrm>
+            <a:off x="548640" y="6355080"/>
+            <a:ext cx="11091672" cy="292608"/>
+          </a:xfrm>
+          <a:prstGeom prst="rect">
+            <a:avLst/>
+          </a:prstGeom>
+          <a:noFill/>
+          <a:ln/>
+        </p:spPr>
+        <p:txBody>
+          <a:bodyPr wrap="square" lIns="0" tIns="0" rIns="0" bIns="0" rtlCol="0" anchor="ctr"/>
+          <a:lstStyle/>
+          <a:p>
+            <a:pPr indent="0" marL="0">
+              <a:buNone/>
+            </a:pPr>
+            <a:r>
+              <a:rPr lang="en-US" sz="950" dirty="0">
+                <a:solidFill>
+                  <a:srgbClr val="6B7A8C"/>
+                </a:solidFill>
+                <a:latin typeface="Calibri" pitchFamily="34" charset="0"/>
+                <a:ea typeface="Calibri" pitchFamily="34" charset="-122"/>
+                <a:cs typeface="Calibri" pitchFamily="34" charset="-120"/>
+              </a:rPr>
+              <a:t>Copyright © Alcoholics Anonymous World Services, Inc. All rights reserved. Intended for personal use only, and not to be reproduced further or distributed for resale.</a:t>
+            </a:r>
+            <a:endParaRPr lang="en-US" sz="950" dirty="0"/>
+          </a:p>
+        </p:txBody>
+      </p:sp>
+    </p:spTree>
+  </p:cSld>
+  <p:clrMapOvr>
+    <a:masterClrMapping/>
+  </p:clrMapOvr>
+</p:sld>
+</file>
+
+<file path=ppt/slides/slide3.xml><?xml version="1.0" encoding="utf-8"?>
+<p:sld xmlns:a="http://schemas.openxmlformats.org/drawingml/2006/main" xmlns:r="http://schemas.openxmlformats.org/officeDocument/2006/relationships" xmlns:p="http://schemas.openxmlformats.org/presentationml/2006/main">
+  <p:cSld name="Slide 3">
+    <p:bg>
+      <p:bgPr>
+        <a:solidFill>
+          <a:srgbClr val="FFFFFF"/>
+        </a:solidFill>
+      </p:bgPr>
+    </p:bg>
+    <p:spTree>
+      <p:nvGrpSpPr>
+        <p:cNvPr id="1" name=""/>
+        <p:cNvGrpSpPr/>
+        <p:nvPr/>
+      </p:nvGrpSpPr>
+      <p:grpSpPr>
+        <a:xfrm>
+          <a:off x="0" y="0"/>
+          <a:ext cx="0" cy="0"/>
+          <a:chOff x="0" y="0"/>
+          <a:chExt cx="0" cy="0"/>
+        </a:xfrm>
+      </p:grpSpPr>
+      <p:sp>
+        <p:nvSpPr>
+          <p:cNvPr id="2" name="Text 0"/>
+          <p:cNvSpPr/>
+          <p:nvPr/>
+        </p:nvSpPr>
+        <p:spPr>
+          <a:xfrm>
+            <a:off x="548640" y="320040"/>
+            <a:ext cx="7863840" cy="566928"/>
+          </a:xfrm>
+          <a:prstGeom prst="rect">
+            <a:avLst/>
+          </a:prstGeom>
+          <a:noFill/>
+          <a:ln/>
+        </p:spPr>
+        <p:txBody>
+          <a:bodyPr wrap="square" lIns="0" tIns="0" rIns="0" bIns="0" rtlCol="0" anchor="ctr"/>
+          <a:lstStyle/>
+          <a:p>
+            <a:pPr indent="0" marL="0">
+              <a:buNone/>
+            </a:pPr>
+            <a:r>
+              <a:rPr lang="en-US" sz="4000" b="1" dirty="0">
+                <a:solidFill>
+                  <a:srgbClr val="1B2A41"/>
+                </a:solidFill>
+                <a:latin typeface="Cambria" pitchFamily="34" charset="0"/>
+                <a:ea typeface="Cambria" pitchFamily="34" charset="-122"/>
+                <a:cs typeface="Cambria" pitchFamily="34" charset="-120"/>
+              </a:rPr>
+              <a:t>Check Out the Newcomer</a:t>
+            </a:r>
+            <a:endParaRPr lang="en-US" sz="4000" dirty="0"/>
+          </a:p>
+        </p:txBody>
+      </p:sp>
+      <p:sp>
+        <p:nvSpPr>
+          <p:cNvPr id="3" name="Text 1"/>
+          <p:cNvSpPr/>
+          <p:nvPr/>
+        </p:nvSpPr>
+        <p:spPr>
+          <a:xfrm>
+            <a:off x="548640" y="914400"/>
+            <a:ext cx="7863840" cy="347472"/>
+          </a:xfrm>
+          <a:prstGeom prst="rect">
+            <a:avLst/>
+          </a:prstGeom>
+          <a:noFill/>
+          <a:ln/>
+        </p:spPr>
+        <p:txBody>
+          <a:bodyPr wrap="square" lIns="0" tIns="0" rIns="0" bIns="0" rtlCol="0" anchor="ctr"/>
+          <a:lstStyle/>
+          <a:p>
+            <a:pPr indent="0" marL="0">
+              <a:buNone/>
+            </a:pPr>
+            <a:r>
+              <a:rPr lang="en-US" sz="1700" i="1" dirty="0">
+                <a:solidFill>
+                  <a:srgbClr val="6B7A8C"/>
+                </a:solidFill>
+                <a:latin typeface="Calibri" pitchFamily="34" charset="0"/>
+                <a:ea typeface="Calibri" pitchFamily="34" charset="-122"/>
+                <a:cs typeface="Calibri" pitchFamily="34" charset="-120"/>
+              </a:rPr>
+              <a:t>“Start here with the newcomer.”</a:t>
+            </a:r>
+            <a:endParaRPr lang="en-US" sz="1700" dirty="0"/>
+          </a:p>
+        </p:txBody>
+      </p:sp>
+      <p:sp>
+        <p:nvSpPr>
+          <p:cNvPr id="4" name="Shape 2"/>
+          <p:cNvSpPr/>
+          <p:nvPr/>
+        </p:nvSpPr>
+        <p:spPr>
+          <a:xfrm>
+            <a:off x="8778240" y="320040"/>
+            <a:ext cx="2862072" cy="960120"/>
+          </a:xfrm>
+          <a:prstGeom prst="roundRect">
+            <a:avLst>
+              <a:gd name="adj" fmla="val 9524"/>
+            </a:avLst>
+          </a:prstGeom>
+          <a:solidFill>
+            <a:srgbClr val="9E1B60"/>
+          </a:solidFill>
+          <a:ln/>
+        </p:spPr>
+      </p:sp>
+      <p:sp>
+        <p:nvSpPr>
+          <p:cNvPr id="5" name="Text 3"/>
+          <p:cNvSpPr/>
+          <p:nvPr/>
+        </p:nvSpPr>
+        <p:spPr>
+          <a:xfrm>
+            <a:off x="8778240" y="320040"/>
+            <a:ext cx="2862072" cy="960120"/>
+          </a:xfrm>
+          <a:prstGeom prst="rect">
+            <a:avLst/>
+          </a:prstGeom>
+          <a:noFill/>
+          <a:ln/>
+        </p:spPr>
+        <p:txBody>
+          <a:bodyPr wrap="square" lIns="0" tIns="0" rIns="0" bIns="0" rtlCol="0" anchor="ctr"/>
+          <a:lstStyle/>
+          <a:p>
+            <a:pPr algn="ctr" indent="0" marL="0">
+              <a:buNone/>
+            </a:pPr>
+            <a:r>
+              <a:rPr lang="en-US" sz="1900" b="1" dirty="0">
+                <a:solidFill>
+                  <a:srgbClr val="FFFFFF"/>
+                </a:solidFill>
+                <a:latin typeface="Cambria" pitchFamily="34" charset="0"/>
+                <a:ea typeface="Cambria" pitchFamily="34" charset="-122"/>
+                <a:cs typeface="Cambria" pitchFamily="34" charset="-120"/>
+              </a:rPr>
+              <a:t>The “MUSTS”</a:t>
+            </a:r>
+            <a:endParaRPr lang="en-US" sz="1900" dirty="0"/>
+          </a:p>
+          <a:p>
+            <a:pPr algn="ctr" indent="0" marL="0">
+              <a:buNone/>
+            </a:pPr>
+            <a:r>
+              <a:rPr lang="en-US" sz="1400" dirty="0">
+                <a:solidFill>
+                  <a:srgbClr val="F7D9E8"/>
+                </a:solidFill>
+                <a:latin typeface="Calibri" pitchFamily="34" charset="0"/>
+                <a:ea typeface="Calibri" pitchFamily="34" charset="-122"/>
+                <a:cs typeface="Calibri" pitchFamily="34" charset="-120"/>
+              </a:rPr>
+              <a:t>Page 142</a:t>
+            </a:r>
+            <a:endParaRPr lang="en-US" sz="1900" dirty="0"/>
+          </a:p>
+        </p:txBody>
+      </p:sp>
+      <p:sp>
+        <p:nvSpPr>
+          <p:cNvPr id="6" name="Shape 4"/>
+          <p:cNvSpPr/>
+          <p:nvPr/>
+        </p:nvSpPr>
+        <p:spPr>
+          <a:xfrm>
+            <a:off x="548640" y="1463040"/>
+            <a:ext cx="11091672" cy="914400"/>
+          </a:xfrm>
+          <a:prstGeom prst="roundRect">
+            <a:avLst>
+              <a:gd name="adj" fmla="val 8000"/>
+            </a:avLst>
+          </a:prstGeom>
+          <a:solidFill>
+            <a:srgbClr val="FFF7D9"/>
+          </a:solidFill>
+          <a:ln/>
+        </p:spPr>
+      </p:sp>
+      <p:sp>
+        <p:nvSpPr>
+          <p:cNvPr id="7" name="Shape 5"/>
+          <p:cNvSpPr/>
+          <p:nvPr/>
+        </p:nvSpPr>
+        <p:spPr>
+          <a:xfrm>
+            <a:off x="822960" y="1700784"/>
+            <a:ext cx="438912" cy="438912"/>
+          </a:xfrm>
+          <a:prstGeom prst="ellipse">
+            <a:avLst/>
+          </a:prstGeom>
+          <a:solidFill>
+            <a:srgbClr val="9E1B60"/>
+          </a:solidFill>
+          <a:ln/>
+        </p:spPr>
+      </p:sp>
+      <p:sp>
+        <p:nvSpPr>
+          <p:cNvPr id="8" name="Text 6"/>
+          <p:cNvSpPr/>
+          <p:nvPr/>
+        </p:nvSpPr>
+        <p:spPr>
+          <a:xfrm>
+            <a:off x="822960" y="1700784"/>
+            <a:ext cx="438912" cy="438912"/>
+          </a:xfrm>
+          <a:prstGeom prst="rect">
+            <a:avLst/>
+          </a:prstGeom>
+          <a:noFill/>
+          <a:ln/>
+        </p:spPr>
+        <p:txBody>
+          <a:bodyPr wrap="square" lIns="0" tIns="0" rIns="0" bIns="0" rtlCol="0" anchor="ctr"/>
+          <a:lstStyle/>
+          <a:p>
+            <a:pPr algn="ctr" indent="0" marL="0">
+              <a:buNone/>
+            </a:pPr>
+            <a:r>
+              <a:rPr lang="en-US" sz="1600" b="1" dirty="0">
+                <a:solidFill>
+                  <a:srgbClr val="FFFFFF"/>
+                </a:solidFill>
+                <a:latin typeface="Calibri" pitchFamily="34" charset="0"/>
+                <a:ea typeface="Calibri" pitchFamily="34" charset="-122"/>
+                <a:cs typeface="Calibri" pitchFamily="34" charset="-120"/>
+              </a:rPr>
+              <a:t>1</a:t>
+            </a:r>
+            <a:endParaRPr lang="en-US" sz="1600" dirty="0"/>
+          </a:p>
+        </p:txBody>
+      </p:sp>
+      <p:sp>
+        <p:nvSpPr>
+          <p:cNvPr id="9" name="Text 7"/>
+          <p:cNvSpPr/>
+          <p:nvPr/>
+        </p:nvSpPr>
+        <p:spPr>
+          <a:xfrm>
+            <a:off x="1463040" y="1463040"/>
+            <a:ext cx="10012680" cy="914400"/>
+          </a:xfrm>
+          <a:prstGeom prst="rect">
+            <a:avLst/>
+          </a:prstGeom>
+          <a:noFill/>
+          <a:ln/>
+        </p:spPr>
+        <p:txBody>
+          <a:bodyPr wrap="square" lIns="0" tIns="0" rIns="0" bIns="0" rtlCol="0" anchor="ctr"/>
+          <a:lstStyle/>
+          <a:p>
+            <a:pPr indent="0" marL="0">
+              <a:lnSpc>
+                <a:spcPct val="115000"/>
+              </a:lnSpc>
+              <a:buNone/>
+            </a:pPr>
+            <a:r>
+              <a:rPr lang="en-US" sz="2000" dirty="0">
+                <a:solidFill>
+                  <a:srgbClr val="1B2A41"/>
+                </a:solidFill>
+                <a:latin typeface="Calibri" pitchFamily="34" charset="0"/>
+                <a:ea typeface="Calibri" pitchFamily="34" charset="-122"/>
+                <a:cs typeface="Calibri" pitchFamily="34" charset="-120"/>
+              </a:rPr>
+              <a:t>Will he take every necessary step, submit to anything to get well, to stop drinking forever?</a:t>
+            </a:r>
+            <a:endParaRPr lang="en-US" sz="2000" dirty="0"/>
+          </a:p>
+        </p:txBody>
+      </p:sp>
+      <p:sp>
+        <p:nvSpPr>
+          <p:cNvPr id="10" name="Shape 8"/>
+          <p:cNvSpPr/>
+          <p:nvPr/>
+        </p:nvSpPr>
+        <p:spPr>
+          <a:xfrm>
+            <a:off x="548640" y="2560320"/>
+            <a:ext cx="11091672" cy="1554480"/>
+          </a:xfrm>
+          <a:prstGeom prst="roundRect">
+            <a:avLst>
+              <a:gd name="adj" fmla="val 4706"/>
+            </a:avLst>
+          </a:prstGeom>
+          <a:solidFill>
+            <a:srgbClr val="FFF7D9"/>
+          </a:solidFill>
+          <a:ln/>
+        </p:spPr>
+      </p:sp>
+      <p:sp>
+        <p:nvSpPr>
+          <p:cNvPr id="11" name="Shape 9"/>
+          <p:cNvSpPr/>
+          <p:nvPr/>
+        </p:nvSpPr>
+        <p:spPr>
+          <a:xfrm>
+            <a:off x="822960" y="3118104"/>
+            <a:ext cx="438912" cy="438912"/>
+          </a:xfrm>
+          <a:prstGeom prst="ellipse">
+            <a:avLst/>
+          </a:prstGeom>
+          <a:solidFill>
+            <a:srgbClr val="9E1B60"/>
+          </a:solidFill>
+          <a:ln/>
+        </p:spPr>
+      </p:sp>
+      <p:sp>
+        <p:nvSpPr>
+          <p:cNvPr id="12" name="Text 10"/>
+          <p:cNvSpPr/>
+          <p:nvPr/>
+        </p:nvSpPr>
+        <p:spPr>
+          <a:xfrm>
+            <a:off x="822960" y="3118104"/>
+            <a:ext cx="438912" cy="438912"/>
+          </a:xfrm>
+          <a:prstGeom prst="rect">
+            <a:avLst/>
+          </a:prstGeom>
+          <a:noFill/>
+          <a:ln/>
+        </p:spPr>
+        <p:txBody>
+          <a:bodyPr wrap="square" lIns="0" tIns="0" rIns="0" bIns="0" rtlCol="0" anchor="ctr"/>
+          <a:lstStyle/>
+          <a:p>
+            <a:pPr algn="ctr" indent="0" marL="0">
+              <a:buNone/>
+            </a:pPr>
+            <a:r>
+              <a:rPr lang="en-US" sz="1600" b="1" dirty="0">
+                <a:solidFill>
+                  <a:srgbClr val="FFFFFF"/>
+                </a:solidFill>
+                <a:latin typeface="Calibri" pitchFamily="34" charset="0"/>
+                <a:ea typeface="Calibri" pitchFamily="34" charset="-122"/>
+                <a:cs typeface="Calibri" pitchFamily="34" charset="-120"/>
+              </a:rPr>
+              <a:t>2</a:t>
+            </a:r>
+            <a:endParaRPr lang="en-US" sz="1600" dirty="0"/>
+          </a:p>
+        </p:txBody>
+      </p:sp>
+      <p:sp>
+        <p:nvSpPr>
+          <p:cNvPr id="13" name="Text 11"/>
+          <p:cNvSpPr/>
+          <p:nvPr/>
+        </p:nvSpPr>
+        <p:spPr>
+          <a:xfrm>
+            <a:off x="1463040" y="2560320"/>
+            <a:ext cx="10012680" cy="1554480"/>
+          </a:xfrm>
+          <a:prstGeom prst="rect">
+            <a:avLst/>
+          </a:prstGeom>
+          <a:noFill/>
+          <a:ln/>
+        </p:spPr>
+        <p:txBody>
+          <a:bodyPr wrap="square" lIns="0" tIns="0" rIns="0" bIns="0" rtlCol="0" anchor="ctr"/>
+          <a:lstStyle/>
+          <a:p>
+            <a:pPr indent="0" marL="0">
+              <a:lnSpc>
+                <a:spcPct val="115000"/>
+              </a:lnSpc>
+              <a:buNone/>
+            </a:pPr>
+            <a:r>
+              <a:rPr lang="en-US" sz="2000" dirty="0">
+                <a:solidFill>
+                  <a:srgbClr val="1B2A41"/>
+                </a:solidFill>
+                <a:latin typeface="Calibri" pitchFamily="34" charset="0"/>
+                <a:ea typeface="Calibri" pitchFamily="34" charset="-122"/>
+                <a:cs typeface="Calibri" pitchFamily="34" charset="-120"/>
+              </a:rPr>
+              <a:t>…does he think he is fooling you, and that after rest and treatment he will be able to get away with a few drinks now and then? We believe a man should be thoroughly probed on these points. Be satisfied he is not deceiving himself or you.</a:t>
+            </a:r>
+            <a:endParaRPr lang="en-US" sz="2000" dirty="0"/>
+          </a:p>
+        </p:txBody>
+      </p:sp>
+      <p:sp>
+        <p:nvSpPr>
+          <p:cNvPr id="14" name="Shape 12"/>
+          <p:cNvSpPr/>
+          <p:nvPr/>
+        </p:nvSpPr>
+        <p:spPr>
+          <a:xfrm>
+            <a:off x="548640" y="4297680"/>
+            <a:ext cx="11091672" cy="1188720"/>
+          </a:xfrm>
+          <a:prstGeom prst="roundRect">
+            <a:avLst>
+              <a:gd name="adj" fmla="val 6154"/>
+            </a:avLst>
+          </a:prstGeom>
+          <a:solidFill>
+            <a:srgbClr val="FFF7D9"/>
+          </a:solidFill>
+          <a:ln/>
+        </p:spPr>
+      </p:sp>
+      <p:sp>
+        <p:nvSpPr>
+          <p:cNvPr id="15" name="Shape 13"/>
+          <p:cNvSpPr/>
+          <p:nvPr/>
+        </p:nvSpPr>
+        <p:spPr>
+          <a:xfrm>
+            <a:off x="822960" y="4672584"/>
+            <a:ext cx="438912" cy="438912"/>
+          </a:xfrm>
+          <a:prstGeom prst="ellipse">
+            <a:avLst/>
+          </a:prstGeom>
+          <a:solidFill>
+            <a:srgbClr val="9E1B60"/>
+          </a:solidFill>
+          <a:ln/>
+        </p:spPr>
+      </p:sp>
+      <p:sp>
+        <p:nvSpPr>
+          <p:cNvPr id="16" name="Text 14"/>
+          <p:cNvSpPr/>
+          <p:nvPr/>
+        </p:nvSpPr>
+        <p:spPr>
+          <a:xfrm>
+            <a:off x="822960" y="4672584"/>
+            <a:ext cx="438912" cy="438912"/>
+          </a:xfrm>
+          <a:prstGeom prst="rect">
+            <a:avLst/>
+          </a:prstGeom>
+          <a:noFill/>
+          <a:ln/>
+        </p:spPr>
+        <p:txBody>
+          <a:bodyPr wrap="square" lIns="0" tIns="0" rIns="0" bIns="0" rtlCol="0" anchor="ctr"/>
+          <a:lstStyle/>
+          <a:p>
+            <a:pPr algn="ctr" indent="0" marL="0">
+              <a:buNone/>
+            </a:pPr>
+            <a:r>
+              <a:rPr lang="en-US" sz="1600" b="1" dirty="0">
+                <a:solidFill>
+                  <a:srgbClr val="FFFFFF"/>
+                </a:solidFill>
+                <a:latin typeface="Calibri" pitchFamily="34" charset="0"/>
+                <a:ea typeface="Calibri" pitchFamily="34" charset="-122"/>
+                <a:cs typeface="Calibri" pitchFamily="34" charset="-120"/>
+              </a:rPr>
+              <a:t>3</a:t>
+            </a:r>
+            <a:endParaRPr lang="en-US" sz="1600" dirty="0"/>
+          </a:p>
+        </p:txBody>
+      </p:sp>
+      <p:sp>
+        <p:nvSpPr>
+          <p:cNvPr id="17" name="Text 15"/>
+          <p:cNvSpPr/>
+          <p:nvPr/>
+        </p:nvSpPr>
+        <p:spPr>
+          <a:xfrm>
+            <a:off x="1463040" y="4297680"/>
+            <a:ext cx="10012680" cy="1188720"/>
+          </a:xfrm>
+          <a:prstGeom prst="rect">
+            <a:avLst/>
+          </a:prstGeom>
+          <a:noFill/>
+          <a:ln/>
+        </p:spPr>
+        <p:txBody>
+          <a:bodyPr wrap="square" lIns="0" tIns="0" rIns="0" bIns="0" rtlCol="0" anchor="ctr"/>
+          <a:lstStyle/>
+          <a:p>
+            <a:pPr indent="0" marL="0">
+              <a:lnSpc>
+                <a:spcPct val="115000"/>
+              </a:lnSpc>
+              <a:buNone/>
+            </a:pPr>
+            <a:r>
+              <a:rPr lang="en-US" sz="2000" dirty="0">
+                <a:solidFill>
+                  <a:srgbClr val="1B2A41"/>
+                </a:solidFill>
+                <a:latin typeface="Calibri" pitchFamily="34" charset="0"/>
+                <a:ea typeface="Calibri" pitchFamily="34" charset="-122"/>
+                <a:cs typeface="Calibri" pitchFamily="34" charset="-120"/>
+              </a:rPr>
+              <a:t>Either you are dealing with a man who can and will get well or you are not. If not, why waste time with him? This may seem severe, but it is usually the best course.</a:t>
+            </a:r>
+            <a:endParaRPr lang="en-US" sz="2000" dirty="0"/>
+          </a:p>
+        </p:txBody>
+      </p:sp>
+      <p:sp>
+        <p:nvSpPr>
+          <p:cNvPr id="18" name="Text 16"/>
+          <p:cNvSpPr/>
+          <p:nvPr/>
+        </p:nvSpPr>
+        <p:spPr>
+          <a:xfrm>
+            <a:off x="548640" y="5715000"/>
+            <a:ext cx="11091672" cy="292608"/>
+          </a:xfrm>
+          <a:prstGeom prst="rect">
+            <a:avLst/>
+          </a:prstGeom>
+          <a:noFill/>
+          <a:ln/>
+        </p:spPr>
+        <p:txBody>
+          <a:bodyPr wrap="square" lIns="0" tIns="0" rIns="0" bIns="0" rtlCol="0" anchor="ctr"/>
+          <a:lstStyle/>
+          <a:p>
+            <a:pPr indent="0" marL="0">
+              <a:buNone/>
+            </a:pPr>
+            <a:r>
+              <a:rPr lang="en-US" sz="1200" i="1" dirty="0">
+                <a:solidFill>
+                  <a:srgbClr val="6B7A8C"/>
+                </a:solidFill>
+                <a:latin typeface="Calibri" pitchFamily="34" charset="0"/>
+                <a:ea typeface="Calibri" pitchFamily="34" charset="-122"/>
+                <a:cs typeface="Calibri" pitchFamily="34" charset="-120"/>
+              </a:rPr>
+              <a:t>Alcoholics Anonymous</a:t>
+            </a:r>
+            <a:pPr indent="0" marL="0">
+              <a:buNone/>
+            </a:pPr>
+            <a:r>
+              <a:rPr lang="en-US" sz="1200" dirty="0">
+                <a:solidFill>
+                  <a:srgbClr val="6B7A8C"/>
+                </a:solidFill>
+                <a:latin typeface="Calibri" pitchFamily="34" charset="0"/>
+                <a:ea typeface="Calibri" pitchFamily="34" charset="-122"/>
+                <a:cs typeface="Calibri" pitchFamily="34" charset="-120"/>
+              </a:rPr>
+              <a:t>, 4th ed., “To Employers,” p. 142.</a:t>
+            </a:r>
+            <a:endParaRPr lang="en-US" sz="1200" dirty="0"/>
+          </a:p>
+        </p:txBody>
+      </p:sp>
+      <p:sp>
+        <p:nvSpPr>
+          <p:cNvPr id="19" name="Text 17"/>
+          <p:cNvSpPr/>
+          <p:nvPr/>
+        </p:nvSpPr>
+        <p:spPr>
+          <a:xfrm>
+            <a:off x="548640" y="6355080"/>
+            <a:ext cx="11091672" cy="292608"/>
+          </a:xfrm>
+          <a:prstGeom prst="rect">
+            <a:avLst/>
+          </a:prstGeom>
+          <a:noFill/>
+          <a:ln/>
+        </p:spPr>
+        <p:txBody>
+          <a:bodyPr wrap="square" lIns="0" tIns="0" rIns="0" bIns="0" rtlCol="0" anchor="ctr"/>
+          <a:lstStyle/>
+          <a:p>
+            <a:pPr indent="0" marL="0">
+              <a:buNone/>
+            </a:pPr>
+            <a:r>
+              <a:rPr lang="en-US" sz="950" dirty="0">
+                <a:solidFill>
+                  <a:srgbClr val="6B7A8C"/>
+                </a:solidFill>
+                <a:latin typeface="Calibri" pitchFamily="34" charset="0"/>
+                <a:ea typeface="Calibri" pitchFamily="34" charset="-122"/>
+                <a:cs typeface="Calibri" pitchFamily="34" charset="-120"/>
+              </a:rPr>
+              <a:t>Copyright © Alcoholics Anonymous World Services, Inc. All rights reserved. Intended for personal use only, and not to be reproduced further or distributed for resale.</a:t>
+            </a:r>
+            <a:endParaRPr lang="en-US" sz="950" dirty="0"/>
           </a:p>
         </p:txBody>
       </p:sp>

</xml_diff>

<commit_message>
Add slide 4: the basic text (Preface, p. vii)
Blue-highlighted Preface passage in two blocks, with the circled term 'basic
text' set in bold and the margin note 'A book for transferring knowledge'
closing the slide as the takeaway.

Also corrects the preview renderer's capture height: headless Chrome's viewport
runs ~90px shorter than the requested window size, which was silently cropping
the copyright footer off the bottom of every preview.

Co-Authored-By: Claude Opus 5 <noreply@anthropic.com>
Claude-Session: https://claude.ai/code/session_01NuCgD3Z7aWvkQrsSvAUX4h
</commit_message>
<xml_diff>
--- a/aa-slideshow/aa-big-book-study.pptx
+++ b/aa-slideshow/aa-big-book-study.pptx
@@ -8,9 +8,10 @@
     <p:sldId id="256" r:id="rId2"/>
     <p:sldId id="257" r:id="rId3"/>
     <p:sldId id="258" r:id="rId4"/>
+    <p:sldId id="259" r:id="rId5"/>
   </p:sldIdLst>
   <p:notesMasterIdLst>
-    <p:notesMasterId r:id="rId5"/>
+    <p:notesMasterId r:id="rId6"/>
   </p:notesMasterIdLst>
   <p:sldSz cx="12192000" cy="6858000"/>
   <p:notesSz cx="6858000" cy="12192000"/>
@@ -718,6 +719,99 @@
             <a:fld id="{F7021451-1387-4CA6-816F-3879F97B5CBC}" type="slidenum">
               <a:rPr lang="en-US"/>
               <a:t>3</a:t>
+            </a:fld>
+            <a:endParaRPr lang="en-US"/>
+          </a:p>
+        </p:txBody>
+      </p:sp>
+    </p:spTree>
+    <p:extLst>
+      <p:ext uri="{BB962C8B-B14F-4D97-AF65-F5344CB8AC3E}">
+        <p14:creationId xmlns:p14="http://schemas.microsoft.com/office/powerpoint/2010/main" val="1024086991"/>
+      </p:ext>
+    </p:extLst>
+  </p:cSld>
+  <p:clrMapOvr>
+    <a:masterClrMapping/>
+  </p:clrMapOvr>
+</p:notes>
+</file>
+
+<file path=ppt/notesSlides/notesSlide4.xml><?xml version="1.0" encoding="utf-8"?>
+<p:notes xmlns:a="http://schemas.openxmlformats.org/drawingml/2006/main" xmlns:r="http://schemas.openxmlformats.org/officeDocument/2006/relationships" xmlns:p="http://schemas.openxmlformats.org/presentationml/2006/main">
+  <p:cSld>
+    <p:spTree>
+      <p:nvGrpSpPr>
+        <p:cNvPr id="1" name=""/>
+        <p:cNvGrpSpPr/>
+        <p:nvPr/>
+      </p:nvGrpSpPr>
+      <p:grpSpPr>
+        <a:xfrm>
+          <a:off x="0" y="0"/>
+          <a:ext cx="0" cy="0"/>
+          <a:chOff x="0" y="0"/>
+          <a:chExt cx="0" cy="0"/>
+        </a:xfrm>
+      </p:grpSpPr>
+      <p:sp>
+        <p:nvSpPr>
+          <p:cNvPr id="2" name="Slide Image Placeholder 1"/>
+          <p:cNvSpPr>
+            <a:spLocks noGrp="1" noRot="1" noChangeAspect="1"/>
+          </p:cNvSpPr>
+          <p:nvPr>
+            <p:ph type="sldImg"/>
+          </p:nvPr>
+        </p:nvSpPr>
+        <p:spPr/>
+      </p:sp>
+      <p:sp>
+        <p:nvSpPr>
+          <p:cNvPr id="3" name="Notes Placeholder 2"/>
+          <p:cNvSpPr>
+            <a:spLocks noGrp="1"/>
+          </p:cNvSpPr>
+          <p:nvPr>
+            <p:ph type="body" idx="1"/>
+          </p:nvPr>
+        </p:nvSpPr>
+        <p:spPr/>
+        <p:txBody>
+          <a:bodyPr/>
+          <a:lstStyle/>
+          <a:p>
+            <a:r>
+              <a:rPr lang="en-US" dirty="0"/>
+              <a:t>Preface, page vii. Why this book is the one we work from.
+It is the basic text - that word is circled for a reason. The first portion, the part
+that describes the recovery program, has been left largely untouched through three
+revisions. The Doctor's Opinion is exactly as Dr. Silkworth wrote it in 1939.
+So: this is a book for transferring knowledge. Not a memoir, not history. The directions
+have not changed because they did not need to.</a:t>
+            </a:r>
+            <a:endParaRPr lang="en-US" dirty="0"/>
+          </a:p>
+        </p:txBody>
+      </p:sp>
+      <p:sp>
+        <p:nvSpPr>
+          <p:cNvPr id="4" name="Slide Number Placeholder 3"/>
+          <p:cNvSpPr>
+            <a:spLocks noGrp="1"/>
+          </p:cNvSpPr>
+          <p:nvPr>
+            <p:ph type="sldNum" sz="quarter" idx="10"/>
+          </p:nvPr>
+        </p:nvSpPr>
+        <p:spPr/>
+        <p:txBody>
+          <a:bodyPr/>
+          <a:lstStyle/>
+          <a:p>
+            <a:fld id="{F7021451-1387-4CA6-816F-3879F97B5CBC}" type="slidenum">
+              <a:rPr lang="en-US"/>
+              <a:t>4</a:t>
             </a:fld>
             <a:endParaRPr lang="en-US"/>
           </a:p>
@@ -3629,6 +3723,548 @@
 </p:sld>
 </file>
 
+<file path=ppt/slides/slide4.xml><?xml version="1.0" encoding="utf-8"?>
+<p:sld xmlns:a="http://schemas.openxmlformats.org/drawingml/2006/main" xmlns:r="http://schemas.openxmlformats.org/officeDocument/2006/relationships" xmlns:p="http://schemas.openxmlformats.org/presentationml/2006/main">
+  <p:cSld name="Slide 4">
+    <p:bg>
+      <p:bgPr>
+        <a:solidFill>
+          <a:srgbClr val="FFFFFF"/>
+        </a:solidFill>
+      </p:bgPr>
+    </p:bg>
+    <p:spTree>
+      <p:nvGrpSpPr>
+        <p:cNvPr id="1" name=""/>
+        <p:cNvGrpSpPr/>
+        <p:nvPr/>
+      </p:nvGrpSpPr>
+      <p:grpSpPr>
+        <a:xfrm>
+          <a:off x="0" y="0"/>
+          <a:ext cx="0" cy="0"/>
+          <a:chOff x="0" y="0"/>
+          <a:chExt cx="0" cy="0"/>
+        </a:xfrm>
+      </p:grpSpPr>
+      <p:sp>
+        <p:nvSpPr>
+          <p:cNvPr id="2" name="Text 0"/>
+          <p:cNvSpPr/>
+          <p:nvPr/>
+        </p:nvSpPr>
+        <p:spPr>
+          <a:xfrm>
+            <a:off x="548640" y="320040"/>
+            <a:ext cx="7863840" cy="566928"/>
+          </a:xfrm>
+          <a:prstGeom prst="rect">
+            <a:avLst/>
+          </a:prstGeom>
+          <a:noFill/>
+          <a:ln/>
+        </p:spPr>
+        <p:txBody>
+          <a:bodyPr wrap="square" lIns="0" tIns="0" rIns="0" bIns="0" rtlCol="0" anchor="ctr"/>
+          <a:lstStyle/>
+          <a:p>
+            <a:pPr indent="0" marL="0">
+              <a:buNone/>
+            </a:pPr>
+            <a:r>
+              <a:rPr lang="en-US" sz="4000" b="1" dirty="0">
+                <a:solidFill>
+                  <a:srgbClr val="1B2A41"/>
+                </a:solidFill>
+                <a:latin typeface="Cambria" pitchFamily="34" charset="0"/>
+                <a:ea typeface="Cambria" pitchFamily="34" charset="-122"/>
+                <a:cs typeface="Cambria" pitchFamily="34" charset="-120"/>
+              </a:rPr>
+              <a:t>The Basic Text</a:t>
+            </a:r>
+            <a:endParaRPr lang="en-US" sz="4000" dirty="0"/>
+          </a:p>
+        </p:txBody>
+      </p:sp>
+      <p:sp>
+        <p:nvSpPr>
+          <p:cNvPr id="3" name="Text 1"/>
+          <p:cNvSpPr/>
+          <p:nvPr/>
+        </p:nvSpPr>
+        <p:spPr>
+          <a:xfrm>
+            <a:off x="548640" y="914400"/>
+            <a:ext cx="7863840" cy="347472"/>
+          </a:xfrm>
+          <a:prstGeom prst="rect">
+            <a:avLst/>
+          </a:prstGeom>
+          <a:noFill/>
+          <a:ln/>
+        </p:spPr>
+        <p:txBody>
+          <a:bodyPr wrap="square" lIns="0" tIns="0" rIns="0" bIns="0" rtlCol="0" anchor="ctr"/>
+          <a:lstStyle/>
+          <a:p>
+            <a:pPr indent="0" marL="0">
+              <a:buNone/>
+            </a:pPr>
+            <a:r>
+              <a:rPr lang="en-US" sz="1700" i="1" dirty="0">
+                <a:solidFill>
+                  <a:srgbClr val="6B7A8C"/>
+                </a:solidFill>
+                <a:latin typeface="Calibri" pitchFamily="34" charset="0"/>
+                <a:ea typeface="Calibri" pitchFamily="34" charset="-122"/>
+                <a:cs typeface="Calibri" pitchFamily="34" charset="-120"/>
+              </a:rPr>
+              <a:t>“…the basic text for our Society.”</a:t>
+            </a:r>
+            <a:endParaRPr lang="en-US" sz="1700" dirty="0"/>
+          </a:p>
+        </p:txBody>
+      </p:sp>
+      <p:sp>
+        <p:nvSpPr>
+          <p:cNvPr id="4" name="Shape 2"/>
+          <p:cNvSpPr/>
+          <p:nvPr/>
+        </p:nvSpPr>
+        <p:spPr>
+          <a:xfrm>
+            <a:off x="8778240" y="320040"/>
+            <a:ext cx="2862072" cy="960120"/>
+          </a:xfrm>
+          <a:prstGeom prst="roundRect">
+            <a:avLst>
+              <a:gd name="adj" fmla="val 9524"/>
+            </a:avLst>
+          </a:prstGeom>
+          <a:solidFill>
+            <a:srgbClr val="065A82"/>
+          </a:solidFill>
+          <a:ln/>
+        </p:spPr>
+      </p:sp>
+      <p:sp>
+        <p:nvSpPr>
+          <p:cNvPr id="5" name="Text 3"/>
+          <p:cNvSpPr/>
+          <p:nvPr/>
+        </p:nvSpPr>
+        <p:spPr>
+          <a:xfrm>
+            <a:off x="8778240" y="320040"/>
+            <a:ext cx="2862072" cy="960120"/>
+          </a:xfrm>
+          <a:prstGeom prst="rect">
+            <a:avLst/>
+          </a:prstGeom>
+          <a:noFill/>
+          <a:ln/>
+        </p:spPr>
+        <p:txBody>
+          <a:bodyPr wrap="square" lIns="0" tIns="0" rIns="0" bIns="0" rtlCol="0" anchor="ctr"/>
+          <a:lstStyle/>
+          <a:p>
+            <a:pPr algn="ctr" indent="0" marL="0">
+              <a:buNone/>
+            </a:pPr>
+            <a:r>
+              <a:rPr lang="en-US" sz="1900" b="1" spc="200" kern="0" dirty="0">
+                <a:solidFill>
+                  <a:srgbClr val="FFFFFF"/>
+                </a:solidFill>
+                <a:latin typeface="Cambria" pitchFamily="34" charset="0"/>
+                <a:ea typeface="Cambria" pitchFamily="34" charset="-122"/>
+                <a:cs typeface="Cambria" pitchFamily="34" charset="-120"/>
+              </a:rPr>
+              <a:t>PREFACE</a:t>
+            </a:r>
+            <a:endParaRPr lang="en-US" sz="1900" dirty="0"/>
+          </a:p>
+          <a:p>
+            <a:pPr algn="ctr" indent="0" marL="0">
+              <a:buNone/>
+            </a:pPr>
+            <a:r>
+              <a:rPr lang="en-US" sz="1400" dirty="0">
+                <a:solidFill>
+                  <a:srgbClr val="C7DEEC"/>
+                </a:solidFill>
+                <a:latin typeface="Calibri" pitchFamily="34" charset="0"/>
+                <a:ea typeface="Calibri" pitchFamily="34" charset="-122"/>
+                <a:cs typeface="Calibri" pitchFamily="34" charset="-120"/>
+              </a:rPr>
+              <a:t>Page vii</a:t>
+            </a:r>
+            <a:endParaRPr lang="en-US" sz="1900" dirty="0"/>
+          </a:p>
+        </p:txBody>
+      </p:sp>
+      <p:sp>
+        <p:nvSpPr>
+          <p:cNvPr id="6" name="Shape 4"/>
+          <p:cNvSpPr/>
+          <p:nvPr/>
+        </p:nvSpPr>
+        <p:spPr>
+          <a:xfrm>
+            <a:off x="548640" y="1463040"/>
+            <a:ext cx="11091672" cy="1737360"/>
+          </a:xfrm>
+          <a:prstGeom prst="roundRect">
+            <a:avLst>
+              <a:gd name="adj" fmla="val 4211"/>
+            </a:avLst>
+          </a:prstGeom>
+          <a:solidFill>
+            <a:srgbClr val="E2EDF4"/>
+          </a:solidFill>
+          <a:ln/>
+        </p:spPr>
+      </p:sp>
+      <p:sp>
+        <p:nvSpPr>
+          <p:cNvPr id="7" name="Text 5"/>
+          <p:cNvSpPr/>
+          <p:nvPr/>
+        </p:nvSpPr>
+        <p:spPr>
+          <a:xfrm>
+            <a:off x="914400" y="1463040"/>
+            <a:ext cx="10360152" cy="1737360"/>
+          </a:xfrm>
+          <a:prstGeom prst="rect">
+            <a:avLst/>
+          </a:prstGeom>
+          <a:noFill/>
+          <a:ln/>
+        </p:spPr>
+        <p:txBody>
+          <a:bodyPr wrap="square" lIns="0" tIns="0" rIns="0" bIns="0" rtlCol="0" anchor="ctr"/>
+          <a:lstStyle/>
+          <a:p>
+            <a:pPr indent="0" marL="0">
+              <a:lnSpc>
+                <a:spcPct val="115000"/>
+              </a:lnSpc>
+              <a:buNone/>
+            </a:pPr>
+            <a:r>
+              <a:rPr lang="en-US" sz="1900" dirty="0">
+                <a:solidFill>
+                  <a:srgbClr val="1B2A41"/>
+                </a:solidFill>
+                <a:latin typeface="Calibri" pitchFamily="34" charset="0"/>
+                <a:ea typeface="Calibri" pitchFamily="34" charset="-122"/>
+                <a:cs typeface="Calibri" pitchFamily="34" charset="-120"/>
+              </a:rPr>
+              <a:t>Because this book has become the </a:t>
+            </a:r>
+            <a:pPr indent="0" marL="0">
+              <a:lnSpc>
+                <a:spcPct val="115000"/>
+              </a:lnSpc>
+              <a:buNone/>
+            </a:pPr>
+            <a:r>
+              <a:rPr lang="en-US" sz="1900" b="1" dirty="0">
+                <a:solidFill>
+                  <a:srgbClr val="1B2A41"/>
+                </a:solidFill>
+                <a:latin typeface="Calibri" pitchFamily="34" charset="0"/>
+                <a:ea typeface="Calibri" pitchFamily="34" charset="-122"/>
+                <a:cs typeface="Calibri" pitchFamily="34" charset="-120"/>
+              </a:rPr>
+              <a:t>basic text</a:t>
+            </a:r>
+            <a:pPr indent="0" marL="0">
+              <a:lnSpc>
+                <a:spcPct val="115000"/>
+              </a:lnSpc>
+              <a:buNone/>
+            </a:pPr>
+            <a:r>
+              <a:rPr lang="en-US" sz="1900" dirty="0">
+                <a:solidFill>
+                  <a:srgbClr val="1B2A41"/>
+                </a:solidFill>
+                <a:latin typeface="Calibri" pitchFamily="34" charset="0"/>
+                <a:ea typeface="Calibri" pitchFamily="34" charset="-122"/>
+                <a:cs typeface="Calibri" pitchFamily="34" charset="-120"/>
+              </a:rPr>
+              <a:t> for our Society and has helped such large numbers of alcoholic men and women to recovery, there exists strong sentiment against any radical changes being made in it. Therefore, the first portion of this volume, describing the A.A. recovery program, has been left largely untouched in the course of revisions made for the second, third, and fourth editions.</a:t>
+            </a:r>
+            <a:endParaRPr lang="en-US" sz="1900" dirty="0"/>
+          </a:p>
+        </p:txBody>
+      </p:sp>
+      <p:sp>
+        <p:nvSpPr>
+          <p:cNvPr id="8" name="Shape 6"/>
+          <p:cNvSpPr/>
+          <p:nvPr/>
+        </p:nvSpPr>
+        <p:spPr>
+          <a:xfrm>
+            <a:off x="548640" y="3383280"/>
+            <a:ext cx="11091672" cy="1097280"/>
+          </a:xfrm>
+          <a:prstGeom prst="roundRect">
+            <a:avLst>
+              <a:gd name="adj" fmla="val 6667"/>
+            </a:avLst>
+          </a:prstGeom>
+          <a:solidFill>
+            <a:srgbClr val="E2EDF4"/>
+          </a:solidFill>
+          <a:ln/>
+        </p:spPr>
+      </p:sp>
+      <p:sp>
+        <p:nvSpPr>
+          <p:cNvPr id="9" name="Text 7"/>
+          <p:cNvSpPr/>
+          <p:nvPr/>
+        </p:nvSpPr>
+        <p:spPr>
+          <a:xfrm>
+            <a:off x="914400" y="3383280"/>
+            <a:ext cx="10360152" cy="1097280"/>
+          </a:xfrm>
+          <a:prstGeom prst="rect">
+            <a:avLst/>
+          </a:prstGeom>
+          <a:noFill/>
+          <a:ln/>
+        </p:spPr>
+        <p:txBody>
+          <a:bodyPr wrap="square" lIns="0" tIns="0" rIns="0" bIns="0" rtlCol="0" anchor="ctr"/>
+          <a:lstStyle/>
+          <a:p>
+            <a:pPr indent="0" marL="0">
+              <a:lnSpc>
+                <a:spcPct val="115000"/>
+              </a:lnSpc>
+              <a:buNone/>
+            </a:pPr>
+            <a:r>
+              <a:rPr lang="en-US" sz="1900" dirty="0">
+                <a:solidFill>
+                  <a:srgbClr val="1B2A41"/>
+                </a:solidFill>
+                <a:latin typeface="Calibri" pitchFamily="34" charset="0"/>
+                <a:ea typeface="Calibri" pitchFamily="34" charset="-122"/>
+                <a:cs typeface="Calibri" pitchFamily="34" charset="-120"/>
+              </a:rPr>
+              <a:t>The section called “The Doctor’s Opinion” has been kept intact, just as it was originally written in 1939 by the late Dr. William D. Silkworth, our Society’s great medical benefactor.</a:t>
+            </a:r>
+            <a:endParaRPr lang="en-US" sz="1900" dirty="0"/>
+          </a:p>
+        </p:txBody>
+      </p:sp>
+      <p:sp>
+        <p:nvSpPr>
+          <p:cNvPr id="10" name="Shape 8"/>
+          <p:cNvSpPr/>
+          <p:nvPr/>
+        </p:nvSpPr>
+        <p:spPr>
+          <a:xfrm>
+            <a:off x="548640" y="4709160"/>
+            <a:ext cx="11091672" cy="914400"/>
+          </a:xfrm>
+          <a:prstGeom prst="roundRect">
+            <a:avLst>
+              <a:gd name="adj" fmla="val 8000"/>
+            </a:avLst>
+          </a:prstGeom>
+          <a:solidFill>
+            <a:srgbClr val="1B2A41"/>
+          </a:solidFill>
+          <a:ln/>
+        </p:spPr>
+      </p:sp>
+      <p:sp>
+        <p:nvSpPr>
+          <p:cNvPr id="11" name="Text 9"/>
+          <p:cNvSpPr/>
+          <p:nvPr/>
+        </p:nvSpPr>
+        <p:spPr>
+          <a:xfrm>
+            <a:off x="914400" y="4828032"/>
+            <a:ext cx="10360152" cy="256032"/>
+          </a:xfrm>
+          <a:prstGeom prst="rect">
+            <a:avLst/>
+          </a:prstGeom>
+          <a:noFill/>
+          <a:ln/>
+        </p:spPr>
+        <p:txBody>
+          <a:bodyPr wrap="square" lIns="0" tIns="0" rIns="0" bIns="0" rtlCol="0" anchor="ctr"/>
+          <a:lstStyle/>
+          <a:p>
+            <a:pPr indent="0" marL="0">
+              <a:buNone/>
+            </a:pPr>
+            <a:r>
+              <a:rPr lang="en-US" sz="1100" b="1" spc="200" kern="0" dirty="0">
+                <a:solidFill>
+                  <a:srgbClr val="A9B8CC"/>
+                </a:solidFill>
+                <a:latin typeface="Calibri" pitchFamily="34" charset="0"/>
+                <a:ea typeface="Calibri" pitchFamily="34" charset="-122"/>
+                <a:cs typeface="Calibri" pitchFamily="34" charset="-120"/>
+              </a:rPr>
+              <a:t>MARGIN NOTE</a:t>
+            </a:r>
+            <a:endParaRPr lang="en-US" sz="1100" dirty="0"/>
+          </a:p>
+        </p:txBody>
+      </p:sp>
+      <p:sp>
+        <p:nvSpPr>
+          <p:cNvPr id="12" name="Text 10"/>
+          <p:cNvSpPr/>
+          <p:nvPr/>
+        </p:nvSpPr>
+        <p:spPr>
+          <a:xfrm>
+            <a:off x="914400" y="5084064"/>
+            <a:ext cx="10360152" cy="411480"/>
+          </a:xfrm>
+          <a:prstGeom prst="rect">
+            <a:avLst/>
+          </a:prstGeom>
+          <a:noFill/>
+          <a:ln/>
+        </p:spPr>
+        <p:txBody>
+          <a:bodyPr wrap="square" lIns="0" tIns="0" rIns="0" bIns="0" rtlCol="0" anchor="ctr"/>
+          <a:lstStyle/>
+          <a:p>
+            <a:pPr indent="0" marL="0">
+              <a:buNone/>
+            </a:pPr>
+            <a:r>
+              <a:rPr lang="en-US" sz="2400" b="1" dirty="0">
+                <a:solidFill>
+                  <a:srgbClr val="FFFFFF"/>
+                </a:solidFill>
+                <a:latin typeface="Cambria" pitchFamily="34" charset="0"/>
+                <a:ea typeface="Cambria" pitchFamily="34" charset="-122"/>
+                <a:cs typeface="Cambria" pitchFamily="34" charset="-120"/>
+              </a:rPr>
+              <a:t>A book for transferring knowledge.</a:t>
+            </a:r>
+            <a:endParaRPr lang="en-US" sz="2400" dirty="0"/>
+          </a:p>
+        </p:txBody>
+      </p:sp>
+      <p:sp>
+        <p:nvSpPr>
+          <p:cNvPr id="13" name="Text 11"/>
+          <p:cNvSpPr/>
+          <p:nvPr/>
+        </p:nvSpPr>
+        <p:spPr>
+          <a:xfrm>
+            <a:off x="548640" y="5760720"/>
+            <a:ext cx="11091672" cy="292608"/>
+          </a:xfrm>
+          <a:prstGeom prst="rect">
+            <a:avLst/>
+          </a:prstGeom>
+          <a:noFill/>
+          <a:ln/>
+        </p:spPr>
+        <p:txBody>
+          <a:bodyPr wrap="square" lIns="0" tIns="0" rIns="0" bIns="0" rtlCol="0" anchor="ctr"/>
+          <a:lstStyle/>
+          <a:p>
+            <a:pPr indent="0" marL="0">
+              <a:buNone/>
+            </a:pPr>
+            <a:r>
+              <a:rPr lang="en-US" sz="1200" i="1" dirty="0">
+                <a:solidFill>
+                  <a:srgbClr val="6B7A8C"/>
+                </a:solidFill>
+                <a:latin typeface="Calibri" pitchFamily="34" charset="0"/>
+                <a:ea typeface="Calibri" pitchFamily="34" charset="-122"/>
+                <a:cs typeface="Calibri" pitchFamily="34" charset="-120"/>
+              </a:rPr>
+              <a:t>Alcoholics Anonymous</a:t>
+            </a:r>
+            <a:pPr indent="0" marL="0">
+              <a:buNone/>
+            </a:pPr>
+            <a:r>
+              <a:rPr lang="en-US" sz="1200" dirty="0">
+                <a:solidFill>
+                  <a:srgbClr val="6B7A8C"/>
+                </a:solidFill>
+                <a:latin typeface="Calibri" pitchFamily="34" charset="0"/>
+                <a:ea typeface="Calibri" pitchFamily="34" charset="-122"/>
+                <a:cs typeface="Calibri" pitchFamily="34" charset="-120"/>
+              </a:rPr>
+              <a:t>, 4th ed., Preface, p. vii.</a:t>
+            </a:r>
+            <a:endParaRPr lang="en-US" sz="1200" dirty="0"/>
+          </a:p>
+        </p:txBody>
+      </p:sp>
+      <p:sp>
+        <p:nvSpPr>
+          <p:cNvPr id="14" name="Text 12"/>
+          <p:cNvSpPr/>
+          <p:nvPr/>
+        </p:nvSpPr>
+        <p:spPr>
+          <a:xfrm>
+            <a:off x="548640" y="6355080"/>
+            <a:ext cx="11091672" cy="292608"/>
+          </a:xfrm>
+          <a:prstGeom prst="rect">
+            <a:avLst/>
+          </a:prstGeom>
+          <a:noFill/>
+          <a:ln/>
+        </p:spPr>
+        <p:txBody>
+          <a:bodyPr wrap="square" lIns="0" tIns="0" rIns="0" bIns="0" rtlCol="0" anchor="ctr"/>
+          <a:lstStyle/>
+          <a:p>
+            <a:pPr indent="0" marL="0">
+              <a:buNone/>
+            </a:pPr>
+            <a:r>
+              <a:rPr lang="en-US" sz="950" dirty="0">
+                <a:solidFill>
+                  <a:srgbClr val="6B7A8C"/>
+                </a:solidFill>
+                <a:latin typeface="Calibri" pitchFamily="34" charset="0"/>
+                <a:ea typeface="Calibri" pitchFamily="34" charset="-122"/>
+                <a:cs typeface="Calibri" pitchFamily="34" charset="-120"/>
+              </a:rPr>
+              <a:t>Copyright © Alcoholics Anonymous World Services, Inc. All rights reserved. Intended for personal use only, and not to be reproduced further or distributed for resale.</a:t>
+            </a:r>
+            <a:endParaRPr lang="en-US" sz="950" dirty="0"/>
+          </a:p>
+        </p:txBody>
+      </p:sp>
+    </p:spTree>
+  </p:cSld>
+  <p:clrMapOvr>
+    <a:masterClrMapping/>
+  </p:clrMapOvr>
+</p:sld>
+</file>
+
 <file path=ppt/theme/theme1.xml><?xml version="1.0" encoding="utf-8"?>
 <a:theme xmlns:a="http://schemas.openxmlformats.org/drawingml/2006/main" name="Office Theme">
   <a:themeElements>

</xml_diff>

<commit_message>
Add slide 5: Foreword to the First Edition (p. ix)
Reproduces the two-color highlight split mid-sentence - green card for the
opening claim, blue for the promise that follows. The circled 'one hundred men
and women' is set bold, and 'precisely how we have recovered' carries the
underline it has in the book.

The 87-raised-to-one-hundred margin note is labeled as a margin note rather than
folded into the quotation, since it is fellowship history and not book text.

Preview renderer now honors italic and underline runs.

Co-Authored-By: Claude Opus 5 <noreply@anthropic.com>
Claude-Session: https://claude.ai/code/session_01NuCgD3Z7aWvkQrsSvAUX4h
</commit_message>
<xml_diff>
--- a/aa-slideshow/aa-big-book-study.pptx
+++ b/aa-slideshow/aa-big-book-study.pptx
@@ -9,9 +9,10 @@
     <p:sldId id="257" r:id="rId3"/>
     <p:sldId id="258" r:id="rId4"/>
     <p:sldId id="259" r:id="rId5"/>
+    <p:sldId id="260" r:id="rId6"/>
   </p:sldIdLst>
   <p:notesMasterIdLst>
-    <p:notesMasterId r:id="rId6"/>
+    <p:notesMasterId r:id="rId7"/>
   </p:notesMasterIdLst>
   <p:sldSz cx="12192000" cy="6858000"/>
   <p:notesSz cx="6858000" cy="12192000"/>
@@ -812,6 +813,100 @@
             <a:fld id="{F7021451-1387-4CA6-816F-3879F97B5CBC}" type="slidenum">
               <a:rPr lang="en-US"/>
               <a:t>4</a:t>
+            </a:fld>
+            <a:endParaRPr lang="en-US"/>
+          </a:p>
+        </p:txBody>
+      </p:sp>
+    </p:spTree>
+    <p:extLst>
+      <p:ext uri="{BB962C8B-B14F-4D97-AF65-F5344CB8AC3E}">
+        <p14:creationId xmlns:p14="http://schemas.microsoft.com/office/powerpoint/2010/main" val="1024086991"/>
+      </p:ext>
+    </p:extLst>
+  </p:cSld>
+  <p:clrMapOvr>
+    <a:masterClrMapping/>
+  </p:clrMapOvr>
+</p:notes>
+</file>
+
+<file path=ppt/notesSlides/notesSlide5.xml><?xml version="1.0" encoding="utf-8"?>
+<p:notes xmlns:a="http://schemas.openxmlformats.org/drawingml/2006/main" xmlns:r="http://schemas.openxmlformats.org/officeDocument/2006/relationships" xmlns:p="http://schemas.openxmlformats.org/presentationml/2006/main">
+  <p:cSld>
+    <p:spTree>
+      <p:nvGrpSpPr>
+        <p:cNvPr id="1" name=""/>
+        <p:cNvGrpSpPr/>
+        <p:nvPr/>
+      </p:nvGrpSpPr>
+      <p:grpSpPr>
+        <a:xfrm>
+          <a:off x="0" y="0"/>
+          <a:ext cx="0" cy="0"/>
+          <a:chOff x="0" y="0"/>
+          <a:chExt cx="0" cy="0"/>
+        </a:xfrm>
+      </p:grpSpPr>
+      <p:sp>
+        <p:nvSpPr>
+          <p:cNvPr id="2" name="Slide Image Placeholder 1"/>
+          <p:cNvSpPr>
+            <a:spLocks noGrp="1" noRot="1" noChangeAspect="1"/>
+          </p:cNvSpPr>
+          <p:nvPr>
+            <p:ph type="sldImg"/>
+          </p:nvPr>
+        </p:nvSpPr>
+        <p:spPr/>
+      </p:sp>
+      <p:sp>
+        <p:nvSpPr>
+          <p:cNvPr id="3" name="Notes Placeholder 2"/>
+          <p:cNvSpPr>
+            <a:spLocks noGrp="1"/>
+          </p:cNvSpPr>
+          <p:nvPr>
+            <p:ph type="body" idx="1"/>
+          </p:nvPr>
+        </p:nvSpPr>
+        <p:spPr/>
+        <p:txBody>
+          <a:bodyPr/>
+          <a:lstStyle/>
+          <a:p>
+            <a:r>
+              <a:rPr lang="en-US" dirty="0"/>
+              <a:t>Foreword to the First Edition - the Foreword as it appeared in 1939.
+Circled: one hundred men and women. That is who authored this book. The margin note
+is fellowship history, not text from the book - the count was 87 and was raised to one
+hundred by printing time.
+Underlined: precisely how we have recovered. Precisely. Not roughly, not our impressions.
+That is the main purpose of the book, stated on page ix before anything else.
+And the promise that follows: no further authentication will be necessary.</a:t>
+            </a:r>
+            <a:endParaRPr lang="en-US" dirty="0"/>
+          </a:p>
+        </p:txBody>
+      </p:sp>
+      <p:sp>
+        <p:nvSpPr>
+          <p:cNvPr id="4" name="Slide Number Placeholder 3"/>
+          <p:cNvSpPr>
+            <a:spLocks noGrp="1"/>
+          </p:cNvSpPr>
+          <p:nvPr>
+            <p:ph type="sldNum" sz="quarter" idx="10"/>
+          </p:nvPr>
+        </p:nvSpPr>
+        <p:spPr/>
+        <p:txBody>
+          <a:bodyPr/>
+          <a:lstStyle/>
+          <a:p>
+            <a:fld id="{F7021451-1387-4CA6-816F-3879F97B5CBC}" type="slidenum">
+              <a:rPr lang="en-US"/>
+              <a:t>5</a:t>
             </a:fld>
             <a:endParaRPr lang="en-US"/>
           </a:p>
@@ -4265,6 +4360,582 @@
 </p:sld>
 </file>
 
+<file path=ppt/slides/slide5.xml><?xml version="1.0" encoding="utf-8"?>
+<p:sld xmlns:a="http://schemas.openxmlformats.org/drawingml/2006/main" xmlns:r="http://schemas.openxmlformats.org/officeDocument/2006/relationships" xmlns:p="http://schemas.openxmlformats.org/presentationml/2006/main">
+  <p:cSld name="Slide 5">
+    <p:bg>
+      <p:bgPr>
+        <a:solidFill>
+          <a:srgbClr val="FFFFFF"/>
+        </a:solidFill>
+      </p:bgPr>
+    </p:bg>
+    <p:spTree>
+      <p:nvGrpSpPr>
+        <p:cNvPr id="1" name=""/>
+        <p:cNvGrpSpPr/>
+        <p:nvPr/>
+      </p:nvGrpSpPr>
+      <p:grpSpPr>
+        <a:xfrm>
+          <a:off x="0" y="0"/>
+          <a:ext cx="0" cy="0"/>
+          <a:chOff x="0" y="0"/>
+          <a:chExt cx="0" cy="0"/>
+        </a:xfrm>
+      </p:grpSpPr>
+      <p:sp>
+        <p:nvSpPr>
+          <p:cNvPr id="2" name="Text 0"/>
+          <p:cNvSpPr/>
+          <p:nvPr/>
+        </p:nvSpPr>
+        <p:spPr>
+          <a:xfrm>
+            <a:off x="548640" y="320040"/>
+            <a:ext cx="8138160" cy="566928"/>
+          </a:xfrm>
+          <a:prstGeom prst="rect">
+            <a:avLst/>
+          </a:prstGeom>
+          <a:noFill/>
+          <a:ln/>
+        </p:spPr>
+        <p:txBody>
+          <a:bodyPr wrap="square" lIns="0" tIns="0" rIns="0" bIns="0" rtlCol="0" anchor="ctr"/>
+          <a:lstStyle/>
+          <a:p>
+            <a:pPr indent="0" marL="0">
+              <a:buNone/>
+            </a:pPr>
+            <a:r>
+              <a:rPr lang="en-US" sz="3800" b="1" dirty="0">
+                <a:solidFill>
+                  <a:srgbClr val="1B2A41"/>
+                </a:solidFill>
+                <a:latin typeface="Cambria" pitchFamily="34" charset="0"/>
+                <a:ea typeface="Cambria" pitchFamily="34" charset="-122"/>
+                <a:cs typeface="Cambria" pitchFamily="34" charset="-120"/>
+              </a:rPr>
+              <a:t>Precisely How We Have Recovered</a:t>
+            </a:r>
+            <a:endParaRPr lang="en-US" sz="3800" dirty="0"/>
+          </a:p>
+        </p:txBody>
+      </p:sp>
+      <p:sp>
+        <p:nvSpPr>
+          <p:cNvPr id="3" name="Text 1"/>
+          <p:cNvSpPr/>
+          <p:nvPr/>
+        </p:nvSpPr>
+        <p:spPr>
+          <a:xfrm>
+            <a:off x="548640" y="914400"/>
+            <a:ext cx="8138160" cy="347472"/>
+          </a:xfrm>
+          <a:prstGeom prst="rect">
+            <a:avLst/>
+          </a:prstGeom>
+          <a:noFill/>
+          <a:ln/>
+        </p:spPr>
+        <p:txBody>
+          <a:bodyPr wrap="square" lIns="0" tIns="0" rIns="0" bIns="0" rtlCol="0" anchor="ctr"/>
+          <a:lstStyle/>
+          <a:p>
+            <a:pPr indent="0" marL="0">
+              <a:buNone/>
+            </a:pPr>
+            <a:r>
+              <a:rPr lang="en-US" sz="1700" i="1" dirty="0">
+                <a:solidFill>
+                  <a:srgbClr val="6B7A8C"/>
+                </a:solidFill>
+                <a:latin typeface="Calibri" pitchFamily="34" charset="0"/>
+                <a:ea typeface="Calibri" pitchFamily="34" charset="-122"/>
+                <a:cs typeface="Calibri" pitchFamily="34" charset="-120"/>
+              </a:rPr>
+              <a:t>The main purpose of this book.</a:t>
+            </a:r>
+            <a:endParaRPr lang="en-US" sz="1700" dirty="0"/>
+          </a:p>
+        </p:txBody>
+      </p:sp>
+      <p:sp>
+        <p:nvSpPr>
+          <p:cNvPr id="4" name="Shape 2"/>
+          <p:cNvSpPr/>
+          <p:nvPr/>
+        </p:nvSpPr>
+        <p:spPr>
+          <a:xfrm>
+            <a:off x="8869680" y="320040"/>
+            <a:ext cx="2770632" cy="960120"/>
+          </a:xfrm>
+          <a:prstGeom prst="roundRect">
+            <a:avLst>
+              <a:gd name="adj" fmla="val 9524"/>
+            </a:avLst>
+          </a:prstGeom>
+          <a:solidFill>
+            <a:srgbClr val="2C5F2D"/>
+          </a:solidFill>
+          <a:ln/>
+        </p:spPr>
+      </p:sp>
+      <p:sp>
+        <p:nvSpPr>
+          <p:cNvPr id="5" name="Text 3"/>
+          <p:cNvSpPr/>
+          <p:nvPr/>
+        </p:nvSpPr>
+        <p:spPr>
+          <a:xfrm>
+            <a:off x="8869680" y="320040"/>
+            <a:ext cx="2770632" cy="960120"/>
+          </a:xfrm>
+          <a:prstGeom prst="rect">
+            <a:avLst/>
+          </a:prstGeom>
+          <a:noFill/>
+          <a:ln/>
+        </p:spPr>
+        <p:txBody>
+          <a:bodyPr wrap="square" lIns="0" tIns="0" rIns="0" bIns="0" rtlCol="0" anchor="ctr"/>
+          <a:lstStyle/>
+          <a:p>
+            <a:pPr algn="ctr" indent="0" marL="0">
+              <a:buNone/>
+            </a:pPr>
+            <a:r>
+              <a:rPr lang="en-US" sz="1700" b="1" spc="100" kern="0" dirty="0">
+                <a:solidFill>
+                  <a:srgbClr val="FFFFFF"/>
+                </a:solidFill>
+                <a:latin typeface="Cambria" pitchFamily="34" charset="0"/>
+                <a:ea typeface="Cambria" pitchFamily="34" charset="-122"/>
+                <a:cs typeface="Cambria" pitchFamily="34" charset="-120"/>
+              </a:rPr>
+              <a:t>FOREWORD</a:t>
+            </a:r>
+            <a:endParaRPr lang="en-US" sz="1700" dirty="0"/>
+          </a:p>
+          <a:p>
+            <a:pPr algn="ctr" indent="0" marL="0">
+              <a:buNone/>
+            </a:pPr>
+            <a:r>
+              <a:rPr lang="en-US" sz="1300" dirty="0">
+                <a:solidFill>
+                  <a:srgbClr val="D5E3CE"/>
+                </a:solidFill>
+                <a:latin typeface="Calibri" pitchFamily="34" charset="0"/>
+                <a:ea typeface="Calibri" pitchFamily="34" charset="-122"/>
+                <a:cs typeface="Calibri" pitchFamily="34" charset="-120"/>
+              </a:rPr>
+              <a:t>First Edition  ·  p. ix</a:t>
+            </a:r>
+            <a:endParaRPr lang="en-US" sz="1700" dirty="0"/>
+          </a:p>
+        </p:txBody>
+      </p:sp>
+      <p:sp>
+        <p:nvSpPr>
+          <p:cNvPr id="6" name="Shape 4"/>
+          <p:cNvSpPr/>
+          <p:nvPr/>
+        </p:nvSpPr>
+        <p:spPr>
+          <a:xfrm>
+            <a:off x="548640" y="1417320"/>
+            <a:ext cx="11091672" cy="1371600"/>
+          </a:xfrm>
+          <a:prstGeom prst="roundRect">
+            <a:avLst>
+              <a:gd name="adj" fmla="val 5333"/>
+            </a:avLst>
+          </a:prstGeom>
+          <a:solidFill>
+            <a:srgbClr val="EAF1E6"/>
+          </a:solidFill>
+          <a:ln/>
+        </p:spPr>
+      </p:sp>
+      <p:sp>
+        <p:nvSpPr>
+          <p:cNvPr id="7" name="Text 5"/>
+          <p:cNvSpPr/>
+          <p:nvPr/>
+        </p:nvSpPr>
+        <p:spPr>
+          <a:xfrm>
+            <a:off x="914400" y="1417320"/>
+            <a:ext cx="10360152" cy="1371600"/>
+          </a:xfrm>
+          <a:prstGeom prst="rect">
+            <a:avLst/>
+          </a:prstGeom>
+          <a:noFill/>
+          <a:ln/>
+        </p:spPr>
+        <p:txBody>
+          <a:bodyPr wrap="square" lIns="0" tIns="0" rIns="0" bIns="0" rtlCol="0" anchor="ctr"/>
+          <a:lstStyle/>
+          <a:p>
+            <a:pPr indent="0" marL="0">
+              <a:lnSpc>
+                <a:spcPct val="115000"/>
+              </a:lnSpc>
+              <a:buNone/>
+            </a:pPr>
+            <a:r>
+              <a:rPr lang="en-US" sz="1900" dirty="0">
+                <a:solidFill>
+                  <a:srgbClr val="1B2A41"/>
+                </a:solidFill>
+                <a:latin typeface="Calibri" pitchFamily="34" charset="0"/>
+                <a:ea typeface="Calibri" pitchFamily="34" charset="-122"/>
+                <a:cs typeface="Calibri" pitchFamily="34" charset="-120"/>
+              </a:rPr>
+              <a:t>We, of Alcoholics Anonymous, are more than </a:t>
+            </a:r>
+            <a:pPr indent="0" marL="0">
+              <a:lnSpc>
+                <a:spcPct val="115000"/>
+              </a:lnSpc>
+              <a:buNone/>
+            </a:pPr>
+            <a:r>
+              <a:rPr lang="en-US" sz="1900" b="1" dirty="0">
+                <a:solidFill>
+                  <a:srgbClr val="2C5F2D"/>
+                </a:solidFill>
+                <a:latin typeface="Calibri" pitchFamily="34" charset="0"/>
+                <a:ea typeface="Calibri" pitchFamily="34" charset="-122"/>
+                <a:cs typeface="Calibri" pitchFamily="34" charset="-120"/>
+              </a:rPr>
+              <a:t>one hundred men and women</a:t>
+            </a:r>
+            <a:pPr indent="0" marL="0">
+              <a:lnSpc>
+                <a:spcPct val="115000"/>
+              </a:lnSpc>
+              <a:buNone/>
+            </a:pPr>
+            <a:r>
+              <a:rPr lang="en-US" sz="1900" dirty="0">
+                <a:solidFill>
+                  <a:srgbClr val="1B2A41"/>
+                </a:solidFill>
+                <a:latin typeface="Calibri" pitchFamily="34" charset="0"/>
+                <a:ea typeface="Calibri" pitchFamily="34" charset="-122"/>
+                <a:cs typeface="Calibri" pitchFamily="34" charset="-120"/>
+              </a:rPr>
+              <a:t> who have recovered from a seemingly hopeless state of mind and body. To show other alcoholics </a:t>
+            </a:r>
+            <a:pPr indent="0" marL="0">
+              <a:lnSpc>
+                <a:spcPct val="115000"/>
+              </a:lnSpc>
+              <a:buNone/>
+            </a:pPr>
+            <a:r>
+              <a:rPr lang="en-US" sz="1900" b="1" i="1" u="sng" dirty="0">
+                <a:solidFill>
+                  <a:srgbClr val="1B2A41"/>
+                </a:solidFill>
+                <a:latin typeface="Calibri" pitchFamily="34" charset="0"/>
+                <a:ea typeface="Calibri" pitchFamily="34" charset="-122"/>
+                <a:cs typeface="Calibri" pitchFamily="34" charset="-120"/>
+              </a:rPr>
+              <a:t>precisely how we have recovered</a:t>
+            </a:r>
+            <a:pPr indent="0" marL="0">
+              <a:lnSpc>
+                <a:spcPct val="115000"/>
+              </a:lnSpc>
+              <a:buNone/>
+            </a:pPr>
+            <a:r>
+              <a:rPr lang="en-US" sz="1900" dirty="0">
+                <a:solidFill>
+                  <a:srgbClr val="1B2A41"/>
+                </a:solidFill>
+                <a:latin typeface="Calibri" pitchFamily="34" charset="0"/>
+                <a:ea typeface="Calibri" pitchFamily="34" charset="-122"/>
+                <a:cs typeface="Calibri" pitchFamily="34" charset="-120"/>
+              </a:rPr>
+              <a:t> is the main purpose of this book. For…</a:t>
+            </a:r>
+            <a:endParaRPr lang="en-US" sz="1900" dirty="0"/>
+          </a:p>
+        </p:txBody>
+      </p:sp>
+      <p:sp>
+        <p:nvSpPr>
+          <p:cNvPr id="8" name="Shape 6"/>
+          <p:cNvSpPr/>
+          <p:nvPr/>
+        </p:nvSpPr>
+        <p:spPr>
+          <a:xfrm>
+            <a:off x="548640" y="3017520"/>
+            <a:ext cx="11091672" cy="1371600"/>
+          </a:xfrm>
+          <a:prstGeom prst="roundRect">
+            <a:avLst>
+              <a:gd name="adj" fmla="val 5333"/>
+            </a:avLst>
+          </a:prstGeom>
+          <a:solidFill>
+            <a:srgbClr val="E2EDF4"/>
+          </a:solidFill>
+          <a:ln/>
+        </p:spPr>
+      </p:sp>
+      <p:sp>
+        <p:nvSpPr>
+          <p:cNvPr id="9" name="Text 7"/>
+          <p:cNvSpPr/>
+          <p:nvPr/>
+        </p:nvSpPr>
+        <p:spPr>
+          <a:xfrm>
+            <a:off x="914400" y="3017520"/>
+            <a:ext cx="10360152" cy="1371600"/>
+          </a:xfrm>
+          <a:prstGeom prst="rect">
+            <a:avLst/>
+          </a:prstGeom>
+          <a:noFill/>
+          <a:ln/>
+        </p:spPr>
+        <p:txBody>
+          <a:bodyPr wrap="square" lIns="0" tIns="0" rIns="0" bIns="0" rtlCol="0" anchor="ctr"/>
+          <a:lstStyle/>
+          <a:p>
+            <a:pPr indent="0" marL="0">
+              <a:lnSpc>
+                <a:spcPct val="115000"/>
+              </a:lnSpc>
+              <a:buNone/>
+            </a:pPr>
+            <a:r>
+              <a:rPr lang="en-US" sz="1900" dirty="0">
+                <a:solidFill>
+                  <a:srgbClr val="1B2A41"/>
+                </a:solidFill>
+                <a:latin typeface="Calibri" pitchFamily="34" charset="0"/>
+                <a:ea typeface="Calibri" pitchFamily="34" charset="-122"/>
+                <a:cs typeface="Calibri" pitchFamily="34" charset="-120"/>
+              </a:rPr>
+              <a:t>…them, we hope these pages will prove so convincing that no further authentication will be necessary. We think this account of our experiences will help everyone to better understand the alcoholic.</a:t>
+            </a:r>
+            <a:endParaRPr lang="en-US" sz="1900" dirty="0"/>
+          </a:p>
+        </p:txBody>
+      </p:sp>
+      <p:sp>
+        <p:nvSpPr>
+          <p:cNvPr id="10" name="Shape 8"/>
+          <p:cNvSpPr/>
+          <p:nvPr/>
+        </p:nvSpPr>
+        <p:spPr>
+          <a:xfrm>
+            <a:off x="548640" y="4617720"/>
+            <a:ext cx="11091672" cy="1051560"/>
+          </a:xfrm>
+          <a:prstGeom prst="roundRect">
+            <a:avLst>
+              <a:gd name="adj" fmla="val 6957"/>
+            </a:avLst>
+          </a:prstGeom>
+          <a:solidFill>
+            <a:srgbClr val="1B2A41"/>
+          </a:solidFill>
+          <a:ln/>
+        </p:spPr>
+      </p:sp>
+      <p:sp>
+        <p:nvSpPr>
+          <p:cNvPr id="11" name="Text 9"/>
+          <p:cNvSpPr/>
+          <p:nvPr/>
+        </p:nvSpPr>
+        <p:spPr>
+          <a:xfrm>
+            <a:off x="914400" y="4736592"/>
+            <a:ext cx="10360152" cy="256032"/>
+          </a:xfrm>
+          <a:prstGeom prst="rect">
+            <a:avLst/>
+          </a:prstGeom>
+          <a:noFill/>
+          <a:ln/>
+        </p:spPr>
+        <p:txBody>
+          <a:bodyPr wrap="square" lIns="0" tIns="0" rIns="0" bIns="0" rtlCol="0" anchor="ctr"/>
+          <a:lstStyle/>
+          <a:p>
+            <a:pPr indent="0" marL="0">
+              <a:buNone/>
+            </a:pPr>
+            <a:r>
+              <a:rPr lang="en-US" sz="1100" b="1" spc="200" kern="0" dirty="0">
+                <a:solidFill>
+                  <a:srgbClr val="A9B8CC"/>
+                </a:solidFill>
+                <a:latin typeface="Calibri" pitchFamily="34" charset="0"/>
+                <a:ea typeface="Calibri" pitchFamily="34" charset="-122"/>
+                <a:cs typeface="Calibri" pitchFamily="34" charset="-120"/>
+              </a:rPr>
+              <a:t>MARGIN NOTE</a:t>
+            </a:r>
+            <a:endParaRPr lang="en-US" sz="1100" dirty="0"/>
+          </a:p>
+        </p:txBody>
+      </p:sp>
+      <p:sp>
+        <p:nvSpPr>
+          <p:cNvPr id="12" name="Text 10"/>
+          <p:cNvSpPr/>
+          <p:nvPr/>
+        </p:nvSpPr>
+        <p:spPr>
+          <a:xfrm>
+            <a:off x="914400" y="5010912"/>
+            <a:ext cx="10360152" cy="548640"/>
+          </a:xfrm>
+          <a:prstGeom prst="rect">
+            <a:avLst/>
+          </a:prstGeom>
+          <a:noFill/>
+          <a:ln/>
+        </p:spPr>
+        <p:txBody>
+          <a:bodyPr wrap="square" lIns="0" tIns="0" rIns="0" bIns="0" rtlCol="0" anchor="ctr"/>
+          <a:lstStyle/>
+          <a:p>
+            <a:pPr indent="0" marL="0">
+              <a:buNone/>
+            </a:pPr>
+            <a:r>
+              <a:rPr lang="en-US" sz="2200" b="1" dirty="0">
+                <a:solidFill>
+                  <a:srgbClr val="FFFFFF"/>
+                </a:solidFill>
+                <a:latin typeface="Cambria" pitchFamily="34" charset="0"/>
+                <a:ea typeface="Cambria" pitchFamily="34" charset="-122"/>
+                <a:cs typeface="Cambria" pitchFamily="34" charset="-120"/>
+              </a:rPr>
+              <a:t>Authored this book — originally 87, raised to one hundred at printing time.</a:t>
+            </a:r>
+            <a:endParaRPr lang="en-US" sz="2200" dirty="0"/>
+          </a:p>
+        </p:txBody>
+      </p:sp>
+      <p:sp>
+        <p:nvSpPr>
+          <p:cNvPr id="13" name="Text 11"/>
+          <p:cNvSpPr/>
+          <p:nvPr/>
+        </p:nvSpPr>
+        <p:spPr>
+          <a:xfrm>
+            <a:off x="548640" y="5852160"/>
+            <a:ext cx="11091672" cy="292608"/>
+          </a:xfrm>
+          <a:prstGeom prst="rect">
+            <a:avLst/>
+          </a:prstGeom>
+          <a:noFill/>
+          <a:ln/>
+        </p:spPr>
+        <p:txBody>
+          <a:bodyPr wrap="square" lIns="0" tIns="0" rIns="0" bIns="0" rtlCol="0" anchor="ctr"/>
+          <a:lstStyle/>
+          <a:p>
+            <a:pPr indent="0" marL="0">
+              <a:buNone/>
+            </a:pPr>
+            <a:r>
+              <a:rPr lang="en-US" sz="1200" i="1" dirty="0">
+                <a:solidFill>
+                  <a:srgbClr val="6B7A8C"/>
+                </a:solidFill>
+                <a:latin typeface="Calibri" pitchFamily="34" charset="0"/>
+                <a:ea typeface="Calibri" pitchFamily="34" charset="-122"/>
+                <a:cs typeface="Calibri" pitchFamily="34" charset="-120"/>
+              </a:rPr>
+              <a:t>Alcoholics Anonymous</a:t>
+            </a:r>
+            <a:pPr indent="0" marL="0">
+              <a:buNone/>
+            </a:pPr>
+            <a:r>
+              <a:rPr lang="en-US" sz="1200" dirty="0">
+                <a:solidFill>
+                  <a:srgbClr val="6B7A8C"/>
+                </a:solidFill>
+                <a:latin typeface="Calibri" pitchFamily="34" charset="0"/>
+                <a:ea typeface="Calibri" pitchFamily="34" charset="-122"/>
+                <a:cs typeface="Calibri" pitchFamily="34" charset="-120"/>
+              </a:rPr>
+              <a:t>, 4th ed., Foreword to the First Edition, p. ix.</a:t>
+            </a:r>
+            <a:endParaRPr lang="en-US" sz="1200" dirty="0"/>
+          </a:p>
+        </p:txBody>
+      </p:sp>
+      <p:sp>
+        <p:nvSpPr>
+          <p:cNvPr id="14" name="Text 12"/>
+          <p:cNvSpPr/>
+          <p:nvPr/>
+        </p:nvSpPr>
+        <p:spPr>
+          <a:xfrm>
+            <a:off x="548640" y="6355080"/>
+            <a:ext cx="11091672" cy="292608"/>
+          </a:xfrm>
+          <a:prstGeom prst="rect">
+            <a:avLst/>
+          </a:prstGeom>
+          <a:noFill/>
+          <a:ln/>
+        </p:spPr>
+        <p:txBody>
+          <a:bodyPr wrap="square" lIns="0" tIns="0" rIns="0" bIns="0" rtlCol="0" anchor="ctr"/>
+          <a:lstStyle/>
+          <a:p>
+            <a:pPr indent="0" marL="0">
+              <a:buNone/>
+            </a:pPr>
+            <a:r>
+              <a:rPr lang="en-US" sz="950" dirty="0">
+                <a:solidFill>
+                  <a:srgbClr val="6B7A8C"/>
+                </a:solidFill>
+                <a:latin typeface="Calibri" pitchFamily="34" charset="0"/>
+                <a:ea typeface="Calibri" pitchFamily="34" charset="-122"/>
+                <a:cs typeface="Calibri" pitchFamily="34" charset="-120"/>
+              </a:rPr>
+              <a:t>Copyright © Alcoholics Anonymous World Services, Inc. All rights reserved. Intended for personal use only, and not to be reproduced further or distributed for resale.</a:t>
+            </a:r>
+            <a:endParaRPr lang="en-US" sz="950" dirty="0"/>
+          </a:p>
+        </p:txBody>
+      </p:sp>
+    </p:spTree>
+  </p:cSld>
+  <p:clrMapOvr>
+    <a:masterClrMapping/>
+  </p:clrMapOvr>
+</p:sld>
+</file>
+
 <file path=ppt/theme/theme1.xml><?xml version="1.0" encoding="utf-8"?>
 <a:theme xmlns:a="http://schemas.openxmlformats.org/drawingml/2006/main" name="Office Theme">
   <a:themeElements>

</xml_diff>

<commit_message>
Add slides 6-10: Foreword to the Second Edition (pp. xi-xiii)
The spark at Akron, what the broker had learned from Silkworth and kept from the
Oxford Groups, the must on p. xii, the two numbered lessons, and A.A. number
three.

Pink highlighting in the source marks a 'must', so it renders in the deck's
magenta to match the MUSTS thread from slides 2-3. Slide 10 carries a dashed
photo frame rather than an image - the A.A.W.S. permission covers literature,
not archival photographs, so that picture gets placed by hand.

Adds header/marginNote/cite helpers to cut repetition, and teaches the preview
renderer to draw ovals as ovals.

Co-Authored-By: Claude Opus 5 <noreply@anthropic.com>
Claude-Session: https://claude.ai/code/session_01NuCgD3Z7aWvkQrsSvAUX4h
</commit_message>
<xml_diff>
--- a/aa-slideshow/aa-big-book-study.pptx
+++ b/aa-slideshow/aa-big-book-study.pptx
@@ -10,9 +10,14 @@
     <p:sldId id="258" r:id="rId4"/>
     <p:sldId id="259" r:id="rId5"/>
     <p:sldId id="260" r:id="rId6"/>
+    <p:sldId id="261" r:id="rId7"/>
+    <p:sldId id="262" r:id="rId8"/>
+    <p:sldId id="263" r:id="rId9"/>
+    <p:sldId id="264" r:id="rId10"/>
+    <p:sldId id="265" r:id="rId11"/>
   </p:sldIdLst>
   <p:notesMasterIdLst>
-    <p:notesMasterId r:id="rId7"/>
+    <p:notesMasterId r:id="rId12"/>
   </p:notesMasterIdLst>
   <p:sldSz cx="12192000" cy="6858000"/>
   <p:notesSz cx="6858000" cy="12192000"/>
@@ -551,6 +556,97 @@
 </p:notes>
 </file>
 
+<file path=ppt/notesSlides/notesSlide10.xml><?xml version="1.0" encoding="utf-8"?>
+<p:notes xmlns:a="http://schemas.openxmlformats.org/drawingml/2006/main" xmlns:r="http://schemas.openxmlformats.org/officeDocument/2006/relationships" xmlns:p="http://schemas.openxmlformats.org/presentationml/2006/main">
+  <p:cSld>
+    <p:spTree>
+      <p:nvGrpSpPr>
+        <p:cNvPr id="1" name=""/>
+        <p:cNvGrpSpPr/>
+        <p:nvPr/>
+      </p:nvGrpSpPr>
+      <p:grpSpPr>
+        <a:xfrm>
+          <a:off x="0" y="0"/>
+          <a:ext cx="0" cy="0"/>
+          <a:chOff x="0" y="0"/>
+          <a:chExt cx="0" cy="0"/>
+        </a:xfrm>
+      </p:grpSpPr>
+      <p:sp>
+        <p:nvSpPr>
+          <p:cNvPr id="2" name="Slide Image Placeholder 1"/>
+          <p:cNvSpPr>
+            <a:spLocks noGrp="1" noRot="1" noChangeAspect="1"/>
+          </p:cNvSpPr>
+          <p:nvPr>
+            <p:ph type="sldImg"/>
+          </p:nvPr>
+        </p:nvSpPr>
+        <p:spPr/>
+      </p:sp>
+      <p:sp>
+        <p:nvSpPr>
+          <p:cNvPr id="3" name="Notes Placeholder 2"/>
+          <p:cNvSpPr>
+            <a:spLocks noGrp="1"/>
+          </p:cNvSpPr>
+          <p:nvPr>
+            <p:ph type="body" idx="1"/>
+          </p:nvPr>
+        </p:nvSpPr>
+        <p:spPr/>
+        <p:txBody>
+          <a:bodyPr/>
+          <a:lstStyle/>
+          <a:p>
+            <a:r>
+              <a:rPr lang="en-US" dirty="0"/>
+              <a:t>The first man they worked on. A desperate case, in a bed at Akron City Hospital, summer 1935.
+He recovered immediately and never had another drink.
+Bill D. - A.A. number three. The man in the photograph.
+Two men who could not stay sober alone stayed sober by working on a third.</a:t>
+            </a:r>
+            <a:endParaRPr lang="en-US" dirty="0"/>
+          </a:p>
+        </p:txBody>
+      </p:sp>
+      <p:sp>
+        <p:nvSpPr>
+          <p:cNvPr id="4" name="Slide Number Placeholder 3"/>
+          <p:cNvSpPr>
+            <a:spLocks noGrp="1"/>
+          </p:cNvSpPr>
+          <p:nvPr>
+            <p:ph type="sldNum" sz="quarter" idx="10"/>
+          </p:nvPr>
+        </p:nvSpPr>
+        <p:spPr/>
+        <p:txBody>
+          <a:bodyPr/>
+          <a:lstStyle/>
+          <a:p>
+            <a:fld id="{F7021451-1387-4CA6-816F-3879F97B5CBC}" type="slidenum">
+              <a:rPr lang="en-US"/>
+              <a:t>10</a:t>
+            </a:fld>
+            <a:endParaRPr lang="en-US"/>
+          </a:p>
+        </p:txBody>
+      </p:sp>
+    </p:spTree>
+    <p:extLst>
+      <p:ext uri="{BB962C8B-B14F-4D97-AF65-F5344CB8AC3E}">
+        <p14:creationId xmlns:p14="http://schemas.microsoft.com/office/powerpoint/2010/main" val="1024086991"/>
+      </p:ext>
+    </p:extLst>
+  </p:cSld>
+  <p:clrMapOvr>
+    <a:masterClrMapping/>
+  </p:clrMapOvr>
+</p:notes>
+</file>
+
 <file path=ppt/notesSlides/notesSlide2.xml><?xml version="1.0" encoding="utf-8"?>
 <p:notes xmlns:a="http://schemas.openxmlformats.org/drawingml/2006/main" xmlns:r="http://schemas.openxmlformats.org/officeDocument/2006/relationships" xmlns:p="http://schemas.openxmlformats.org/presentationml/2006/main">
   <p:cSld>
@@ -907,6 +1003,375 @@
             <a:fld id="{F7021451-1387-4CA6-816F-3879F97B5CBC}" type="slidenum">
               <a:rPr lang="en-US"/>
               <a:t>5</a:t>
+            </a:fld>
+            <a:endParaRPr lang="en-US"/>
+          </a:p>
+        </p:txBody>
+      </p:sp>
+    </p:spTree>
+    <p:extLst>
+      <p:ext uri="{BB962C8B-B14F-4D97-AF65-F5344CB8AC3E}">
+        <p14:creationId xmlns:p14="http://schemas.microsoft.com/office/powerpoint/2010/main" val="1024086991"/>
+      </p:ext>
+    </p:extLst>
+  </p:cSld>
+  <p:clrMapOvr>
+    <a:masterClrMapping/>
+  </p:clrMapOvr>
+</p:notes>
+</file>
+
+<file path=ppt/notesSlides/notesSlide6.xml><?xml version="1.0" encoding="utf-8"?>
+<p:notes xmlns:a="http://schemas.openxmlformats.org/drawingml/2006/main" xmlns:r="http://schemas.openxmlformats.org/officeDocument/2006/relationships" xmlns:p="http://schemas.openxmlformats.org/presentationml/2006/main">
+  <p:cSld>
+    <p:spTree>
+      <p:nvGrpSpPr>
+        <p:cNvPr id="1" name=""/>
+        <p:cNvGrpSpPr/>
+        <p:nvPr/>
+      </p:nvGrpSpPr>
+      <p:grpSpPr>
+        <a:xfrm>
+          <a:off x="0" y="0"/>
+          <a:ext cx="0" cy="0"/>
+          <a:chOff x="0" y="0"/>
+          <a:chExt cx="0" cy="0"/>
+        </a:xfrm>
+      </p:grpSpPr>
+      <p:sp>
+        <p:nvSpPr>
+          <p:cNvPr id="2" name="Slide Image Placeholder 1"/>
+          <p:cNvSpPr>
+            <a:spLocks noGrp="1" noRot="1" noChangeAspect="1"/>
+          </p:cNvSpPr>
+          <p:nvPr>
+            <p:ph type="sldImg"/>
+          </p:nvPr>
+        </p:nvSpPr>
+        <p:spPr/>
+      </p:sp>
+      <p:sp>
+        <p:nvSpPr>
+          <p:cNvPr id="3" name="Notes Placeholder 2"/>
+          <p:cNvSpPr>
+            <a:spLocks noGrp="1"/>
+          </p:cNvSpPr>
+          <p:nvPr>
+            <p:ph type="body" idx="1"/>
+          </p:nvPr>
+        </p:nvSpPr>
+        <p:spPr/>
+        <p:txBody>
+          <a:bodyPr/>
+          <a:lstStyle/>
+          <a:p>
+            <a:r>
+              <a:rPr lang="en-US" dirty="0"/>
+              <a:t>Stop here and tell the Roland story before reading on.
+Roland Hazard - the chain starts with him. He goes to Carl Jung, is told his case is
+hopeless short of a vital spiritual experience, finds the Oxford Groups, and carries it to
+Ebby. Ebby is the alcoholic friend in this paragraph. Ebby carries it to the broker.
+The broker is Bill W. The Akron physician is Dr. Bob. June 1935.</a:t>
+            </a:r>
+            <a:endParaRPr lang="en-US" dirty="0"/>
+          </a:p>
+        </p:txBody>
+      </p:sp>
+      <p:sp>
+        <p:nvSpPr>
+          <p:cNvPr id="4" name="Slide Number Placeholder 3"/>
+          <p:cNvSpPr>
+            <a:spLocks noGrp="1"/>
+          </p:cNvSpPr>
+          <p:nvPr>
+            <p:ph type="sldNum" sz="quarter" idx="10"/>
+          </p:nvPr>
+        </p:nvSpPr>
+        <p:spPr/>
+        <p:txBody>
+          <a:bodyPr/>
+          <a:lstStyle/>
+          <a:p>
+            <a:fld id="{F7021451-1387-4CA6-816F-3879F97B5CBC}" type="slidenum">
+              <a:rPr lang="en-US"/>
+              <a:t>6</a:t>
+            </a:fld>
+            <a:endParaRPr lang="en-US"/>
+          </a:p>
+        </p:txBody>
+      </p:sp>
+    </p:spTree>
+    <p:extLst>
+      <p:ext uri="{BB962C8B-B14F-4D97-AF65-F5344CB8AC3E}">
+        <p14:creationId xmlns:p14="http://schemas.microsoft.com/office/powerpoint/2010/main" val="1024086991"/>
+      </p:ext>
+    </p:extLst>
+  </p:cSld>
+  <p:clrMapOvr>
+    <a:masterClrMapping/>
+  </p:clrMapOvr>
+</p:notes>
+</file>
+
+<file path=ppt/notesSlides/notesSlide7.xml><?xml version="1.0" encoding="utf-8"?>
+<p:notes xmlns:a="http://schemas.openxmlformats.org/drawingml/2006/main" xmlns:r="http://schemas.openxmlformats.org/officeDocument/2006/relationships" xmlns:p="http://schemas.openxmlformats.org/presentationml/2006/main">
+  <p:cSld>
+    <p:spTree>
+      <p:nvGrpSpPr>
+        <p:cNvPr id="1" name=""/>
+        <p:cNvGrpSpPr/>
+        <p:nvPr/>
+      </p:nvGrpSpPr>
+      <p:grpSpPr>
+        <a:xfrm>
+          <a:off x="0" y="0"/>
+          <a:ext cx="0" cy="0"/>
+          <a:chOff x="0" y="0"/>
+          <a:chExt cx="0" cy="0"/>
+        </a:xfrm>
+      </p:grpSpPr>
+      <p:sp>
+        <p:nvSpPr>
+          <p:cNvPr id="2" name="Slide Image Placeholder 1"/>
+          <p:cNvSpPr>
+            <a:spLocks noGrp="1" noRot="1" noChangeAspect="1"/>
+          </p:cNvSpPr>
+          <p:nvPr>
+            <p:ph type="sldImg"/>
+          </p:nvPr>
+        </p:nvSpPr>
+        <p:spPr/>
+      </p:sp>
+      <p:sp>
+        <p:nvSpPr>
+          <p:cNvPr id="3" name="Notes Placeholder 2"/>
+          <p:cNvSpPr>
+            <a:spLocks noGrp="1"/>
+          </p:cNvSpPr>
+          <p:nvPr>
+            <p:ph type="body" idx="1"/>
+          </p:nvPr>
+        </p:nvSpPr>
+        <p:spPr/>
+        <p:txBody>
+          <a:bodyPr/>
+          <a:lstStyle/>
+          <a:p>
+            <a:r>
+              <a:rPr lang="en-US" dirty="0"/>
+              <a:t>Five things, and every one of them ends up in the Twelve Steps.
+Moral inventory - Step 4. Confession of personality defects - Step 5. Restitution to those
+harmed - Steps 8 and 9. Helpfulness to others - Step 12. Dependence upon God - Steps 3 and 11.
+He could not accept all of the Oxford Groups. He kept these.</a:t>
+            </a:r>
+            <a:endParaRPr lang="en-US" dirty="0"/>
+          </a:p>
+        </p:txBody>
+      </p:sp>
+      <p:sp>
+        <p:nvSpPr>
+          <p:cNvPr id="4" name="Slide Number Placeholder 3"/>
+          <p:cNvSpPr>
+            <a:spLocks noGrp="1"/>
+          </p:cNvSpPr>
+          <p:nvPr>
+            <p:ph type="sldNum" sz="quarter" idx="10"/>
+          </p:nvPr>
+        </p:nvSpPr>
+        <p:spPr/>
+        <p:txBody>
+          <a:bodyPr/>
+          <a:lstStyle/>
+          <a:p>
+            <a:fld id="{F7021451-1387-4CA6-816F-3879F97B5CBC}" type="slidenum">
+              <a:rPr lang="en-US"/>
+              <a:t>7</a:t>
+            </a:fld>
+            <a:endParaRPr lang="en-US"/>
+          </a:p>
+        </p:txBody>
+      </p:sp>
+    </p:spTree>
+    <p:extLst>
+      <p:ext uri="{BB962C8B-B14F-4D97-AF65-F5344CB8AC3E}">
+        <p14:creationId xmlns:p14="http://schemas.microsoft.com/office/powerpoint/2010/main" val="1024086991"/>
+      </p:ext>
+    </p:extLst>
+  </p:cSld>
+  <p:clrMapOvr>
+    <a:masterClrMapping/>
+  </p:clrMapOvr>
+</p:notes>
+</file>
+
+<file path=ppt/notesSlides/notesSlide8.xml><?xml version="1.0" encoding="utf-8"?>
+<p:notes xmlns:a="http://schemas.openxmlformats.org/drawingml/2006/main" xmlns:r="http://schemas.openxmlformats.org/officeDocument/2006/relationships" xmlns:p="http://schemas.openxmlformats.org/presentationml/2006/main">
+  <p:cSld>
+    <p:spTree>
+      <p:nvGrpSpPr>
+        <p:cNvPr id="1" name=""/>
+        <p:cNvGrpSpPr/>
+        <p:nvPr/>
+      </p:nvGrpSpPr>
+      <p:grpSpPr>
+        <a:xfrm>
+          <a:off x="0" y="0"/>
+          <a:ext cx="0" cy="0"/>
+          <a:chOff x="0" y="0"/>
+          <a:chExt cx="0" cy="0"/>
+        </a:xfrm>
+      </p:grpSpPr>
+      <p:sp>
+        <p:nvSpPr>
+          <p:cNvPr id="2" name="Slide Image Placeholder 1"/>
+          <p:cNvSpPr>
+            <a:spLocks noGrp="1" noRot="1" noChangeAspect="1"/>
+          </p:cNvSpPr>
+          <p:nvPr>
+            <p:ph type="sldImg"/>
+          </p:nvPr>
+        </p:nvSpPr>
+        <p:spPr/>
+      </p:sp>
+      <p:sp>
+        <p:nvSpPr>
+          <p:cNvPr id="3" name="Notes Placeholder 2"/>
+          <p:cNvSpPr>
+            <a:spLocks noGrp="1"/>
+          </p:cNvSpPr>
+          <p:nvPr>
+            <p:ph type="body" idx="1"/>
+          </p:nvPr>
+        </p:nvSpPr>
+        <p:spPr/>
+        <p:txBody>
+          <a:bodyPr/>
+          <a:lstStyle/>
+          <a:p>
+            <a:r>
+              <a:rPr lang="en-US" dirty="0"/>
+              <a:t>He had it backwards for six months. He worked hard on other alcoholics on the theory that
+only an alcoholic could help an alcoholic - and all it did was keep him sober. Which,
+it turns out, was the point.
+Akron. Business venture collapsed. Afraid he is going to drink. And what he realizes is
+not that he needs a meeting or a drink or a plan - he must carry the message to another
+alcoholic in order to save himself.
+That alcoholic turned out to be Dr. Bob.</a:t>
+            </a:r>
+            <a:endParaRPr lang="en-US" dirty="0"/>
+          </a:p>
+        </p:txBody>
+      </p:sp>
+      <p:sp>
+        <p:nvSpPr>
+          <p:cNvPr id="4" name="Slide Number Placeholder 3"/>
+          <p:cNvSpPr>
+            <a:spLocks noGrp="1"/>
+          </p:cNvSpPr>
+          <p:nvPr>
+            <p:ph type="sldNum" sz="quarter" idx="10"/>
+          </p:nvPr>
+        </p:nvSpPr>
+        <p:spPr/>
+        <p:txBody>
+          <a:bodyPr/>
+          <a:lstStyle/>
+          <a:p>
+            <a:fld id="{F7021451-1387-4CA6-816F-3879F97B5CBC}" type="slidenum">
+              <a:rPr lang="en-US"/>
+              <a:t>8</a:t>
+            </a:fld>
+            <a:endParaRPr lang="en-US"/>
+          </a:p>
+        </p:txBody>
+      </p:sp>
+    </p:spTree>
+    <p:extLst>
+      <p:ext uri="{BB962C8B-B14F-4D97-AF65-F5344CB8AC3E}">
+        <p14:creationId xmlns:p14="http://schemas.microsoft.com/office/powerpoint/2010/main" val="1024086991"/>
+      </p:ext>
+    </p:extLst>
+  </p:cSld>
+  <p:clrMapOvr>
+    <a:masterClrMapping/>
+  </p:clrMapOvr>
+</p:notes>
+</file>
+
+<file path=ppt/notesSlides/notesSlide9.xml><?xml version="1.0" encoding="utf-8"?>
+<p:notes xmlns:a="http://schemas.openxmlformats.org/drawingml/2006/main" xmlns:r="http://schemas.openxmlformats.org/officeDocument/2006/relationships" xmlns:p="http://schemas.openxmlformats.org/presentationml/2006/main">
+  <p:cSld>
+    <p:spTree>
+      <p:nvGrpSpPr>
+        <p:cNvPr id="1" name=""/>
+        <p:cNvGrpSpPr/>
+        <p:nvPr/>
+      </p:nvGrpSpPr>
+      <p:grpSpPr>
+        <a:xfrm>
+          <a:off x="0" y="0"/>
+          <a:ext cx="0" cy="0"/>
+          <a:chOff x="0" y="0"/>
+          <a:chExt cx="0" cy="0"/>
+        </a:xfrm>
+      </p:grpSpPr>
+      <p:sp>
+        <p:nvSpPr>
+          <p:cNvPr id="2" name="Slide Image Placeholder 1"/>
+          <p:cNvSpPr>
+            <a:spLocks noGrp="1" noRot="1" noChangeAspect="1"/>
+          </p:cNvSpPr>
+          <p:nvPr>
+            <p:ph type="sldImg"/>
+          </p:nvPr>
+        </p:nvSpPr>
+        <p:spPr/>
+      </p:sp>
+      <p:sp>
+        <p:nvSpPr>
+          <p:cNvPr id="3" name="Notes Placeholder 2"/>
+          <p:cNvSpPr>
+            <a:spLocks noGrp="1"/>
+          </p:cNvSpPr>
+          <p:nvPr>
+            <p:ph type="body" idx="1"/>
+          </p:nvPr>
+        </p:nvSpPr>
+        <p:spPr/>
+        <p:txBody>
+          <a:bodyPr/>
+          <a:lstStyle/>
+          <a:p>
+            <a:r>
+              <a:rPr lang="en-US" dirty="0"/>
+              <a:t>These two are numbered in the book for a reason. Everything A.A. does rests on them.
+One: an alcoholic reaches another alcoholic in a way that no nonalcoholic can. Not a
+doctor, not a preacher, not a spouse. That is why we have sponsors.
+Two: strenuous work, one alcoholic with another. Strenuous. Not casual, not when it is
+convenient. Vital to permanent recovery - vital meaning you do not live without it.</a:t>
+            </a:r>
+            <a:endParaRPr lang="en-US" dirty="0"/>
+          </a:p>
+        </p:txBody>
+      </p:sp>
+      <p:sp>
+        <p:nvSpPr>
+          <p:cNvPr id="4" name="Slide Number Placeholder 3"/>
+          <p:cNvSpPr>
+            <a:spLocks noGrp="1"/>
+          </p:cNvSpPr>
+          <p:nvPr>
+            <p:ph type="sldNum" sz="quarter" idx="10"/>
+          </p:nvPr>
+        </p:nvSpPr>
+        <p:spPr/>
+        <p:txBody>
+          <a:bodyPr/>
+          <a:lstStyle/>
+          <a:p>
+            <a:fld id="{F7021451-1387-4CA6-816F-3879F97B5CBC}" type="slidenum">
+              <a:rPr lang="en-US"/>
+              <a:t>9</a:t>
             </a:fld>
             <a:endParaRPr lang="en-US"/>
           </a:p>
@@ -1487,6 +1952,620 @@
 </p:sld>
 </file>
 
+<file path=ppt/slides/slide10.xml><?xml version="1.0" encoding="utf-8"?>
+<p:sld xmlns:a="http://schemas.openxmlformats.org/drawingml/2006/main" xmlns:r="http://schemas.openxmlformats.org/officeDocument/2006/relationships" xmlns:p="http://schemas.openxmlformats.org/presentationml/2006/main">
+  <p:cSld name="Slide 10">
+    <p:bg>
+      <p:bgPr>
+        <a:solidFill>
+          <a:srgbClr val="FFFFFF"/>
+        </a:solidFill>
+      </p:bgPr>
+    </p:bg>
+    <p:spTree>
+      <p:nvGrpSpPr>
+        <p:cNvPr id="1" name=""/>
+        <p:cNvGrpSpPr/>
+        <p:nvPr/>
+      </p:nvGrpSpPr>
+      <p:grpSpPr>
+        <a:xfrm>
+          <a:off x="0" y="0"/>
+          <a:ext cx="0" cy="0"/>
+          <a:chOff x="0" y="0"/>
+          <a:chExt cx="0" cy="0"/>
+        </a:xfrm>
+      </p:grpSpPr>
+      <p:sp>
+        <p:nvSpPr>
+          <p:cNvPr id="2" name="Text 0"/>
+          <p:cNvSpPr/>
+          <p:nvPr/>
+        </p:nvSpPr>
+        <p:spPr>
+          <a:xfrm>
+            <a:off x="548640" y="320040"/>
+            <a:ext cx="8138160" cy="566928"/>
+          </a:xfrm>
+          <a:prstGeom prst="rect">
+            <a:avLst/>
+          </a:prstGeom>
+          <a:noFill/>
+          <a:ln/>
+        </p:spPr>
+        <p:txBody>
+          <a:bodyPr wrap="square" lIns="0" tIns="0" rIns="0" bIns="0" rtlCol="0" anchor="ctr"/>
+          <a:lstStyle/>
+          <a:p>
+            <a:pPr indent="0" marL="0">
+              <a:buNone/>
+            </a:pPr>
+            <a:r>
+              <a:rPr lang="en-US" sz="3800" b="1" dirty="0">
+                <a:solidFill>
+                  <a:srgbClr val="1B2A41"/>
+                </a:solidFill>
+                <a:latin typeface="Cambria" pitchFamily="34" charset="0"/>
+                <a:ea typeface="Cambria" pitchFamily="34" charset="-122"/>
+                <a:cs typeface="Cambria" pitchFamily="34" charset="-120"/>
+              </a:rPr>
+              <a:t>A.A. Number Three</a:t>
+            </a:r>
+            <a:endParaRPr lang="en-US" sz="3800" dirty="0"/>
+          </a:p>
+        </p:txBody>
+      </p:sp>
+      <p:sp>
+        <p:nvSpPr>
+          <p:cNvPr id="3" name="Text 1"/>
+          <p:cNvSpPr/>
+          <p:nvPr/>
+        </p:nvSpPr>
+        <p:spPr>
+          <a:xfrm>
+            <a:off x="548640" y="914400"/>
+            <a:ext cx="8138160" cy="347472"/>
+          </a:xfrm>
+          <a:prstGeom prst="rect">
+            <a:avLst/>
+          </a:prstGeom>
+          <a:noFill/>
+          <a:ln/>
+        </p:spPr>
+        <p:txBody>
+          <a:bodyPr wrap="square" lIns="0" tIns="0" rIns="0" bIns="0" rtlCol="0" anchor="ctr"/>
+          <a:lstStyle/>
+          <a:p>
+            <a:pPr indent="0" marL="0">
+              <a:buNone/>
+            </a:pPr>
+            <a:r>
+              <a:rPr lang="en-US" sz="1700" i="1" dirty="0">
+                <a:solidFill>
+                  <a:srgbClr val="6B7A8C"/>
+                </a:solidFill>
+                <a:latin typeface="Calibri" pitchFamily="34" charset="0"/>
+                <a:ea typeface="Calibri" pitchFamily="34" charset="-122"/>
+                <a:cs typeface="Calibri" pitchFamily="34" charset="-120"/>
+              </a:rPr>
+              <a:t>Their very first case.</a:t>
+            </a:r>
+            <a:endParaRPr lang="en-US" sz="1700" dirty="0"/>
+          </a:p>
+        </p:txBody>
+      </p:sp>
+      <p:sp>
+        <p:nvSpPr>
+          <p:cNvPr id="4" name="Shape 2"/>
+          <p:cNvSpPr/>
+          <p:nvPr/>
+        </p:nvSpPr>
+        <p:spPr>
+          <a:xfrm>
+            <a:off x="8869680" y="320040"/>
+            <a:ext cx="2770632" cy="960120"/>
+          </a:xfrm>
+          <a:prstGeom prst="roundRect">
+            <a:avLst>
+              <a:gd name="adj" fmla="val 9524"/>
+            </a:avLst>
+          </a:prstGeom>
+          <a:solidFill>
+            <a:srgbClr val="2C5F2D"/>
+          </a:solidFill>
+          <a:ln/>
+        </p:spPr>
+      </p:sp>
+      <p:sp>
+        <p:nvSpPr>
+          <p:cNvPr id="5" name="Text 3"/>
+          <p:cNvSpPr/>
+          <p:nvPr/>
+        </p:nvSpPr>
+        <p:spPr>
+          <a:xfrm>
+            <a:off x="8869680" y="320040"/>
+            <a:ext cx="2770632" cy="960120"/>
+          </a:xfrm>
+          <a:prstGeom prst="rect">
+            <a:avLst/>
+          </a:prstGeom>
+          <a:noFill/>
+          <a:ln/>
+        </p:spPr>
+        <p:txBody>
+          <a:bodyPr wrap="square" lIns="0" tIns="0" rIns="0" bIns="0" rtlCol="0" anchor="ctr"/>
+          <a:lstStyle/>
+          <a:p>
+            <a:pPr algn="ctr" indent="0" marL="0">
+              <a:buNone/>
+            </a:pPr>
+            <a:r>
+              <a:rPr lang="en-US" sz="1700" b="1" spc="100" kern="0" dirty="0">
+                <a:solidFill>
+                  <a:srgbClr val="FFFFFF"/>
+                </a:solidFill>
+                <a:latin typeface="Cambria" pitchFamily="34" charset="0"/>
+                <a:ea typeface="Cambria" pitchFamily="34" charset="-122"/>
+                <a:cs typeface="Cambria" pitchFamily="34" charset="-120"/>
+              </a:rPr>
+              <a:t>FOREWORD</a:t>
+            </a:r>
+            <a:endParaRPr lang="en-US" sz="1700" dirty="0"/>
+          </a:p>
+          <a:p>
+            <a:pPr algn="ctr" indent="0" marL="0">
+              <a:buNone/>
+            </a:pPr>
+            <a:r>
+              <a:rPr lang="en-US" sz="1300" dirty="0">
+                <a:solidFill>
+                  <a:srgbClr val="D5E3CE"/>
+                </a:solidFill>
+                <a:latin typeface="Calibri" pitchFamily="34" charset="0"/>
+                <a:ea typeface="Calibri" pitchFamily="34" charset="-122"/>
+                <a:cs typeface="Calibri" pitchFamily="34" charset="-120"/>
+              </a:rPr>
+              <a:t>Second Ed.  ·  p. xiii</a:t>
+            </a:r>
+            <a:endParaRPr lang="en-US" sz="1700" dirty="0"/>
+          </a:p>
+        </p:txBody>
+      </p:sp>
+      <p:sp>
+        <p:nvSpPr>
+          <p:cNvPr id="6" name="Shape 4"/>
+          <p:cNvSpPr/>
+          <p:nvPr/>
+        </p:nvSpPr>
+        <p:spPr>
+          <a:xfrm>
+            <a:off x="548640" y="1463040"/>
+            <a:ext cx="4892040" cy="3657600"/>
+          </a:xfrm>
+          <a:prstGeom prst="roundRect">
+            <a:avLst>
+              <a:gd name="adj" fmla="val 2000"/>
+            </a:avLst>
+          </a:prstGeom>
+          <a:solidFill>
+            <a:srgbClr val="F1F4F7"/>
+          </a:solidFill>
+          <a:ln w="19050">
+            <a:solidFill>
+              <a:srgbClr val="AEBBC9"/>
+            </a:solidFill>
+            <a:prstDash val="dash"/>
+          </a:ln>
+        </p:spPr>
+      </p:sp>
+      <p:sp>
+        <p:nvSpPr>
+          <p:cNvPr id="7" name="Text 5"/>
+          <p:cNvSpPr/>
+          <p:nvPr/>
+        </p:nvSpPr>
+        <p:spPr>
+          <a:xfrm>
+            <a:off x="822960" y="1463040"/>
+            <a:ext cx="4343400" cy="3657600"/>
+          </a:xfrm>
+          <a:prstGeom prst="rect">
+            <a:avLst/>
+          </a:prstGeom>
+          <a:noFill/>
+          <a:ln/>
+        </p:spPr>
+        <p:txBody>
+          <a:bodyPr wrap="square" lIns="0" tIns="0" rIns="0" bIns="0" rtlCol="0" anchor="ctr"/>
+          <a:lstStyle/>
+          <a:p>
+            <a:pPr algn="ctr" indent="0" marL="0">
+              <a:buNone/>
+            </a:pPr>
+            <a:r>
+              <a:rPr lang="en-US" sz="1100" b="1" spc="200" kern="0" dirty="0">
+                <a:solidFill>
+                  <a:srgbClr val="6B7A8C"/>
+                </a:solidFill>
+                <a:latin typeface="Calibri" pitchFamily="34" charset="0"/>
+                <a:ea typeface="Calibri" pitchFamily="34" charset="-122"/>
+                <a:cs typeface="Calibri" pitchFamily="34" charset="-120"/>
+              </a:rPr>
+              <a:t>PHOTOGRAPH</a:t>
+            </a:r>
+            <a:endParaRPr lang="en-US" sz="1100" dirty="0"/>
+          </a:p>
+          <a:p>
+            <a:pPr algn="ctr" indent="0" marL="0">
+              <a:buNone/>
+            </a:pPr>
+            <a:r>
+              <a:rPr lang="en-US" sz="800" dirty="0">
+                <a:solidFill>
+                  <a:srgbClr val="000000"/>
+                </a:solidFill>
+                <a:latin typeface="Calibri" pitchFamily="34" charset="0"/>
+                <a:ea typeface="Calibri" pitchFamily="34" charset="-122"/>
+                <a:cs typeface="Calibri" pitchFamily="34" charset="-120"/>
+              </a:rPr>
+              <a:t>
+</a:t>
+            </a:r>
+            <a:endParaRPr lang="en-US" sz="1100" dirty="0"/>
+          </a:p>
+          <a:p>
+            <a:pPr algn="ctr" indent="0" marL="0">
+              <a:buNone/>
+            </a:pPr>
+            <a:r>
+              <a:rPr lang="en-US" sz="1700" b="1" dirty="0">
+                <a:solidFill>
+                  <a:srgbClr val="1B2A41"/>
+                </a:solidFill>
+                <a:latin typeface="Calibri" pitchFamily="34" charset="0"/>
+                <a:ea typeface="Calibri" pitchFamily="34" charset="-122"/>
+                <a:cs typeface="Calibri" pitchFamily="34" charset="-120"/>
+              </a:rPr>
+              <a:t>Bill D. in the hospital bed</a:t>
+            </a:r>
+            <a:endParaRPr lang="en-US" sz="1100" dirty="0"/>
+          </a:p>
+          <a:p>
+            <a:pPr algn="ctr" indent="0" marL="0">
+              <a:buNone/>
+            </a:pPr>
+            <a:r>
+              <a:rPr lang="en-US" sz="1500" dirty="0">
+                <a:solidFill>
+                  <a:srgbClr val="6B7A8C"/>
+                </a:solidFill>
+                <a:latin typeface="Calibri" pitchFamily="34" charset="0"/>
+                <a:ea typeface="Calibri" pitchFamily="34" charset="-122"/>
+                <a:cs typeface="Calibri" pitchFamily="34" charset="-120"/>
+              </a:rPr>
+              <a:t>Akron City Hospital, 1935</a:t>
+            </a:r>
+            <a:endParaRPr lang="en-US" sz="1100" dirty="0"/>
+          </a:p>
+          <a:p>
+            <a:pPr algn="ctr" indent="0" marL="0">
+              <a:buNone/>
+            </a:pPr>
+            <a:r>
+              <a:rPr lang="en-US" sz="800" dirty="0">
+                <a:solidFill>
+                  <a:srgbClr val="000000"/>
+                </a:solidFill>
+                <a:latin typeface="Calibri" pitchFamily="34" charset="0"/>
+                <a:ea typeface="Calibri" pitchFamily="34" charset="-122"/>
+                <a:cs typeface="Calibri" pitchFamily="34" charset="-120"/>
+              </a:rPr>
+              <a:t>
+</a:t>
+            </a:r>
+            <a:endParaRPr lang="en-US" sz="1100" dirty="0"/>
+          </a:p>
+          <a:p>
+            <a:pPr algn="ctr" indent="0" marL="0">
+              <a:buNone/>
+            </a:pPr>
+            <a:r>
+              <a:rPr lang="en-US" sz="1300" i="1" dirty="0">
+                <a:solidFill>
+                  <a:srgbClr val="6B7A8C"/>
+                </a:solidFill>
+                <a:latin typeface="Calibri" pitchFamily="34" charset="0"/>
+                <a:ea typeface="Calibri" pitchFamily="34" charset="-122"/>
+                <a:cs typeface="Calibri" pitchFamily="34" charset="-120"/>
+              </a:rPr>
+              <a:t>Drop the image into this frame in PowerPoint.</a:t>
+            </a:r>
+            <a:endParaRPr lang="en-US" sz="1100" dirty="0"/>
+          </a:p>
+        </p:txBody>
+      </p:sp>
+      <p:sp>
+        <p:nvSpPr>
+          <p:cNvPr id="8" name="Shape 6"/>
+          <p:cNvSpPr/>
+          <p:nvPr/>
+        </p:nvSpPr>
+        <p:spPr>
+          <a:xfrm>
+            <a:off x="5760720" y="1463040"/>
+            <a:ext cx="5879592" cy="2057400"/>
+          </a:xfrm>
+          <a:prstGeom prst="roundRect">
+            <a:avLst>
+              <a:gd name="adj" fmla="val 3556"/>
+            </a:avLst>
+          </a:prstGeom>
+          <a:solidFill>
+            <a:srgbClr val="EAF1E6"/>
+          </a:solidFill>
+          <a:ln/>
+        </p:spPr>
+      </p:sp>
+      <p:sp>
+        <p:nvSpPr>
+          <p:cNvPr id="9" name="Text 7"/>
+          <p:cNvSpPr/>
+          <p:nvPr/>
+        </p:nvSpPr>
+        <p:spPr>
+          <a:xfrm>
+            <a:off x="6126480" y="1463040"/>
+            <a:ext cx="5148072" cy="2057400"/>
+          </a:xfrm>
+          <a:prstGeom prst="rect">
+            <a:avLst/>
+          </a:prstGeom>
+          <a:noFill/>
+          <a:ln/>
+        </p:spPr>
+        <p:txBody>
+          <a:bodyPr wrap="square" lIns="0" tIns="0" rIns="0" bIns="0" rtlCol="0" anchor="ctr"/>
+          <a:lstStyle/>
+          <a:p>
+            <a:pPr indent="0" marL="0">
+              <a:lnSpc>
+                <a:spcPct val="115000"/>
+              </a:lnSpc>
+              <a:buNone/>
+            </a:pPr>
+            <a:r>
+              <a:rPr lang="en-US" sz="1900" b="1" u="sng" dirty="0">
+                <a:solidFill>
+                  <a:srgbClr val="1B2A41"/>
+                </a:solidFill>
+                <a:latin typeface="Calibri" pitchFamily="34" charset="0"/>
+                <a:ea typeface="Calibri" pitchFamily="34" charset="-122"/>
+                <a:cs typeface="Calibri" pitchFamily="34" charset="-120"/>
+              </a:rPr>
+              <a:t>Their very first case, a desperate one, recovered immediately and became A.A. number three.</a:t>
+            </a:r>
+            <a:pPr indent="0" marL="0">
+              <a:lnSpc>
+                <a:spcPct val="115000"/>
+              </a:lnSpc>
+              <a:buNone/>
+            </a:pPr>
+            <a:r>
+              <a:rPr lang="en-US" sz="1900" dirty="0">
+                <a:solidFill>
+                  <a:srgbClr val="1B2A41"/>
+                </a:solidFill>
+                <a:latin typeface="Calibri" pitchFamily="34" charset="0"/>
+                <a:ea typeface="Calibri" pitchFamily="34" charset="-122"/>
+                <a:cs typeface="Calibri" pitchFamily="34" charset="-120"/>
+              </a:rPr>
+              <a:t> He never had another drink.</a:t>
+            </a:r>
+            <a:endParaRPr lang="en-US" sz="1900" dirty="0"/>
+          </a:p>
+        </p:txBody>
+      </p:sp>
+      <p:sp>
+        <p:nvSpPr>
+          <p:cNvPr id="10" name="Shape 8"/>
+          <p:cNvSpPr/>
+          <p:nvPr/>
+        </p:nvSpPr>
+        <p:spPr>
+          <a:xfrm>
+            <a:off x="5760720" y="3703320"/>
+            <a:ext cx="5879592" cy="1417320"/>
+          </a:xfrm>
+          <a:prstGeom prst="roundRect">
+            <a:avLst>
+              <a:gd name="adj" fmla="val 5161"/>
+            </a:avLst>
+          </a:prstGeom>
+          <a:solidFill>
+            <a:srgbClr val="1B2A41"/>
+          </a:solidFill>
+          <a:ln/>
+        </p:spPr>
+      </p:sp>
+      <p:sp>
+        <p:nvSpPr>
+          <p:cNvPr id="11" name="Text 9"/>
+          <p:cNvSpPr/>
+          <p:nvPr/>
+        </p:nvSpPr>
+        <p:spPr>
+          <a:xfrm>
+            <a:off x="6126480" y="3840480"/>
+            <a:ext cx="5148072" cy="256032"/>
+          </a:xfrm>
+          <a:prstGeom prst="rect">
+            <a:avLst/>
+          </a:prstGeom>
+          <a:noFill/>
+          <a:ln/>
+        </p:spPr>
+        <p:txBody>
+          <a:bodyPr wrap="square" lIns="0" tIns="0" rIns="0" bIns="0" rtlCol="0" anchor="ctr"/>
+          <a:lstStyle/>
+          <a:p>
+            <a:pPr indent="0" marL="0">
+              <a:buNone/>
+            </a:pPr>
+            <a:r>
+              <a:rPr lang="en-US" sz="1100" b="1" spc="200" kern="0" dirty="0">
+                <a:solidFill>
+                  <a:srgbClr val="A9B8CC"/>
+                </a:solidFill>
+                <a:latin typeface="Calibri" pitchFamily="34" charset="0"/>
+                <a:ea typeface="Calibri" pitchFamily="34" charset="-122"/>
+                <a:cs typeface="Calibri" pitchFamily="34" charset="-120"/>
+              </a:rPr>
+              <a:t>MARGIN NOTE</a:t>
+            </a:r>
+            <a:endParaRPr lang="en-US" sz="1100" dirty="0"/>
+          </a:p>
+        </p:txBody>
+      </p:sp>
+      <p:sp>
+        <p:nvSpPr>
+          <p:cNvPr id="12" name="Text 10"/>
+          <p:cNvSpPr/>
+          <p:nvPr/>
+        </p:nvSpPr>
+        <p:spPr>
+          <a:xfrm>
+            <a:off x="6126480" y="4133088"/>
+            <a:ext cx="5148072" cy="777240"/>
+          </a:xfrm>
+          <a:prstGeom prst="rect">
+            <a:avLst/>
+          </a:prstGeom>
+          <a:noFill/>
+          <a:ln/>
+        </p:spPr>
+        <p:txBody>
+          <a:bodyPr wrap="square" lIns="0" tIns="0" rIns="0" bIns="0" rtlCol="0" anchor="ctr"/>
+          <a:lstStyle/>
+          <a:p>
+            <a:pPr indent="0" marL="0">
+              <a:buNone/>
+            </a:pPr>
+            <a:r>
+              <a:rPr lang="en-US" sz="2200" b="1" dirty="0">
+                <a:solidFill>
+                  <a:srgbClr val="FFFFFF"/>
+                </a:solidFill>
+                <a:latin typeface="Cambria" pitchFamily="34" charset="0"/>
+                <a:ea typeface="Cambria" pitchFamily="34" charset="-122"/>
+                <a:cs typeface="Cambria" pitchFamily="34" charset="-120"/>
+              </a:rPr>
+              <a:t>Bill D. — A.A. Number Three</a:t>
+            </a:r>
+            <a:endParaRPr lang="en-US" sz="2200" dirty="0"/>
+          </a:p>
+        </p:txBody>
+      </p:sp>
+      <p:sp>
+        <p:nvSpPr>
+          <p:cNvPr id="13" name="Text 11"/>
+          <p:cNvSpPr/>
+          <p:nvPr/>
+        </p:nvSpPr>
+        <p:spPr>
+          <a:xfrm>
+            <a:off x="548640" y="5349240"/>
+            <a:ext cx="11091672" cy="292608"/>
+          </a:xfrm>
+          <a:prstGeom prst="rect">
+            <a:avLst/>
+          </a:prstGeom>
+          <a:noFill/>
+          <a:ln/>
+        </p:spPr>
+        <p:txBody>
+          <a:bodyPr wrap="square" lIns="0" tIns="0" rIns="0" bIns="0" rtlCol="0" anchor="ctr"/>
+          <a:lstStyle/>
+          <a:p>
+            <a:pPr indent="0" marL="0">
+              <a:buNone/>
+            </a:pPr>
+            <a:r>
+              <a:rPr lang="en-US" sz="1200" i="1" dirty="0">
+                <a:solidFill>
+                  <a:srgbClr val="6B7A8C"/>
+                </a:solidFill>
+                <a:latin typeface="Calibri" pitchFamily="34" charset="0"/>
+                <a:ea typeface="Calibri" pitchFamily="34" charset="-122"/>
+                <a:cs typeface="Calibri" pitchFamily="34" charset="-120"/>
+              </a:rPr>
+              <a:t>Alcoholics Anonymous</a:t>
+            </a:r>
+            <a:pPr indent="0" marL="0">
+              <a:buNone/>
+            </a:pPr>
+            <a:r>
+              <a:rPr lang="en-US" sz="1200" dirty="0">
+                <a:solidFill>
+                  <a:srgbClr val="6B7A8C"/>
+                </a:solidFill>
+                <a:latin typeface="Calibri" pitchFamily="34" charset="0"/>
+                <a:ea typeface="Calibri" pitchFamily="34" charset="-122"/>
+                <a:cs typeface="Calibri" pitchFamily="34" charset="-120"/>
+              </a:rPr>
+              <a:t>, 4th ed., Foreword to the Second Edition, p. xiii.</a:t>
+            </a:r>
+            <a:endParaRPr lang="en-US" sz="1200" dirty="0"/>
+          </a:p>
+        </p:txBody>
+      </p:sp>
+      <p:sp>
+        <p:nvSpPr>
+          <p:cNvPr id="14" name="Text 12"/>
+          <p:cNvSpPr/>
+          <p:nvPr/>
+        </p:nvSpPr>
+        <p:spPr>
+          <a:xfrm>
+            <a:off x="548640" y="6355080"/>
+            <a:ext cx="11091672" cy="292608"/>
+          </a:xfrm>
+          <a:prstGeom prst="rect">
+            <a:avLst/>
+          </a:prstGeom>
+          <a:noFill/>
+          <a:ln/>
+        </p:spPr>
+        <p:txBody>
+          <a:bodyPr wrap="square" lIns="0" tIns="0" rIns="0" bIns="0" rtlCol="0" anchor="ctr"/>
+          <a:lstStyle/>
+          <a:p>
+            <a:pPr indent="0" marL="0">
+              <a:buNone/>
+            </a:pPr>
+            <a:r>
+              <a:rPr lang="en-US" sz="950" dirty="0">
+                <a:solidFill>
+                  <a:srgbClr val="6B7A8C"/>
+                </a:solidFill>
+                <a:latin typeface="Calibri" pitchFamily="34" charset="0"/>
+                <a:ea typeface="Calibri" pitchFamily="34" charset="-122"/>
+                <a:cs typeface="Calibri" pitchFamily="34" charset="-120"/>
+              </a:rPr>
+              <a:t>Copyright © Alcoholics Anonymous World Services, Inc. All rights reserved. Intended for personal use only, and not to be reproduced further or distributed for resale.</a:t>
+            </a:r>
+            <a:endParaRPr lang="en-US" sz="950" dirty="0"/>
+          </a:p>
+        </p:txBody>
+      </p:sp>
+    </p:spTree>
+  </p:cSld>
+  <p:clrMapOvr>
+    <a:masterClrMapping/>
+  </p:clrMapOvr>
+</p:sld>
+</file>
+
 <file path=ppt/slides/slide2.xml><?xml version="1.0" encoding="utf-8"?>
 <p:sld xmlns:a="http://schemas.openxmlformats.org/drawingml/2006/main" xmlns:r="http://schemas.openxmlformats.org/officeDocument/2006/relationships" xmlns:p="http://schemas.openxmlformats.org/presentationml/2006/main">
   <p:cSld name="Slide 2">
@@ -4892,6 +5971,2032 @@
       <p:sp>
         <p:nvSpPr>
           <p:cNvPr id="14" name="Text 12"/>
+          <p:cNvSpPr/>
+          <p:nvPr/>
+        </p:nvSpPr>
+        <p:spPr>
+          <a:xfrm>
+            <a:off x="548640" y="6355080"/>
+            <a:ext cx="11091672" cy="292608"/>
+          </a:xfrm>
+          <a:prstGeom prst="rect">
+            <a:avLst/>
+          </a:prstGeom>
+          <a:noFill/>
+          <a:ln/>
+        </p:spPr>
+        <p:txBody>
+          <a:bodyPr wrap="square" lIns="0" tIns="0" rIns="0" bIns="0" rtlCol="0" anchor="ctr"/>
+          <a:lstStyle/>
+          <a:p>
+            <a:pPr indent="0" marL="0">
+              <a:buNone/>
+            </a:pPr>
+            <a:r>
+              <a:rPr lang="en-US" sz="950" dirty="0">
+                <a:solidFill>
+                  <a:srgbClr val="6B7A8C"/>
+                </a:solidFill>
+                <a:latin typeface="Calibri" pitchFamily="34" charset="0"/>
+                <a:ea typeface="Calibri" pitchFamily="34" charset="-122"/>
+                <a:cs typeface="Calibri" pitchFamily="34" charset="-120"/>
+              </a:rPr>
+              <a:t>Copyright © Alcoholics Anonymous World Services, Inc. All rights reserved. Intended for personal use only, and not to be reproduced further or distributed for resale.</a:t>
+            </a:r>
+            <a:endParaRPr lang="en-US" sz="950" dirty="0"/>
+          </a:p>
+        </p:txBody>
+      </p:sp>
+    </p:spTree>
+  </p:cSld>
+  <p:clrMapOvr>
+    <a:masterClrMapping/>
+  </p:clrMapOvr>
+</p:sld>
+</file>
+
+<file path=ppt/slides/slide6.xml><?xml version="1.0" encoding="utf-8"?>
+<p:sld xmlns:a="http://schemas.openxmlformats.org/drawingml/2006/main" xmlns:r="http://schemas.openxmlformats.org/officeDocument/2006/relationships" xmlns:p="http://schemas.openxmlformats.org/presentationml/2006/main">
+  <p:cSld name="Slide 6">
+    <p:bg>
+      <p:bgPr>
+        <a:solidFill>
+          <a:srgbClr val="FFFFFF"/>
+        </a:solidFill>
+      </p:bgPr>
+    </p:bg>
+    <p:spTree>
+      <p:nvGrpSpPr>
+        <p:cNvPr id="1" name=""/>
+        <p:cNvGrpSpPr/>
+        <p:nvPr/>
+      </p:nvGrpSpPr>
+      <p:grpSpPr>
+        <a:xfrm>
+          <a:off x="0" y="0"/>
+          <a:ext cx="0" cy="0"/>
+          <a:chOff x="0" y="0"/>
+          <a:chExt cx="0" cy="0"/>
+        </a:xfrm>
+      </p:grpSpPr>
+      <p:sp>
+        <p:nvSpPr>
+          <p:cNvPr id="2" name="Text 0"/>
+          <p:cNvSpPr/>
+          <p:nvPr/>
+        </p:nvSpPr>
+        <p:spPr>
+          <a:xfrm>
+            <a:off x="548640" y="320040"/>
+            <a:ext cx="8138160" cy="566928"/>
+          </a:xfrm>
+          <a:prstGeom prst="rect">
+            <a:avLst/>
+          </a:prstGeom>
+          <a:noFill/>
+          <a:ln/>
+        </p:spPr>
+        <p:txBody>
+          <a:bodyPr wrap="square" lIns="0" tIns="0" rIns="0" bIns="0" rtlCol="0" anchor="ctr"/>
+          <a:lstStyle/>
+          <a:p>
+            <a:pPr indent="0" marL="0">
+              <a:buNone/>
+            </a:pPr>
+            <a:r>
+              <a:rPr lang="en-US" sz="3800" b="1" dirty="0">
+                <a:solidFill>
+                  <a:srgbClr val="1B2A41"/>
+                </a:solidFill>
+                <a:latin typeface="Cambria" pitchFamily="34" charset="0"/>
+                <a:ea typeface="Cambria" pitchFamily="34" charset="-122"/>
+                <a:cs typeface="Cambria" pitchFamily="34" charset="-120"/>
+              </a:rPr>
+              <a:t>The Spark</a:t>
+            </a:r>
+            <a:endParaRPr lang="en-US" sz="3800" dirty="0"/>
+          </a:p>
+        </p:txBody>
+      </p:sp>
+      <p:sp>
+        <p:nvSpPr>
+          <p:cNvPr id="3" name="Text 1"/>
+          <p:cNvSpPr/>
+          <p:nvPr/>
+        </p:nvSpPr>
+        <p:spPr>
+          <a:xfrm>
+            <a:off x="548640" y="914400"/>
+            <a:ext cx="8138160" cy="347472"/>
+          </a:xfrm>
+          <a:prstGeom prst="rect">
+            <a:avLst/>
+          </a:prstGeom>
+          <a:noFill/>
+          <a:ln/>
+        </p:spPr>
+        <p:txBody>
+          <a:bodyPr wrap="square" lIns="0" tIns="0" rIns="0" bIns="0" rtlCol="0" anchor="ctr"/>
+          <a:lstStyle/>
+          <a:p>
+            <a:pPr indent="0" marL="0">
+              <a:buNone/>
+            </a:pPr>
+            <a:r>
+              <a:rPr lang="en-US" sz="1700" i="1" dirty="0">
+                <a:solidFill>
+                  <a:srgbClr val="6B7A8C"/>
+                </a:solidFill>
+                <a:latin typeface="Calibri" pitchFamily="34" charset="0"/>
+                <a:ea typeface="Calibri" pitchFamily="34" charset="-122"/>
+                <a:cs typeface="Calibri" pitchFamily="34" charset="-120"/>
+              </a:rPr>
+              <a:t>Akron, Ohio — June 1935.</a:t>
+            </a:r>
+            <a:endParaRPr lang="en-US" sz="1700" dirty="0"/>
+          </a:p>
+        </p:txBody>
+      </p:sp>
+      <p:sp>
+        <p:nvSpPr>
+          <p:cNvPr id="4" name="Shape 2"/>
+          <p:cNvSpPr/>
+          <p:nvPr/>
+        </p:nvSpPr>
+        <p:spPr>
+          <a:xfrm>
+            <a:off x="8869680" y="320040"/>
+            <a:ext cx="2770632" cy="960120"/>
+          </a:xfrm>
+          <a:prstGeom prst="roundRect">
+            <a:avLst>
+              <a:gd name="adj" fmla="val 9524"/>
+            </a:avLst>
+          </a:prstGeom>
+          <a:solidFill>
+            <a:srgbClr val="065A82"/>
+          </a:solidFill>
+          <a:ln/>
+        </p:spPr>
+      </p:sp>
+      <p:sp>
+        <p:nvSpPr>
+          <p:cNvPr id="5" name="Text 3"/>
+          <p:cNvSpPr/>
+          <p:nvPr/>
+        </p:nvSpPr>
+        <p:spPr>
+          <a:xfrm>
+            <a:off x="8869680" y="320040"/>
+            <a:ext cx="2770632" cy="960120"/>
+          </a:xfrm>
+          <a:prstGeom prst="rect">
+            <a:avLst/>
+          </a:prstGeom>
+          <a:noFill/>
+          <a:ln/>
+        </p:spPr>
+        <p:txBody>
+          <a:bodyPr wrap="square" lIns="0" tIns="0" rIns="0" bIns="0" rtlCol="0" anchor="ctr"/>
+          <a:lstStyle/>
+          <a:p>
+            <a:pPr algn="ctr" indent="0" marL="0">
+              <a:buNone/>
+            </a:pPr>
+            <a:r>
+              <a:rPr lang="en-US" sz="1700" b="1" spc="100" kern="0" dirty="0">
+                <a:solidFill>
+                  <a:srgbClr val="FFFFFF"/>
+                </a:solidFill>
+                <a:latin typeface="Cambria" pitchFamily="34" charset="0"/>
+                <a:ea typeface="Cambria" pitchFamily="34" charset="-122"/>
+                <a:cs typeface="Cambria" pitchFamily="34" charset="-120"/>
+              </a:rPr>
+              <a:t>FOREWORD</a:t>
+            </a:r>
+            <a:endParaRPr lang="en-US" sz="1700" dirty="0"/>
+          </a:p>
+          <a:p>
+            <a:pPr algn="ctr" indent="0" marL="0">
+              <a:buNone/>
+            </a:pPr>
+            <a:r>
+              <a:rPr lang="en-US" sz="1300" dirty="0">
+                <a:solidFill>
+                  <a:srgbClr val="C7DEEC"/>
+                </a:solidFill>
+                <a:latin typeface="Calibri" pitchFamily="34" charset="0"/>
+                <a:ea typeface="Calibri" pitchFamily="34" charset="-122"/>
+                <a:cs typeface="Calibri" pitchFamily="34" charset="-120"/>
+              </a:rPr>
+              <a:t>Second Ed.  ·  p. xi</a:t>
+            </a:r>
+            <a:endParaRPr lang="en-US" sz="1700" dirty="0"/>
+          </a:p>
+        </p:txBody>
+      </p:sp>
+      <p:sp>
+        <p:nvSpPr>
+          <p:cNvPr id="6" name="Shape 4"/>
+          <p:cNvSpPr/>
+          <p:nvPr/>
+        </p:nvSpPr>
+        <p:spPr>
+          <a:xfrm>
+            <a:off x="548640" y="1463040"/>
+            <a:ext cx="11091672" cy="2103120"/>
+          </a:xfrm>
+          <a:prstGeom prst="roundRect">
+            <a:avLst>
+              <a:gd name="adj" fmla="val 3478"/>
+            </a:avLst>
+          </a:prstGeom>
+          <a:solidFill>
+            <a:srgbClr val="E2EDF4"/>
+          </a:solidFill>
+          <a:ln/>
+        </p:spPr>
+      </p:sp>
+      <p:sp>
+        <p:nvSpPr>
+          <p:cNvPr id="7" name="Text 5"/>
+          <p:cNvSpPr/>
+          <p:nvPr/>
+        </p:nvSpPr>
+        <p:spPr>
+          <a:xfrm>
+            <a:off x="914400" y="1463040"/>
+            <a:ext cx="10360152" cy="2103120"/>
+          </a:xfrm>
+          <a:prstGeom prst="rect">
+            <a:avLst/>
+          </a:prstGeom>
+          <a:noFill/>
+          <a:ln/>
+        </p:spPr>
+        <p:txBody>
+          <a:bodyPr wrap="square" lIns="0" tIns="0" rIns="0" bIns="0" rtlCol="0" anchor="ctr"/>
+          <a:lstStyle/>
+          <a:p>
+            <a:pPr indent="0" marL="0">
+              <a:lnSpc>
+                <a:spcPct val="115000"/>
+              </a:lnSpc>
+              <a:buNone/>
+            </a:pPr>
+            <a:r>
+              <a:rPr lang="en-US" sz="2100" dirty="0">
+                <a:solidFill>
+                  <a:srgbClr val="1B2A41"/>
+                </a:solidFill>
+                <a:latin typeface="Calibri" pitchFamily="34" charset="0"/>
+                <a:ea typeface="Calibri" pitchFamily="34" charset="-122"/>
+                <a:cs typeface="Calibri" pitchFamily="34" charset="-120"/>
+              </a:rPr>
+              <a:t>The spark that was to flare into the first A.A. group was struck at Akron, Ohio, in June 1935, during a talk between a New York stockbroker and an Akron physician. Six months earlier, the broker had been relieved of his drink obsession by a sudden spiritual experience, following a meeting with an alcoholic friend who had been in contact with the Oxford Groups of that day.</a:t>
+            </a:r>
+            <a:endParaRPr lang="en-US" sz="2100" dirty="0"/>
+          </a:p>
+        </p:txBody>
+      </p:sp>
+      <p:sp>
+        <p:nvSpPr>
+          <p:cNvPr id="8" name="Shape 6"/>
+          <p:cNvSpPr/>
+          <p:nvPr/>
+        </p:nvSpPr>
+        <p:spPr>
+          <a:xfrm>
+            <a:off x="548640" y="3840480"/>
+            <a:ext cx="11091672" cy="1234440"/>
+          </a:xfrm>
+          <a:prstGeom prst="roundRect">
+            <a:avLst>
+              <a:gd name="adj" fmla="val 5926"/>
+            </a:avLst>
+          </a:prstGeom>
+          <a:solidFill>
+            <a:srgbClr val="1B2A41"/>
+          </a:solidFill>
+          <a:ln/>
+        </p:spPr>
+      </p:sp>
+      <p:sp>
+        <p:nvSpPr>
+          <p:cNvPr id="9" name="Text 7"/>
+          <p:cNvSpPr/>
+          <p:nvPr/>
+        </p:nvSpPr>
+        <p:spPr>
+          <a:xfrm>
+            <a:off x="914400" y="3959352"/>
+            <a:ext cx="10360152" cy="256032"/>
+          </a:xfrm>
+          <a:prstGeom prst="rect">
+            <a:avLst/>
+          </a:prstGeom>
+          <a:noFill/>
+          <a:ln/>
+        </p:spPr>
+        <p:txBody>
+          <a:bodyPr wrap="square" lIns="0" tIns="0" rIns="0" bIns="0" rtlCol="0" anchor="ctr"/>
+          <a:lstStyle/>
+          <a:p>
+            <a:pPr indent="0" marL="0">
+              <a:buNone/>
+            </a:pPr>
+            <a:r>
+              <a:rPr lang="en-US" sz="1100" b="1" spc="200" kern="0" dirty="0">
+                <a:solidFill>
+                  <a:srgbClr val="A9B8CC"/>
+                </a:solidFill>
+                <a:latin typeface="Calibri" pitchFamily="34" charset="0"/>
+                <a:ea typeface="Calibri" pitchFamily="34" charset="-122"/>
+                <a:cs typeface="Calibri" pitchFamily="34" charset="-120"/>
+              </a:rPr>
+              <a:t>MARGIN NOTE</a:t>
+            </a:r>
+            <a:endParaRPr lang="en-US" sz="1100" dirty="0"/>
+          </a:p>
+        </p:txBody>
+      </p:sp>
+      <p:sp>
+        <p:nvSpPr>
+          <p:cNvPr id="10" name="Text 8"/>
+          <p:cNvSpPr/>
+          <p:nvPr/>
+        </p:nvSpPr>
+        <p:spPr>
+          <a:xfrm>
+            <a:off x="914400" y="4233672"/>
+            <a:ext cx="10360152" cy="722376"/>
+          </a:xfrm>
+          <a:prstGeom prst="rect">
+            <a:avLst/>
+          </a:prstGeom>
+          <a:noFill/>
+          <a:ln/>
+        </p:spPr>
+        <p:txBody>
+          <a:bodyPr wrap="square" lIns="0" tIns="0" rIns="0" bIns="0" rtlCol="0" anchor="ctr"/>
+          <a:lstStyle/>
+          <a:p>
+            <a:pPr indent="0" marL="0">
+              <a:buNone/>
+            </a:pPr>
+            <a:r>
+              <a:rPr lang="en-US" sz="2200" b="1" dirty="0">
+                <a:solidFill>
+                  <a:srgbClr val="FFFFFF"/>
+                </a:solidFill>
+                <a:latin typeface="Cambria" pitchFamily="34" charset="0"/>
+                <a:ea typeface="Cambria" pitchFamily="34" charset="-122"/>
+                <a:cs typeface="Cambria" pitchFamily="34" charset="-120"/>
+              </a:rPr>
+              <a:t>Tell the history from Roland.</a:t>
+            </a:r>
+            <a:endParaRPr lang="en-US" sz="2200" dirty="0"/>
+          </a:p>
+        </p:txBody>
+      </p:sp>
+      <p:sp>
+        <p:nvSpPr>
+          <p:cNvPr id="11" name="Text 9"/>
+          <p:cNvSpPr/>
+          <p:nvPr/>
+        </p:nvSpPr>
+        <p:spPr>
+          <a:xfrm>
+            <a:off x="548640" y="5257800"/>
+            <a:ext cx="11091672" cy="292608"/>
+          </a:xfrm>
+          <a:prstGeom prst="rect">
+            <a:avLst/>
+          </a:prstGeom>
+          <a:noFill/>
+          <a:ln/>
+        </p:spPr>
+        <p:txBody>
+          <a:bodyPr wrap="square" lIns="0" tIns="0" rIns="0" bIns="0" rtlCol="0" anchor="ctr"/>
+          <a:lstStyle/>
+          <a:p>
+            <a:pPr indent="0" marL="0">
+              <a:buNone/>
+            </a:pPr>
+            <a:r>
+              <a:rPr lang="en-US" sz="1200" i="1" dirty="0">
+                <a:solidFill>
+                  <a:srgbClr val="6B7A8C"/>
+                </a:solidFill>
+                <a:latin typeface="Calibri" pitchFamily="34" charset="0"/>
+                <a:ea typeface="Calibri" pitchFamily="34" charset="-122"/>
+                <a:cs typeface="Calibri" pitchFamily="34" charset="-120"/>
+              </a:rPr>
+              <a:t>Alcoholics Anonymous</a:t>
+            </a:r>
+            <a:pPr indent="0" marL="0">
+              <a:buNone/>
+            </a:pPr>
+            <a:r>
+              <a:rPr lang="en-US" sz="1200" dirty="0">
+                <a:solidFill>
+                  <a:srgbClr val="6B7A8C"/>
+                </a:solidFill>
+                <a:latin typeface="Calibri" pitchFamily="34" charset="0"/>
+                <a:ea typeface="Calibri" pitchFamily="34" charset="-122"/>
+                <a:cs typeface="Calibri" pitchFamily="34" charset="-120"/>
+              </a:rPr>
+              <a:t>, 4th ed., Foreword to the Second Edition, pp. xi–xii.</a:t>
+            </a:r>
+            <a:endParaRPr lang="en-US" sz="1200" dirty="0"/>
+          </a:p>
+        </p:txBody>
+      </p:sp>
+      <p:sp>
+        <p:nvSpPr>
+          <p:cNvPr id="12" name="Text 10"/>
+          <p:cNvSpPr/>
+          <p:nvPr/>
+        </p:nvSpPr>
+        <p:spPr>
+          <a:xfrm>
+            <a:off x="548640" y="6355080"/>
+            <a:ext cx="11091672" cy="292608"/>
+          </a:xfrm>
+          <a:prstGeom prst="rect">
+            <a:avLst/>
+          </a:prstGeom>
+          <a:noFill/>
+          <a:ln/>
+        </p:spPr>
+        <p:txBody>
+          <a:bodyPr wrap="square" lIns="0" tIns="0" rIns="0" bIns="0" rtlCol="0" anchor="ctr"/>
+          <a:lstStyle/>
+          <a:p>
+            <a:pPr indent="0" marL="0">
+              <a:buNone/>
+            </a:pPr>
+            <a:r>
+              <a:rPr lang="en-US" sz="950" dirty="0">
+                <a:solidFill>
+                  <a:srgbClr val="6B7A8C"/>
+                </a:solidFill>
+                <a:latin typeface="Calibri" pitchFamily="34" charset="0"/>
+                <a:ea typeface="Calibri" pitchFamily="34" charset="-122"/>
+                <a:cs typeface="Calibri" pitchFamily="34" charset="-120"/>
+              </a:rPr>
+              <a:t>Copyright © Alcoholics Anonymous World Services, Inc. All rights reserved. Intended for personal use only, and not to be reproduced further or distributed for resale.</a:t>
+            </a:r>
+            <a:endParaRPr lang="en-US" sz="950" dirty="0"/>
+          </a:p>
+        </p:txBody>
+      </p:sp>
+    </p:spTree>
+  </p:cSld>
+  <p:clrMapOvr>
+    <a:masterClrMapping/>
+  </p:clrMapOvr>
+</p:sld>
+</file>
+
+<file path=ppt/slides/slide7.xml><?xml version="1.0" encoding="utf-8"?>
+<p:sld xmlns:a="http://schemas.openxmlformats.org/drawingml/2006/main" xmlns:r="http://schemas.openxmlformats.org/officeDocument/2006/relationships" xmlns:p="http://schemas.openxmlformats.org/presentationml/2006/main">
+  <p:cSld name="Slide 7">
+    <p:bg>
+      <p:bgPr>
+        <a:solidFill>
+          <a:srgbClr val="FFFFFF"/>
+        </a:solidFill>
+      </p:bgPr>
+    </p:bg>
+    <p:spTree>
+      <p:nvGrpSpPr>
+        <p:cNvPr id="1" name=""/>
+        <p:cNvGrpSpPr/>
+        <p:nvPr/>
+      </p:nvGrpSpPr>
+      <p:grpSpPr>
+        <a:xfrm>
+          <a:off x="0" y="0"/>
+          <a:ext cx="0" cy="0"/>
+          <a:chOff x="0" y="0"/>
+          <a:chExt cx="0" cy="0"/>
+        </a:xfrm>
+      </p:grpSpPr>
+      <p:sp>
+        <p:nvSpPr>
+          <p:cNvPr id="2" name="Text 0"/>
+          <p:cNvSpPr/>
+          <p:nvPr/>
+        </p:nvSpPr>
+        <p:spPr>
+          <a:xfrm>
+            <a:off x="548640" y="320040"/>
+            <a:ext cx="8138160" cy="566928"/>
+          </a:xfrm>
+          <a:prstGeom prst="rect">
+            <a:avLst/>
+          </a:prstGeom>
+          <a:noFill/>
+          <a:ln/>
+        </p:spPr>
+        <p:txBody>
+          <a:bodyPr wrap="square" lIns="0" tIns="0" rIns="0" bIns="0" rtlCol="0" anchor="ctr"/>
+          <a:lstStyle/>
+          <a:p>
+            <a:pPr indent="0" marL="0">
+              <a:buNone/>
+            </a:pPr>
+            <a:r>
+              <a:rPr lang="en-US" sz="3800" b="1" dirty="0">
+                <a:solidFill>
+                  <a:srgbClr val="1B2A41"/>
+                </a:solidFill>
+                <a:latin typeface="Cambria" pitchFamily="34" charset="0"/>
+                <a:ea typeface="Cambria" pitchFamily="34" charset="-122"/>
+                <a:cs typeface="Cambria" pitchFamily="34" charset="-120"/>
+              </a:rPr>
+              <a:t>The Grave Nature of Alcoholism</a:t>
+            </a:r>
+            <a:endParaRPr lang="en-US" sz="3800" dirty="0"/>
+          </a:p>
+        </p:txBody>
+      </p:sp>
+      <p:sp>
+        <p:nvSpPr>
+          <p:cNvPr id="3" name="Text 1"/>
+          <p:cNvSpPr/>
+          <p:nvPr/>
+        </p:nvSpPr>
+        <p:spPr>
+          <a:xfrm>
+            <a:off x="548640" y="914400"/>
+            <a:ext cx="8138160" cy="347472"/>
+          </a:xfrm>
+          <a:prstGeom prst="rect">
+            <a:avLst/>
+          </a:prstGeom>
+          <a:noFill/>
+          <a:ln/>
+        </p:spPr>
+        <p:txBody>
+          <a:bodyPr wrap="square" lIns="0" tIns="0" rIns="0" bIns="0" rtlCol="0" anchor="ctr"/>
+          <a:lstStyle/>
+          <a:p>
+            <a:pPr indent="0" marL="0">
+              <a:buNone/>
+            </a:pPr>
+            <a:r>
+              <a:rPr lang="en-US" sz="1700" i="1" dirty="0">
+                <a:solidFill>
+                  <a:srgbClr val="6B7A8C"/>
+                </a:solidFill>
+                <a:latin typeface="Calibri" pitchFamily="34" charset="0"/>
+                <a:ea typeface="Calibri" pitchFamily="34" charset="-122"/>
+                <a:cs typeface="Calibri" pitchFamily="34" charset="-120"/>
+              </a:rPr>
+              <a:t>What the broker had already learned.</a:t>
+            </a:r>
+            <a:endParaRPr lang="en-US" sz="1700" dirty="0"/>
+          </a:p>
+        </p:txBody>
+      </p:sp>
+      <p:sp>
+        <p:nvSpPr>
+          <p:cNvPr id="4" name="Shape 2"/>
+          <p:cNvSpPr/>
+          <p:nvPr/>
+        </p:nvSpPr>
+        <p:spPr>
+          <a:xfrm>
+            <a:off x="8869680" y="320040"/>
+            <a:ext cx="2770632" cy="960120"/>
+          </a:xfrm>
+          <a:prstGeom prst="roundRect">
+            <a:avLst>
+              <a:gd name="adj" fmla="val 9524"/>
+            </a:avLst>
+          </a:prstGeom>
+          <a:solidFill>
+            <a:srgbClr val="065A82"/>
+          </a:solidFill>
+          <a:ln/>
+        </p:spPr>
+      </p:sp>
+      <p:sp>
+        <p:nvSpPr>
+          <p:cNvPr id="5" name="Text 3"/>
+          <p:cNvSpPr/>
+          <p:nvPr/>
+        </p:nvSpPr>
+        <p:spPr>
+          <a:xfrm>
+            <a:off x="8869680" y="320040"/>
+            <a:ext cx="2770632" cy="960120"/>
+          </a:xfrm>
+          <a:prstGeom prst="rect">
+            <a:avLst/>
+          </a:prstGeom>
+          <a:noFill/>
+          <a:ln/>
+        </p:spPr>
+        <p:txBody>
+          <a:bodyPr wrap="square" lIns="0" tIns="0" rIns="0" bIns="0" rtlCol="0" anchor="ctr"/>
+          <a:lstStyle/>
+          <a:p>
+            <a:pPr algn="ctr" indent="0" marL="0">
+              <a:buNone/>
+            </a:pPr>
+            <a:r>
+              <a:rPr lang="en-US" sz="1700" b="1" spc="100" kern="0" dirty="0">
+                <a:solidFill>
+                  <a:srgbClr val="FFFFFF"/>
+                </a:solidFill>
+                <a:latin typeface="Cambria" pitchFamily="34" charset="0"/>
+                <a:ea typeface="Cambria" pitchFamily="34" charset="-122"/>
+                <a:cs typeface="Cambria" pitchFamily="34" charset="-120"/>
+              </a:rPr>
+              <a:t>FOREWORD</a:t>
+            </a:r>
+            <a:endParaRPr lang="en-US" sz="1700" dirty="0"/>
+          </a:p>
+          <a:p>
+            <a:pPr algn="ctr" indent="0" marL="0">
+              <a:buNone/>
+            </a:pPr>
+            <a:r>
+              <a:rPr lang="en-US" sz="1300" dirty="0">
+                <a:solidFill>
+                  <a:srgbClr val="C7DEEC"/>
+                </a:solidFill>
+                <a:latin typeface="Calibri" pitchFamily="34" charset="0"/>
+                <a:ea typeface="Calibri" pitchFamily="34" charset="-122"/>
+                <a:cs typeface="Calibri" pitchFamily="34" charset="-120"/>
+              </a:rPr>
+              <a:t>Second Ed.  ·  p. xii</a:t>
+            </a:r>
+            <a:endParaRPr lang="en-US" sz="1700" dirty="0"/>
+          </a:p>
+        </p:txBody>
+      </p:sp>
+      <p:sp>
+        <p:nvSpPr>
+          <p:cNvPr id="6" name="Shape 4"/>
+          <p:cNvSpPr/>
+          <p:nvPr/>
+        </p:nvSpPr>
+        <p:spPr>
+          <a:xfrm>
+            <a:off x="548640" y="1417320"/>
+            <a:ext cx="11091672" cy="1783080"/>
+          </a:xfrm>
+          <a:prstGeom prst="roundRect">
+            <a:avLst>
+              <a:gd name="adj" fmla="val 4103"/>
+            </a:avLst>
+          </a:prstGeom>
+          <a:solidFill>
+            <a:srgbClr val="E2EDF4"/>
+          </a:solidFill>
+          <a:ln/>
+        </p:spPr>
+      </p:sp>
+      <p:sp>
+        <p:nvSpPr>
+          <p:cNvPr id="7" name="Text 5"/>
+          <p:cNvSpPr/>
+          <p:nvPr/>
+        </p:nvSpPr>
+        <p:spPr>
+          <a:xfrm>
+            <a:off x="914400" y="1417320"/>
+            <a:ext cx="10360152" cy="1783080"/>
+          </a:xfrm>
+          <a:prstGeom prst="rect">
+            <a:avLst/>
+          </a:prstGeom>
+          <a:noFill/>
+          <a:ln/>
+        </p:spPr>
+        <p:txBody>
+          <a:bodyPr wrap="square" lIns="0" tIns="0" rIns="0" bIns="0" rtlCol="0" anchor="ctr"/>
+          <a:lstStyle/>
+          <a:p>
+            <a:pPr indent="0" marL="0">
+              <a:lnSpc>
+                <a:spcPct val="115000"/>
+              </a:lnSpc>
+              <a:buNone/>
+            </a:pPr>
+            <a:r>
+              <a:rPr lang="en-US" sz="1900" dirty="0">
+                <a:solidFill>
+                  <a:srgbClr val="1B2A41"/>
+                </a:solidFill>
+                <a:latin typeface="Calibri" pitchFamily="34" charset="0"/>
+                <a:ea typeface="Calibri" pitchFamily="34" charset="-122"/>
+                <a:cs typeface="Calibri" pitchFamily="34" charset="-120"/>
+              </a:rPr>
+              <a:t>He had also been greatly helped by the late Dr. William D. Silkworth, a New York specialist in alcoholism who is now accounted no less than a medical saint by A.A. members, and whose story of the early days of our Society appears in the next pages. From this doctor, the broker had learned the grave nature of alcoholism.</a:t>
+            </a:r>
+            <a:endParaRPr lang="en-US" sz="1900" dirty="0"/>
+          </a:p>
+        </p:txBody>
+      </p:sp>
+      <p:sp>
+        <p:nvSpPr>
+          <p:cNvPr id="8" name="Shape 6"/>
+          <p:cNvSpPr/>
+          <p:nvPr/>
+        </p:nvSpPr>
+        <p:spPr>
+          <a:xfrm>
+            <a:off x="548640" y="3383280"/>
+            <a:ext cx="11091672" cy="1828800"/>
+          </a:xfrm>
+          <a:prstGeom prst="roundRect">
+            <a:avLst>
+              <a:gd name="adj" fmla="val 4000"/>
+            </a:avLst>
+          </a:prstGeom>
+          <a:solidFill>
+            <a:srgbClr val="E2EDF4"/>
+          </a:solidFill>
+          <a:ln/>
+        </p:spPr>
+      </p:sp>
+      <p:sp>
+        <p:nvSpPr>
+          <p:cNvPr id="9" name="Text 7"/>
+          <p:cNvSpPr/>
+          <p:nvPr/>
+        </p:nvSpPr>
+        <p:spPr>
+          <a:xfrm>
+            <a:off x="914400" y="3383280"/>
+            <a:ext cx="10360152" cy="1828800"/>
+          </a:xfrm>
+          <a:prstGeom prst="rect">
+            <a:avLst/>
+          </a:prstGeom>
+          <a:noFill/>
+          <a:ln/>
+        </p:spPr>
+        <p:txBody>
+          <a:bodyPr wrap="square" lIns="0" tIns="0" rIns="0" bIns="0" rtlCol="0" anchor="ctr"/>
+          <a:lstStyle/>
+          <a:p>
+            <a:pPr indent="0" marL="0">
+              <a:lnSpc>
+                <a:spcPct val="115000"/>
+              </a:lnSpc>
+              <a:buNone/>
+            </a:pPr>
+            <a:r>
+              <a:rPr lang="en-US" sz="1900" dirty="0">
+                <a:solidFill>
+                  <a:srgbClr val="1B2A41"/>
+                </a:solidFill>
+                <a:latin typeface="Calibri" pitchFamily="34" charset="0"/>
+                <a:ea typeface="Calibri" pitchFamily="34" charset="-122"/>
+                <a:cs typeface="Calibri" pitchFamily="34" charset="-120"/>
+              </a:rPr>
+              <a:t>Though he could not accept all the tenets of the Oxford Groups, he was convinced of the need for </a:t>
+            </a:r>
+            <a:pPr indent="0" marL="0">
+              <a:lnSpc>
+                <a:spcPct val="115000"/>
+              </a:lnSpc>
+              <a:buNone/>
+            </a:pPr>
+            <a:r>
+              <a:rPr lang="en-US" sz="1900" b="1" dirty="0">
+                <a:solidFill>
+                  <a:srgbClr val="065A82"/>
+                </a:solidFill>
+                <a:latin typeface="Calibri" pitchFamily="34" charset="0"/>
+                <a:ea typeface="Calibri" pitchFamily="34" charset="-122"/>
+                <a:cs typeface="Calibri" pitchFamily="34" charset="-120"/>
+              </a:rPr>
+              <a:t>moral inventory</a:t>
+            </a:r>
+            <a:pPr indent="0" marL="0">
+              <a:lnSpc>
+                <a:spcPct val="115000"/>
+              </a:lnSpc>
+              <a:buNone/>
+            </a:pPr>
+            <a:r>
+              <a:rPr lang="en-US" sz="1900" dirty="0">
+                <a:solidFill>
+                  <a:srgbClr val="1B2A41"/>
+                </a:solidFill>
+                <a:latin typeface="Calibri" pitchFamily="34" charset="0"/>
+                <a:ea typeface="Calibri" pitchFamily="34" charset="-122"/>
+                <a:cs typeface="Calibri" pitchFamily="34" charset="-120"/>
+              </a:rPr>
+              <a:t>, </a:t>
+            </a:r>
+            <a:pPr indent="0" marL="0">
+              <a:lnSpc>
+                <a:spcPct val="115000"/>
+              </a:lnSpc>
+              <a:buNone/>
+            </a:pPr>
+            <a:r>
+              <a:rPr lang="en-US" sz="1900" b="1" dirty="0">
+                <a:solidFill>
+                  <a:srgbClr val="065A82"/>
+                </a:solidFill>
+                <a:latin typeface="Calibri" pitchFamily="34" charset="0"/>
+                <a:ea typeface="Calibri" pitchFamily="34" charset="-122"/>
+                <a:cs typeface="Calibri" pitchFamily="34" charset="-120"/>
+              </a:rPr>
+              <a:t>confession of personality defects</a:t>
+            </a:r>
+            <a:pPr indent="0" marL="0">
+              <a:lnSpc>
+                <a:spcPct val="115000"/>
+              </a:lnSpc>
+              <a:buNone/>
+            </a:pPr>
+            <a:r>
+              <a:rPr lang="en-US" sz="1900" dirty="0">
+                <a:solidFill>
+                  <a:srgbClr val="1B2A41"/>
+                </a:solidFill>
+                <a:latin typeface="Calibri" pitchFamily="34" charset="0"/>
+                <a:ea typeface="Calibri" pitchFamily="34" charset="-122"/>
+                <a:cs typeface="Calibri" pitchFamily="34" charset="-120"/>
+              </a:rPr>
+              <a:t>, </a:t>
+            </a:r>
+            <a:pPr indent="0" marL="0">
+              <a:lnSpc>
+                <a:spcPct val="115000"/>
+              </a:lnSpc>
+              <a:buNone/>
+            </a:pPr>
+            <a:r>
+              <a:rPr lang="en-US" sz="1900" b="1" dirty="0">
+                <a:solidFill>
+                  <a:srgbClr val="065A82"/>
+                </a:solidFill>
+                <a:latin typeface="Calibri" pitchFamily="34" charset="0"/>
+                <a:ea typeface="Calibri" pitchFamily="34" charset="-122"/>
+                <a:cs typeface="Calibri" pitchFamily="34" charset="-120"/>
+              </a:rPr>
+              <a:t>restitution to those harmed</a:t>
+            </a:r>
+            <a:pPr indent="0" marL="0">
+              <a:lnSpc>
+                <a:spcPct val="115000"/>
+              </a:lnSpc>
+              <a:buNone/>
+            </a:pPr>
+            <a:r>
+              <a:rPr lang="en-US" sz="1900" dirty="0">
+                <a:solidFill>
+                  <a:srgbClr val="1B2A41"/>
+                </a:solidFill>
+                <a:latin typeface="Calibri" pitchFamily="34" charset="0"/>
+                <a:ea typeface="Calibri" pitchFamily="34" charset="-122"/>
+                <a:cs typeface="Calibri" pitchFamily="34" charset="-120"/>
+              </a:rPr>
+              <a:t>, </a:t>
+            </a:r>
+            <a:pPr indent="0" marL="0">
+              <a:lnSpc>
+                <a:spcPct val="115000"/>
+              </a:lnSpc>
+              <a:buNone/>
+            </a:pPr>
+            <a:r>
+              <a:rPr lang="en-US" sz="1900" b="1" dirty="0">
+                <a:solidFill>
+                  <a:srgbClr val="065A82"/>
+                </a:solidFill>
+                <a:latin typeface="Calibri" pitchFamily="34" charset="0"/>
+                <a:ea typeface="Calibri" pitchFamily="34" charset="-122"/>
+                <a:cs typeface="Calibri" pitchFamily="34" charset="-120"/>
+              </a:rPr>
+              <a:t>helpfulness to others</a:t>
+            </a:r>
+            <a:pPr indent="0" marL="0">
+              <a:lnSpc>
+                <a:spcPct val="115000"/>
+              </a:lnSpc>
+              <a:buNone/>
+            </a:pPr>
+            <a:r>
+              <a:rPr lang="en-US" sz="1900" dirty="0">
+                <a:solidFill>
+                  <a:srgbClr val="1B2A41"/>
+                </a:solidFill>
+                <a:latin typeface="Calibri" pitchFamily="34" charset="0"/>
+                <a:ea typeface="Calibri" pitchFamily="34" charset="-122"/>
+                <a:cs typeface="Calibri" pitchFamily="34" charset="-120"/>
+              </a:rPr>
+              <a:t>, and the necessity of </a:t>
+            </a:r>
+            <a:pPr indent="0" marL="0">
+              <a:lnSpc>
+                <a:spcPct val="115000"/>
+              </a:lnSpc>
+              <a:buNone/>
+            </a:pPr>
+            <a:r>
+              <a:rPr lang="en-US" sz="1900" b="1" dirty="0">
+                <a:solidFill>
+                  <a:srgbClr val="065A82"/>
+                </a:solidFill>
+                <a:latin typeface="Calibri" pitchFamily="34" charset="0"/>
+                <a:ea typeface="Calibri" pitchFamily="34" charset="-122"/>
+                <a:cs typeface="Calibri" pitchFamily="34" charset="-120"/>
+              </a:rPr>
+              <a:t>belief in and dependence upon God</a:t>
+            </a:r>
+            <a:pPr indent="0" marL="0">
+              <a:lnSpc>
+                <a:spcPct val="115000"/>
+              </a:lnSpc>
+              <a:buNone/>
+            </a:pPr>
+            <a:r>
+              <a:rPr lang="en-US" sz="1900" dirty="0">
+                <a:solidFill>
+                  <a:srgbClr val="1B2A41"/>
+                </a:solidFill>
+                <a:latin typeface="Calibri" pitchFamily="34" charset="0"/>
+                <a:ea typeface="Calibri" pitchFamily="34" charset="-122"/>
+                <a:cs typeface="Calibri" pitchFamily="34" charset="-120"/>
+              </a:rPr>
+              <a:t>.</a:t>
+            </a:r>
+            <a:endParaRPr lang="en-US" sz="1900" dirty="0"/>
+          </a:p>
+        </p:txBody>
+      </p:sp>
+      <p:sp>
+        <p:nvSpPr>
+          <p:cNvPr id="10" name="Text 8"/>
+          <p:cNvSpPr/>
+          <p:nvPr/>
+        </p:nvSpPr>
+        <p:spPr>
+          <a:xfrm>
+            <a:off x="548640" y="5440680"/>
+            <a:ext cx="11091672" cy="292608"/>
+          </a:xfrm>
+          <a:prstGeom prst="rect">
+            <a:avLst/>
+          </a:prstGeom>
+          <a:noFill/>
+          <a:ln/>
+        </p:spPr>
+        <p:txBody>
+          <a:bodyPr wrap="square" lIns="0" tIns="0" rIns="0" bIns="0" rtlCol="0" anchor="ctr"/>
+          <a:lstStyle/>
+          <a:p>
+            <a:pPr indent="0" marL="0">
+              <a:buNone/>
+            </a:pPr>
+            <a:r>
+              <a:rPr lang="en-US" sz="1200" i="1" dirty="0">
+                <a:solidFill>
+                  <a:srgbClr val="6B7A8C"/>
+                </a:solidFill>
+                <a:latin typeface="Calibri" pitchFamily="34" charset="0"/>
+                <a:ea typeface="Calibri" pitchFamily="34" charset="-122"/>
+                <a:cs typeface="Calibri" pitchFamily="34" charset="-120"/>
+              </a:rPr>
+              <a:t>Alcoholics Anonymous</a:t>
+            </a:r>
+            <a:pPr indent="0" marL="0">
+              <a:buNone/>
+            </a:pPr>
+            <a:r>
+              <a:rPr lang="en-US" sz="1200" dirty="0">
+                <a:solidFill>
+                  <a:srgbClr val="6B7A8C"/>
+                </a:solidFill>
+                <a:latin typeface="Calibri" pitchFamily="34" charset="0"/>
+                <a:ea typeface="Calibri" pitchFamily="34" charset="-122"/>
+                <a:cs typeface="Calibri" pitchFamily="34" charset="-120"/>
+              </a:rPr>
+              <a:t>, 4th ed., Foreword to the Second Edition, p. xii.</a:t>
+            </a:r>
+            <a:endParaRPr lang="en-US" sz="1200" dirty="0"/>
+          </a:p>
+        </p:txBody>
+      </p:sp>
+      <p:sp>
+        <p:nvSpPr>
+          <p:cNvPr id="11" name="Text 9"/>
+          <p:cNvSpPr/>
+          <p:nvPr/>
+        </p:nvSpPr>
+        <p:spPr>
+          <a:xfrm>
+            <a:off x="548640" y="6355080"/>
+            <a:ext cx="11091672" cy="292608"/>
+          </a:xfrm>
+          <a:prstGeom prst="rect">
+            <a:avLst/>
+          </a:prstGeom>
+          <a:noFill/>
+          <a:ln/>
+        </p:spPr>
+        <p:txBody>
+          <a:bodyPr wrap="square" lIns="0" tIns="0" rIns="0" bIns="0" rtlCol="0" anchor="ctr"/>
+          <a:lstStyle/>
+          <a:p>
+            <a:pPr indent="0" marL="0">
+              <a:buNone/>
+            </a:pPr>
+            <a:r>
+              <a:rPr lang="en-US" sz="950" dirty="0">
+                <a:solidFill>
+                  <a:srgbClr val="6B7A8C"/>
+                </a:solidFill>
+                <a:latin typeface="Calibri" pitchFamily="34" charset="0"/>
+                <a:ea typeface="Calibri" pitchFamily="34" charset="-122"/>
+                <a:cs typeface="Calibri" pitchFamily="34" charset="-120"/>
+              </a:rPr>
+              <a:t>Copyright © Alcoholics Anonymous World Services, Inc. All rights reserved. Intended for personal use only, and not to be reproduced further or distributed for resale.</a:t>
+            </a:r>
+            <a:endParaRPr lang="en-US" sz="950" dirty="0"/>
+          </a:p>
+        </p:txBody>
+      </p:sp>
+    </p:spTree>
+  </p:cSld>
+  <p:clrMapOvr>
+    <a:masterClrMapping/>
+  </p:clrMapOvr>
+</p:sld>
+</file>
+
+<file path=ppt/slides/slide8.xml><?xml version="1.0" encoding="utf-8"?>
+<p:sld xmlns:a="http://schemas.openxmlformats.org/drawingml/2006/main" xmlns:r="http://schemas.openxmlformats.org/officeDocument/2006/relationships" xmlns:p="http://schemas.openxmlformats.org/presentationml/2006/main">
+  <p:cSld name="Slide 8">
+    <p:bg>
+      <p:bgPr>
+        <a:solidFill>
+          <a:srgbClr val="FFFFFF"/>
+        </a:solidFill>
+      </p:bgPr>
+    </p:bg>
+    <p:spTree>
+      <p:nvGrpSpPr>
+        <p:cNvPr id="1" name=""/>
+        <p:cNvGrpSpPr/>
+        <p:nvPr/>
+      </p:nvGrpSpPr>
+      <p:grpSpPr>
+        <a:xfrm>
+          <a:off x="0" y="0"/>
+          <a:ext cx="0" cy="0"/>
+          <a:chOff x="0" y="0"/>
+          <a:chExt cx="0" cy="0"/>
+        </a:xfrm>
+      </p:grpSpPr>
+      <p:sp>
+        <p:nvSpPr>
+          <p:cNvPr id="2" name="Text 0"/>
+          <p:cNvSpPr/>
+          <p:nvPr/>
+        </p:nvSpPr>
+        <p:spPr>
+          <a:xfrm>
+            <a:off x="548640" y="320040"/>
+            <a:ext cx="8138160" cy="566928"/>
+          </a:xfrm>
+          <a:prstGeom prst="rect">
+            <a:avLst/>
+          </a:prstGeom>
+          <a:noFill/>
+          <a:ln/>
+        </p:spPr>
+        <p:txBody>
+          <a:bodyPr wrap="square" lIns="0" tIns="0" rIns="0" bIns="0" rtlCol="0" anchor="ctr"/>
+          <a:lstStyle/>
+          <a:p>
+            <a:pPr indent="0" marL="0">
+              <a:buNone/>
+            </a:pPr>
+            <a:r>
+              <a:rPr lang="en-US" sz="3800" b="1" dirty="0">
+                <a:solidFill>
+                  <a:srgbClr val="1B2A41"/>
+                </a:solidFill>
+                <a:latin typeface="Cambria" pitchFamily="34" charset="0"/>
+                <a:ea typeface="Cambria" pitchFamily="34" charset="-122"/>
+                <a:cs typeface="Cambria" pitchFamily="34" charset="-120"/>
+              </a:rPr>
+              <a:t>He Must Carry His Message</a:t>
+            </a:r>
+            <a:endParaRPr lang="en-US" sz="3800" dirty="0"/>
+          </a:p>
+        </p:txBody>
+      </p:sp>
+      <p:sp>
+        <p:nvSpPr>
+          <p:cNvPr id="3" name="Text 1"/>
+          <p:cNvSpPr/>
+          <p:nvPr/>
+        </p:nvSpPr>
+        <p:spPr>
+          <a:xfrm>
+            <a:off x="548640" y="914400"/>
+            <a:ext cx="8138160" cy="347472"/>
+          </a:xfrm>
+          <a:prstGeom prst="rect">
+            <a:avLst/>
+          </a:prstGeom>
+          <a:noFill/>
+          <a:ln/>
+        </p:spPr>
+        <p:txBody>
+          <a:bodyPr wrap="square" lIns="0" tIns="0" rIns="0" bIns="0" rtlCol="0" anchor="ctr"/>
+          <a:lstStyle/>
+          <a:p>
+            <a:pPr indent="0" marL="0">
+              <a:buNone/>
+            </a:pPr>
+            <a:r>
+              <a:rPr lang="en-US" sz="1700" i="1" dirty="0">
+                <a:solidFill>
+                  <a:srgbClr val="6B7A8C"/>
+                </a:solidFill>
+                <a:latin typeface="Calibri" pitchFamily="34" charset="0"/>
+                <a:ea typeface="Calibri" pitchFamily="34" charset="-122"/>
+                <a:cs typeface="Calibri" pitchFamily="34" charset="-120"/>
+              </a:rPr>
+              <a:t>In order to save himself.</a:t>
+            </a:r>
+            <a:endParaRPr lang="en-US" sz="1700" dirty="0"/>
+          </a:p>
+        </p:txBody>
+      </p:sp>
+      <p:sp>
+        <p:nvSpPr>
+          <p:cNvPr id="4" name="Shape 2"/>
+          <p:cNvSpPr/>
+          <p:nvPr/>
+        </p:nvSpPr>
+        <p:spPr>
+          <a:xfrm>
+            <a:off x="8869680" y="320040"/>
+            <a:ext cx="2770632" cy="960120"/>
+          </a:xfrm>
+          <a:prstGeom prst="roundRect">
+            <a:avLst>
+              <a:gd name="adj" fmla="val 9524"/>
+            </a:avLst>
+          </a:prstGeom>
+          <a:solidFill>
+            <a:srgbClr val="2C5F2D"/>
+          </a:solidFill>
+          <a:ln/>
+        </p:spPr>
+      </p:sp>
+      <p:sp>
+        <p:nvSpPr>
+          <p:cNvPr id="5" name="Text 3"/>
+          <p:cNvSpPr/>
+          <p:nvPr/>
+        </p:nvSpPr>
+        <p:spPr>
+          <a:xfrm>
+            <a:off x="8869680" y="320040"/>
+            <a:ext cx="2770632" cy="960120"/>
+          </a:xfrm>
+          <a:prstGeom prst="rect">
+            <a:avLst/>
+          </a:prstGeom>
+          <a:noFill/>
+          <a:ln/>
+        </p:spPr>
+        <p:txBody>
+          <a:bodyPr wrap="square" lIns="0" tIns="0" rIns="0" bIns="0" rtlCol="0" anchor="ctr"/>
+          <a:lstStyle/>
+          <a:p>
+            <a:pPr algn="ctr" indent="0" marL="0">
+              <a:buNone/>
+            </a:pPr>
+            <a:r>
+              <a:rPr lang="en-US" sz="1700" b="1" spc="100" kern="0" dirty="0">
+                <a:solidFill>
+                  <a:srgbClr val="FFFFFF"/>
+                </a:solidFill>
+                <a:latin typeface="Cambria" pitchFamily="34" charset="0"/>
+                <a:ea typeface="Cambria" pitchFamily="34" charset="-122"/>
+                <a:cs typeface="Cambria" pitchFamily="34" charset="-120"/>
+              </a:rPr>
+              <a:t>FOREWORD</a:t>
+            </a:r>
+            <a:endParaRPr lang="en-US" sz="1700" dirty="0"/>
+          </a:p>
+          <a:p>
+            <a:pPr algn="ctr" indent="0" marL="0">
+              <a:buNone/>
+            </a:pPr>
+            <a:r>
+              <a:rPr lang="en-US" sz="1300" dirty="0">
+                <a:solidFill>
+                  <a:srgbClr val="D5E3CE"/>
+                </a:solidFill>
+                <a:latin typeface="Calibri" pitchFamily="34" charset="0"/>
+                <a:ea typeface="Calibri" pitchFamily="34" charset="-122"/>
+                <a:cs typeface="Calibri" pitchFamily="34" charset="-120"/>
+              </a:rPr>
+              <a:t>Second Ed.  ·  p. xii</a:t>
+            </a:r>
+            <a:endParaRPr lang="en-US" sz="1700" dirty="0"/>
+          </a:p>
+        </p:txBody>
+      </p:sp>
+      <p:sp>
+        <p:nvSpPr>
+          <p:cNvPr id="6" name="Shape 4"/>
+          <p:cNvSpPr/>
+          <p:nvPr/>
+        </p:nvSpPr>
+        <p:spPr>
+          <a:xfrm>
+            <a:off x="548640" y="1417320"/>
+            <a:ext cx="11091672" cy="2286000"/>
+          </a:xfrm>
+          <a:prstGeom prst="roundRect">
+            <a:avLst>
+              <a:gd name="adj" fmla="val 3200"/>
+            </a:avLst>
+          </a:prstGeom>
+          <a:solidFill>
+            <a:srgbClr val="EAF1E6"/>
+          </a:solidFill>
+          <a:ln/>
+        </p:spPr>
+      </p:sp>
+      <p:sp>
+        <p:nvSpPr>
+          <p:cNvPr id="7" name="Text 5"/>
+          <p:cNvSpPr/>
+          <p:nvPr/>
+        </p:nvSpPr>
+        <p:spPr>
+          <a:xfrm>
+            <a:off x="914400" y="1417320"/>
+            <a:ext cx="10360152" cy="2286000"/>
+          </a:xfrm>
+          <a:prstGeom prst="rect">
+            <a:avLst/>
+          </a:prstGeom>
+          <a:noFill/>
+          <a:ln/>
+        </p:spPr>
+        <p:txBody>
+          <a:bodyPr wrap="square" lIns="0" tIns="0" rIns="0" bIns="0" rtlCol="0" anchor="ctr"/>
+          <a:lstStyle/>
+          <a:p>
+            <a:pPr indent="0" marL="0">
+              <a:lnSpc>
+                <a:spcPct val="115000"/>
+              </a:lnSpc>
+              <a:buNone/>
+            </a:pPr>
+            <a:r>
+              <a:rPr lang="en-US" sz="1900" dirty="0">
+                <a:solidFill>
+                  <a:srgbClr val="1B2A41"/>
+                </a:solidFill>
+                <a:latin typeface="Calibri" pitchFamily="34" charset="0"/>
+                <a:ea typeface="Calibri" pitchFamily="34" charset="-122"/>
+                <a:cs typeface="Calibri" pitchFamily="34" charset="-120"/>
+              </a:rPr>
+              <a:t>Prior to his journey to Akron, the broker had worked hard with many alcoholics on the theory that only an alcoholic could help an alcoholic, but he had succeeded only in keeping sober himself. The broker had gone to Akron on a business venture which had collapsed, leaving him greatly in fear that he might start drinking again. He suddenly realized that in order to save himself </a:t>
+            </a:r>
+            <a:pPr indent="0" marL="0">
+              <a:lnSpc>
+                <a:spcPct val="115000"/>
+              </a:lnSpc>
+              <a:buNone/>
+            </a:pPr>
+            <a:r>
+              <a:rPr lang="en-US" sz="1900" b="1" dirty="0">
+                <a:solidFill>
+                  <a:srgbClr val="9E1B60"/>
+                </a:solidFill>
+                <a:latin typeface="Calibri" pitchFamily="34" charset="0"/>
+                <a:ea typeface="Calibri" pitchFamily="34" charset="-122"/>
+                <a:cs typeface="Calibri" pitchFamily="34" charset="-120"/>
+              </a:rPr>
+              <a:t>he must carry his message to another alcoholic</a:t>
+            </a:r>
+            <a:pPr indent="0" marL="0">
+              <a:lnSpc>
+                <a:spcPct val="115000"/>
+              </a:lnSpc>
+              <a:buNone/>
+            </a:pPr>
+            <a:r>
+              <a:rPr lang="en-US" sz="1900" dirty="0">
+                <a:solidFill>
+                  <a:srgbClr val="1B2A41"/>
+                </a:solidFill>
+                <a:latin typeface="Calibri" pitchFamily="34" charset="0"/>
+                <a:ea typeface="Calibri" pitchFamily="34" charset="-122"/>
+                <a:cs typeface="Calibri" pitchFamily="34" charset="-120"/>
+              </a:rPr>
+              <a:t>. That alcoholic turned out to be the Akron physician.</a:t>
+            </a:r>
+            <a:endParaRPr lang="en-US" sz="1900" dirty="0"/>
+          </a:p>
+        </p:txBody>
+      </p:sp>
+      <p:sp>
+        <p:nvSpPr>
+          <p:cNvPr id="8" name="Shape 6"/>
+          <p:cNvSpPr/>
+          <p:nvPr/>
+        </p:nvSpPr>
+        <p:spPr>
+          <a:xfrm>
+            <a:off x="548640" y="3931920"/>
+            <a:ext cx="11091672" cy="1234440"/>
+          </a:xfrm>
+          <a:prstGeom prst="roundRect">
+            <a:avLst>
+              <a:gd name="adj" fmla="val 5926"/>
+            </a:avLst>
+          </a:prstGeom>
+          <a:solidFill>
+            <a:srgbClr val="9E1B60"/>
+          </a:solidFill>
+          <a:ln/>
+        </p:spPr>
+      </p:sp>
+      <p:sp>
+        <p:nvSpPr>
+          <p:cNvPr id="9" name="Text 7"/>
+          <p:cNvSpPr/>
+          <p:nvPr/>
+        </p:nvSpPr>
+        <p:spPr>
+          <a:xfrm>
+            <a:off x="914400" y="4050792"/>
+            <a:ext cx="10360152" cy="256032"/>
+          </a:xfrm>
+          <a:prstGeom prst="rect">
+            <a:avLst/>
+          </a:prstGeom>
+          <a:noFill/>
+          <a:ln/>
+        </p:spPr>
+        <p:txBody>
+          <a:bodyPr wrap="square" lIns="0" tIns="0" rIns="0" bIns="0" rtlCol="0" anchor="ctr"/>
+          <a:lstStyle/>
+          <a:p>
+            <a:pPr indent="0" marL="0">
+              <a:buNone/>
+            </a:pPr>
+            <a:r>
+              <a:rPr lang="en-US" sz="1100" b="1" spc="200" kern="0" dirty="0">
+                <a:solidFill>
+                  <a:srgbClr val="F7D9E8"/>
+                </a:solidFill>
+                <a:latin typeface="Calibri" pitchFamily="34" charset="0"/>
+                <a:ea typeface="Calibri" pitchFamily="34" charset="-122"/>
+                <a:cs typeface="Calibri" pitchFamily="34" charset="-120"/>
+              </a:rPr>
+              <a:t>A “MUST”</a:t>
+            </a:r>
+            <a:endParaRPr lang="en-US" sz="1100" dirty="0"/>
+          </a:p>
+        </p:txBody>
+      </p:sp>
+      <p:sp>
+        <p:nvSpPr>
+          <p:cNvPr id="10" name="Text 8"/>
+          <p:cNvSpPr/>
+          <p:nvPr/>
+        </p:nvSpPr>
+        <p:spPr>
+          <a:xfrm>
+            <a:off x="914400" y="4325112"/>
+            <a:ext cx="10360152" cy="685800"/>
+          </a:xfrm>
+          <a:prstGeom prst="rect">
+            <a:avLst/>
+          </a:prstGeom>
+          <a:noFill/>
+          <a:ln/>
+        </p:spPr>
+        <p:txBody>
+          <a:bodyPr wrap="square" lIns="0" tIns="0" rIns="0" bIns="0" rtlCol="0" anchor="ctr"/>
+          <a:lstStyle/>
+          <a:p>
+            <a:pPr indent="0" marL="0">
+              <a:buNone/>
+            </a:pPr>
+            <a:r>
+              <a:rPr lang="en-US" sz="2400" b="1" dirty="0">
+                <a:solidFill>
+                  <a:srgbClr val="FFFFFF"/>
+                </a:solidFill>
+                <a:latin typeface="Cambria" pitchFamily="34" charset="0"/>
+                <a:ea typeface="Cambria" pitchFamily="34" charset="-122"/>
+                <a:cs typeface="Cambria" pitchFamily="34" charset="-120"/>
+              </a:rPr>
+              <a:t>…he must carry his message to another alcoholic.</a:t>
+            </a:r>
+            <a:endParaRPr lang="en-US" sz="2400" dirty="0"/>
+          </a:p>
+        </p:txBody>
+      </p:sp>
+      <p:sp>
+        <p:nvSpPr>
+          <p:cNvPr id="11" name="Text 9"/>
+          <p:cNvSpPr/>
+          <p:nvPr/>
+        </p:nvSpPr>
+        <p:spPr>
+          <a:xfrm>
+            <a:off x="548640" y="5394960"/>
+            <a:ext cx="11091672" cy="292608"/>
+          </a:xfrm>
+          <a:prstGeom prst="rect">
+            <a:avLst/>
+          </a:prstGeom>
+          <a:noFill/>
+          <a:ln/>
+        </p:spPr>
+        <p:txBody>
+          <a:bodyPr wrap="square" lIns="0" tIns="0" rIns="0" bIns="0" rtlCol="0" anchor="ctr"/>
+          <a:lstStyle/>
+          <a:p>
+            <a:pPr indent="0" marL="0">
+              <a:buNone/>
+            </a:pPr>
+            <a:r>
+              <a:rPr lang="en-US" sz="1200" i="1" dirty="0">
+                <a:solidFill>
+                  <a:srgbClr val="6B7A8C"/>
+                </a:solidFill>
+                <a:latin typeface="Calibri" pitchFamily="34" charset="0"/>
+                <a:ea typeface="Calibri" pitchFamily="34" charset="-122"/>
+                <a:cs typeface="Calibri" pitchFamily="34" charset="-120"/>
+              </a:rPr>
+              <a:t>Alcoholics Anonymous</a:t>
+            </a:r>
+            <a:pPr indent="0" marL="0">
+              <a:buNone/>
+            </a:pPr>
+            <a:r>
+              <a:rPr lang="en-US" sz="1200" dirty="0">
+                <a:solidFill>
+                  <a:srgbClr val="6B7A8C"/>
+                </a:solidFill>
+                <a:latin typeface="Calibri" pitchFamily="34" charset="0"/>
+                <a:ea typeface="Calibri" pitchFamily="34" charset="-122"/>
+                <a:cs typeface="Calibri" pitchFamily="34" charset="-120"/>
+              </a:rPr>
+              <a:t>, 4th ed., Foreword to the Second Edition, p. xii.</a:t>
+            </a:r>
+            <a:endParaRPr lang="en-US" sz="1200" dirty="0"/>
+          </a:p>
+        </p:txBody>
+      </p:sp>
+      <p:sp>
+        <p:nvSpPr>
+          <p:cNvPr id="12" name="Text 10"/>
+          <p:cNvSpPr/>
+          <p:nvPr/>
+        </p:nvSpPr>
+        <p:spPr>
+          <a:xfrm>
+            <a:off x="548640" y="6355080"/>
+            <a:ext cx="11091672" cy="292608"/>
+          </a:xfrm>
+          <a:prstGeom prst="rect">
+            <a:avLst/>
+          </a:prstGeom>
+          <a:noFill/>
+          <a:ln/>
+        </p:spPr>
+        <p:txBody>
+          <a:bodyPr wrap="square" lIns="0" tIns="0" rIns="0" bIns="0" rtlCol="0" anchor="ctr"/>
+          <a:lstStyle/>
+          <a:p>
+            <a:pPr indent="0" marL="0">
+              <a:buNone/>
+            </a:pPr>
+            <a:r>
+              <a:rPr lang="en-US" sz="950" dirty="0">
+                <a:solidFill>
+                  <a:srgbClr val="6B7A8C"/>
+                </a:solidFill>
+                <a:latin typeface="Calibri" pitchFamily="34" charset="0"/>
+                <a:ea typeface="Calibri" pitchFamily="34" charset="-122"/>
+                <a:cs typeface="Calibri" pitchFamily="34" charset="-120"/>
+              </a:rPr>
+              <a:t>Copyright © Alcoholics Anonymous World Services, Inc. All rights reserved. Intended for personal use only, and not to be reproduced further or distributed for resale.</a:t>
+            </a:r>
+            <a:endParaRPr lang="en-US" sz="950" dirty="0"/>
+          </a:p>
+        </p:txBody>
+      </p:sp>
+    </p:spTree>
+  </p:cSld>
+  <p:clrMapOvr>
+    <a:masterClrMapping/>
+  </p:clrMapOvr>
+</p:sld>
+</file>
+
+<file path=ppt/slides/slide9.xml><?xml version="1.0" encoding="utf-8"?>
+<p:sld xmlns:a="http://schemas.openxmlformats.org/drawingml/2006/main" xmlns:r="http://schemas.openxmlformats.org/officeDocument/2006/relationships" xmlns:p="http://schemas.openxmlformats.org/presentationml/2006/main">
+  <p:cSld name="Slide 9">
+    <p:bg>
+      <p:bgPr>
+        <a:solidFill>
+          <a:srgbClr val="FFFFFF"/>
+        </a:solidFill>
+      </p:bgPr>
+    </p:bg>
+    <p:spTree>
+      <p:nvGrpSpPr>
+        <p:cNvPr id="1" name=""/>
+        <p:cNvGrpSpPr/>
+        <p:nvPr/>
+      </p:nvGrpSpPr>
+      <p:grpSpPr>
+        <a:xfrm>
+          <a:off x="0" y="0"/>
+          <a:ext cx="0" cy="0"/>
+          <a:chOff x="0" y="0"/>
+          <a:chExt cx="0" cy="0"/>
+        </a:xfrm>
+      </p:grpSpPr>
+      <p:sp>
+        <p:nvSpPr>
+          <p:cNvPr id="2" name="Text 0"/>
+          <p:cNvSpPr/>
+          <p:nvPr/>
+        </p:nvSpPr>
+        <p:spPr>
+          <a:xfrm>
+            <a:off x="548640" y="320040"/>
+            <a:ext cx="8138160" cy="566928"/>
+          </a:xfrm>
+          <a:prstGeom prst="rect">
+            <a:avLst/>
+          </a:prstGeom>
+          <a:noFill/>
+          <a:ln/>
+        </p:spPr>
+        <p:txBody>
+          <a:bodyPr wrap="square" lIns="0" tIns="0" rIns="0" bIns="0" rtlCol="0" anchor="ctr"/>
+          <a:lstStyle/>
+          <a:p>
+            <a:pPr indent="0" marL="0">
+              <a:buNone/>
+            </a:pPr>
+            <a:r>
+              <a:rPr lang="en-US" sz="3800" b="1" dirty="0">
+                <a:solidFill>
+                  <a:srgbClr val="1B2A41"/>
+                </a:solidFill>
+                <a:latin typeface="Cambria" pitchFamily="34" charset="0"/>
+                <a:ea typeface="Cambria" pitchFamily="34" charset="-122"/>
+                <a:cs typeface="Cambria" pitchFamily="34" charset="-120"/>
+              </a:rPr>
+              <a:t>Two Things We Learned</a:t>
+            </a:r>
+            <a:endParaRPr lang="en-US" sz="3800" dirty="0"/>
+          </a:p>
+        </p:txBody>
+      </p:sp>
+      <p:sp>
+        <p:nvSpPr>
+          <p:cNvPr id="3" name="Text 1"/>
+          <p:cNvSpPr/>
+          <p:nvPr/>
+        </p:nvSpPr>
+        <p:spPr>
+          <a:xfrm>
+            <a:off x="548640" y="914400"/>
+            <a:ext cx="8138160" cy="347472"/>
+          </a:xfrm>
+          <a:prstGeom prst="rect">
+            <a:avLst/>
+          </a:prstGeom>
+          <a:noFill/>
+          <a:ln/>
+        </p:spPr>
+        <p:txBody>
+          <a:bodyPr wrap="square" lIns="0" tIns="0" rIns="0" bIns="0" rtlCol="0" anchor="ctr"/>
+          <a:lstStyle/>
+          <a:p>
+            <a:pPr indent="0" marL="0">
+              <a:buNone/>
+            </a:pPr>
+            <a:r>
+              <a:rPr lang="en-US" sz="1700" i="1" dirty="0">
+                <a:solidFill>
+                  <a:srgbClr val="6B7A8C"/>
+                </a:solidFill>
+                <a:latin typeface="Calibri" pitchFamily="34" charset="0"/>
+                <a:ea typeface="Calibri" pitchFamily="34" charset="-122"/>
+                <a:cs typeface="Calibri" pitchFamily="34" charset="-120"/>
+              </a:rPr>
+              <a:t>From the first talk between the broker and the physician.</a:t>
+            </a:r>
+            <a:endParaRPr lang="en-US" sz="1700" dirty="0"/>
+          </a:p>
+        </p:txBody>
+      </p:sp>
+      <p:sp>
+        <p:nvSpPr>
+          <p:cNvPr id="4" name="Shape 2"/>
+          <p:cNvSpPr/>
+          <p:nvPr/>
+        </p:nvSpPr>
+        <p:spPr>
+          <a:xfrm>
+            <a:off x="8869680" y="320040"/>
+            <a:ext cx="2770632" cy="960120"/>
+          </a:xfrm>
+          <a:prstGeom prst="roundRect">
+            <a:avLst>
+              <a:gd name="adj" fmla="val 9524"/>
+            </a:avLst>
+          </a:prstGeom>
+          <a:solidFill>
+            <a:srgbClr val="1B2A41"/>
+          </a:solidFill>
+          <a:ln/>
+        </p:spPr>
+      </p:sp>
+      <p:sp>
+        <p:nvSpPr>
+          <p:cNvPr id="5" name="Text 3"/>
+          <p:cNvSpPr/>
+          <p:nvPr/>
+        </p:nvSpPr>
+        <p:spPr>
+          <a:xfrm>
+            <a:off x="8869680" y="320040"/>
+            <a:ext cx="2770632" cy="960120"/>
+          </a:xfrm>
+          <a:prstGeom prst="rect">
+            <a:avLst/>
+          </a:prstGeom>
+          <a:noFill/>
+          <a:ln/>
+        </p:spPr>
+        <p:txBody>
+          <a:bodyPr wrap="square" lIns="0" tIns="0" rIns="0" bIns="0" rtlCol="0" anchor="ctr"/>
+          <a:lstStyle/>
+          <a:p>
+            <a:pPr algn="ctr" indent="0" marL="0">
+              <a:buNone/>
+            </a:pPr>
+            <a:r>
+              <a:rPr lang="en-US" sz="1700" b="1" spc="100" kern="0" dirty="0">
+                <a:solidFill>
+                  <a:srgbClr val="FFFFFF"/>
+                </a:solidFill>
+                <a:latin typeface="Cambria" pitchFamily="34" charset="0"/>
+                <a:ea typeface="Cambria" pitchFamily="34" charset="-122"/>
+                <a:cs typeface="Cambria" pitchFamily="34" charset="-120"/>
+              </a:rPr>
+              <a:t>FOREWORD</a:t>
+            </a:r>
+            <a:endParaRPr lang="en-US" sz="1700" dirty="0"/>
+          </a:p>
+          <a:p>
+            <a:pPr algn="ctr" indent="0" marL="0">
+              <a:buNone/>
+            </a:pPr>
+            <a:r>
+              <a:rPr lang="en-US" sz="1300" dirty="0">
+                <a:solidFill>
+                  <a:srgbClr val="A9B8CC"/>
+                </a:solidFill>
+                <a:latin typeface="Calibri" pitchFamily="34" charset="0"/>
+                <a:ea typeface="Calibri" pitchFamily="34" charset="-122"/>
+                <a:cs typeface="Calibri" pitchFamily="34" charset="-120"/>
+              </a:rPr>
+              <a:t>Second Ed.  ·  pp. xii–xiii</a:t>
+            </a:r>
+            <a:endParaRPr lang="en-US" sz="1700" dirty="0"/>
+          </a:p>
+        </p:txBody>
+      </p:sp>
+      <p:sp>
+        <p:nvSpPr>
+          <p:cNvPr id="6" name="Shape 4"/>
+          <p:cNvSpPr/>
+          <p:nvPr/>
+        </p:nvSpPr>
+        <p:spPr>
+          <a:xfrm>
+            <a:off x="548640" y="1600200"/>
+            <a:ext cx="11091672" cy="1554480"/>
+          </a:xfrm>
+          <a:prstGeom prst="roundRect">
+            <a:avLst>
+              <a:gd name="adj" fmla="val 4706"/>
+            </a:avLst>
+          </a:prstGeom>
+          <a:solidFill>
+            <a:srgbClr val="E2EDF4"/>
+          </a:solidFill>
+          <a:ln/>
+        </p:spPr>
+      </p:sp>
+      <p:sp>
+        <p:nvSpPr>
+          <p:cNvPr id="7" name="Shape 5"/>
+          <p:cNvSpPr/>
+          <p:nvPr/>
+        </p:nvSpPr>
+        <p:spPr>
+          <a:xfrm>
+            <a:off x="914400" y="2084832"/>
+            <a:ext cx="585216" cy="585216"/>
+          </a:xfrm>
+          <a:prstGeom prst="ellipse">
+            <a:avLst/>
+          </a:prstGeom>
+          <a:solidFill>
+            <a:srgbClr val="065A82"/>
+          </a:solidFill>
+          <a:ln/>
+        </p:spPr>
+      </p:sp>
+      <p:sp>
+        <p:nvSpPr>
+          <p:cNvPr id="8" name="Text 6"/>
+          <p:cNvSpPr/>
+          <p:nvPr/>
+        </p:nvSpPr>
+        <p:spPr>
+          <a:xfrm>
+            <a:off x="914400" y="2084832"/>
+            <a:ext cx="585216" cy="585216"/>
+          </a:xfrm>
+          <a:prstGeom prst="rect">
+            <a:avLst/>
+          </a:prstGeom>
+          <a:noFill/>
+          <a:ln/>
+        </p:spPr>
+        <p:txBody>
+          <a:bodyPr wrap="square" lIns="0" tIns="0" rIns="0" bIns="0" rtlCol="0" anchor="ctr"/>
+          <a:lstStyle/>
+          <a:p>
+            <a:pPr algn="ctr" indent="0" marL="0">
+              <a:buNone/>
+            </a:pPr>
+            <a:r>
+              <a:rPr lang="en-US" sz="2200" b="1" dirty="0">
+                <a:solidFill>
+                  <a:srgbClr val="FFFFFF"/>
+                </a:solidFill>
+                <a:latin typeface="Cambria" pitchFamily="34" charset="0"/>
+                <a:ea typeface="Cambria" pitchFamily="34" charset="-122"/>
+                <a:cs typeface="Cambria" pitchFamily="34" charset="-120"/>
+              </a:rPr>
+              <a:t>1</a:t>
+            </a:r>
+            <a:endParaRPr lang="en-US" sz="2200" dirty="0"/>
+          </a:p>
+        </p:txBody>
+      </p:sp>
+      <p:sp>
+        <p:nvSpPr>
+          <p:cNvPr id="9" name="Text 7"/>
+          <p:cNvSpPr/>
+          <p:nvPr/>
+        </p:nvSpPr>
+        <p:spPr>
+          <a:xfrm>
+            <a:off x="1783080" y="1600200"/>
+            <a:ext cx="9509760" cy="1554480"/>
+          </a:xfrm>
+          <a:prstGeom prst="rect">
+            <a:avLst/>
+          </a:prstGeom>
+          <a:noFill/>
+          <a:ln/>
+        </p:spPr>
+        <p:txBody>
+          <a:bodyPr wrap="square" lIns="0" tIns="0" rIns="0" bIns="0" rtlCol="0" anchor="ctr"/>
+          <a:lstStyle/>
+          <a:p>
+            <a:pPr indent="0" marL="0">
+              <a:lnSpc>
+                <a:spcPct val="115000"/>
+              </a:lnSpc>
+              <a:buNone/>
+            </a:pPr>
+            <a:r>
+              <a:rPr lang="en-US" sz="2200" dirty="0">
+                <a:solidFill>
+                  <a:srgbClr val="1B2A41"/>
+                </a:solidFill>
+                <a:latin typeface="Calibri" pitchFamily="34" charset="0"/>
+                <a:ea typeface="Calibri" pitchFamily="34" charset="-122"/>
+                <a:cs typeface="Calibri" pitchFamily="34" charset="-120"/>
+              </a:rPr>
+              <a:t>This seemed to prove that one alcoholic could affect another as no nonalcoholic could.</a:t>
+            </a:r>
+            <a:endParaRPr lang="en-US" sz="2200" dirty="0"/>
+          </a:p>
+        </p:txBody>
+      </p:sp>
+      <p:sp>
+        <p:nvSpPr>
+          <p:cNvPr id="10" name="Shape 8"/>
+          <p:cNvSpPr/>
+          <p:nvPr/>
+        </p:nvSpPr>
+        <p:spPr>
+          <a:xfrm>
+            <a:off x="548640" y="3383280"/>
+            <a:ext cx="11091672" cy="1554480"/>
+          </a:xfrm>
+          <a:prstGeom prst="roundRect">
+            <a:avLst>
+              <a:gd name="adj" fmla="val 4706"/>
+            </a:avLst>
+          </a:prstGeom>
+          <a:solidFill>
+            <a:srgbClr val="EAF1E6"/>
+          </a:solidFill>
+          <a:ln/>
+        </p:spPr>
+      </p:sp>
+      <p:sp>
+        <p:nvSpPr>
+          <p:cNvPr id="11" name="Shape 9"/>
+          <p:cNvSpPr/>
+          <p:nvPr/>
+        </p:nvSpPr>
+        <p:spPr>
+          <a:xfrm>
+            <a:off x="914400" y="3867912"/>
+            <a:ext cx="585216" cy="585216"/>
+          </a:xfrm>
+          <a:prstGeom prst="ellipse">
+            <a:avLst/>
+          </a:prstGeom>
+          <a:solidFill>
+            <a:srgbClr val="2C5F2D"/>
+          </a:solidFill>
+          <a:ln/>
+        </p:spPr>
+      </p:sp>
+      <p:sp>
+        <p:nvSpPr>
+          <p:cNvPr id="12" name="Text 10"/>
+          <p:cNvSpPr/>
+          <p:nvPr/>
+        </p:nvSpPr>
+        <p:spPr>
+          <a:xfrm>
+            <a:off x="914400" y="3867912"/>
+            <a:ext cx="585216" cy="585216"/>
+          </a:xfrm>
+          <a:prstGeom prst="rect">
+            <a:avLst/>
+          </a:prstGeom>
+          <a:noFill/>
+          <a:ln/>
+        </p:spPr>
+        <p:txBody>
+          <a:bodyPr wrap="square" lIns="0" tIns="0" rIns="0" bIns="0" rtlCol="0" anchor="ctr"/>
+          <a:lstStyle/>
+          <a:p>
+            <a:pPr algn="ctr" indent="0" marL="0">
+              <a:buNone/>
+            </a:pPr>
+            <a:r>
+              <a:rPr lang="en-US" sz="2200" b="1" dirty="0">
+                <a:solidFill>
+                  <a:srgbClr val="FFFFFF"/>
+                </a:solidFill>
+                <a:latin typeface="Cambria" pitchFamily="34" charset="0"/>
+                <a:ea typeface="Cambria" pitchFamily="34" charset="-122"/>
+                <a:cs typeface="Cambria" pitchFamily="34" charset="-120"/>
+              </a:rPr>
+              <a:t>2</a:t>
+            </a:r>
+            <a:endParaRPr lang="en-US" sz="2200" dirty="0"/>
+          </a:p>
+        </p:txBody>
+      </p:sp>
+      <p:sp>
+        <p:nvSpPr>
+          <p:cNvPr id="13" name="Text 11"/>
+          <p:cNvSpPr/>
+          <p:nvPr/>
+        </p:nvSpPr>
+        <p:spPr>
+          <a:xfrm>
+            <a:off x="1783080" y="3383280"/>
+            <a:ext cx="9509760" cy="1554480"/>
+          </a:xfrm>
+          <a:prstGeom prst="rect">
+            <a:avLst/>
+          </a:prstGeom>
+          <a:noFill/>
+          <a:ln/>
+        </p:spPr>
+        <p:txBody>
+          <a:bodyPr wrap="square" lIns="0" tIns="0" rIns="0" bIns="0" rtlCol="0" anchor="ctr"/>
+          <a:lstStyle/>
+          <a:p>
+            <a:pPr indent="0" marL="0">
+              <a:lnSpc>
+                <a:spcPct val="115000"/>
+              </a:lnSpc>
+              <a:buNone/>
+            </a:pPr>
+            <a:r>
+              <a:rPr lang="en-US" sz="2200" dirty="0">
+                <a:solidFill>
+                  <a:srgbClr val="1B2A41"/>
+                </a:solidFill>
+                <a:latin typeface="Calibri" pitchFamily="34" charset="0"/>
+                <a:ea typeface="Calibri" pitchFamily="34" charset="-122"/>
+                <a:cs typeface="Calibri" pitchFamily="34" charset="-120"/>
+              </a:rPr>
+              <a:t>It also indicated that strenuous work, one alcoholic with another, was vital to permanent recovery.</a:t>
+            </a:r>
+            <a:endParaRPr lang="en-US" sz="2200" dirty="0"/>
+          </a:p>
+        </p:txBody>
+      </p:sp>
+      <p:sp>
+        <p:nvSpPr>
+          <p:cNvPr id="14" name="Text 12"/>
+          <p:cNvSpPr/>
+          <p:nvPr/>
+        </p:nvSpPr>
+        <p:spPr>
+          <a:xfrm>
+            <a:off x="548640" y="5166360"/>
+            <a:ext cx="11091672" cy="292608"/>
+          </a:xfrm>
+          <a:prstGeom prst="rect">
+            <a:avLst/>
+          </a:prstGeom>
+          <a:noFill/>
+          <a:ln/>
+        </p:spPr>
+        <p:txBody>
+          <a:bodyPr wrap="square" lIns="0" tIns="0" rIns="0" bIns="0" rtlCol="0" anchor="ctr"/>
+          <a:lstStyle/>
+          <a:p>
+            <a:pPr indent="0" marL="0">
+              <a:buNone/>
+            </a:pPr>
+            <a:r>
+              <a:rPr lang="en-US" sz="1200" i="1" dirty="0">
+                <a:solidFill>
+                  <a:srgbClr val="6B7A8C"/>
+                </a:solidFill>
+                <a:latin typeface="Calibri" pitchFamily="34" charset="0"/>
+                <a:ea typeface="Calibri" pitchFamily="34" charset="-122"/>
+                <a:cs typeface="Calibri" pitchFamily="34" charset="-120"/>
+              </a:rPr>
+              <a:t>Alcoholics Anonymous</a:t>
+            </a:r>
+            <a:pPr indent="0" marL="0">
+              <a:buNone/>
+            </a:pPr>
+            <a:r>
+              <a:rPr lang="en-US" sz="1200" dirty="0">
+                <a:solidFill>
+                  <a:srgbClr val="6B7A8C"/>
+                </a:solidFill>
+                <a:latin typeface="Calibri" pitchFamily="34" charset="0"/>
+                <a:ea typeface="Calibri" pitchFamily="34" charset="-122"/>
+                <a:cs typeface="Calibri" pitchFamily="34" charset="-120"/>
+              </a:rPr>
+              <a:t>, 4th ed., Foreword to the Second Edition, pp. xii–xiii.</a:t>
+            </a:r>
+            <a:endParaRPr lang="en-US" sz="1200" dirty="0"/>
+          </a:p>
+        </p:txBody>
+      </p:sp>
+      <p:sp>
+        <p:nvSpPr>
+          <p:cNvPr id="15" name="Text 13"/>
           <p:cNvSpPr/>
           <p:nvPr/>
         </p:nvSpPr>

</xml_diff>

<commit_message>
Add slides 11-14: Foreword to the Second Edition (pp. xiv-xvii)
The adolescent period and the conviction that came out of it, the recovery
percentages, the not-a-religious-organization paragraph, and the December 1941
membership figures.

The p. xvii margin note was illegible at full-page scale; enlarged and
contrast-stretched it reads 'Clarence Snyder was using the book - is why the #'s
were higher.' Cleveland's row is filled solid so the outlier reads before anyone
finishes the numbers.

Percentages stay inline and bolded rather than becoming stat tiles - the deck
already has a visual grammar and a KPI row is not part of it.

Co-Authored-By: Claude Opus 5 <noreply@anthropic.com>
Claude-Session: https://claude.ai/code/session_01NuCgD3Z7aWvkQrsSvAUX4h
</commit_message>
<xml_diff>
--- a/aa-slideshow/aa-big-book-study.pptx
+++ b/aa-slideshow/aa-big-book-study.pptx
@@ -15,9 +15,13 @@
     <p:sldId id="263" r:id="rId9"/>
     <p:sldId id="264" r:id="rId10"/>
     <p:sldId id="265" r:id="rId11"/>
+    <p:sldId id="266" r:id="rId12"/>
+    <p:sldId id="267" r:id="rId13"/>
+    <p:sldId id="268" r:id="rId14"/>
+    <p:sldId id="269" r:id="rId15"/>
   </p:sldIdLst>
   <p:notesMasterIdLst>
-    <p:notesMasterId r:id="rId12"/>
+    <p:notesMasterId r:id="rId16"/>
   </p:notesMasterIdLst>
   <p:sldSz cx="12192000" cy="6858000"/>
   <p:notesSz cx="6858000" cy="12192000"/>
@@ -629,6 +633,380 @@
             <a:fld id="{F7021451-1387-4CA6-816F-3879F97B5CBC}" type="slidenum">
               <a:rPr lang="en-US"/>
               <a:t>10</a:t>
+            </a:fld>
+            <a:endParaRPr lang="en-US"/>
+          </a:p>
+        </p:txBody>
+      </p:sp>
+    </p:spTree>
+    <p:extLst>
+      <p:ext uri="{BB962C8B-B14F-4D97-AF65-F5344CB8AC3E}">
+        <p14:creationId xmlns:p14="http://schemas.microsoft.com/office/powerpoint/2010/main" val="1024086991"/>
+      </p:ext>
+    </p:extLst>
+  </p:cSld>
+  <p:clrMapOvr>
+    <a:masterClrMapping/>
+  </p:clrMapOvr>
+</p:notes>
+</file>
+
+<file path=ppt/notesSlides/notesSlide11.xml><?xml version="1.0" encoding="utf-8"?>
+<p:notes xmlns:a="http://schemas.openxmlformats.org/drawingml/2006/main" xmlns:r="http://schemas.openxmlformats.org/officeDocument/2006/relationships" xmlns:p="http://schemas.openxmlformats.org/presentationml/2006/main">
+  <p:cSld>
+    <p:spTree>
+      <p:nvGrpSpPr>
+        <p:cNvPr id="1" name=""/>
+        <p:cNvGrpSpPr/>
+        <p:nvPr/>
+      </p:nvGrpSpPr>
+      <p:grpSpPr>
+        <a:xfrm>
+          <a:off x="0" y="0"/>
+          <a:ext cx="0" cy="0"/>
+          <a:chOff x="0" y="0"/>
+          <a:chExt cx="0" cy="0"/>
+        </a:xfrm>
+      </p:grpSpPr>
+      <p:sp>
+        <p:nvSpPr>
+          <p:cNvPr id="2" name="Slide Image Placeholder 1"/>
+          <p:cNvSpPr>
+            <a:spLocks noGrp="1" noRot="1" noChangeAspect="1"/>
+          </p:cNvSpPr>
+          <p:nvPr>
+            <p:ph type="sldImg"/>
+          </p:nvPr>
+        </p:nvSpPr>
+        <p:spPr/>
+      </p:sp>
+      <p:sp>
+        <p:nvSpPr>
+          <p:cNvPr id="3" name="Notes Placeholder 2"/>
+          <p:cNvSpPr>
+            <a:spLocks noGrp="1"/>
+          </p:cNvSpPr>
+          <p:nvPr>
+            <p:ph type="body" idx="1"/>
+          </p:nvPr>
+        </p:nvSpPr>
+        <p:spPr/>
+        <p:txBody>
+          <a:bodyPr/>
+          <a:lstStyle/>
+          <a:p>
+            <a:r>
+              <a:rPr lang="en-US" dirty="0"/>
+              <a:t>Everything in this paragraph is a question, and every one of them got answered the hard way.
+Quarrels over membership, leadership, money. Strivings for power and prestige. Schisms.
+A.A. had all of it.
+What came out of it was the Twelve Traditions - and the conviction underneath them:
+hang together or die separately.
+Note the order of events. The book came first, in 1939. The Fellowship took its name
+from the book, not the other way around.</a:t>
+            </a:r>
+            <a:endParaRPr lang="en-US" dirty="0"/>
+          </a:p>
+        </p:txBody>
+      </p:sp>
+      <p:sp>
+        <p:nvSpPr>
+          <p:cNvPr id="4" name="Slide Number Placeholder 3"/>
+          <p:cNvSpPr>
+            <a:spLocks noGrp="1"/>
+          </p:cNvSpPr>
+          <p:nvPr>
+            <p:ph type="sldNum" sz="quarter" idx="10"/>
+          </p:nvPr>
+        </p:nvSpPr>
+        <p:spPr/>
+        <p:txBody>
+          <a:bodyPr/>
+          <a:lstStyle/>
+          <a:p>
+            <a:fld id="{F7021451-1387-4CA6-816F-3879F97B5CBC}" type="slidenum">
+              <a:rPr lang="en-US"/>
+              <a:t>11</a:t>
+            </a:fld>
+            <a:endParaRPr lang="en-US"/>
+          </a:p>
+        </p:txBody>
+      </p:sp>
+    </p:spTree>
+    <p:extLst>
+      <p:ext uri="{BB962C8B-B14F-4D97-AF65-F5344CB8AC3E}">
+        <p14:creationId xmlns:p14="http://schemas.microsoft.com/office/powerpoint/2010/main" val="1024086991"/>
+      </p:ext>
+    </p:extLst>
+  </p:cSld>
+  <p:clrMapOvr>
+    <a:masterClrMapping/>
+  </p:clrMapOvr>
+</p:notes>
+</file>
+
+<file path=ppt/notesSlides/notesSlide12.xml><?xml version="1.0" encoding="utf-8"?>
+<p:notes xmlns:a="http://schemas.openxmlformats.org/drawingml/2006/main" xmlns:r="http://schemas.openxmlformats.org/officeDocument/2006/relationships" xmlns:p="http://schemas.openxmlformats.org/presentationml/2006/main">
+  <p:cSld>
+    <p:spTree>
+      <p:nvGrpSpPr>
+        <p:cNvPr id="1" name=""/>
+        <p:cNvGrpSpPr/>
+        <p:nvPr/>
+      </p:nvGrpSpPr>
+      <p:grpSpPr>
+        <a:xfrm>
+          <a:off x="0" y="0"/>
+          <a:ext cx="0" cy="0"/>
+          <a:chOff x="0" y="0"/>
+          <a:chExt cx="0" cy="0"/>
+        </a:xfrm>
+      </p:grpSpPr>
+      <p:sp>
+        <p:nvSpPr>
+          <p:cNvPr id="2" name="Slide Image Placeholder 1"/>
+          <p:cNvSpPr>
+            <a:spLocks noGrp="1" noRot="1" noChangeAspect="1"/>
+          </p:cNvSpPr>
+          <p:nvPr>
+            <p:ph type="sldImg"/>
+          </p:nvPr>
+        </p:nvSpPr>
+        <p:spPr/>
+      </p:sp>
+      <p:sp>
+        <p:nvSpPr>
+          <p:cNvPr id="3" name="Notes Placeholder 2"/>
+          <p:cNvSpPr>
+            <a:spLocks noGrp="1"/>
+          </p:cNvSpPr>
+          <p:nvPr>
+            <p:ph type="body" idx="1"/>
+          </p:nvPr>
+        </p:nvSpPr>
+        <p:spPr/>
+        <p:txBody>
+          <a:bodyPr/>
+          <a:lstStyle/>
+          <a:p>
+            <a:r>
+              <a:rPr lang="en-US" dirty="0"/>
+              <a:t>Two principal reasons the public came around: recoveries, and reunited homes. Not
+advertising. Not argument. Results people could see in their own neighborhoods.
+Watch the qualifier - came to A.A. and really tried. The numbers are attached to that
+phrase, not to attendance.
+And the last line is the one to sit on: of the thousands who came, decided they did not
+want it, and left - about two out of three came back.</a:t>
+            </a:r>
+            <a:endParaRPr lang="en-US" dirty="0"/>
+          </a:p>
+        </p:txBody>
+      </p:sp>
+      <p:sp>
+        <p:nvSpPr>
+          <p:cNvPr id="4" name="Slide Number Placeholder 3"/>
+          <p:cNvSpPr>
+            <a:spLocks noGrp="1"/>
+          </p:cNvSpPr>
+          <p:nvPr>
+            <p:ph type="sldNum" sz="quarter" idx="10"/>
+          </p:nvPr>
+        </p:nvSpPr>
+        <p:spPr/>
+        <p:txBody>
+          <a:bodyPr/>
+          <a:lstStyle/>
+          <a:p>
+            <a:fld id="{F7021451-1387-4CA6-816F-3879F97B5CBC}" type="slidenum">
+              <a:rPr lang="en-US"/>
+              <a:t>12</a:t>
+            </a:fld>
+            <a:endParaRPr lang="en-US"/>
+          </a:p>
+        </p:txBody>
+      </p:sp>
+    </p:spTree>
+    <p:extLst>
+      <p:ext uri="{BB962C8B-B14F-4D97-AF65-F5344CB8AC3E}">
+        <p14:creationId xmlns:p14="http://schemas.microsoft.com/office/powerpoint/2010/main" val="1024086991"/>
+      </p:ext>
+    </p:extLst>
+  </p:cSld>
+  <p:clrMapOvr>
+    <a:masterClrMapping/>
+  </p:clrMapOvr>
+</p:notes>
+</file>
+
+<file path=ppt/notesSlides/notesSlide13.xml><?xml version="1.0" encoding="utf-8"?>
+<p:notes xmlns:a="http://schemas.openxmlformats.org/drawingml/2006/main" xmlns:r="http://schemas.openxmlformats.org/officeDocument/2006/relationships" xmlns:p="http://schemas.openxmlformats.org/presentationml/2006/main">
+  <p:cSld>
+    <p:spTree>
+      <p:nvGrpSpPr>
+        <p:cNvPr id="1" name=""/>
+        <p:cNvGrpSpPr/>
+        <p:nvPr/>
+      </p:nvGrpSpPr>
+      <p:grpSpPr>
+        <a:xfrm>
+          <a:off x="0" y="0"/>
+          <a:ext cx="0" cy="0"/>
+          <a:chOff x="0" y="0"/>
+          <a:chExt cx="0" cy="0"/>
+        </a:xfrm>
+      </p:grpSpPr>
+      <p:sp>
+        <p:nvSpPr>
+          <p:cNvPr id="2" name="Slide Image Placeholder 1"/>
+          <p:cNvSpPr>
+            <a:spLocks noGrp="1" noRot="1" noChangeAspect="1"/>
+          </p:cNvSpPr>
+          <p:nvPr>
+            <p:ph type="sldImg"/>
+          </p:nvPr>
+        </p:nvSpPr>
+        <p:spPr/>
+      </p:sp>
+      <p:sp>
+        <p:nvSpPr>
+          <p:cNvPr id="3" name="Notes Placeholder 2"/>
+          <p:cNvSpPr>
+            <a:spLocks noGrp="1"/>
+          </p:cNvSpPr>
+          <p:nvPr>
+            <p:ph type="body" idx="1"/>
+          </p:nvPr>
+        </p:nvSpPr>
+        <p:spPr/>
+        <p:txBody>
+          <a:bodyPr/>
+          <a:lstStyle/>
+          <a:p>
+            <a:r>
+              <a:rPr lang="en-US" dirty="0"/>
+              <a:t>This is the paragraph for the person sitting in the back who has been told all his life
+that A.A. is a religion, or a cult, or a hospital program.
+Not a religious organization. No particular medical point of view. We cooperate with
+both and we are neither.
+Ninety words that have kept more newcomers in the room than any argument ever has.</a:t>
+            </a:r>
+            <a:endParaRPr lang="en-US" dirty="0"/>
+          </a:p>
+        </p:txBody>
+      </p:sp>
+      <p:sp>
+        <p:nvSpPr>
+          <p:cNvPr id="4" name="Slide Number Placeholder 3"/>
+          <p:cNvSpPr>
+            <a:spLocks noGrp="1"/>
+          </p:cNvSpPr>
+          <p:nvPr>
+            <p:ph type="sldNum" sz="quarter" idx="10"/>
+          </p:nvPr>
+        </p:nvSpPr>
+        <p:spPr/>
+        <p:txBody>
+          <a:bodyPr/>
+          <a:lstStyle/>
+          <a:p>
+            <a:fld id="{F7021451-1387-4CA6-816F-3879F97B5CBC}" type="slidenum">
+              <a:rPr lang="en-US"/>
+              <a:t>13</a:t>
+            </a:fld>
+            <a:endParaRPr lang="en-US"/>
+          </a:p>
+        </p:txBody>
+      </p:sp>
+    </p:spTree>
+    <p:extLst>
+      <p:ext uri="{BB962C8B-B14F-4D97-AF65-F5344CB8AC3E}">
+        <p14:creationId xmlns:p14="http://schemas.microsoft.com/office/powerpoint/2010/main" val="1024086991"/>
+      </p:ext>
+    </p:extLst>
+  </p:cSld>
+  <p:clrMapOvr>
+    <a:masterClrMapping/>
+  </p:clrMapOvr>
+</p:notes>
+</file>
+
+<file path=ppt/notesSlides/notesSlide14.xml><?xml version="1.0" encoding="utf-8"?>
+<p:notes xmlns:a="http://schemas.openxmlformats.org/drawingml/2006/main" xmlns:r="http://schemas.openxmlformats.org/officeDocument/2006/relationships" xmlns:p="http://schemas.openxmlformats.org/presentationml/2006/main">
+  <p:cSld>
+    <p:spTree>
+      <p:nvGrpSpPr>
+        <p:cNvPr id="1" name=""/>
+        <p:cNvGrpSpPr/>
+        <p:nvPr/>
+      </p:nvGrpSpPr>
+      <p:grpSpPr>
+        <a:xfrm>
+          <a:off x="0" y="0"/>
+          <a:ext cx="0" cy="0"/>
+          <a:chOff x="0" y="0"/>
+          <a:chExt cx="0" cy="0"/>
+        </a:xfrm>
+      </p:grpSpPr>
+      <p:sp>
+        <p:nvSpPr>
+          <p:cNvPr id="2" name="Slide Image Placeholder 1"/>
+          <p:cNvSpPr>
+            <a:spLocks noGrp="1" noRot="1" noChangeAspect="1"/>
+          </p:cNvSpPr>
+          <p:nvPr>
+            <p:ph type="sldImg"/>
+          </p:nvPr>
+        </p:nvSpPr>
+        <p:spPr/>
+      </p:sp>
+      <p:sp>
+        <p:nvSpPr>
+          <p:cNvPr id="3" name="Notes Placeholder 2"/>
+          <p:cNvSpPr>
+            <a:spLocks noGrp="1"/>
+          </p:cNvSpPr>
+          <p:nvPr>
+            <p:ph type="body" idx="1"/>
+          </p:nvPr>
+        </p:nvSpPr>
+        <p:spPr/>
+        <p:txBody>
+          <a:bodyPr/>
+          <a:lstStyle/>
+          <a:p>
+            <a:r>
+              <a:rPr lang="en-US" dirty="0"/>
+              <a:t>These figures are the margin note, not text from the book. Read them as such.
+Look at the shape of it. New York, where Bill was, 450. Akron, where it started, 225.
+Detroit, 175. Cleveland - 1,100. More than the other three put together.
+Clarence Snyder started the Cleveland group in 1939, the first to call itself Alcoholics
+Anonymous. Cleveland took newcomers straight through the book and built sponsorship
+around it. That is fellowship history rather than book text, but the numbers are hard
+to argue with.
+They used the book. The numbers were higher.</a:t>
+            </a:r>
+            <a:endParaRPr lang="en-US" dirty="0"/>
+          </a:p>
+        </p:txBody>
+      </p:sp>
+      <p:sp>
+        <p:nvSpPr>
+          <p:cNvPr id="4" name="Slide Number Placeholder 3"/>
+          <p:cNvSpPr>
+            <a:spLocks noGrp="1"/>
+          </p:cNvSpPr>
+          <p:nvPr>
+            <p:ph type="sldNum" sz="quarter" idx="10"/>
+          </p:nvPr>
+        </p:nvSpPr>
+        <p:spPr/>
+        <p:txBody>
+          <a:bodyPr/>
+          <a:lstStyle/>
+          <a:p>
+            <a:fld id="{F7021451-1387-4CA6-816F-3879F97B5CBC}" type="slidenum">
+              <a:rPr lang="en-US"/>
+              <a:t>14</a:t>
             </a:fld>
             <a:endParaRPr lang="en-US"/>
           </a:p>
@@ -2566,6 +2944,2319 @@
 </p:sld>
 </file>
 
+<file path=ppt/slides/slide11.xml><?xml version="1.0" encoding="utf-8"?>
+<p:sld xmlns:a="http://schemas.openxmlformats.org/drawingml/2006/main" xmlns:r="http://schemas.openxmlformats.org/officeDocument/2006/relationships" xmlns:p="http://schemas.openxmlformats.org/presentationml/2006/main">
+  <p:cSld name="Slide 11">
+    <p:bg>
+      <p:bgPr>
+        <a:solidFill>
+          <a:srgbClr val="FFFFFF"/>
+        </a:solidFill>
+      </p:bgPr>
+    </p:bg>
+    <p:spTree>
+      <p:nvGrpSpPr>
+        <p:cNvPr id="1" name=""/>
+        <p:cNvGrpSpPr/>
+        <p:nvPr/>
+      </p:nvGrpSpPr>
+      <p:grpSpPr>
+        <a:xfrm>
+          <a:off x="0" y="0"/>
+          <a:ext cx="0" cy="0"/>
+          <a:chOff x="0" y="0"/>
+          <a:chExt cx="0" cy="0"/>
+        </a:xfrm>
+      </p:grpSpPr>
+      <p:sp>
+        <p:nvSpPr>
+          <p:cNvPr id="2" name="Text 0"/>
+          <p:cNvSpPr/>
+          <p:nvPr/>
+        </p:nvSpPr>
+        <p:spPr>
+          <a:xfrm>
+            <a:off x="548640" y="320040"/>
+            <a:ext cx="8138160" cy="566928"/>
+          </a:xfrm>
+          <a:prstGeom prst="rect">
+            <a:avLst/>
+          </a:prstGeom>
+          <a:noFill/>
+          <a:ln/>
+        </p:spPr>
+        <p:txBody>
+          <a:bodyPr wrap="square" lIns="0" tIns="0" rIns="0" bIns="0" rtlCol="0" anchor="ctr"/>
+          <a:lstStyle/>
+          <a:p>
+            <a:pPr indent="0" marL="0">
+              <a:buNone/>
+            </a:pPr>
+            <a:r>
+              <a:rPr lang="en-US" sz="3800" b="1" dirty="0">
+                <a:solidFill>
+                  <a:srgbClr val="1B2A41"/>
+                </a:solidFill>
+                <a:latin typeface="Cambria" pitchFamily="34" charset="0"/>
+                <a:ea typeface="Cambria" pitchFamily="34" charset="-122"/>
+                <a:cs typeface="Cambria" pitchFamily="34" charset="-120"/>
+              </a:rPr>
+              <a:t>Hang Together or Die Separately</a:t>
+            </a:r>
+            <a:endParaRPr lang="en-US" sz="3800" dirty="0"/>
+          </a:p>
+        </p:txBody>
+      </p:sp>
+      <p:sp>
+        <p:nvSpPr>
+          <p:cNvPr id="3" name="Text 1"/>
+          <p:cNvSpPr/>
+          <p:nvPr/>
+        </p:nvSpPr>
+        <p:spPr>
+          <a:xfrm>
+            <a:off x="548640" y="914400"/>
+            <a:ext cx="8138160" cy="347472"/>
+          </a:xfrm>
+          <a:prstGeom prst="rect">
+            <a:avLst/>
+          </a:prstGeom>
+          <a:noFill/>
+          <a:ln/>
+        </p:spPr>
+        <p:txBody>
+          <a:bodyPr wrap="square" lIns="0" tIns="0" rIns="0" bIns="0" rtlCol="0" anchor="ctr"/>
+          <a:lstStyle/>
+          <a:p>
+            <a:pPr indent="0" marL="0">
+              <a:buNone/>
+            </a:pPr>
+            <a:r>
+              <a:rPr lang="en-US" sz="1700" i="1" dirty="0">
+                <a:solidFill>
+                  <a:srgbClr val="6B7A8C"/>
+                </a:solidFill>
+                <a:latin typeface="Calibri" pitchFamily="34" charset="0"/>
+                <a:ea typeface="Calibri" pitchFamily="34" charset="-122"/>
+                <a:cs typeface="Calibri" pitchFamily="34" charset="-120"/>
+              </a:rPr>
+              <a:t>The adolescent period, and the test it faced.</a:t>
+            </a:r>
+            <a:endParaRPr lang="en-US" sz="1700" dirty="0"/>
+          </a:p>
+        </p:txBody>
+      </p:sp>
+      <p:sp>
+        <p:nvSpPr>
+          <p:cNvPr id="4" name="Shape 2"/>
+          <p:cNvSpPr/>
+          <p:nvPr/>
+        </p:nvSpPr>
+        <p:spPr>
+          <a:xfrm>
+            <a:off x="8869680" y="320040"/>
+            <a:ext cx="2770632" cy="960120"/>
+          </a:xfrm>
+          <a:prstGeom prst="roundRect">
+            <a:avLst>
+              <a:gd name="adj" fmla="val 9524"/>
+            </a:avLst>
+          </a:prstGeom>
+          <a:solidFill>
+            <a:srgbClr val="065A82"/>
+          </a:solidFill>
+          <a:ln/>
+        </p:spPr>
+      </p:sp>
+      <p:sp>
+        <p:nvSpPr>
+          <p:cNvPr id="5" name="Text 3"/>
+          <p:cNvSpPr/>
+          <p:nvPr/>
+        </p:nvSpPr>
+        <p:spPr>
+          <a:xfrm>
+            <a:off x="8869680" y="320040"/>
+            <a:ext cx="2770632" cy="960120"/>
+          </a:xfrm>
+          <a:prstGeom prst="rect">
+            <a:avLst/>
+          </a:prstGeom>
+          <a:noFill/>
+          <a:ln/>
+        </p:spPr>
+        <p:txBody>
+          <a:bodyPr wrap="square" lIns="0" tIns="0" rIns="0" bIns="0" rtlCol="0" anchor="ctr"/>
+          <a:lstStyle/>
+          <a:p>
+            <a:pPr algn="ctr" indent="0" marL="0">
+              <a:buNone/>
+            </a:pPr>
+            <a:r>
+              <a:rPr lang="en-US" sz="1700" b="1" spc="100" kern="0" dirty="0">
+                <a:solidFill>
+                  <a:srgbClr val="FFFFFF"/>
+                </a:solidFill>
+                <a:latin typeface="Cambria" pitchFamily="34" charset="0"/>
+                <a:ea typeface="Cambria" pitchFamily="34" charset="-122"/>
+                <a:cs typeface="Cambria" pitchFamily="34" charset="-120"/>
+              </a:rPr>
+              <a:t>FOREWORD</a:t>
+            </a:r>
+            <a:endParaRPr lang="en-US" sz="1700" dirty="0"/>
+          </a:p>
+          <a:p>
+            <a:pPr algn="ctr" indent="0" marL="0">
+              <a:buNone/>
+            </a:pPr>
+            <a:r>
+              <a:rPr lang="en-US" sz="1300" dirty="0">
+                <a:solidFill>
+                  <a:srgbClr val="C7DEEC"/>
+                </a:solidFill>
+                <a:latin typeface="Calibri" pitchFamily="34" charset="0"/>
+                <a:ea typeface="Calibri" pitchFamily="34" charset="-122"/>
+                <a:cs typeface="Calibri" pitchFamily="34" charset="-120"/>
+              </a:rPr>
+              <a:t>Second Ed.  ·  pp. xiv–xv</a:t>
+            </a:r>
+            <a:endParaRPr lang="en-US" sz="1700" dirty="0"/>
+          </a:p>
+        </p:txBody>
+      </p:sp>
+      <p:sp>
+        <p:nvSpPr>
+          <p:cNvPr id="6" name="Shape 4"/>
+          <p:cNvSpPr/>
+          <p:nvPr/>
+        </p:nvSpPr>
+        <p:spPr>
+          <a:xfrm>
+            <a:off x="548640" y="1417320"/>
+            <a:ext cx="11091672" cy="1645920"/>
+          </a:xfrm>
+          <a:prstGeom prst="roundRect">
+            <a:avLst>
+              <a:gd name="adj" fmla="val 4444"/>
+            </a:avLst>
+          </a:prstGeom>
+          <a:solidFill>
+            <a:srgbClr val="E2EDF4"/>
+          </a:solidFill>
+          <a:ln/>
+        </p:spPr>
+      </p:sp>
+      <p:sp>
+        <p:nvSpPr>
+          <p:cNvPr id="7" name="Text 5"/>
+          <p:cNvSpPr/>
+          <p:nvPr/>
+        </p:nvSpPr>
+        <p:spPr>
+          <a:xfrm>
+            <a:off x="914400" y="1417320"/>
+            <a:ext cx="10360152" cy="1645920"/>
+          </a:xfrm>
+          <a:prstGeom prst="rect">
+            <a:avLst/>
+          </a:prstGeom>
+          <a:noFill/>
+          <a:ln/>
+        </p:spPr>
+        <p:txBody>
+          <a:bodyPr wrap="square" lIns="0" tIns="0" rIns="0" bIns="0" rtlCol="0" anchor="ctr"/>
+          <a:lstStyle/>
+          <a:p>
+            <a:pPr indent="0" marL="0">
+              <a:lnSpc>
+                <a:spcPct val="115000"/>
+              </a:lnSpc>
+              <a:buNone/>
+            </a:pPr>
+            <a:r>
+              <a:rPr lang="en-US" sz="1900" dirty="0">
+                <a:solidFill>
+                  <a:srgbClr val="1B2A41"/>
+                </a:solidFill>
+                <a:latin typeface="Calibri" pitchFamily="34" charset="0"/>
+                <a:ea typeface="Calibri" pitchFamily="34" charset="-122"/>
+                <a:cs typeface="Calibri" pitchFamily="34" charset="-120"/>
+              </a:rPr>
+              <a:t>Our Society then entered a fearsome and exciting adolescent period. The test that it faced was this: Could these large numbers of erstwhile erratic alcoholics successfully meet and work together? Would there be quarrels over membership, leadership, and money? Would there be strivings for power and prestige? Would there be schisms which would split A.A. apart?</a:t>
+            </a:r>
+            <a:endParaRPr lang="en-US" sz="1900" dirty="0"/>
+          </a:p>
+        </p:txBody>
+      </p:sp>
+      <p:sp>
+        <p:nvSpPr>
+          <p:cNvPr id="8" name="Shape 6"/>
+          <p:cNvSpPr/>
+          <p:nvPr/>
+        </p:nvSpPr>
+        <p:spPr>
+          <a:xfrm>
+            <a:off x="548640" y="3246120"/>
+            <a:ext cx="11091672" cy="1325880"/>
+          </a:xfrm>
+          <a:prstGeom prst="roundRect">
+            <a:avLst>
+              <a:gd name="adj" fmla="val 5517"/>
+            </a:avLst>
+          </a:prstGeom>
+          <a:solidFill>
+            <a:srgbClr val="E2EDF4"/>
+          </a:solidFill>
+          <a:ln/>
+        </p:spPr>
+      </p:sp>
+      <p:sp>
+        <p:nvSpPr>
+          <p:cNvPr id="9" name="Text 7"/>
+          <p:cNvSpPr/>
+          <p:nvPr/>
+        </p:nvSpPr>
+        <p:spPr>
+          <a:xfrm>
+            <a:off x="914400" y="3246120"/>
+            <a:ext cx="10360152" cy="1325880"/>
+          </a:xfrm>
+          <a:prstGeom prst="rect">
+            <a:avLst/>
+          </a:prstGeom>
+          <a:noFill/>
+          <a:ln/>
+        </p:spPr>
+        <p:txBody>
+          <a:bodyPr wrap="square" lIns="0" tIns="0" rIns="0" bIns="0" rtlCol="0" anchor="ctr"/>
+          <a:lstStyle/>
+          <a:p>
+            <a:pPr indent="0" marL="0">
+              <a:lnSpc>
+                <a:spcPct val="115000"/>
+              </a:lnSpc>
+              <a:buNone/>
+            </a:pPr>
+            <a:r>
+              <a:rPr lang="en-US" sz="1900" dirty="0">
+                <a:solidFill>
+                  <a:srgbClr val="1B2A41"/>
+                </a:solidFill>
+                <a:latin typeface="Calibri" pitchFamily="34" charset="0"/>
+                <a:ea typeface="Calibri" pitchFamily="34" charset="-122"/>
+                <a:cs typeface="Calibri" pitchFamily="34" charset="-120"/>
+              </a:rPr>
+              <a:t>Soon A.A. was beset by these very problems on every side and in every group. But out of this frightening and at first disrupting experience the conviction grew that </a:t>
+            </a:r>
+            <a:pPr indent="0" marL="0">
+              <a:lnSpc>
+                <a:spcPct val="115000"/>
+              </a:lnSpc>
+              <a:buNone/>
+            </a:pPr>
+            <a:r>
+              <a:rPr lang="en-US" sz="1900" b="1" dirty="0">
+                <a:solidFill>
+                  <a:srgbClr val="065A82"/>
+                </a:solidFill>
+                <a:latin typeface="Calibri" pitchFamily="34" charset="0"/>
+                <a:ea typeface="Calibri" pitchFamily="34" charset="-122"/>
+                <a:cs typeface="Calibri" pitchFamily="34" charset="-120"/>
+              </a:rPr>
+              <a:t>A.A.’s had to hang together or die separately</a:t>
+            </a:r>
+            <a:pPr indent="0" marL="0">
+              <a:lnSpc>
+                <a:spcPct val="115000"/>
+              </a:lnSpc>
+              <a:buNone/>
+            </a:pPr>
+            <a:r>
+              <a:rPr lang="en-US" sz="1900" dirty="0">
+                <a:solidFill>
+                  <a:srgbClr val="1B2A41"/>
+                </a:solidFill>
+                <a:latin typeface="Calibri" pitchFamily="34" charset="0"/>
+                <a:ea typeface="Calibri" pitchFamily="34" charset="-122"/>
+                <a:cs typeface="Calibri" pitchFamily="34" charset="-120"/>
+              </a:rPr>
+              <a:t>. We had to unify our Fellowship or pass off the scene.</a:t>
+            </a:r>
+            <a:endParaRPr lang="en-US" sz="1900" dirty="0"/>
+          </a:p>
+        </p:txBody>
+      </p:sp>
+      <p:sp>
+        <p:nvSpPr>
+          <p:cNvPr id="10" name="Shape 8"/>
+          <p:cNvSpPr/>
+          <p:nvPr/>
+        </p:nvSpPr>
+        <p:spPr>
+          <a:xfrm>
+            <a:off x="548640" y="4846320"/>
+            <a:ext cx="11091672" cy="914400"/>
+          </a:xfrm>
+          <a:prstGeom prst="roundRect">
+            <a:avLst>
+              <a:gd name="adj" fmla="val 8000"/>
+            </a:avLst>
+          </a:prstGeom>
+          <a:solidFill>
+            <a:srgbClr val="1B2A41"/>
+          </a:solidFill>
+          <a:ln/>
+        </p:spPr>
+      </p:sp>
+      <p:sp>
+        <p:nvSpPr>
+          <p:cNvPr id="11" name="Text 9"/>
+          <p:cNvSpPr/>
+          <p:nvPr/>
+        </p:nvSpPr>
+        <p:spPr>
+          <a:xfrm>
+            <a:off x="914400" y="4965192"/>
+            <a:ext cx="10360152" cy="256032"/>
+          </a:xfrm>
+          <a:prstGeom prst="rect">
+            <a:avLst/>
+          </a:prstGeom>
+          <a:noFill/>
+          <a:ln/>
+        </p:spPr>
+        <p:txBody>
+          <a:bodyPr wrap="square" lIns="0" tIns="0" rIns="0" bIns="0" rtlCol="0" anchor="ctr"/>
+          <a:lstStyle/>
+          <a:p>
+            <a:pPr indent="0" marL="0">
+              <a:buNone/>
+            </a:pPr>
+            <a:r>
+              <a:rPr lang="en-US" sz="1100" b="1" spc="200" kern="0" dirty="0">
+                <a:solidFill>
+                  <a:srgbClr val="A9B8CC"/>
+                </a:solidFill>
+                <a:latin typeface="Calibri" pitchFamily="34" charset="0"/>
+                <a:ea typeface="Calibri" pitchFamily="34" charset="-122"/>
+                <a:cs typeface="Calibri" pitchFamily="34" charset="-120"/>
+              </a:rPr>
+              <a:t>MARGIN NOTE</a:t>
+            </a:r>
+            <a:endParaRPr lang="en-US" sz="1100" dirty="0"/>
+          </a:p>
+        </p:txBody>
+      </p:sp>
+      <p:sp>
+        <p:nvSpPr>
+          <p:cNvPr id="12" name="Text 10"/>
+          <p:cNvSpPr/>
+          <p:nvPr/>
+        </p:nvSpPr>
+        <p:spPr>
+          <a:xfrm>
+            <a:off x="914400" y="5239512"/>
+            <a:ext cx="10360152" cy="402336"/>
+          </a:xfrm>
+          <a:prstGeom prst="rect">
+            <a:avLst/>
+          </a:prstGeom>
+          <a:noFill/>
+          <a:ln/>
+        </p:spPr>
+        <p:txBody>
+          <a:bodyPr wrap="square" lIns="0" tIns="0" rIns="0" bIns="0" rtlCol="0" anchor="ctr"/>
+          <a:lstStyle/>
+          <a:p>
+            <a:pPr indent="0" marL="0">
+              <a:buNone/>
+            </a:pPr>
+            <a:r>
+              <a:rPr lang="en-US" sz="2200" b="1" dirty="0">
+                <a:solidFill>
+                  <a:srgbClr val="FFFFFF"/>
+                </a:solidFill>
+                <a:latin typeface="Cambria" pitchFamily="34" charset="0"/>
+                <a:ea typeface="Cambria" pitchFamily="34" charset="-122"/>
+                <a:cs typeface="Cambria" pitchFamily="34" charset="-120"/>
+              </a:rPr>
+              <a:t>The Fellowship was named by the book — Alcoholics Anonymous.</a:t>
+            </a:r>
+            <a:endParaRPr lang="en-US" sz="2200" dirty="0"/>
+          </a:p>
+        </p:txBody>
+      </p:sp>
+      <p:sp>
+        <p:nvSpPr>
+          <p:cNvPr id="13" name="Text 11"/>
+          <p:cNvSpPr/>
+          <p:nvPr/>
+        </p:nvSpPr>
+        <p:spPr>
+          <a:xfrm>
+            <a:off x="548640" y="5897880"/>
+            <a:ext cx="11091672" cy="292608"/>
+          </a:xfrm>
+          <a:prstGeom prst="rect">
+            <a:avLst/>
+          </a:prstGeom>
+          <a:noFill/>
+          <a:ln/>
+        </p:spPr>
+        <p:txBody>
+          <a:bodyPr wrap="square" lIns="0" tIns="0" rIns="0" bIns="0" rtlCol="0" anchor="ctr"/>
+          <a:lstStyle/>
+          <a:p>
+            <a:pPr indent="0" marL="0">
+              <a:buNone/>
+            </a:pPr>
+            <a:r>
+              <a:rPr lang="en-US" sz="1200" i="1" dirty="0">
+                <a:solidFill>
+                  <a:srgbClr val="6B7A8C"/>
+                </a:solidFill>
+                <a:latin typeface="Calibri" pitchFamily="34" charset="0"/>
+                <a:ea typeface="Calibri" pitchFamily="34" charset="-122"/>
+                <a:cs typeface="Calibri" pitchFamily="34" charset="-120"/>
+              </a:rPr>
+              <a:t>Alcoholics Anonymous</a:t>
+            </a:r>
+            <a:pPr indent="0" marL="0">
+              <a:buNone/>
+            </a:pPr>
+            <a:r>
+              <a:rPr lang="en-US" sz="1200" dirty="0">
+                <a:solidFill>
+                  <a:srgbClr val="6B7A8C"/>
+                </a:solidFill>
+                <a:latin typeface="Calibri" pitchFamily="34" charset="0"/>
+                <a:ea typeface="Calibri" pitchFamily="34" charset="-122"/>
+                <a:cs typeface="Calibri" pitchFamily="34" charset="-120"/>
+              </a:rPr>
+              <a:t>, 4th ed., Foreword to the Second Edition, pp. xiv–xv.</a:t>
+            </a:r>
+            <a:endParaRPr lang="en-US" sz="1200" dirty="0"/>
+          </a:p>
+        </p:txBody>
+      </p:sp>
+      <p:sp>
+        <p:nvSpPr>
+          <p:cNvPr id="14" name="Text 12"/>
+          <p:cNvSpPr/>
+          <p:nvPr/>
+        </p:nvSpPr>
+        <p:spPr>
+          <a:xfrm>
+            <a:off x="548640" y="6355080"/>
+            <a:ext cx="11091672" cy="292608"/>
+          </a:xfrm>
+          <a:prstGeom prst="rect">
+            <a:avLst/>
+          </a:prstGeom>
+          <a:noFill/>
+          <a:ln/>
+        </p:spPr>
+        <p:txBody>
+          <a:bodyPr wrap="square" lIns="0" tIns="0" rIns="0" bIns="0" rtlCol="0" anchor="ctr"/>
+          <a:lstStyle/>
+          <a:p>
+            <a:pPr indent="0" marL="0">
+              <a:buNone/>
+            </a:pPr>
+            <a:r>
+              <a:rPr lang="en-US" sz="950" dirty="0">
+                <a:solidFill>
+                  <a:srgbClr val="6B7A8C"/>
+                </a:solidFill>
+                <a:latin typeface="Calibri" pitchFamily="34" charset="0"/>
+                <a:ea typeface="Calibri" pitchFamily="34" charset="-122"/>
+                <a:cs typeface="Calibri" pitchFamily="34" charset="-120"/>
+              </a:rPr>
+              <a:t>Copyright © Alcoholics Anonymous World Services, Inc. All rights reserved. Intended for personal use only, and not to be reproduced further or distributed for resale.</a:t>
+            </a:r>
+            <a:endParaRPr lang="en-US" sz="950" dirty="0"/>
+          </a:p>
+        </p:txBody>
+      </p:sp>
+    </p:spTree>
+  </p:cSld>
+  <p:clrMapOvr>
+    <a:masterClrMapping/>
+  </p:clrMapOvr>
+</p:sld>
+</file>
+
+<file path=ppt/slides/slide12.xml><?xml version="1.0" encoding="utf-8"?>
+<p:sld xmlns:a="http://schemas.openxmlformats.org/drawingml/2006/main" xmlns:r="http://schemas.openxmlformats.org/officeDocument/2006/relationships" xmlns:p="http://schemas.openxmlformats.org/presentationml/2006/main">
+  <p:cSld name="Slide 12">
+    <p:bg>
+      <p:bgPr>
+        <a:solidFill>
+          <a:srgbClr val="FFFFFF"/>
+        </a:solidFill>
+      </p:bgPr>
+    </p:bg>
+    <p:spTree>
+      <p:nvGrpSpPr>
+        <p:cNvPr id="1" name=""/>
+        <p:cNvGrpSpPr/>
+        <p:nvPr/>
+      </p:nvGrpSpPr>
+      <p:grpSpPr>
+        <a:xfrm>
+          <a:off x="0" y="0"/>
+          <a:ext cx="0" cy="0"/>
+          <a:chOff x="0" y="0"/>
+          <a:chExt cx="0" cy="0"/>
+        </a:xfrm>
+      </p:grpSpPr>
+      <p:sp>
+        <p:nvSpPr>
+          <p:cNvPr id="2" name="Text 0"/>
+          <p:cNvSpPr/>
+          <p:nvPr/>
+        </p:nvSpPr>
+        <p:spPr>
+          <a:xfrm>
+            <a:off x="548640" y="320040"/>
+            <a:ext cx="8138160" cy="566928"/>
+          </a:xfrm>
+          <a:prstGeom prst="rect">
+            <a:avLst/>
+          </a:prstGeom>
+          <a:noFill/>
+          <a:ln/>
+        </p:spPr>
+        <p:txBody>
+          <a:bodyPr wrap="square" lIns="0" tIns="0" rIns="0" bIns="0" rtlCol="0" anchor="ctr"/>
+          <a:lstStyle/>
+          <a:p>
+            <a:pPr indent="0" marL="0">
+              <a:buNone/>
+            </a:pPr>
+            <a:r>
+              <a:rPr lang="en-US" sz="3800" b="1" dirty="0">
+                <a:solidFill>
+                  <a:srgbClr val="1B2A41"/>
+                </a:solidFill>
+                <a:latin typeface="Cambria" pitchFamily="34" charset="0"/>
+                <a:ea typeface="Cambria" pitchFamily="34" charset="-122"/>
+                <a:cs typeface="Cambria" pitchFamily="34" charset="-120"/>
+              </a:rPr>
+              <a:t>Came to A.A. and Really Tried</a:t>
+            </a:r>
+            <a:endParaRPr lang="en-US" sz="3800" dirty="0"/>
+          </a:p>
+        </p:txBody>
+      </p:sp>
+      <p:sp>
+        <p:nvSpPr>
+          <p:cNvPr id="3" name="Text 1"/>
+          <p:cNvSpPr/>
+          <p:nvPr/>
+        </p:nvSpPr>
+        <p:spPr>
+          <a:xfrm>
+            <a:off x="548640" y="914400"/>
+            <a:ext cx="8138160" cy="347472"/>
+          </a:xfrm>
+          <a:prstGeom prst="rect">
+            <a:avLst/>
+          </a:prstGeom>
+          <a:noFill/>
+          <a:ln/>
+        </p:spPr>
+        <p:txBody>
+          <a:bodyPr wrap="square" lIns="0" tIns="0" rIns="0" bIns="0" rtlCol="0" anchor="ctr"/>
+          <a:lstStyle/>
+          <a:p>
+            <a:pPr indent="0" marL="0">
+              <a:buNone/>
+            </a:pPr>
+            <a:r>
+              <a:rPr lang="en-US" sz="1700" i="1" dirty="0">
+                <a:solidFill>
+                  <a:srgbClr val="6B7A8C"/>
+                </a:solidFill>
+                <a:latin typeface="Calibri" pitchFamily="34" charset="0"/>
+                <a:ea typeface="Calibri" pitchFamily="34" charset="-122"/>
+                <a:cs typeface="Calibri" pitchFamily="34" charset="-120"/>
+              </a:rPr>
+              <a:t>Why public acceptance grew.</a:t>
+            </a:r>
+            <a:endParaRPr lang="en-US" sz="1700" dirty="0"/>
+          </a:p>
+        </p:txBody>
+      </p:sp>
+      <p:sp>
+        <p:nvSpPr>
+          <p:cNvPr id="4" name="Shape 2"/>
+          <p:cNvSpPr/>
+          <p:nvPr/>
+        </p:nvSpPr>
+        <p:spPr>
+          <a:xfrm>
+            <a:off x="8869680" y="320040"/>
+            <a:ext cx="2770632" cy="960120"/>
+          </a:xfrm>
+          <a:prstGeom prst="roundRect">
+            <a:avLst>
+              <a:gd name="adj" fmla="val 9524"/>
+            </a:avLst>
+          </a:prstGeom>
+          <a:solidFill>
+            <a:srgbClr val="2C5F2D"/>
+          </a:solidFill>
+          <a:ln/>
+        </p:spPr>
+      </p:sp>
+      <p:sp>
+        <p:nvSpPr>
+          <p:cNvPr id="5" name="Text 3"/>
+          <p:cNvSpPr/>
+          <p:nvPr/>
+        </p:nvSpPr>
+        <p:spPr>
+          <a:xfrm>
+            <a:off x="8869680" y="320040"/>
+            <a:ext cx="2770632" cy="960120"/>
+          </a:xfrm>
+          <a:prstGeom prst="rect">
+            <a:avLst/>
+          </a:prstGeom>
+          <a:noFill/>
+          <a:ln/>
+        </p:spPr>
+        <p:txBody>
+          <a:bodyPr wrap="square" lIns="0" tIns="0" rIns="0" bIns="0" rtlCol="0" anchor="ctr"/>
+          <a:lstStyle/>
+          <a:p>
+            <a:pPr algn="ctr" indent="0" marL="0">
+              <a:buNone/>
+            </a:pPr>
+            <a:r>
+              <a:rPr lang="en-US" sz="1700" b="1" spc="100" kern="0" dirty="0">
+                <a:solidFill>
+                  <a:srgbClr val="FFFFFF"/>
+                </a:solidFill>
+                <a:latin typeface="Cambria" pitchFamily="34" charset="0"/>
+                <a:ea typeface="Cambria" pitchFamily="34" charset="-122"/>
+                <a:cs typeface="Cambria" pitchFamily="34" charset="-120"/>
+              </a:rPr>
+              <a:t>FOREWORD</a:t>
+            </a:r>
+            <a:endParaRPr lang="en-US" sz="1700" dirty="0"/>
+          </a:p>
+          <a:p>
+            <a:pPr algn="ctr" indent="0" marL="0">
+              <a:buNone/>
+            </a:pPr>
+            <a:r>
+              <a:rPr lang="en-US" sz="1300" dirty="0">
+                <a:solidFill>
+                  <a:srgbClr val="D5E3CE"/>
+                </a:solidFill>
+                <a:latin typeface="Calibri" pitchFamily="34" charset="0"/>
+                <a:ea typeface="Calibri" pitchFamily="34" charset="-122"/>
+                <a:cs typeface="Calibri" pitchFamily="34" charset="-120"/>
+              </a:rPr>
+              <a:t>Second Ed.  ·  pp. xv–xvi</a:t>
+            </a:r>
+            <a:endParaRPr lang="en-US" sz="1700" dirty="0"/>
+          </a:p>
+        </p:txBody>
+      </p:sp>
+      <p:sp>
+        <p:nvSpPr>
+          <p:cNvPr id="6" name="Shape 4"/>
+          <p:cNvSpPr/>
+          <p:nvPr/>
+        </p:nvSpPr>
+        <p:spPr>
+          <a:xfrm>
+            <a:off x="548640" y="1417320"/>
+            <a:ext cx="11091672" cy="1371600"/>
+          </a:xfrm>
+          <a:prstGeom prst="roundRect">
+            <a:avLst>
+              <a:gd name="adj" fmla="val 5333"/>
+            </a:avLst>
+          </a:prstGeom>
+          <a:solidFill>
+            <a:srgbClr val="EAF1E6"/>
+          </a:solidFill>
+          <a:ln/>
+        </p:spPr>
+      </p:sp>
+      <p:sp>
+        <p:nvSpPr>
+          <p:cNvPr id="7" name="Text 5"/>
+          <p:cNvSpPr/>
+          <p:nvPr/>
+        </p:nvSpPr>
+        <p:spPr>
+          <a:xfrm>
+            <a:off x="914400" y="1417320"/>
+            <a:ext cx="10360152" cy="1371600"/>
+          </a:xfrm>
+          <a:prstGeom prst="rect">
+            <a:avLst/>
+          </a:prstGeom>
+          <a:noFill/>
+          <a:ln/>
+        </p:spPr>
+        <p:txBody>
+          <a:bodyPr wrap="square" lIns="0" tIns="0" rIns="0" bIns="0" rtlCol="0" anchor="ctr"/>
+          <a:lstStyle/>
+          <a:p>
+            <a:pPr indent="0" marL="0">
+              <a:lnSpc>
+                <a:spcPct val="115000"/>
+              </a:lnSpc>
+              <a:buNone/>
+            </a:pPr>
+            <a:r>
+              <a:rPr lang="en-US" sz="1900" dirty="0">
+                <a:solidFill>
+                  <a:srgbClr val="1B2A41"/>
+                </a:solidFill>
+                <a:latin typeface="Calibri" pitchFamily="34" charset="0"/>
+                <a:ea typeface="Calibri" pitchFamily="34" charset="-122"/>
+                <a:cs typeface="Calibri" pitchFamily="34" charset="-120"/>
+              </a:rPr>
+              <a:t>While the internal difficulties of our adolescent period were being ironed out, public acceptance of A.A. grew by leaps and bounds. For this there were two principal reasons: the large numbers of recoveries, and reunited homes. These made their impressions everywhere.</a:t>
+            </a:r>
+            <a:endParaRPr lang="en-US" sz="1900" dirty="0"/>
+          </a:p>
+        </p:txBody>
+      </p:sp>
+      <p:sp>
+        <p:nvSpPr>
+          <p:cNvPr id="8" name="Shape 6"/>
+          <p:cNvSpPr/>
+          <p:nvPr/>
+        </p:nvSpPr>
+        <p:spPr>
+          <a:xfrm>
+            <a:off x="548640" y="2971800"/>
+            <a:ext cx="11091672" cy="2011680"/>
+          </a:xfrm>
+          <a:prstGeom prst="roundRect">
+            <a:avLst>
+              <a:gd name="adj" fmla="val 3636"/>
+            </a:avLst>
+          </a:prstGeom>
+          <a:solidFill>
+            <a:srgbClr val="EAF1E6"/>
+          </a:solidFill>
+          <a:ln/>
+        </p:spPr>
+      </p:sp>
+      <p:sp>
+        <p:nvSpPr>
+          <p:cNvPr id="9" name="Text 7"/>
+          <p:cNvSpPr/>
+          <p:nvPr/>
+        </p:nvSpPr>
+        <p:spPr>
+          <a:xfrm>
+            <a:off x="914400" y="2971800"/>
+            <a:ext cx="10360152" cy="2011680"/>
+          </a:xfrm>
+          <a:prstGeom prst="rect">
+            <a:avLst/>
+          </a:prstGeom>
+          <a:noFill/>
+          <a:ln/>
+        </p:spPr>
+        <p:txBody>
+          <a:bodyPr wrap="square" lIns="0" tIns="0" rIns="0" bIns="0" rtlCol="0" anchor="ctr"/>
+          <a:lstStyle/>
+          <a:p>
+            <a:pPr indent="0" marL="0">
+              <a:lnSpc>
+                <a:spcPct val="115000"/>
+              </a:lnSpc>
+              <a:buNone/>
+            </a:pPr>
+            <a:r>
+              <a:rPr lang="en-US" sz="1900" dirty="0">
+                <a:solidFill>
+                  <a:srgbClr val="1B2A41"/>
+                </a:solidFill>
+                <a:latin typeface="Calibri" pitchFamily="34" charset="0"/>
+                <a:ea typeface="Calibri" pitchFamily="34" charset="-122"/>
+                <a:cs typeface="Calibri" pitchFamily="34" charset="-120"/>
+              </a:rPr>
+              <a:t>Of alcoholics who came to A.A. and </a:t>
+            </a:r>
+            <a:pPr indent="0" marL="0">
+              <a:lnSpc>
+                <a:spcPct val="115000"/>
+              </a:lnSpc>
+              <a:buNone/>
+            </a:pPr>
+            <a:r>
+              <a:rPr lang="en-US" sz="1900" b="1" i="1" dirty="0">
+                <a:solidFill>
+                  <a:srgbClr val="1B2A41"/>
+                </a:solidFill>
+                <a:latin typeface="Calibri" pitchFamily="34" charset="0"/>
+                <a:ea typeface="Calibri" pitchFamily="34" charset="-122"/>
+                <a:cs typeface="Calibri" pitchFamily="34" charset="-120"/>
+              </a:rPr>
+              <a:t>really tried</a:t>
+            </a:r>
+            <a:pPr indent="0" marL="0">
+              <a:lnSpc>
+                <a:spcPct val="115000"/>
+              </a:lnSpc>
+              <a:buNone/>
+            </a:pPr>
+            <a:r>
+              <a:rPr lang="en-US" sz="1900" dirty="0">
+                <a:solidFill>
+                  <a:srgbClr val="1B2A41"/>
+                </a:solidFill>
+                <a:latin typeface="Calibri" pitchFamily="34" charset="0"/>
+                <a:ea typeface="Calibri" pitchFamily="34" charset="-122"/>
+                <a:cs typeface="Calibri" pitchFamily="34" charset="-120"/>
+              </a:rPr>
+              <a:t>, </a:t>
+            </a:r>
+            <a:pPr indent="0" marL="0">
+              <a:lnSpc>
+                <a:spcPct val="115000"/>
+              </a:lnSpc>
+              <a:buNone/>
+            </a:pPr>
+            <a:r>
+              <a:rPr lang="en-US" sz="1900" b="1" dirty="0">
+                <a:solidFill>
+                  <a:srgbClr val="2C5F2D"/>
+                </a:solidFill>
+                <a:latin typeface="Calibri" pitchFamily="34" charset="0"/>
+                <a:ea typeface="Calibri" pitchFamily="34" charset="-122"/>
+                <a:cs typeface="Calibri" pitchFamily="34" charset="-120"/>
+              </a:rPr>
+              <a:t>50%</a:t>
+            </a:r>
+            <a:pPr indent="0" marL="0">
+              <a:lnSpc>
+                <a:spcPct val="115000"/>
+              </a:lnSpc>
+              <a:buNone/>
+            </a:pPr>
+            <a:r>
+              <a:rPr lang="en-US" sz="1900" dirty="0">
+                <a:solidFill>
+                  <a:srgbClr val="1B2A41"/>
+                </a:solidFill>
+                <a:latin typeface="Calibri" pitchFamily="34" charset="0"/>
+                <a:ea typeface="Calibri" pitchFamily="34" charset="-122"/>
+                <a:cs typeface="Calibri" pitchFamily="34" charset="-120"/>
+              </a:rPr>
+              <a:t> got sober at once and remained that way; </a:t>
+            </a:r>
+            <a:pPr indent="0" marL="0">
+              <a:lnSpc>
+                <a:spcPct val="115000"/>
+              </a:lnSpc>
+              <a:buNone/>
+            </a:pPr>
+            <a:r>
+              <a:rPr lang="en-US" sz="1900" b="1" dirty="0">
+                <a:solidFill>
+                  <a:srgbClr val="2C5F2D"/>
+                </a:solidFill>
+                <a:latin typeface="Calibri" pitchFamily="34" charset="0"/>
+                <a:ea typeface="Calibri" pitchFamily="34" charset="-122"/>
+                <a:cs typeface="Calibri" pitchFamily="34" charset="-120"/>
+              </a:rPr>
+              <a:t>25%</a:t>
+            </a:r>
+            <a:pPr indent="0" marL="0">
+              <a:lnSpc>
+                <a:spcPct val="115000"/>
+              </a:lnSpc>
+              <a:buNone/>
+            </a:pPr>
+            <a:r>
+              <a:rPr lang="en-US" sz="1900" dirty="0">
+                <a:solidFill>
+                  <a:srgbClr val="1B2A41"/>
+                </a:solidFill>
+                <a:latin typeface="Calibri" pitchFamily="34" charset="0"/>
+                <a:ea typeface="Calibri" pitchFamily="34" charset="-122"/>
+                <a:cs typeface="Calibri" pitchFamily="34" charset="-120"/>
+              </a:rPr>
+              <a:t> sobered up after some relapses, and among the remainder, those who stayed on with A.A. showed improvement. Other thousands came to a few A.A. meetings and at first decided they didn’t want the program. But great numbers of these—</a:t>
+            </a:r>
+            <a:pPr indent="0" marL="0">
+              <a:lnSpc>
+                <a:spcPct val="115000"/>
+              </a:lnSpc>
+              <a:buNone/>
+            </a:pPr>
+            <a:r>
+              <a:rPr lang="en-US" sz="1900" b="1" dirty="0">
+                <a:solidFill>
+                  <a:srgbClr val="2C5F2D"/>
+                </a:solidFill>
+                <a:latin typeface="Calibri" pitchFamily="34" charset="0"/>
+                <a:ea typeface="Calibri" pitchFamily="34" charset="-122"/>
+                <a:cs typeface="Calibri" pitchFamily="34" charset="-120"/>
+              </a:rPr>
+              <a:t>about two out of three</a:t>
+            </a:r>
+            <a:pPr indent="0" marL="0">
+              <a:lnSpc>
+                <a:spcPct val="115000"/>
+              </a:lnSpc>
+              <a:buNone/>
+            </a:pPr>
+            <a:r>
+              <a:rPr lang="en-US" sz="1900" dirty="0">
+                <a:solidFill>
+                  <a:srgbClr val="1B2A41"/>
+                </a:solidFill>
+                <a:latin typeface="Calibri" pitchFamily="34" charset="0"/>
+                <a:ea typeface="Calibri" pitchFamily="34" charset="-122"/>
+                <a:cs typeface="Calibri" pitchFamily="34" charset="-120"/>
+              </a:rPr>
+              <a:t>—began to return as time passed.</a:t>
+            </a:r>
+            <a:endParaRPr lang="en-US" sz="1900" dirty="0"/>
+          </a:p>
+        </p:txBody>
+      </p:sp>
+      <p:sp>
+        <p:nvSpPr>
+          <p:cNvPr id="10" name="Text 8"/>
+          <p:cNvSpPr/>
+          <p:nvPr/>
+        </p:nvSpPr>
+        <p:spPr>
+          <a:xfrm>
+            <a:off x="548640" y="5257800"/>
+            <a:ext cx="11091672" cy="292608"/>
+          </a:xfrm>
+          <a:prstGeom prst="rect">
+            <a:avLst/>
+          </a:prstGeom>
+          <a:noFill/>
+          <a:ln/>
+        </p:spPr>
+        <p:txBody>
+          <a:bodyPr wrap="square" lIns="0" tIns="0" rIns="0" bIns="0" rtlCol="0" anchor="ctr"/>
+          <a:lstStyle/>
+          <a:p>
+            <a:pPr indent="0" marL="0">
+              <a:buNone/>
+            </a:pPr>
+            <a:r>
+              <a:rPr lang="en-US" sz="1200" i="1" dirty="0">
+                <a:solidFill>
+                  <a:srgbClr val="6B7A8C"/>
+                </a:solidFill>
+                <a:latin typeface="Calibri" pitchFamily="34" charset="0"/>
+                <a:ea typeface="Calibri" pitchFamily="34" charset="-122"/>
+                <a:cs typeface="Calibri" pitchFamily="34" charset="-120"/>
+              </a:rPr>
+              <a:t>Alcoholics Anonymous</a:t>
+            </a:r>
+            <a:pPr indent="0" marL="0">
+              <a:buNone/>
+            </a:pPr>
+            <a:r>
+              <a:rPr lang="en-US" sz="1200" dirty="0">
+                <a:solidFill>
+                  <a:srgbClr val="6B7A8C"/>
+                </a:solidFill>
+                <a:latin typeface="Calibri" pitchFamily="34" charset="0"/>
+                <a:ea typeface="Calibri" pitchFamily="34" charset="-122"/>
+                <a:cs typeface="Calibri" pitchFamily="34" charset="-120"/>
+              </a:rPr>
+              <a:t>, 4th ed., Foreword to the Second Edition, pp. xv–xvi.</a:t>
+            </a:r>
+            <a:endParaRPr lang="en-US" sz="1200" dirty="0"/>
+          </a:p>
+        </p:txBody>
+      </p:sp>
+      <p:sp>
+        <p:nvSpPr>
+          <p:cNvPr id="11" name="Text 9"/>
+          <p:cNvSpPr/>
+          <p:nvPr/>
+        </p:nvSpPr>
+        <p:spPr>
+          <a:xfrm>
+            <a:off x="548640" y="6355080"/>
+            <a:ext cx="11091672" cy="292608"/>
+          </a:xfrm>
+          <a:prstGeom prst="rect">
+            <a:avLst/>
+          </a:prstGeom>
+          <a:noFill/>
+          <a:ln/>
+        </p:spPr>
+        <p:txBody>
+          <a:bodyPr wrap="square" lIns="0" tIns="0" rIns="0" bIns="0" rtlCol="0" anchor="ctr"/>
+          <a:lstStyle/>
+          <a:p>
+            <a:pPr indent="0" marL="0">
+              <a:buNone/>
+            </a:pPr>
+            <a:r>
+              <a:rPr lang="en-US" sz="950" dirty="0">
+                <a:solidFill>
+                  <a:srgbClr val="6B7A8C"/>
+                </a:solidFill>
+                <a:latin typeface="Calibri" pitchFamily="34" charset="0"/>
+                <a:ea typeface="Calibri" pitchFamily="34" charset="-122"/>
+                <a:cs typeface="Calibri" pitchFamily="34" charset="-120"/>
+              </a:rPr>
+              <a:t>Copyright © Alcoholics Anonymous World Services, Inc. All rights reserved. Intended for personal use only, and not to be reproduced further or distributed for resale.</a:t>
+            </a:r>
+            <a:endParaRPr lang="en-US" sz="950" dirty="0"/>
+          </a:p>
+        </p:txBody>
+      </p:sp>
+    </p:spTree>
+  </p:cSld>
+  <p:clrMapOvr>
+    <a:masterClrMapping/>
+  </p:clrMapOvr>
+</p:sld>
+</file>
+
+<file path=ppt/slides/slide13.xml><?xml version="1.0" encoding="utf-8"?>
+<p:sld xmlns:a="http://schemas.openxmlformats.org/drawingml/2006/main" xmlns:r="http://schemas.openxmlformats.org/officeDocument/2006/relationships" xmlns:p="http://schemas.openxmlformats.org/presentationml/2006/main">
+  <p:cSld name="Slide 13">
+    <p:bg>
+      <p:bgPr>
+        <a:solidFill>
+          <a:srgbClr val="FFFFFF"/>
+        </a:solidFill>
+      </p:bgPr>
+    </p:bg>
+    <p:spTree>
+      <p:nvGrpSpPr>
+        <p:cNvPr id="1" name=""/>
+        <p:cNvGrpSpPr/>
+        <p:nvPr/>
+      </p:nvGrpSpPr>
+      <p:grpSpPr>
+        <a:xfrm>
+          <a:off x="0" y="0"/>
+          <a:ext cx="0" cy="0"/>
+          <a:chOff x="0" y="0"/>
+          <a:chExt cx="0" cy="0"/>
+        </a:xfrm>
+      </p:grpSpPr>
+      <p:sp>
+        <p:nvSpPr>
+          <p:cNvPr id="2" name="Text 0"/>
+          <p:cNvSpPr/>
+          <p:nvPr/>
+        </p:nvSpPr>
+        <p:spPr>
+          <a:xfrm>
+            <a:off x="548640" y="320040"/>
+            <a:ext cx="8138160" cy="566928"/>
+          </a:xfrm>
+          <a:prstGeom prst="rect">
+            <a:avLst/>
+          </a:prstGeom>
+          <a:noFill/>
+          <a:ln/>
+        </p:spPr>
+        <p:txBody>
+          <a:bodyPr wrap="square" lIns="0" tIns="0" rIns="0" bIns="0" rtlCol="0" anchor="ctr"/>
+          <a:lstStyle/>
+          <a:p>
+            <a:pPr indent="0" marL="0">
+              <a:buNone/>
+            </a:pPr>
+            <a:r>
+              <a:rPr lang="en-US" sz="3800" b="1" dirty="0">
+                <a:solidFill>
+                  <a:srgbClr val="1B2A41"/>
+                </a:solidFill>
+                <a:latin typeface="Cambria" pitchFamily="34" charset="0"/>
+                <a:ea typeface="Cambria" pitchFamily="34" charset="-122"/>
+                <a:cs typeface="Cambria" pitchFamily="34" charset="-120"/>
+              </a:rPr>
+              <a:t>Not a Religious Organization</a:t>
+            </a:r>
+            <a:endParaRPr lang="en-US" sz="3800" dirty="0"/>
+          </a:p>
+        </p:txBody>
+      </p:sp>
+      <p:sp>
+        <p:nvSpPr>
+          <p:cNvPr id="3" name="Text 1"/>
+          <p:cNvSpPr/>
+          <p:nvPr/>
+        </p:nvSpPr>
+        <p:spPr>
+          <a:xfrm>
+            <a:off x="548640" y="914400"/>
+            <a:ext cx="8138160" cy="347472"/>
+          </a:xfrm>
+          <a:prstGeom prst="rect">
+            <a:avLst/>
+          </a:prstGeom>
+          <a:noFill/>
+          <a:ln/>
+        </p:spPr>
+        <p:txBody>
+          <a:bodyPr wrap="square" lIns="0" tIns="0" rIns="0" bIns="0" rtlCol="0" anchor="ctr"/>
+          <a:lstStyle/>
+          <a:p>
+            <a:pPr indent="0" marL="0">
+              <a:buNone/>
+            </a:pPr>
+            <a:r>
+              <a:rPr lang="en-US" sz="1700" i="1" dirty="0">
+                <a:solidFill>
+                  <a:srgbClr val="6B7A8C"/>
+                </a:solidFill>
+                <a:latin typeface="Calibri" pitchFamily="34" charset="0"/>
+                <a:ea typeface="Calibri" pitchFamily="34" charset="-122"/>
+                <a:cs typeface="Calibri" pitchFamily="34" charset="-120"/>
+              </a:rPr>
+              <a:t>What A.A. is not.</a:t>
+            </a:r>
+            <a:endParaRPr lang="en-US" sz="1700" dirty="0"/>
+          </a:p>
+        </p:txBody>
+      </p:sp>
+      <p:sp>
+        <p:nvSpPr>
+          <p:cNvPr id="4" name="Shape 2"/>
+          <p:cNvSpPr/>
+          <p:nvPr/>
+        </p:nvSpPr>
+        <p:spPr>
+          <a:xfrm>
+            <a:off x="8869680" y="320040"/>
+            <a:ext cx="2770632" cy="960120"/>
+          </a:xfrm>
+          <a:prstGeom prst="roundRect">
+            <a:avLst>
+              <a:gd name="adj" fmla="val 9524"/>
+            </a:avLst>
+          </a:prstGeom>
+          <a:solidFill>
+            <a:srgbClr val="065A82"/>
+          </a:solidFill>
+          <a:ln/>
+        </p:spPr>
+      </p:sp>
+      <p:sp>
+        <p:nvSpPr>
+          <p:cNvPr id="5" name="Text 3"/>
+          <p:cNvSpPr/>
+          <p:nvPr/>
+        </p:nvSpPr>
+        <p:spPr>
+          <a:xfrm>
+            <a:off x="8869680" y="320040"/>
+            <a:ext cx="2770632" cy="960120"/>
+          </a:xfrm>
+          <a:prstGeom prst="rect">
+            <a:avLst/>
+          </a:prstGeom>
+          <a:noFill/>
+          <a:ln/>
+        </p:spPr>
+        <p:txBody>
+          <a:bodyPr wrap="square" lIns="0" tIns="0" rIns="0" bIns="0" rtlCol="0" anchor="ctr"/>
+          <a:lstStyle/>
+          <a:p>
+            <a:pPr algn="ctr" indent="0" marL="0">
+              <a:buNone/>
+            </a:pPr>
+            <a:r>
+              <a:rPr lang="en-US" sz="1700" b="1" spc="100" kern="0" dirty="0">
+                <a:solidFill>
+                  <a:srgbClr val="FFFFFF"/>
+                </a:solidFill>
+                <a:latin typeface="Cambria" pitchFamily="34" charset="0"/>
+                <a:ea typeface="Cambria" pitchFamily="34" charset="-122"/>
+                <a:cs typeface="Cambria" pitchFamily="34" charset="-120"/>
+              </a:rPr>
+              <a:t>FOREWORD</a:t>
+            </a:r>
+            <a:endParaRPr lang="en-US" sz="1700" dirty="0"/>
+          </a:p>
+          <a:p>
+            <a:pPr algn="ctr" indent="0" marL="0">
+              <a:buNone/>
+            </a:pPr>
+            <a:r>
+              <a:rPr lang="en-US" sz="1300" dirty="0">
+                <a:solidFill>
+                  <a:srgbClr val="C7DEEC"/>
+                </a:solidFill>
+                <a:latin typeface="Calibri" pitchFamily="34" charset="0"/>
+                <a:ea typeface="Calibri" pitchFamily="34" charset="-122"/>
+                <a:cs typeface="Calibri" pitchFamily="34" charset="-120"/>
+              </a:rPr>
+              <a:t>Second Ed.  ·  p. xvi</a:t>
+            </a:r>
+            <a:endParaRPr lang="en-US" sz="1700" dirty="0"/>
+          </a:p>
+        </p:txBody>
+      </p:sp>
+      <p:sp>
+        <p:nvSpPr>
+          <p:cNvPr id="6" name="Shape 4"/>
+          <p:cNvSpPr/>
+          <p:nvPr/>
+        </p:nvSpPr>
+        <p:spPr>
+          <a:xfrm>
+            <a:off x="548640" y="1737360"/>
+            <a:ext cx="11091672" cy="2194560"/>
+          </a:xfrm>
+          <a:prstGeom prst="roundRect">
+            <a:avLst>
+              <a:gd name="adj" fmla="val 3333"/>
+            </a:avLst>
+          </a:prstGeom>
+          <a:solidFill>
+            <a:srgbClr val="E2EDF4"/>
+          </a:solidFill>
+          <a:ln/>
+        </p:spPr>
+      </p:sp>
+      <p:sp>
+        <p:nvSpPr>
+          <p:cNvPr id="7" name="Text 5"/>
+          <p:cNvSpPr/>
+          <p:nvPr/>
+        </p:nvSpPr>
+        <p:spPr>
+          <a:xfrm>
+            <a:off x="914400" y="1737360"/>
+            <a:ext cx="10360152" cy="2194560"/>
+          </a:xfrm>
+          <a:prstGeom prst="rect">
+            <a:avLst/>
+          </a:prstGeom>
+          <a:noFill/>
+          <a:ln/>
+        </p:spPr>
+        <p:txBody>
+          <a:bodyPr wrap="square" lIns="0" tIns="0" rIns="0" bIns="0" rtlCol="0" anchor="ctr"/>
+          <a:lstStyle/>
+          <a:p>
+            <a:pPr indent="0" marL="0">
+              <a:lnSpc>
+                <a:spcPct val="115000"/>
+              </a:lnSpc>
+              <a:buNone/>
+            </a:pPr>
+            <a:r>
+              <a:rPr lang="en-US" sz="2600" b="1" dirty="0">
+                <a:solidFill>
+                  <a:srgbClr val="1B2A41"/>
+                </a:solidFill>
+                <a:latin typeface="Calibri" pitchFamily="34" charset="0"/>
+                <a:ea typeface="Calibri" pitchFamily="34" charset="-122"/>
+                <a:cs typeface="Calibri" pitchFamily="34" charset="-120"/>
+              </a:rPr>
+              <a:t>Alcoholics Anonymous is not a religious organization.</a:t>
+            </a:r>
+            <a:pPr indent="0" marL="0">
+              <a:lnSpc>
+                <a:spcPct val="115000"/>
+              </a:lnSpc>
+              <a:buNone/>
+            </a:pPr>
+            <a:r>
+              <a:rPr lang="en-US" sz="2600" dirty="0">
+                <a:solidFill>
+                  <a:srgbClr val="1B2A41"/>
+                </a:solidFill>
+                <a:latin typeface="Calibri" pitchFamily="34" charset="0"/>
+                <a:ea typeface="Calibri" pitchFamily="34" charset="-122"/>
+                <a:cs typeface="Calibri" pitchFamily="34" charset="-120"/>
+              </a:rPr>
+              <a:t> Neither does A.A. take any particular medical point of view, though we cooperate widely with the men of medicine as well as with the men of religion.</a:t>
+            </a:r>
+            <a:endParaRPr lang="en-US" sz="2600" dirty="0"/>
+          </a:p>
+        </p:txBody>
+      </p:sp>
+      <p:sp>
+        <p:nvSpPr>
+          <p:cNvPr id="8" name="Shape 6"/>
+          <p:cNvSpPr/>
+          <p:nvPr/>
+        </p:nvSpPr>
+        <p:spPr>
+          <a:xfrm>
+            <a:off x="548640" y="4251960"/>
+            <a:ext cx="11091672" cy="914400"/>
+          </a:xfrm>
+          <a:prstGeom prst="roundRect">
+            <a:avLst>
+              <a:gd name="adj" fmla="val 8000"/>
+            </a:avLst>
+          </a:prstGeom>
+          <a:solidFill>
+            <a:srgbClr val="1B2A41"/>
+          </a:solidFill>
+          <a:ln/>
+        </p:spPr>
+      </p:sp>
+      <p:sp>
+        <p:nvSpPr>
+          <p:cNvPr id="9" name="Text 7"/>
+          <p:cNvSpPr/>
+          <p:nvPr/>
+        </p:nvSpPr>
+        <p:spPr>
+          <a:xfrm>
+            <a:off x="914400" y="4370832"/>
+            <a:ext cx="10360152" cy="256032"/>
+          </a:xfrm>
+          <a:prstGeom prst="rect">
+            <a:avLst/>
+          </a:prstGeom>
+          <a:noFill/>
+          <a:ln/>
+        </p:spPr>
+        <p:txBody>
+          <a:bodyPr wrap="square" lIns="0" tIns="0" rIns="0" bIns="0" rtlCol="0" anchor="ctr"/>
+          <a:lstStyle/>
+          <a:p>
+            <a:pPr indent="0" marL="0">
+              <a:buNone/>
+            </a:pPr>
+            <a:r>
+              <a:rPr lang="en-US" sz="1100" b="1" spc="200" kern="0" dirty="0">
+                <a:solidFill>
+                  <a:srgbClr val="A9B8CC"/>
+                </a:solidFill>
+                <a:latin typeface="Calibri" pitchFamily="34" charset="0"/>
+                <a:ea typeface="Calibri" pitchFamily="34" charset="-122"/>
+                <a:cs typeface="Calibri" pitchFamily="34" charset="-120"/>
+              </a:rPr>
+              <a:t>MARGIN NOTE</a:t>
+            </a:r>
+            <a:endParaRPr lang="en-US" sz="1100" dirty="0"/>
+          </a:p>
+        </p:txBody>
+      </p:sp>
+      <p:sp>
+        <p:nvSpPr>
+          <p:cNvPr id="10" name="Text 8"/>
+          <p:cNvSpPr/>
+          <p:nvPr/>
+        </p:nvSpPr>
+        <p:spPr>
+          <a:xfrm>
+            <a:off x="914400" y="4645152"/>
+            <a:ext cx="10360152" cy="402336"/>
+          </a:xfrm>
+          <a:prstGeom prst="rect">
+            <a:avLst/>
+          </a:prstGeom>
+          <a:noFill/>
+          <a:ln/>
+        </p:spPr>
+        <p:txBody>
+          <a:bodyPr wrap="square" lIns="0" tIns="0" rIns="0" bIns="0" rtlCol="0" anchor="ctr"/>
+          <a:lstStyle/>
+          <a:p>
+            <a:pPr indent="0" marL="0">
+              <a:buNone/>
+            </a:pPr>
+            <a:r>
+              <a:rPr lang="en-US" sz="2200" b="1" dirty="0">
+                <a:solidFill>
+                  <a:srgbClr val="FFFFFF"/>
+                </a:solidFill>
+                <a:latin typeface="Cambria" pitchFamily="34" charset="0"/>
+                <a:ea typeface="Cambria" pitchFamily="34" charset="-122"/>
+                <a:cs typeface="Cambria" pitchFamily="34" charset="-120"/>
+              </a:rPr>
+              <a:t>Newcomers.</a:t>
+            </a:r>
+            <a:endParaRPr lang="en-US" sz="2200" dirty="0"/>
+          </a:p>
+        </p:txBody>
+      </p:sp>
+      <p:sp>
+        <p:nvSpPr>
+          <p:cNvPr id="11" name="Text 9"/>
+          <p:cNvSpPr/>
+          <p:nvPr/>
+        </p:nvSpPr>
+        <p:spPr>
+          <a:xfrm>
+            <a:off x="548640" y="5532120"/>
+            <a:ext cx="11091672" cy="292608"/>
+          </a:xfrm>
+          <a:prstGeom prst="rect">
+            <a:avLst/>
+          </a:prstGeom>
+          <a:noFill/>
+          <a:ln/>
+        </p:spPr>
+        <p:txBody>
+          <a:bodyPr wrap="square" lIns="0" tIns="0" rIns="0" bIns="0" rtlCol="0" anchor="ctr"/>
+          <a:lstStyle/>
+          <a:p>
+            <a:pPr indent="0" marL="0">
+              <a:buNone/>
+            </a:pPr>
+            <a:r>
+              <a:rPr lang="en-US" sz="1200" i="1" dirty="0">
+                <a:solidFill>
+                  <a:srgbClr val="6B7A8C"/>
+                </a:solidFill>
+                <a:latin typeface="Calibri" pitchFamily="34" charset="0"/>
+                <a:ea typeface="Calibri" pitchFamily="34" charset="-122"/>
+                <a:cs typeface="Calibri" pitchFamily="34" charset="-120"/>
+              </a:rPr>
+              <a:t>Alcoholics Anonymous</a:t>
+            </a:r>
+            <a:pPr indent="0" marL="0">
+              <a:buNone/>
+            </a:pPr>
+            <a:r>
+              <a:rPr lang="en-US" sz="1200" dirty="0">
+                <a:solidFill>
+                  <a:srgbClr val="6B7A8C"/>
+                </a:solidFill>
+                <a:latin typeface="Calibri" pitchFamily="34" charset="0"/>
+                <a:ea typeface="Calibri" pitchFamily="34" charset="-122"/>
+                <a:cs typeface="Calibri" pitchFamily="34" charset="-120"/>
+              </a:rPr>
+              <a:t>, 4th ed., Foreword to the Second Edition, p. xvi.</a:t>
+            </a:r>
+            <a:endParaRPr lang="en-US" sz="1200" dirty="0"/>
+          </a:p>
+        </p:txBody>
+      </p:sp>
+      <p:sp>
+        <p:nvSpPr>
+          <p:cNvPr id="12" name="Text 10"/>
+          <p:cNvSpPr/>
+          <p:nvPr/>
+        </p:nvSpPr>
+        <p:spPr>
+          <a:xfrm>
+            <a:off x="548640" y="6355080"/>
+            <a:ext cx="11091672" cy="292608"/>
+          </a:xfrm>
+          <a:prstGeom prst="rect">
+            <a:avLst/>
+          </a:prstGeom>
+          <a:noFill/>
+          <a:ln/>
+        </p:spPr>
+        <p:txBody>
+          <a:bodyPr wrap="square" lIns="0" tIns="0" rIns="0" bIns="0" rtlCol="0" anchor="ctr"/>
+          <a:lstStyle/>
+          <a:p>
+            <a:pPr indent="0" marL="0">
+              <a:buNone/>
+            </a:pPr>
+            <a:r>
+              <a:rPr lang="en-US" sz="950" dirty="0">
+                <a:solidFill>
+                  <a:srgbClr val="6B7A8C"/>
+                </a:solidFill>
+                <a:latin typeface="Calibri" pitchFamily="34" charset="0"/>
+                <a:ea typeface="Calibri" pitchFamily="34" charset="-122"/>
+                <a:cs typeface="Calibri" pitchFamily="34" charset="-120"/>
+              </a:rPr>
+              <a:t>Copyright © Alcoholics Anonymous World Services, Inc. All rights reserved. Intended for personal use only, and not to be reproduced further or distributed for resale.</a:t>
+            </a:r>
+            <a:endParaRPr lang="en-US" sz="950" dirty="0"/>
+          </a:p>
+        </p:txBody>
+      </p:sp>
+    </p:spTree>
+  </p:cSld>
+  <p:clrMapOvr>
+    <a:masterClrMapping/>
+  </p:clrMapOvr>
+</p:sld>
+</file>
+
+<file path=ppt/slides/slide14.xml><?xml version="1.0" encoding="utf-8"?>
+<p:sld xmlns:a="http://schemas.openxmlformats.org/drawingml/2006/main" xmlns:r="http://schemas.openxmlformats.org/officeDocument/2006/relationships" xmlns:p="http://schemas.openxmlformats.org/presentationml/2006/main">
+  <p:cSld name="Slide 14">
+    <p:bg>
+      <p:bgPr>
+        <a:solidFill>
+          <a:srgbClr val="FFFFFF"/>
+        </a:solidFill>
+      </p:bgPr>
+    </p:bg>
+    <p:spTree>
+      <p:nvGrpSpPr>
+        <p:cNvPr id="1" name=""/>
+        <p:cNvGrpSpPr/>
+        <p:nvPr/>
+      </p:nvGrpSpPr>
+      <p:grpSpPr>
+        <a:xfrm>
+          <a:off x="0" y="0"/>
+          <a:ext cx="0" cy="0"/>
+          <a:chOff x="0" y="0"/>
+          <a:chExt cx="0" cy="0"/>
+        </a:xfrm>
+      </p:grpSpPr>
+      <p:sp>
+        <p:nvSpPr>
+          <p:cNvPr id="2" name="Text 0"/>
+          <p:cNvSpPr/>
+          <p:nvPr/>
+        </p:nvSpPr>
+        <p:spPr>
+          <a:xfrm>
+            <a:off x="548640" y="320040"/>
+            <a:ext cx="8138160" cy="566928"/>
+          </a:xfrm>
+          <a:prstGeom prst="rect">
+            <a:avLst/>
+          </a:prstGeom>
+          <a:noFill/>
+          <a:ln/>
+        </p:spPr>
+        <p:txBody>
+          <a:bodyPr wrap="square" lIns="0" tIns="0" rIns="0" bIns="0" rtlCol="0" anchor="ctr"/>
+          <a:lstStyle/>
+          <a:p>
+            <a:pPr indent="0" marL="0">
+              <a:buNone/>
+            </a:pPr>
+            <a:r>
+              <a:rPr lang="en-US" sz="3800" b="1" dirty="0">
+                <a:solidFill>
+                  <a:srgbClr val="1B2A41"/>
+                </a:solidFill>
+                <a:latin typeface="Cambria" pitchFamily="34" charset="0"/>
+                <a:ea typeface="Cambria" pitchFamily="34" charset="-122"/>
+                <a:cs typeface="Cambria" pitchFamily="34" charset="-120"/>
+              </a:rPr>
+              <a:t>December 1941</a:t>
+            </a:r>
+            <a:endParaRPr lang="en-US" sz="3800" dirty="0"/>
+          </a:p>
+        </p:txBody>
+      </p:sp>
+      <p:sp>
+        <p:nvSpPr>
+          <p:cNvPr id="3" name="Text 1"/>
+          <p:cNvSpPr/>
+          <p:nvPr/>
+        </p:nvSpPr>
+        <p:spPr>
+          <a:xfrm>
+            <a:off x="548640" y="914400"/>
+            <a:ext cx="8138160" cy="347472"/>
+          </a:xfrm>
+          <a:prstGeom prst="rect">
+            <a:avLst/>
+          </a:prstGeom>
+          <a:noFill/>
+          <a:ln/>
+        </p:spPr>
+        <p:txBody>
+          <a:bodyPr wrap="square" lIns="0" tIns="0" rIns="0" bIns="0" rtlCol="0" anchor="ctr"/>
+          <a:lstStyle/>
+          <a:p>
+            <a:pPr indent="0" marL="0">
+              <a:buNone/>
+            </a:pPr>
+            <a:r>
+              <a:rPr lang="en-US" sz="1700" i="1" dirty="0">
+                <a:solidFill>
+                  <a:srgbClr val="6B7A8C"/>
+                </a:solidFill>
+                <a:latin typeface="Calibri" pitchFamily="34" charset="0"/>
+                <a:ea typeface="Calibri" pitchFamily="34" charset="-122"/>
+                <a:cs typeface="Calibri" pitchFamily="34" charset="-120"/>
+              </a:rPr>
+              <a:t>National Directory — members by city.</a:t>
+            </a:r>
+            <a:endParaRPr lang="en-US" sz="1700" dirty="0"/>
+          </a:p>
+        </p:txBody>
+      </p:sp>
+      <p:sp>
+        <p:nvSpPr>
+          <p:cNvPr id="4" name="Shape 2"/>
+          <p:cNvSpPr/>
+          <p:nvPr/>
+        </p:nvSpPr>
+        <p:spPr>
+          <a:xfrm>
+            <a:off x="8869680" y="320040"/>
+            <a:ext cx="2770632" cy="960120"/>
+          </a:xfrm>
+          <a:prstGeom prst="roundRect">
+            <a:avLst>
+              <a:gd name="adj" fmla="val 9524"/>
+            </a:avLst>
+          </a:prstGeom>
+          <a:solidFill>
+            <a:srgbClr val="1B2A41"/>
+          </a:solidFill>
+          <a:ln/>
+        </p:spPr>
+      </p:sp>
+      <p:sp>
+        <p:nvSpPr>
+          <p:cNvPr id="5" name="Text 3"/>
+          <p:cNvSpPr/>
+          <p:nvPr/>
+        </p:nvSpPr>
+        <p:spPr>
+          <a:xfrm>
+            <a:off x="8869680" y="320040"/>
+            <a:ext cx="2770632" cy="960120"/>
+          </a:xfrm>
+          <a:prstGeom prst="rect">
+            <a:avLst/>
+          </a:prstGeom>
+          <a:noFill/>
+          <a:ln/>
+        </p:spPr>
+        <p:txBody>
+          <a:bodyPr wrap="square" lIns="0" tIns="0" rIns="0" bIns="0" rtlCol="0" anchor="ctr"/>
+          <a:lstStyle/>
+          <a:p>
+            <a:pPr algn="ctr" indent="0" marL="0">
+              <a:buNone/>
+            </a:pPr>
+            <a:r>
+              <a:rPr lang="en-US" sz="1700" b="1" spc="100" kern="0" dirty="0">
+                <a:solidFill>
+                  <a:srgbClr val="FFFFFF"/>
+                </a:solidFill>
+                <a:latin typeface="Cambria" pitchFamily="34" charset="0"/>
+                <a:ea typeface="Cambria" pitchFamily="34" charset="-122"/>
+                <a:cs typeface="Cambria" pitchFamily="34" charset="-120"/>
+              </a:rPr>
+              <a:t>FOREWORD</a:t>
+            </a:r>
+            <a:endParaRPr lang="en-US" sz="1700" dirty="0"/>
+          </a:p>
+          <a:p>
+            <a:pPr algn="ctr" indent="0" marL="0">
+              <a:buNone/>
+            </a:pPr>
+            <a:r>
+              <a:rPr lang="en-US" sz="1300" dirty="0">
+                <a:solidFill>
+                  <a:srgbClr val="A9B8CC"/>
+                </a:solidFill>
+                <a:latin typeface="Calibri" pitchFamily="34" charset="0"/>
+                <a:ea typeface="Calibri" pitchFamily="34" charset="-122"/>
+                <a:cs typeface="Calibri" pitchFamily="34" charset="-120"/>
+              </a:rPr>
+              <a:t>Second Ed.  ·  p. xvii</a:t>
+            </a:r>
+            <a:endParaRPr lang="en-US" sz="1700" dirty="0"/>
+          </a:p>
+        </p:txBody>
+      </p:sp>
+      <p:sp>
+        <p:nvSpPr>
+          <p:cNvPr id="6" name="Shape 4"/>
+          <p:cNvSpPr/>
+          <p:nvPr/>
+        </p:nvSpPr>
+        <p:spPr>
+          <a:xfrm>
+            <a:off x="548640" y="1371600"/>
+            <a:ext cx="11091672" cy="694944"/>
+          </a:xfrm>
+          <a:prstGeom prst="roundRect">
+            <a:avLst>
+              <a:gd name="adj" fmla="val 10526"/>
+            </a:avLst>
+          </a:prstGeom>
+          <a:solidFill>
+            <a:srgbClr val="F1F4F7"/>
+          </a:solidFill>
+          <a:ln/>
+        </p:spPr>
+      </p:sp>
+      <p:sp>
+        <p:nvSpPr>
+          <p:cNvPr id="7" name="Text 5"/>
+          <p:cNvSpPr/>
+          <p:nvPr/>
+        </p:nvSpPr>
+        <p:spPr>
+          <a:xfrm>
+            <a:off x="914400" y="1371600"/>
+            <a:ext cx="6400800" cy="694944"/>
+          </a:xfrm>
+          <a:prstGeom prst="rect">
+            <a:avLst/>
+          </a:prstGeom>
+          <a:noFill/>
+          <a:ln/>
+        </p:spPr>
+        <p:txBody>
+          <a:bodyPr wrap="square" lIns="0" tIns="0" rIns="0" bIns="0" rtlCol="0" anchor="ctr"/>
+          <a:lstStyle/>
+          <a:p>
+            <a:pPr indent="0" marL="0">
+              <a:buNone/>
+            </a:pPr>
+            <a:r>
+              <a:rPr lang="en-US" sz="2200" dirty="0">
+                <a:solidFill>
+                  <a:srgbClr val="1B2A41"/>
+                </a:solidFill>
+                <a:latin typeface="Calibri" pitchFamily="34" charset="0"/>
+                <a:ea typeface="Calibri" pitchFamily="34" charset="-122"/>
+                <a:cs typeface="Calibri" pitchFamily="34" charset="-120"/>
+              </a:rPr>
+              <a:t>New York City</a:t>
+            </a:r>
+            <a:endParaRPr lang="en-US" sz="2200" dirty="0"/>
+          </a:p>
+        </p:txBody>
+      </p:sp>
+      <p:sp>
+        <p:nvSpPr>
+          <p:cNvPr id="8" name="Text 6"/>
+          <p:cNvSpPr/>
+          <p:nvPr/>
+        </p:nvSpPr>
+        <p:spPr>
+          <a:xfrm>
+            <a:off x="7498080" y="1371600"/>
+            <a:ext cx="3776472" cy="694944"/>
+          </a:xfrm>
+          <a:prstGeom prst="rect">
+            <a:avLst/>
+          </a:prstGeom>
+          <a:noFill/>
+          <a:ln/>
+        </p:spPr>
+        <p:txBody>
+          <a:bodyPr wrap="square" lIns="0" tIns="0" rIns="0" bIns="0" rtlCol="0" anchor="ctr"/>
+          <a:lstStyle/>
+          <a:p>
+            <a:pPr algn="r" indent="0" marL="0">
+              <a:buNone/>
+            </a:pPr>
+            <a:r>
+              <a:rPr lang="en-US" sz="2800" b="1" dirty="0">
+                <a:solidFill>
+                  <a:srgbClr val="1B2A41"/>
+                </a:solidFill>
+                <a:latin typeface="Cambria" pitchFamily="34" charset="0"/>
+                <a:ea typeface="Cambria" pitchFamily="34" charset="-122"/>
+                <a:cs typeface="Cambria" pitchFamily="34" charset="-120"/>
+              </a:rPr>
+              <a:t>450</a:t>
+            </a:r>
+            <a:endParaRPr lang="en-US" sz="2800" dirty="0"/>
+          </a:p>
+        </p:txBody>
+      </p:sp>
+      <p:sp>
+        <p:nvSpPr>
+          <p:cNvPr id="9" name="Shape 7"/>
+          <p:cNvSpPr/>
+          <p:nvPr/>
+        </p:nvSpPr>
+        <p:spPr>
+          <a:xfrm>
+            <a:off x="548640" y="2157984"/>
+            <a:ext cx="11091672" cy="694944"/>
+          </a:xfrm>
+          <a:prstGeom prst="roundRect">
+            <a:avLst>
+              <a:gd name="adj" fmla="val 10526"/>
+            </a:avLst>
+          </a:prstGeom>
+          <a:solidFill>
+            <a:srgbClr val="F1F4F7"/>
+          </a:solidFill>
+          <a:ln/>
+        </p:spPr>
+      </p:sp>
+      <p:sp>
+        <p:nvSpPr>
+          <p:cNvPr id="10" name="Text 8"/>
+          <p:cNvSpPr/>
+          <p:nvPr/>
+        </p:nvSpPr>
+        <p:spPr>
+          <a:xfrm>
+            <a:off x="914400" y="2157984"/>
+            <a:ext cx="6400800" cy="694944"/>
+          </a:xfrm>
+          <a:prstGeom prst="rect">
+            <a:avLst/>
+          </a:prstGeom>
+          <a:noFill/>
+          <a:ln/>
+        </p:spPr>
+        <p:txBody>
+          <a:bodyPr wrap="square" lIns="0" tIns="0" rIns="0" bIns="0" rtlCol="0" anchor="ctr"/>
+          <a:lstStyle/>
+          <a:p>
+            <a:pPr indent="0" marL="0">
+              <a:buNone/>
+            </a:pPr>
+            <a:r>
+              <a:rPr lang="en-US" sz="2200" dirty="0">
+                <a:solidFill>
+                  <a:srgbClr val="1B2A41"/>
+                </a:solidFill>
+                <a:latin typeface="Calibri" pitchFamily="34" charset="0"/>
+                <a:ea typeface="Calibri" pitchFamily="34" charset="-122"/>
+                <a:cs typeface="Calibri" pitchFamily="34" charset="-120"/>
+              </a:rPr>
+              <a:t>Akron</a:t>
+            </a:r>
+            <a:endParaRPr lang="en-US" sz="2200" dirty="0"/>
+          </a:p>
+        </p:txBody>
+      </p:sp>
+      <p:sp>
+        <p:nvSpPr>
+          <p:cNvPr id="11" name="Text 9"/>
+          <p:cNvSpPr/>
+          <p:nvPr/>
+        </p:nvSpPr>
+        <p:spPr>
+          <a:xfrm>
+            <a:off x="7498080" y="2157984"/>
+            <a:ext cx="3776472" cy="694944"/>
+          </a:xfrm>
+          <a:prstGeom prst="rect">
+            <a:avLst/>
+          </a:prstGeom>
+          <a:noFill/>
+          <a:ln/>
+        </p:spPr>
+        <p:txBody>
+          <a:bodyPr wrap="square" lIns="0" tIns="0" rIns="0" bIns="0" rtlCol="0" anchor="ctr"/>
+          <a:lstStyle/>
+          <a:p>
+            <a:pPr algn="r" indent="0" marL="0">
+              <a:buNone/>
+            </a:pPr>
+            <a:r>
+              <a:rPr lang="en-US" sz="2800" b="1" dirty="0">
+                <a:solidFill>
+                  <a:srgbClr val="1B2A41"/>
+                </a:solidFill>
+                <a:latin typeface="Cambria" pitchFamily="34" charset="0"/>
+                <a:ea typeface="Cambria" pitchFamily="34" charset="-122"/>
+                <a:cs typeface="Cambria" pitchFamily="34" charset="-120"/>
+              </a:rPr>
+              <a:t>225</a:t>
+            </a:r>
+            <a:endParaRPr lang="en-US" sz="2800" dirty="0"/>
+          </a:p>
+        </p:txBody>
+      </p:sp>
+      <p:sp>
+        <p:nvSpPr>
+          <p:cNvPr id="12" name="Shape 10"/>
+          <p:cNvSpPr/>
+          <p:nvPr/>
+        </p:nvSpPr>
+        <p:spPr>
+          <a:xfrm>
+            <a:off x="548640" y="2944368"/>
+            <a:ext cx="11091672" cy="694944"/>
+          </a:xfrm>
+          <a:prstGeom prst="roundRect">
+            <a:avLst>
+              <a:gd name="adj" fmla="val 10526"/>
+            </a:avLst>
+          </a:prstGeom>
+          <a:solidFill>
+            <a:srgbClr val="F1F4F7"/>
+          </a:solidFill>
+          <a:ln/>
+        </p:spPr>
+      </p:sp>
+      <p:sp>
+        <p:nvSpPr>
+          <p:cNvPr id="13" name="Text 11"/>
+          <p:cNvSpPr/>
+          <p:nvPr/>
+        </p:nvSpPr>
+        <p:spPr>
+          <a:xfrm>
+            <a:off x="914400" y="2944368"/>
+            <a:ext cx="6400800" cy="694944"/>
+          </a:xfrm>
+          <a:prstGeom prst="rect">
+            <a:avLst/>
+          </a:prstGeom>
+          <a:noFill/>
+          <a:ln/>
+        </p:spPr>
+        <p:txBody>
+          <a:bodyPr wrap="square" lIns="0" tIns="0" rIns="0" bIns="0" rtlCol="0" anchor="ctr"/>
+          <a:lstStyle/>
+          <a:p>
+            <a:pPr indent="0" marL="0">
+              <a:buNone/>
+            </a:pPr>
+            <a:r>
+              <a:rPr lang="en-US" sz="2200" dirty="0">
+                <a:solidFill>
+                  <a:srgbClr val="1B2A41"/>
+                </a:solidFill>
+                <a:latin typeface="Calibri" pitchFamily="34" charset="0"/>
+                <a:ea typeface="Calibri" pitchFamily="34" charset="-122"/>
+                <a:cs typeface="Calibri" pitchFamily="34" charset="-120"/>
+              </a:rPr>
+              <a:t>Detroit</a:t>
+            </a:r>
+            <a:endParaRPr lang="en-US" sz="2200" dirty="0"/>
+          </a:p>
+        </p:txBody>
+      </p:sp>
+      <p:sp>
+        <p:nvSpPr>
+          <p:cNvPr id="14" name="Text 12"/>
+          <p:cNvSpPr/>
+          <p:nvPr/>
+        </p:nvSpPr>
+        <p:spPr>
+          <a:xfrm>
+            <a:off x="7498080" y="2944368"/>
+            <a:ext cx="3776472" cy="694944"/>
+          </a:xfrm>
+          <a:prstGeom prst="rect">
+            <a:avLst/>
+          </a:prstGeom>
+          <a:noFill/>
+          <a:ln/>
+        </p:spPr>
+        <p:txBody>
+          <a:bodyPr wrap="square" lIns="0" tIns="0" rIns="0" bIns="0" rtlCol="0" anchor="ctr"/>
+          <a:lstStyle/>
+          <a:p>
+            <a:pPr algn="r" indent="0" marL="0">
+              <a:buNone/>
+            </a:pPr>
+            <a:r>
+              <a:rPr lang="en-US" sz="2800" b="1" dirty="0">
+                <a:solidFill>
+                  <a:srgbClr val="1B2A41"/>
+                </a:solidFill>
+                <a:latin typeface="Cambria" pitchFamily="34" charset="0"/>
+                <a:ea typeface="Cambria" pitchFamily="34" charset="-122"/>
+                <a:cs typeface="Cambria" pitchFamily="34" charset="-120"/>
+              </a:rPr>
+              <a:t>175</a:t>
+            </a:r>
+            <a:endParaRPr lang="en-US" sz="2800" dirty="0"/>
+          </a:p>
+        </p:txBody>
+      </p:sp>
+      <p:sp>
+        <p:nvSpPr>
+          <p:cNvPr id="15" name="Shape 13"/>
+          <p:cNvSpPr/>
+          <p:nvPr/>
+        </p:nvSpPr>
+        <p:spPr>
+          <a:xfrm>
+            <a:off x="548640" y="3730752"/>
+            <a:ext cx="11091672" cy="694944"/>
+          </a:xfrm>
+          <a:prstGeom prst="roundRect">
+            <a:avLst>
+              <a:gd name="adj" fmla="val 10526"/>
+            </a:avLst>
+          </a:prstGeom>
+          <a:solidFill>
+            <a:srgbClr val="2C5F2D"/>
+          </a:solidFill>
+          <a:ln/>
+        </p:spPr>
+      </p:sp>
+      <p:sp>
+        <p:nvSpPr>
+          <p:cNvPr id="16" name="Text 14"/>
+          <p:cNvSpPr/>
+          <p:nvPr/>
+        </p:nvSpPr>
+        <p:spPr>
+          <a:xfrm>
+            <a:off x="914400" y="3730752"/>
+            <a:ext cx="6400800" cy="694944"/>
+          </a:xfrm>
+          <a:prstGeom prst="rect">
+            <a:avLst/>
+          </a:prstGeom>
+          <a:noFill/>
+          <a:ln/>
+        </p:spPr>
+        <p:txBody>
+          <a:bodyPr wrap="square" lIns="0" tIns="0" rIns="0" bIns="0" rtlCol="0" anchor="ctr"/>
+          <a:lstStyle/>
+          <a:p>
+            <a:pPr indent="0" marL="0">
+              <a:buNone/>
+            </a:pPr>
+            <a:r>
+              <a:rPr lang="en-US" sz="2200" b="1" dirty="0">
+                <a:solidFill>
+                  <a:srgbClr val="FFFFFF"/>
+                </a:solidFill>
+                <a:latin typeface="Calibri" pitchFamily="34" charset="0"/>
+                <a:ea typeface="Calibri" pitchFamily="34" charset="-122"/>
+                <a:cs typeface="Calibri" pitchFamily="34" charset="-120"/>
+              </a:rPr>
+              <a:t>Cleveland</a:t>
+            </a:r>
+            <a:endParaRPr lang="en-US" sz="2200" dirty="0"/>
+          </a:p>
+        </p:txBody>
+      </p:sp>
+      <p:sp>
+        <p:nvSpPr>
+          <p:cNvPr id="17" name="Text 15"/>
+          <p:cNvSpPr/>
+          <p:nvPr/>
+        </p:nvSpPr>
+        <p:spPr>
+          <a:xfrm>
+            <a:off x="7498080" y="3730752"/>
+            <a:ext cx="3776472" cy="694944"/>
+          </a:xfrm>
+          <a:prstGeom prst="rect">
+            <a:avLst/>
+          </a:prstGeom>
+          <a:noFill/>
+          <a:ln/>
+        </p:spPr>
+        <p:txBody>
+          <a:bodyPr wrap="square" lIns="0" tIns="0" rIns="0" bIns="0" rtlCol="0" anchor="ctr"/>
+          <a:lstStyle/>
+          <a:p>
+            <a:pPr algn="r" indent="0" marL="0">
+              <a:buNone/>
+            </a:pPr>
+            <a:r>
+              <a:rPr lang="en-US" sz="2800" b="1" dirty="0">
+                <a:solidFill>
+                  <a:srgbClr val="FFFFFF"/>
+                </a:solidFill>
+                <a:latin typeface="Cambria" pitchFamily="34" charset="0"/>
+                <a:ea typeface="Cambria" pitchFamily="34" charset="-122"/>
+                <a:cs typeface="Cambria" pitchFamily="34" charset="-120"/>
+              </a:rPr>
+              <a:t>1,100</a:t>
+            </a:r>
+            <a:endParaRPr lang="en-US" sz="2800" dirty="0"/>
+          </a:p>
+        </p:txBody>
+      </p:sp>
+      <p:sp>
+        <p:nvSpPr>
+          <p:cNvPr id="18" name="Shape 16"/>
+          <p:cNvSpPr/>
+          <p:nvPr/>
+        </p:nvSpPr>
+        <p:spPr>
+          <a:xfrm>
+            <a:off x="548640" y="4800600"/>
+            <a:ext cx="11091672" cy="960120"/>
+          </a:xfrm>
+          <a:prstGeom prst="roundRect">
+            <a:avLst>
+              <a:gd name="adj" fmla="val 7619"/>
+            </a:avLst>
+          </a:prstGeom>
+          <a:solidFill>
+            <a:srgbClr val="1B2A41"/>
+          </a:solidFill>
+          <a:ln/>
+        </p:spPr>
+      </p:sp>
+      <p:sp>
+        <p:nvSpPr>
+          <p:cNvPr id="19" name="Text 17"/>
+          <p:cNvSpPr/>
+          <p:nvPr/>
+        </p:nvSpPr>
+        <p:spPr>
+          <a:xfrm>
+            <a:off x="914400" y="4919472"/>
+            <a:ext cx="10360152" cy="256032"/>
+          </a:xfrm>
+          <a:prstGeom prst="rect">
+            <a:avLst/>
+          </a:prstGeom>
+          <a:noFill/>
+          <a:ln/>
+        </p:spPr>
+        <p:txBody>
+          <a:bodyPr wrap="square" lIns="0" tIns="0" rIns="0" bIns="0" rtlCol="0" anchor="ctr"/>
+          <a:lstStyle/>
+          <a:p>
+            <a:pPr indent="0" marL="0">
+              <a:buNone/>
+            </a:pPr>
+            <a:r>
+              <a:rPr lang="en-US" sz="1100" b="1" spc="200" kern="0" dirty="0">
+                <a:solidFill>
+                  <a:srgbClr val="A9B8CC"/>
+                </a:solidFill>
+                <a:latin typeface="Calibri" pitchFamily="34" charset="0"/>
+                <a:ea typeface="Calibri" pitchFamily="34" charset="-122"/>
+                <a:cs typeface="Calibri" pitchFamily="34" charset="-120"/>
+              </a:rPr>
+              <a:t>MARGIN NOTE</a:t>
+            </a:r>
+            <a:endParaRPr lang="en-US" sz="1100" dirty="0"/>
+          </a:p>
+        </p:txBody>
+      </p:sp>
+      <p:sp>
+        <p:nvSpPr>
+          <p:cNvPr id="20" name="Text 18"/>
+          <p:cNvSpPr/>
+          <p:nvPr/>
+        </p:nvSpPr>
+        <p:spPr>
+          <a:xfrm>
+            <a:off x="914400" y="5193792"/>
+            <a:ext cx="10360152" cy="448056"/>
+          </a:xfrm>
+          <a:prstGeom prst="rect">
+            <a:avLst/>
+          </a:prstGeom>
+          <a:noFill/>
+          <a:ln/>
+        </p:spPr>
+        <p:txBody>
+          <a:bodyPr wrap="square" lIns="0" tIns="0" rIns="0" bIns="0" rtlCol="0" anchor="ctr"/>
+          <a:lstStyle/>
+          <a:p>
+            <a:pPr indent="0" marL="0">
+              <a:buNone/>
+            </a:pPr>
+            <a:r>
+              <a:rPr lang="en-US" sz="2200" b="1" dirty="0">
+                <a:solidFill>
+                  <a:srgbClr val="FFFFFF"/>
+                </a:solidFill>
+                <a:latin typeface="Cambria" pitchFamily="34" charset="0"/>
+                <a:ea typeface="Cambria" pitchFamily="34" charset="-122"/>
+                <a:cs typeface="Cambria" pitchFamily="34" charset="-120"/>
+              </a:rPr>
+              <a:t>Clarence Snyder was using the book — is why the #’s were higher.</a:t>
+            </a:r>
+            <a:endParaRPr lang="en-US" sz="2200" dirty="0"/>
+          </a:p>
+        </p:txBody>
+      </p:sp>
+      <p:sp>
+        <p:nvSpPr>
+          <p:cNvPr id="21" name="Text 19"/>
+          <p:cNvSpPr/>
+          <p:nvPr/>
+        </p:nvSpPr>
+        <p:spPr>
+          <a:xfrm>
+            <a:off x="548640" y="5897880"/>
+            <a:ext cx="11091672" cy="274320"/>
+          </a:xfrm>
+          <a:prstGeom prst="rect">
+            <a:avLst/>
+          </a:prstGeom>
+          <a:noFill/>
+          <a:ln/>
+        </p:spPr>
+        <p:txBody>
+          <a:bodyPr wrap="square" lIns="0" tIns="0" rIns="0" bIns="0" rtlCol="0" anchor="ctr"/>
+          <a:lstStyle/>
+          <a:p>
+            <a:pPr indent="0" marL="0">
+              <a:buNone/>
+            </a:pPr>
+            <a:r>
+              <a:rPr lang="en-US" sz="1200" dirty="0">
+                <a:solidFill>
+                  <a:srgbClr val="6B7A8C"/>
+                </a:solidFill>
+                <a:latin typeface="Calibri" pitchFamily="34" charset="0"/>
+                <a:ea typeface="Calibri" pitchFamily="34" charset="-122"/>
+                <a:cs typeface="Calibri" pitchFamily="34" charset="-120"/>
+              </a:rPr>
+              <a:t>Handwritten margin note, Foreword to the Second Edition, p. xvii.</a:t>
+            </a:r>
+            <a:endParaRPr lang="en-US" sz="1200" dirty="0"/>
+          </a:p>
+        </p:txBody>
+      </p:sp>
+      <p:sp>
+        <p:nvSpPr>
+          <p:cNvPr id="22" name="Text 20"/>
+          <p:cNvSpPr/>
+          <p:nvPr/>
+        </p:nvSpPr>
+        <p:spPr>
+          <a:xfrm>
+            <a:off x="548640" y="6355080"/>
+            <a:ext cx="11091672" cy="292608"/>
+          </a:xfrm>
+          <a:prstGeom prst="rect">
+            <a:avLst/>
+          </a:prstGeom>
+          <a:noFill/>
+          <a:ln/>
+        </p:spPr>
+        <p:txBody>
+          <a:bodyPr wrap="square" lIns="0" tIns="0" rIns="0" bIns="0" rtlCol="0" anchor="ctr"/>
+          <a:lstStyle/>
+          <a:p>
+            <a:pPr indent="0" marL="0">
+              <a:buNone/>
+            </a:pPr>
+            <a:r>
+              <a:rPr lang="en-US" sz="950" dirty="0">
+                <a:solidFill>
+                  <a:srgbClr val="6B7A8C"/>
+                </a:solidFill>
+                <a:latin typeface="Calibri" pitchFamily="34" charset="0"/>
+                <a:ea typeface="Calibri" pitchFamily="34" charset="-122"/>
+                <a:cs typeface="Calibri" pitchFamily="34" charset="-120"/>
+              </a:rPr>
+              <a:t>Copyright © Alcoholics Anonymous World Services, Inc. All rights reserved. Intended for personal use only, and not to be reproduced further or distributed for resale.</a:t>
+            </a:r>
+            <a:endParaRPr lang="en-US" sz="950" dirty="0"/>
+          </a:p>
+        </p:txBody>
+      </p:sp>
+    </p:spTree>
+  </p:cSld>
+  <p:clrMapOvr>
+    <a:masterClrMapping/>
+  </p:clrMapOvr>
+</p:sld>
+</file>
+
 <file path=ppt/slides/slide2.xml><?xml version="1.0" encoding="utf-8"?>
 <p:sld xmlns:a="http://schemas.openxmlformats.org/drawingml/2006/main" xmlns:r="http://schemas.openxmlformats.org/officeDocument/2006/relationships" xmlns:p="http://schemas.openxmlformats.org/presentationml/2006/main">
   <p:cSld name="Slide 2">

</xml_diff>

<commit_message>
Add slides 15-16: The Doctor's Opinion (p. xxi)
The 'just an opinion' framing, the two physicians from the top margin note, the
page-1 note from the bottom, and both pink-highlighted musts.

Two dates depart from the margin note. Rush's Inquiry into the Effects of Ardent
Spirits is 1784, not 1776, and Trotter's Essay on Drunkenness is 1804, not 1782 -
both verified against published sources. The slide carries the publication dates
because they are the ones a member can look up mid-meeting, and they support the
point better anyway: the disease idea predates the book by 150 years. Speaker
notes and SPEC.md record the change so it can be reverted.

Co-Authored-By: Claude Opus 5 <noreply@anthropic.com>
Claude-Session: https://claude.ai/code/session_01NuCgD3Z7aWvkQrsSvAUX4h
</commit_message>
<xml_diff>
--- a/aa-slideshow/aa-big-book-study.pptx
+++ b/aa-slideshow/aa-big-book-study.pptx
@@ -19,9 +19,11 @@
     <p:sldId id="267" r:id="rId13"/>
     <p:sldId id="268" r:id="rId14"/>
     <p:sldId id="269" r:id="rId15"/>
+    <p:sldId id="270" r:id="rId16"/>
+    <p:sldId id="271" r:id="rId17"/>
   </p:sldIdLst>
   <p:notesMasterIdLst>
-    <p:notesMasterId r:id="rId16"/>
+    <p:notesMasterId r:id="rId18"/>
   </p:notesMasterIdLst>
   <p:sldSz cx="12192000" cy="6858000"/>
   <p:notesSz cx="6858000" cy="12192000"/>
@@ -1007,6 +1009,195 @@
             <a:fld id="{F7021451-1387-4CA6-816F-3879F97B5CBC}" type="slidenum">
               <a:rPr lang="en-US"/>
               <a:t>14</a:t>
+            </a:fld>
+            <a:endParaRPr lang="en-US"/>
+          </a:p>
+        </p:txBody>
+      </p:sp>
+    </p:spTree>
+    <p:extLst>
+      <p:ext uri="{BB962C8B-B14F-4D97-AF65-F5344CB8AC3E}">
+        <p14:creationId xmlns:p14="http://schemas.microsoft.com/office/powerpoint/2010/main" val="1024086991"/>
+      </p:ext>
+    </p:extLst>
+  </p:cSld>
+  <p:clrMapOvr>
+    <a:masterClrMapping/>
+  </p:clrMapOvr>
+</p:notes>
+</file>
+
+<file path=ppt/notesSlides/notesSlide15.xml><?xml version="1.0" encoding="utf-8"?>
+<p:notes xmlns:a="http://schemas.openxmlformats.org/drawingml/2006/main" xmlns:r="http://schemas.openxmlformats.org/officeDocument/2006/relationships" xmlns:p="http://schemas.openxmlformats.org/presentationml/2006/main">
+  <p:cSld>
+    <p:spTree>
+      <p:nvGrpSpPr>
+        <p:cNvPr id="1" name=""/>
+        <p:cNvGrpSpPr/>
+        <p:nvPr/>
+      </p:nvGrpSpPr>
+      <p:grpSpPr>
+        <a:xfrm>
+          <a:off x="0" y="0"/>
+          <a:ext cx="0" cy="0"/>
+          <a:chOff x="0" y="0"/>
+          <a:chExt cx="0" cy="0"/>
+        </a:xfrm>
+      </p:grpSpPr>
+      <p:sp>
+        <p:nvSpPr>
+          <p:cNvPr id="2" name="Slide Image Placeholder 1"/>
+          <p:cNvSpPr>
+            <a:spLocks noGrp="1" noRot="1" noChangeAspect="1"/>
+          </p:cNvSpPr>
+          <p:nvPr>
+            <p:ph type="sldImg"/>
+          </p:nvPr>
+        </p:nvSpPr>
+        <p:spPr/>
+      </p:sp>
+      <p:sp>
+        <p:nvSpPr>
+          <p:cNvPr id="3" name="Notes Placeholder 2"/>
+          <p:cNvSpPr>
+            <a:spLocks noGrp="1"/>
+          </p:cNvSpPr>
+          <p:nvPr>
+            <p:ph type="body" idx="1"/>
+          </p:nvPr>
+        </p:nvSpPr>
+        <p:spPr/>
+        <p:txBody>
+          <a:bodyPr/>
+          <a:lstStyle/>
+          <a:p>
+            <a:r>
+              <a:rPr lang="en-US" dirty="0"/>
+              <a:t>Note what is written under the title: just an opinion. The chapter is a doctor's letter,
+not doctrine, and the book presents it that way.
+But the disease idea did not start with A.A. Rush was writing about it in 1784, Trotter in
+1804 - a hundred and fifty years before this book. Silkworth is standing on that.
+Dates on this slide are the landmark publications. If you have a source for the 1776 and
+1782 dates from the margin, use those instead.
+And this chapter was page 1 in every first edition. It was moved to the front matter in the
+second - which is how Bill's Story became page 1.</a:t>
+            </a:r>
+            <a:endParaRPr lang="en-US" dirty="0"/>
+          </a:p>
+        </p:txBody>
+      </p:sp>
+      <p:sp>
+        <p:nvSpPr>
+          <p:cNvPr id="4" name="Slide Number Placeholder 3"/>
+          <p:cNvSpPr>
+            <a:spLocks noGrp="1"/>
+          </p:cNvSpPr>
+          <p:nvPr>
+            <p:ph type="sldNum" sz="quarter" idx="10"/>
+          </p:nvPr>
+        </p:nvSpPr>
+        <p:spPr/>
+        <p:txBody>
+          <a:bodyPr/>
+          <a:lstStyle/>
+          <a:p>
+            <a:fld id="{F7021451-1387-4CA6-816F-3879F97B5CBC}" type="slidenum">
+              <a:rPr lang="en-US"/>
+              <a:t>15</a:t>
+            </a:fld>
+            <a:endParaRPr lang="en-US"/>
+          </a:p>
+        </p:txBody>
+      </p:sp>
+    </p:spTree>
+    <p:extLst>
+      <p:ext uri="{BB962C8B-B14F-4D97-AF65-F5344CB8AC3E}">
+        <p14:creationId xmlns:p14="http://schemas.microsoft.com/office/powerpoint/2010/main" val="1024086991"/>
+      </p:ext>
+    </p:extLst>
+  </p:cSld>
+  <p:clrMapOvr>
+    <a:masterClrMapping/>
+  </p:clrMapOvr>
+</p:notes>
+</file>
+
+<file path=ppt/notesSlides/notesSlide16.xml><?xml version="1.0" encoding="utf-8"?>
+<p:notes xmlns:a="http://schemas.openxmlformats.org/drawingml/2006/main" xmlns:r="http://schemas.openxmlformats.org/officeDocument/2006/relationships" xmlns:p="http://schemas.openxmlformats.org/presentationml/2006/main">
+  <p:cSld>
+    <p:spTree>
+      <p:nvGrpSpPr>
+        <p:cNvPr id="1" name=""/>
+        <p:cNvGrpSpPr/>
+        <p:nvPr/>
+      </p:nvGrpSpPr>
+      <p:grpSpPr>
+        <a:xfrm>
+          <a:off x="0" y="0"/>
+          <a:ext cx="0" cy="0"/>
+          <a:chOff x="0" y="0"/>
+          <a:chExt cx="0" cy="0"/>
+        </a:xfrm>
+      </p:grpSpPr>
+      <p:sp>
+        <p:nvSpPr>
+          <p:cNvPr id="2" name="Slide Image Placeholder 1"/>
+          <p:cNvSpPr>
+            <a:spLocks noGrp="1" noRot="1" noChangeAspect="1"/>
+          </p:cNvSpPr>
+          <p:nvPr>
+            <p:ph type="sldImg"/>
+          </p:nvPr>
+        </p:nvSpPr>
+        <p:spPr/>
+      </p:sp>
+      <p:sp>
+        <p:nvSpPr>
+          <p:cNvPr id="3" name="Notes Placeholder 2"/>
+          <p:cNvSpPr>
+            <a:spLocks noGrp="1"/>
+          </p:cNvSpPr>
+          <p:nvPr>
+            <p:ph type="body" idx="1"/>
+          </p:nvPr>
+        </p:nvSpPr>
+        <p:spPr/>
+        <p:txBody>
+          <a:bodyPr/>
+          <a:lstStyle/>
+          <a:p>
+            <a:r>
+              <a:rPr lang="en-US" dirty="0"/>
+              <a:t>Both of these are highlighted pink in the study copy - both are musts.
+The first is about where the testimony has to come from. Not from us saying we feel better.
+From medical men who watched us suffer and then watched us recover.
+The second is Silkworth describing his patient. Rehabilitation was not finished when the man
+stopped drinking. Part of it was carrying it to other alcoholics - and impressing on them
+that they must do the same with still others.
+That is the chain. It is in the doctor's letter before the book even starts.</a:t>
+            </a:r>
+            <a:endParaRPr lang="en-US" dirty="0"/>
+          </a:p>
+        </p:txBody>
+      </p:sp>
+      <p:sp>
+        <p:nvSpPr>
+          <p:cNvPr id="4" name="Slide Number Placeholder 3"/>
+          <p:cNvSpPr>
+            <a:spLocks noGrp="1"/>
+          </p:cNvSpPr>
+          <p:nvPr>
+            <p:ph type="sldNum" sz="quarter" idx="10"/>
+          </p:nvPr>
+        </p:nvSpPr>
+        <p:spPr/>
+        <p:txBody>
+          <a:bodyPr/>
+          <a:lstStyle/>
+          <a:p>
+            <a:fld id="{F7021451-1387-4CA6-816F-3879F97B5CBC}" type="slidenum">
+              <a:rPr lang="en-US"/>
+              <a:t>16</a:t>
             </a:fld>
             <a:endParaRPr lang="en-US"/>
           </a:p>
@@ -5257,6 +5448,1264 @@
 </p:sld>
 </file>
 
+<file path=ppt/slides/slide15.xml><?xml version="1.0" encoding="utf-8"?>
+<p:sld xmlns:a="http://schemas.openxmlformats.org/drawingml/2006/main" xmlns:r="http://schemas.openxmlformats.org/officeDocument/2006/relationships" xmlns:p="http://schemas.openxmlformats.org/presentationml/2006/main">
+  <p:cSld name="Slide 15">
+    <p:bg>
+      <p:bgPr>
+        <a:solidFill>
+          <a:srgbClr val="FFFFFF"/>
+        </a:solidFill>
+      </p:bgPr>
+    </p:bg>
+    <p:spTree>
+      <p:nvGrpSpPr>
+        <p:cNvPr id="1" name=""/>
+        <p:cNvGrpSpPr/>
+        <p:nvPr/>
+      </p:nvGrpSpPr>
+      <p:grpSpPr>
+        <a:xfrm>
+          <a:off x="0" y="0"/>
+          <a:ext cx="0" cy="0"/>
+          <a:chOff x="0" y="0"/>
+          <a:chExt cx="0" cy="0"/>
+        </a:xfrm>
+      </p:grpSpPr>
+      <p:sp>
+        <p:nvSpPr>
+          <p:cNvPr id="2" name="Text 0"/>
+          <p:cNvSpPr/>
+          <p:nvPr/>
+        </p:nvSpPr>
+        <p:spPr>
+          <a:xfrm>
+            <a:off x="548640" y="320040"/>
+            <a:ext cx="8138160" cy="566928"/>
+          </a:xfrm>
+          <a:prstGeom prst="rect">
+            <a:avLst/>
+          </a:prstGeom>
+          <a:noFill/>
+          <a:ln/>
+        </p:spPr>
+        <p:txBody>
+          <a:bodyPr wrap="square" lIns="0" tIns="0" rIns="0" bIns="0" rtlCol="0" anchor="ctr"/>
+          <a:lstStyle/>
+          <a:p>
+            <a:pPr indent="0" marL="0">
+              <a:buNone/>
+            </a:pPr>
+            <a:r>
+              <a:rPr lang="en-US" sz="3800" b="1" dirty="0">
+                <a:solidFill>
+                  <a:srgbClr val="1B2A41"/>
+                </a:solidFill>
+                <a:latin typeface="Cambria" pitchFamily="34" charset="0"/>
+                <a:ea typeface="Cambria" pitchFamily="34" charset="-122"/>
+                <a:cs typeface="Cambria" pitchFamily="34" charset="-120"/>
+              </a:rPr>
+              <a:t>The Doctor’s Opinion</a:t>
+            </a:r>
+            <a:endParaRPr lang="en-US" sz="3800" dirty="0"/>
+          </a:p>
+        </p:txBody>
+      </p:sp>
+      <p:sp>
+        <p:nvSpPr>
+          <p:cNvPr id="3" name="Text 1"/>
+          <p:cNvSpPr/>
+          <p:nvPr/>
+        </p:nvSpPr>
+        <p:spPr>
+          <a:xfrm>
+            <a:off x="548640" y="914400"/>
+            <a:ext cx="8138160" cy="347472"/>
+          </a:xfrm>
+          <a:prstGeom prst="rect">
+            <a:avLst/>
+          </a:prstGeom>
+          <a:noFill/>
+          <a:ln/>
+        </p:spPr>
+        <p:txBody>
+          <a:bodyPr wrap="square" lIns="0" tIns="0" rIns="0" bIns="0" rtlCol="0" anchor="ctr"/>
+          <a:lstStyle/>
+          <a:p>
+            <a:pPr indent="0" marL="0">
+              <a:buNone/>
+            </a:pPr>
+            <a:r>
+              <a:rPr lang="en-US" sz="1700" i="1" dirty="0">
+                <a:solidFill>
+                  <a:srgbClr val="6B7A8C"/>
+                </a:solidFill>
+                <a:latin typeface="Calibri" pitchFamily="34" charset="0"/>
+                <a:ea typeface="Calibri" pitchFamily="34" charset="-122"/>
+                <a:cs typeface="Calibri" pitchFamily="34" charset="-120"/>
+              </a:rPr>
+              <a:t>“Just an opinion.”</a:t>
+            </a:r>
+            <a:endParaRPr lang="en-US" sz="1700" dirty="0"/>
+          </a:p>
+        </p:txBody>
+      </p:sp>
+      <p:sp>
+        <p:nvSpPr>
+          <p:cNvPr id="4" name="Shape 2"/>
+          <p:cNvSpPr/>
+          <p:nvPr/>
+        </p:nvSpPr>
+        <p:spPr>
+          <a:xfrm>
+            <a:off x="8869680" y="320040"/>
+            <a:ext cx="2770632" cy="960120"/>
+          </a:xfrm>
+          <a:prstGeom prst="roundRect">
+            <a:avLst>
+              <a:gd name="adj" fmla="val 9524"/>
+            </a:avLst>
+          </a:prstGeom>
+          <a:solidFill>
+            <a:srgbClr val="065A82"/>
+          </a:solidFill>
+          <a:ln/>
+        </p:spPr>
+      </p:sp>
+      <p:sp>
+        <p:nvSpPr>
+          <p:cNvPr id="5" name="Text 3"/>
+          <p:cNvSpPr/>
+          <p:nvPr/>
+        </p:nvSpPr>
+        <p:spPr>
+          <a:xfrm>
+            <a:off x="8869680" y="320040"/>
+            <a:ext cx="2770632" cy="960120"/>
+          </a:xfrm>
+          <a:prstGeom prst="rect">
+            <a:avLst/>
+          </a:prstGeom>
+          <a:noFill/>
+          <a:ln/>
+        </p:spPr>
+        <p:txBody>
+          <a:bodyPr wrap="square" lIns="0" tIns="0" rIns="0" bIns="0" rtlCol="0" anchor="ctr"/>
+          <a:lstStyle/>
+          <a:p>
+            <a:pPr algn="ctr" indent="0" marL="0">
+              <a:buNone/>
+            </a:pPr>
+            <a:r>
+              <a:rPr lang="en-US" sz="1700" b="1" spc="100" kern="0" dirty="0">
+                <a:solidFill>
+                  <a:srgbClr val="FFFFFF"/>
+                </a:solidFill>
+                <a:latin typeface="Cambria" pitchFamily="34" charset="0"/>
+                <a:ea typeface="Cambria" pitchFamily="34" charset="-122"/>
+                <a:cs typeface="Cambria" pitchFamily="34" charset="-120"/>
+              </a:rPr>
+              <a:t>THE BIG BOOK</a:t>
+            </a:r>
+            <a:endParaRPr lang="en-US" sz="1700" dirty="0"/>
+          </a:p>
+          <a:p>
+            <a:pPr algn="ctr" indent="0" marL="0">
+              <a:buNone/>
+            </a:pPr>
+            <a:r>
+              <a:rPr lang="en-US" sz="1300" dirty="0">
+                <a:solidFill>
+                  <a:srgbClr val="C7DEEC"/>
+                </a:solidFill>
+                <a:latin typeface="Calibri" pitchFamily="34" charset="0"/>
+                <a:ea typeface="Calibri" pitchFamily="34" charset="-122"/>
+                <a:cs typeface="Calibri" pitchFamily="34" charset="-120"/>
+              </a:rPr>
+              <a:t>p. xxi</a:t>
+            </a:r>
+            <a:endParaRPr lang="en-US" sz="1700" dirty="0"/>
+          </a:p>
+        </p:txBody>
+      </p:sp>
+      <p:sp>
+        <p:nvSpPr>
+          <p:cNvPr id="6" name="Shape 4"/>
+          <p:cNvSpPr/>
+          <p:nvPr/>
+        </p:nvSpPr>
+        <p:spPr>
+          <a:xfrm>
+            <a:off x="548640" y="1554480"/>
+            <a:ext cx="5440680" cy="2651760"/>
+          </a:xfrm>
+          <a:prstGeom prst="roundRect">
+            <a:avLst>
+              <a:gd name="adj" fmla="val 2759"/>
+            </a:avLst>
+          </a:prstGeom>
+          <a:solidFill>
+            <a:srgbClr val="E2EDF4"/>
+          </a:solidFill>
+          <a:ln/>
+        </p:spPr>
+      </p:sp>
+      <p:sp>
+        <p:nvSpPr>
+          <p:cNvPr id="7" name="Text 5"/>
+          <p:cNvSpPr/>
+          <p:nvPr/>
+        </p:nvSpPr>
+        <p:spPr>
+          <a:xfrm>
+            <a:off x="868680" y="1828800"/>
+            <a:ext cx="4800600" cy="411480"/>
+          </a:xfrm>
+          <a:prstGeom prst="rect">
+            <a:avLst/>
+          </a:prstGeom>
+          <a:noFill/>
+          <a:ln/>
+        </p:spPr>
+        <p:txBody>
+          <a:bodyPr wrap="square" lIns="0" tIns="0" rIns="0" bIns="0" rtlCol="0" anchor="ctr"/>
+          <a:lstStyle/>
+          <a:p>
+            <a:pPr indent="0" marL="0">
+              <a:buNone/>
+            </a:pPr>
+            <a:r>
+              <a:rPr lang="en-US" sz="2400" b="1" dirty="0">
+                <a:solidFill>
+                  <a:srgbClr val="1B2A41"/>
+                </a:solidFill>
+                <a:latin typeface="Cambria" pitchFamily="34" charset="0"/>
+                <a:ea typeface="Cambria" pitchFamily="34" charset="-122"/>
+                <a:cs typeface="Cambria" pitchFamily="34" charset="-120"/>
+              </a:rPr>
+              <a:t>Dr. Benjamin Rush</a:t>
+            </a:r>
+            <a:endParaRPr lang="en-US" sz="2400" dirty="0"/>
+          </a:p>
+        </p:txBody>
+      </p:sp>
+      <p:sp>
+        <p:nvSpPr>
+          <p:cNvPr id="8" name="Text 6"/>
+          <p:cNvSpPr/>
+          <p:nvPr/>
+        </p:nvSpPr>
+        <p:spPr>
+          <a:xfrm>
+            <a:off x="868680" y="2240280"/>
+            <a:ext cx="4800600" cy="274320"/>
+          </a:xfrm>
+          <a:prstGeom prst="rect">
+            <a:avLst/>
+          </a:prstGeom>
+          <a:noFill/>
+          <a:ln/>
+        </p:spPr>
+        <p:txBody>
+          <a:bodyPr wrap="square" lIns="0" tIns="0" rIns="0" bIns="0" rtlCol="0" anchor="ctr"/>
+          <a:lstStyle/>
+          <a:p>
+            <a:pPr indent="0" marL="0">
+              <a:buNone/>
+            </a:pPr>
+            <a:r>
+              <a:rPr lang="en-US" sz="1400" b="1" spc="100" kern="0" dirty="0">
+                <a:solidFill>
+                  <a:srgbClr val="065A82"/>
+                </a:solidFill>
+                <a:latin typeface="Calibri" pitchFamily="34" charset="0"/>
+                <a:ea typeface="Calibri" pitchFamily="34" charset="-122"/>
+                <a:cs typeface="Calibri" pitchFamily="34" charset="-120"/>
+              </a:rPr>
+              <a:t>Surgeon General of the Continental Army</a:t>
+            </a:r>
+            <a:endParaRPr lang="en-US" sz="1400" dirty="0"/>
+          </a:p>
+        </p:txBody>
+      </p:sp>
+      <p:sp>
+        <p:nvSpPr>
+          <p:cNvPr id="9" name="Text 7"/>
+          <p:cNvSpPr/>
+          <p:nvPr/>
+        </p:nvSpPr>
+        <p:spPr>
+          <a:xfrm>
+            <a:off x="868680" y="2606040"/>
+            <a:ext cx="4800600" cy="1371600"/>
+          </a:xfrm>
+          <a:prstGeom prst="rect">
+            <a:avLst/>
+          </a:prstGeom>
+          <a:noFill/>
+          <a:ln/>
+        </p:spPr>
+        <p:txBody>
+          <a:bodyPr wrap="square" lIns="0" tIns="0" rIns="0" bIns="0" rtlCol="0" anchor="t"/>
+          <a:lstStyle/>
+          <a:p>
+            <a:pPr indent="0" marL="0">
+              <a:lnSpc>
+                <a:spcPct val="115000"/>
+              </a:lnSpc>
+              <a:buNone/>
+            </a:pPr>
+            <a:r>
+              <a:rPr lang="en-US" sz="1700" dirty="0">
+                <a:solidFill>
+                  <a:srgbClr val="1B2A41"/>
+                </a:solidFill>
+                <a:latin typeface="Calibri" pitchFamily="34" charset="0"/>
+                <a:ea typeface="Calibri" pitchFamily="34" charset="-122"/>
+                <a:cs typeface="Calibri" pitchFamily="34" charset="-120"/>
+              </a:rPr>
+              <a:t>In 1784 he published </a:t>
+            </a:r>
+            <a:pPr indent="0" marL="0">
+              <a:lnSpc>
+                <a:spcPct val="115000"/>
+              </a:lnSpc>
+              <a:buNone/>
+            </a:pPr>
+            <a:r>
+              <a:rPr lang="en-US" sz="1700" i="1" dirty="0">
+                <a:solidFill>
+                  <a:srgbClr val="1B2A41"/>
+                </a:solidFill>
+                <a:latin typeface="Calibri" pitchFamily="34" charset="0"/>
+                <a:ea typeface="Calibri" pitchFamily="34" charset="-122"/>
+                <a:cs typeface="Calibri" pitchFamily="34" charset="-120"/>
+              </a:rPr>
+              <a:t>An Inquiry into the Effects of Ardent Spirits upon the Human Body and Mind</a:t>
+            </a:r>
+            <a:pPr indent="0" marL="0">
+              <a:lnSpc>
+                <a:spcPct val="115000"/>
+              </a:lnSpc>
+              <a:buNone/>
+            </a:pPr>
+            <a:r>
+              <a:rPr lang="en-US" sz="1700" dirty="0">
+                <a:solidFill>
+                  <a:srgbClr val="1B2A41"/>
+                </a:solidFill>
+                <a:latin typeface="Calibri" pitchFamily="34" charset="0"/>
+                <a:ea typeface="Calibri" pitchFamily="34" charset="-122"/>
+                <a:cs typeface="Calibri" pitchFamily="34" charset="-120"/>
+              </a:rPr>
+              <a:t> — the first American physician to argue in print that alcoholism is a disease.</a:t>
+            </a:r>
+            <a:endParaRPr lang="en-US" sz="1700" dirty="0"/>
+          </a:p>
+        </p:txBody>
+      </p:sp>
+      <p:sp>
+        <p:nvSpPr>
+          <p:cNvPr id="10" name="Shape 8"/>
+          <p:cNvSpPr/>
+          <p:nvPr/>
+        </p:nvSpPr>
+        <p:spPr>
+          <a:xfrm>
+            <a:off x="6199632" y="1554480"/>
+            <a:ext cx="5440680" cy="2651760"/>
+          </a:xfrm>
+          <a:prstGeom prst="roundRect">
+            <a:avLst>
+              <a:gd name="adj" fmla="val 2759"/>
+            </a:avLst>
+          </a:prstGeom>
+          <a:solidFill>
+            <a:srgbClr val="E2EDF4"/>
+          </a:solidFill>
+          <a:ln/>
+        </p:spPr>
+      </p:sp>
+      <p:sp>
+        <p:nvSpPr>
+          <p:cNvPr id="11" name="Text 9"/>
+          <p:cNvSpPr/>
+          <p:nvPr/>
+        </p:nvSpPr>
+        <p:spPr>
+          <a:xfrm>
+            <a:off x="6519672" y="1828800"/>
+            <a:ext cx="4800600" cy="411480"/>
+          </a:xfrm>
+          <a:prstGeom prst="rect">
+            <a:avLst/>
+          </a:prstGeom>
+          <a:noFill/>
+          <a:ln/>
+        </p:spPr>
+        <p:txBody>
+          <a:bodyPr wrap="square" lIns="0" tIns="0" rIns="0" bIns="0" rtlCol="0" anchor="ctr"/>
+          <a:lstStyle/>
+          <a:p>
+            <a:pPr indent="0" marL="0">
+              <a:buNone/>
+            </a:pPr>
+            <a:r>
+              <a:rPr lang="en-US" sz="2400" b="1" dirty="0">
+                <a:solidFill>
+                  <a:srgbClr val="1B2A41"/>
+                </a:solidFill>
+                <a:latin typeface="Cambria" pitchFamily="34" charset="0"/>
+                <a:ea typeface="Cambria" pitchFamily="34" charset="-122"/>
+                <a:cs typeface="Cambria" pitchFamily="34" charset="-120"/>
+              </a:rPr>
+              <a:t>Dr. Thomas Trotter</a:t>
+            </a:r>
+            <a:endParaRPr lang="en-US" sz="2400" dirty="0"/>
+          </a:p>
+        </p:txBody>
+      </p:sp>
+      <p:sp>
+        <p:nvSpPr>
+          <p:cNvPr id="12" name="Text 10"/>
+          <p:cNvSpPr/>
+          <p:nvPr/>
+        </p:nvSpPr>
+        <p:spPr>
+          <a:xfrm>
+            <a:off x="6519672" y="2240280"/>
+            <a:ext cx="4800600" cy="274320"/>
+          </a:xfrm>
+          <a:prstGeom prst="rect">
+            <a:avLst/>
+          </a:prstGeom>
+          <a:noFill/>
+          <a:ln/>
+        </p:spPr>
+        <p:txBody>
+          <a:bodyPr wrap="square" lIns="0" tIns="0" rIns="0" bIns="0" rtlCol="0" anchor="ctr"/>
+          <a:lstStyle/>
+          <a:p>
+            <a:pPr indent="0" marL="0">
+              <a:buNone/>
+            </a:pPr>
+            <a:r>
+              <a:rPr lang="en-US" sz="1400" b="1" spc="100" kern="0" dirty="0">
+                <a:solidFill>
+                  <a:srgbClr val="065A82"/>
+                </a:solidFill>
+                <a:latin typeface="Calibri" pitchFamily="34" charset="0"/>
+                <a:ea typeface="Calibri" pitchFamily="34" charset="-122"/>
+                <a:cs typeface="Calibri" pitchFamily="34" charset="-120"/>
+              </a:rPr>
+              <a:t>Physician to the British Fleet</a:t>
+            </a:r>
+            <a:endParaRPr lang="en-US" sz="1400" dirty="0"/>
+          </a:p>
+        </p:txBody>
+      </p:sp>
+      <p:sp>
+        <p:nvSpPr>
+          <p:cNvPr id="13" name="Text 11"/>
+          <p:cNvSpPr/>
+          <p:nvPr/>
+        </p:nvSpPr>
+        <p:spPr>
+          <a:xfrm>
+            <a:off x="6519672" y="2606040"/>
+            <a:ext cx="4800600" cy="1371600"/>
+          </a:xfrm>
+          <a:prstGeom prst="rect">
+            <a:avLst/>
+          </a:prstGeom>
+          <a:noFill/>
+          <a:ln/>
+        </p:spPr>
+        <p:txBody>
+          <a:bodyPr wrap="square" lIns="0" tIns="0" rIns="0" bIns="0" rtlCol="0" anchor="t"/>
+          <a:lstStyle/>
+          <a:p>
+            <a:pPr indent="0" marL="0">
+              <a:lnSpc>
+                <a:spcPct val="115000"/>
+              </a:lnSpc>
+              <a:buNone/>
+            </a:pPr>
+            <a:r>
+              <a:rPr lang="en-US" sz="1700" dirty="0">
+                <a:solidFill>
+                  <a:srgbClr val="1B2A41"/>
+                </a:solidFill>
+                <a:latin typeface="Calibri" pitchFamily="34" charset="0"/>
+                <a:ea typeface="Calibri" pitchFamily="34" charset="-122"/>
+                <a:cs typeface="Calibri" pitchFamily="34" charset="-120"/>
+              </a:rPr>
+              <a:t>His </a:t>
+            </a:r>
+            <a:pPr indent="0" marL="0">
+              <a:lnSpc>
+                <a:spcPct val="115000"/>
+              </a:lnSpc>
+              <a:buNone/>
+            </a:pPr>
+            <a:r>
+              <a:rPr lang="en-US" sz="1700" i="1" dirty="0">
+                <a:solidFill>
+                  <a:srgbClr val="1B2A41"/>
+                </a:solidFill>
+                <a:latin typeface="Calibri" pitchFamily="34" charset="0"/>
+                <a:ea typeface="Calibri" pitchFamily="34" charset="-122"/>
+                <a:cs typeface="Calibri" pitchFamily="34" charset="-120"/>
+              </a:rPr>
+              <a:t>Essay on Drunkenness, and its Effects on the Human Body</a:t>
+            </a:r>
+            <a:pPr indent="0" marL="0">
+              <a:lnSpc>
+                <a:spcPct val="115000"/>
+              </a:lnSpc>
+              <a:buNone/>
+            </a:pPr>
+            <a:r>
+              <a:rPr lang="en-US" sz="1700" dirty="0">
+                <a:solidFill>
+                  <a:srgbClr val="1B2A41"/>
+                </a:solidFill>
+                <a:latin typeface="Calibri" pitchFamily="34" charset="0"/>
+                <a:ea typeface="Calibri" pitchFamily="34" charset="-122"/>
+                <a:cs typeface="Calibri" pitchFamily="34" charset="-120"/>
+              </a:rPr>
+              <a:t>, published in 1804, was the first book-length medical study of alcohol dependence.</a:t>
+            </a:r>
+            <a:endParaRPr lang="en-US" sz="1700" dirty="0"/>
+          </a:p>
+        </p:txBody>
+      </p:sp>
+      <p:sp>
+        <p:nvSpPr>
+          <p:cNvPr id="14" name="Shape 12"/>
+          <p:cNvSpPr/>
+          <p:nvPr/>
+        </p:nvSpPr>
+        <p:spPr>
+          <a:xfrm>
+            <a:off x="548640" y="4480560"/>
+            <a:ext cx="11091672" cy="1005840"/>
+          </a:xfrm>
+          <a:prstGeom prst="roundRect">
+            <a:avLst>
+              <a:gd name="adj" fmla="val 7273"/>
+            </a:avLst>
+          </a:prstGeom>
+          <a:solidFill>
+            <a:srgbClr val="1B2A41"/>
+          </a:solidFill>
+          <a:ln/>
+        </p:spPr>
+      </p:sp>
+      <p:sp>
+        <p:nvSpPr>
+          <p:cNvPr id="15" name="Text 13"/>
+          <p:cNvSpPr/>
+          <p:nvPr/>
+        </p:nvSpPr>
+        <p:spPr>
+          <a:xfrm>
+            <a:off x="914400" y="4599432"/>
+            <a:ext cx="10360152" cy="256032"/>
+          </a:xfrm>
+          <a:prstGeom prst="rect">
+            <a:avLst/>
+          </a:prstGeom>
+          <a:noFill/>
+          <a:ln/>
+        </p:spPr>
+        <p:txBody>
+          <a:bodyPr wrap="square" lIns="0" tIns="0" rIns="0" bIns="0" rtlCol="0" anchor="ctr"/>
+          <a:lstStyle/>
+          <a:p>
+            <a:pPr indent="0" marL="0">
+              <a:buNone/>
+            </a:pPr>
+            <a:r>
+              <a:rPr lang="en-US" sz="1100" b="1" spc="200" kern="0" dirty="0">
+                <a:solidFill>
+                  <a:srgbClr val="A9B8CC"/>
+                </a:solidFill>
+                <a:latin typeface="Calibri" pitchFamily="34" charset="0"/>
+                <a:ea typeface="Calibri" pitchFamily="34" charset="-122"/>
+                <a:cs typeface="Calibri" pitchFamily="34" charset="-120"/>
+              </a:rPr>
+              <a:t>MARGIN NOTE</a:t>
+            </a:r>
+            <a:endParaRPr lang="en-US" sz="1100" dirty="0"/>
+          </a:p>
+        </p:txBody>
+      </p:sp>
+      <p:sp>
+        <p:nvSpPr>
+          <p:cNvPr id="16" name="Text 14"/>
+          <p:cNvSpPr/>
+          <p:nvPr/>
+        </p:nvSpPr>
+        <p:spPr>
+          <a:xfrm>
+            <a:off x="914400" y="4873752"/>
+            <a:ext cx="10360152" cy="493776"/>
+          </a:xfrm>
+          <a:prstGeom prst="rect">
+            <a:avLst/>
+          </a:prstGeom>
+          <a:noFill/>
+          <a:ln/>
+        </p:spPr>
+        <p:txBody>
+          <a:bodyPr wrap="square" lIns="0" tIns="0" rIns="0" bIns="0" rtlCol="0" anchor="ctr"/>
+          <a:lstStyle/>
+          <a:p>
+            <a:pPr indent="0" marL="0">
+              <a:buNone/>
+            </a:pPr>
+            <a:r>
+              <a:rPr lang="en-US" sz="2200" b="1" dirty="0">
+                <a:solidFill>
+                  <a:srgbClr val="FFFFFF"/>
+                </a:solidFill>
+                <a:latin typeface="Cambria" pitchFamily="34" charset="0"/>
+                <a:ea typeface="Cambria" pitchFamily="34" charset="-122"/>
+                <a:cs typeface="Cambria" pitchFamily="34" charset="-120"/>
+              </a:rPr>
+              <a:t>Page 1 in every first edition. Moved to the front matter in the second.</a:t>
+            </a:r>
+            <a:endParaRPr lang="en-US" sz="2200" dirty="0"/>
+          </a:p>
+        </p:txBody>
+      </p:sp>
+      <p:sp>
+        <p:nvSpPr>
+          <p:cNvPr id="17" name="Text 15"/>
+          <p:cNvSpPr/>
+          <p:nvPr/>
+        </p:nvSpPr>
+        <p:spPr>
+          <a:xfrm>
+            <a:off x="548640" y="5669280"/>
+            <a:ext cx="11091672" cy="292608"/>
+          </a:xfrm>
+          <a:prstGeom prst="rect">
+            <a:avLst/>
+          </a:prstGeom>
+          <a:noFill/>
+          <a:ln/>
+        </p:spPr>
+        <p:txBody>
+          <a:bodyPr wrap="square" lIns="0" tIns="0" rIns="0" bIns="0" rtlCol="0" anchor="ctr"/>
+          <a:lstStyle/>
+          <a:p>
+            <a:pPr indent="0" marL="0">
+              <a:buNone/>
+            </a:pPr>
+            <a:r>
+              <a:rPr lang="en-US" sz="1200" i="1" dirty="0">
+                <a:solidFill>
+                  <a:srgbClr val="6B7A8C"/>
+                </a:solidFill>
+                <a:latin typeface="Calibri" pitchFamily="34" charset="0"/>
+                <a:ea typeface="Calibri" pitchFamily="34" charset="-122"/>
+                <a:cs typeface="Calibri" pitchFamily="34" charset="-120"/>
+              </a:rPr>
+              <a:t>Alcoholics Anonymous</a:t>
+            </a:r>
+            <a:pPr indent="0" marL="0">
+              <a:buNone/>
+            </a:pPr>
+            <a:r>
+              <a:rPr lang="en-US" sz="1200" dirty="0">
+                <a:solidFill>
+                  <a:srgbClr val="6B7A8C"/>
+                </a:solidFill>
+                <a:latin typeface="Calibri" pitchFamily="34" charset="0"/>
+                <a:ea typeface="Calibri" pitchFamily="34" charset="-122"/>
+                <a:cs typeface="Calibri" pitchFamily="34" charset="-120"/>
+              </a:rPr>
+              <a:t>, 4th ed., “The Doctor’s Opinion,” p. xxi.</a:t>
+            </a:r>
+            <a:endParaRPr lang="en-US" sz="1200" dirty="0"/>
+          </a:p>
+        </p:txBody>
+      </p:sp>
+      <p:sp>
+        <p:nvSpPr>
+          <p:cNvPr id="18" name="Text 16"/>
+          <p:cNvSpPr/>
+          <p:nvPr/>
+        </p:nvSpPr>
+        <p:spPr>
+          <a:xfrm>
+            <a:off x="548640" y="6355080"/>
+            <a:ext cx="11091672" cy="292608"/>
+          </a:xfrm>
+          <a:prstGeom prst="rect">
+            <a:avLst/>
+          </a:prstGeom>
+          <a:noFill/>
+          <a:ln/>
+        </p:spPr>
+        <p:txBody>
+          <a:bodyPr wrap="square" lIns="0" tIns="0" rIns="0" bIns="0" rtlCol="0" anchor="ctr"/>
+          <a:lstStyle/>
+          <a:p>
+            <a:pPr indent="0" marL="0">
+              <a:buNone/>
+            </a:pPr>
+            <a:r>
+              <a:rPr lang="en-US" sz="950" dirty="0">
+                <a:solidFill>
+                  <a:srgbClr val="6B7A8C"/>
+                </a:solidFill>
+                <a:latin typeface="Calibri" pitchFamily="34" charset="0"/>
+                <a:ea typeface="Calibri" pitchFamily="34" charset="-122"/>
+                <a:cs typeface="Calibri" pitchFamily="34" charset="-120"/>
+              </a:rPr>
+              <a:t>Copyright © Alcoholics Anonymous World Services, Inc. All rights reserved. Intended for personal use only, and not to be reproduced further or distributed for resale.</a:t>
+            </a:r>
+            <a:endParaRPr lang="en-US" sz="950" dirty="0"/>
+          </a:p>
+        </p:txBody>
+      </p:sp>
+    </p:spTree>
+  </p:cSld>
+  <p:clrMapOvr>
+    <a:masterClrMapping/>
+  </p:clrMapOvr>
+</p:sld>
+</file>
+
+<file path=ppt/slides/slide16.xml><?xml version="1.0" encoding="utf-8"?>
+<p:sld xmlns:a="http://schemas.openxmlformats.org/drawingml/2006/main" xmlns:r="http://schemas.openxmlformats.org/officeDocument/2006/relationships" xmlns:p="http://schemas.openxmlformats.org/presentationml/2006/main">
+  <p:cSld name="Slide 16">
+    <p:bg>
+      <p:bgPr>
+        <a:solidFill>
+          <a:srgbClr val="FFFFFF"/>
+        </a:solidFill>
+      </p:bgPr>
+    </p:bg>
+    <p:spTree>
+      <p:nvGrpSpPr>
+        <p:cNvPr id="1" name=""/>
+        <p:cNvGrpSpPr/>
+        <p:nvPr/>
+      </p:nvGrpSpPr>
+      <p:grpSpPr>
+        <a:xfrm>
+          <a:off x="0" y="0"/>
+          <a:ext cx="0" cy="0"/>
+          <a:chOff x="0" y="0"/>
+          <a:chExt cx="0" cy="0"/>
+        </a:xfrm>
+      </p:grpSpPr>
+      <p:sp>
+        <p:nvSpPr>
+          <p:cNvPr id="2" name="Text 0"/>
+          <p:cNvSpPr/>
+          <p:nvPr/>
+        </p:nvSpPr>
+        <p:spPr>
+          <a:xfrm>
+            <a:off x="548640" y="320040"/>
+            <a:ext cx="8138160" cy="566928"/>
+          </a:xfrm>
+          <a:prstGeom prst="rect">
+            <a:avLst/>
+          </a:prstGeom>
+          <a:noFill/>
+          <a:ln/>
+        </p:spPr>
+        <p:txBody>
+          <a:bodyPr wrap="square" lIns="0" tIns="0" rIns="0" bIns="0" rtlCol="0" anchor="ctr"/>
+          <a:lstStyle/>
+          <a:p>
+            <a:pPr indent="0" marL="0">
+              <a:buNone/>
+            </a:pPr>
+            <a:r>
+              <a:rPr lang="en-US" sz="3800" b="1" dirty="0">
+                <a:solidFill>
+                  <a:srgbClr val="1B2A41"/>
+                </a:solidFill>
+                <a:latin typeface="Cambria" pitchFamily="34" charset="0"/>
+                <a:ea typeface="Cambria" pitchFamily="34" charset="-122"/>
+                <a:cs typeface="Cambria" pitchFamily="34" charset="-120"/>
+              </a:rPr>
+              <a:t>Two Musts</a:t>
+            </a:r>
+            <a:endParaRPr lang="en-US" sz="3800" dirty="0"/>
+          </a:p>
+        </p:txBody>
+      </p:sp>
+      <p:sp>
+        <p:nvSpPr>
+          <p:cNvPr id="3" name="Text 1"/>
+          <p:cNvSpPr/>
+          <p:nvPr/>
+        </p:nvSpPr>
+        <p:spPr>
+          <a:xfrm>
+            <a:off x="548640" y="914400"/>
+            <a:ext cx="8138160" cy="347472"/>
+          </a:xfrm>
+          <a:prstGeom prst="rect">
+            <a:avLst/>
+          </a:prstGeom>
+          <a:noFill/>
+          <a:ln/>
+        </p:spPr>
+        <p:txBody>
+          <a:bodyPr wrap="square" lIns="0" tIns="0" rIns="0" bIns="0" rtlCol="0" anchor="ctr"/>
+          <a:lstStyle/>
+          <a:p>
+            <a:pPr indent="0" marL="0">
+              <a:buNone/>
+            </a:pPr>
+            <a:r>
+              <a:rPr lang="en-US" sz="1700" i="1" dirty="0">
+                <a:solidFill>
+                  <a:srgbClr val="6B7A8C"/>
+                </a:solidFill>
+                <a:latin typeface="Calibri" pitchFamily="34" charset="0"/>
+                <a:ea typeface="Calibri" pitchFamily="34" charset="-122"/>
+                <a:cs typeface="Calibri" pitchFamily="34" charset="-120"/>
+              </a:rPr>
+              <a:t>The Doctor’s Opinion.</a:t>
+            </a:r>
+            <a:endParaRPr lang="en-US" sz="1700" dirty="0"/>
+          </a:p>
+        </p:txBody>
+      </p:sp>
+      <p:sp>
+        <p:nvSpPr>
+          <p:cNvPr id="4" name="Shape 2"/>
+          <p:cNvSpPr/>
+          <p:nvPr/>
+        </p:nvSpPr>
+        <p:spPr>
+          <a:xfrm>
+            <a:off x="8869680" y="320040"/>
+            <a:ext cx="2770632" cy="960120"/>
+          </a:xfrm>
+          <a:prstGeom prst="roundRect">
+            <a:avLst>
+              <a:gd name="adj" fmla="val 9524"/>
+            </a:avLst>
+          </a:prstGeom>
+          <a:solidFill>
+            <a:srgbClr val="9E1B60"/>
+          </a:solidFill>
+          <a:ln/>
+        </p:spPr>
+      </p:sp>
+      <p:sp>
+        <p:nvSpPr>
+          <p:cNvPr id="5" name="Text 3"/>
+          <p:cNvSpPr/>
+          <p:nvPr/>
+        </p:nvSpPr>
+        <p:spPr>
+          <a:xfrm>
+            <a:off x="8869680" y="320040"/>
+            <a:ext cx="2770632" cy="960120"/>
+          </a:xfrm>
+          <a:prstGeom prst="rect">
+            <a:avLst/>
+          </a:prstGeom>
+          <a:noFill/>
+          <a:ln/>
+        </p:spPr>
+        <p:txBody>
+          <a:bodyPr wrap="square" lIns="0" tIns="0" rIns="0" bIns="0" rtlCol="0" anchor="ctr"/>
+          <a:lstStyle/>
+          <a:p>
+            <a:pPr algn="ctr" indent="0" marL="0">
+              <a:buNone/>
+            </a:pPr>
+            <a:r>
+              <a:rPr lang="en-US" sz="1700" b="1" spc="100" kern="0" dirty="0">
+                <a:solidFill>
+                  <a:srgbClr val="FFFFFF"/>
+                </a:solidFill>
+                <a:latin typeface="Cambria" pitchFamily="34" charset="0"/>
+                <a:ea typeface="Cambria" pitchFamily="34" charset="-122"/>
+                <a:cs typeface="Cambria" pitchFamily="34" charset="-120"/>
+              </a:rPr>
+              <a:t>THE “MUSTS”</a:t>
+            </a:r>
+            <a:endParaRPr lang="en-US" sz="1700" dirty="0"/>
+          </a:p>
+          <a:p>
+            <a:pPr algn="ctr" indent="0" marL="0">
+              <a:buNone/>
+            </a:pPr>
+            <a:r>
+              <a:rPr lang="en-US" sz="1300" dirty="0">
+                <a:solidFill>
+                  <a:srgbClr val="F7D9E8"/>
+                </a:solidFill>
+                <a:latin typeface="Calibri" pitchFamily="34" charset="0"/>
+                <a:ea typeface="Calibri" pitchFamily="34" charset="-122"/>
+                <a:cs typeface="Calibri" pitchFamily="34" charset="-120"/>
+              </a:rPr>
+              <a:t>p. xxi</a:t>
+            </a:r>
+            <a:endParaRPr lang="en-US" sz="1700" dirty="0"/>
+          </a:p>
+        </p:txBody>
+      </p:sp>
+      <p:sp>
+        <p:nvSpPr>
+          <p:cNvPr id="6" name="Shape 4"/>
+          <p:cNvSpPr/>
+          <p:nvPr/>
+        </p:nvSpPr>
+        <p:spPr>
+          <a:xfrm>
+            <a:off x="548640" y="1554480"/>
+            <a:ext cx="11091672" cy="1508760"/>
+          </a:xfrm>
+          <a:prstGeom prst="roundRect">
+            <a:avLst>
+              <a:gd name="adj" fmla="val 4848"/>
+            </a:avLst>
+          </a:prstGeom>
+          <a:solidFill>
+            <a:srgbClr val="F9E3EE"/>
+          </a:solidFill>
+          <a:ln/>
+        </p:spPr>
+      </p:sp>
+      <p:sp>
+        <p:nvSpPr>
+          <p:cNvPr id="7" name="Shape 5"/>
+          <p:cNvSpPr/>
+          <p:nvPr/>
+        </p:nvSpPr>
+        <p:spPr>
+          <a:xfrm>
+            <a:off x="914400" y="2034540"/>
+            <a:ext cx="548640" cy="548640"/>
+          </a:xfrm>
+          <a:prstGeom prst="ellipse">
+            <a:avLst/>
+          </a:prstGeom>
+          <a:solidFill>
+            <a:srgbClr val="9E1B60"/>
+          </a:solidFill>
+          <a:ln/>
+        </p:spPr>
+      </p:sp>
+      <p:sp>
+        <p:nvSpPr>
+          <p:cNvPr id="8" name="Text 6"/>
+          <p:cNvSpPr/>
+          <p:nvPr/>
+        </p:nvSpPr>
+        <p:spPr>
+          <a:xfrm>
+            <a:off x="914400" y="2034540"/>
+            <a:ext cx="548640" cy="548640"/>
+          </a:xfrm>
+          <a:prstGeom prst="rect">
+            <a:avLst/>
+          </a:prstGeom>
+          <a:noFill/>
+          <a:ln/>
+        </p:spPr>
+        <p:txBody>
+          <a:bodyPr wrap="square" lIns="0" tIns="0" rIns="0" bIns="0" rtlCol="0" anchor="ctr"/>
+          <a:lstStyle/>
+          <a:p>
+            <a:pPr algn="ctr" indent="0" marL="0">
+              <a:buNone/>
+            </a:pPr>
+            <a:r>
+              <a:rPr lang="en-US" sz="2100" b="1" dirty="0">
+                <a:solidFill>
+                  <a:srgbClr val="FFFFFF"/>
+                </a:solidFill>
+                <a:latin typeface="Cambria" pitchFamily="34" charset="0"/>
+                <a:ea typeface="Cambria" pitchFamily="34" charset="-122"/>
+                <a:cs typeface="Cambria" pitchFamily="34" charset="-120"/>
+              </a:rPr>
+              <a:t>1</a:t>
+            </a:r>
+            <a:endParaRPr lang="en-US" sz="2100" dirty="0"/>
+          </a:p>
+        </p:txBody>
+      </p:sp>
+      <p:sp>
+        <p:nvSpPr>
+          <p:cNvPr id="9" name="Text 7"/>
+          <p:cNvSpPr/>
+          <p:nvPr/>
+        </p:nvSpPr>
+        <p:spPr>
+          <a:xfrm>
+            <a:off x="1737360" y="1554480"/>
+            <a:ext cx="9555480" cy="1508760"/>
+          </a:xfrm>
+          <a:prstGeom prst="rect">
+            <a:avLst/>
+          </a:prstGeom>
+          <a:noFill/>
+          <a:ln/>
+        </p:spPr>
+        <p:txBody>
+          <a:bodyPr wrap="square" lIns="0" tIns="0" rIns="0" bIns="0" rtlCol="0" anchor="ctr"/>
+          <a:lstStyle/>
+          <a:p>
+            <a:pPr indent="0" marL="0">
+              <a:lnSpc>
+                <a:spcPct val="115000"/>
+              </a:lnSpc>
+              <a:buNone/>
+            </a:pPr>
+            <a:r>
+              <a:rPr lang="en-US" sz="2100" dirty="0">
+                <a:solidFill>
+                  <a:srgbClr val="1B2A41"/>
+                </a:solidFill>
+                <a:latin typeface="Calibri" pitchFamily="34" charset="0"/>
+                <a:ea typeface="Calibri" pitchFamily="34" charset="-122"/>
+                <a:cs typeface="Calibri" pitchFamily="34" charset="-120"/>
+              </a:rPr>
+              <a:t>Convincing testimony must surely come from medical men who have had experience with the sufferings of our members and have witnessed our return to health.</a:t>
+            </a:r>
+            <a:endParaRPr lang="en-US" sz="2100" dirty="0"/>
+          </a:p>
+        </p:txBody>
+      </p:sp>
+      <p:sp>
+        <p:nvSpPr>
+          <p:cNvPr id="10" name="Shape 8"/>
+          <p:cNvSpPr/>
+          <p:nvPr/>
+        </p:nvSpPr>
+        <p:spPr>
+          <a:xfrm>
+            <a:off x="548640" y="3291840"/>
+            <a:ext cx="11091672" cy="1508760"/>
+          </a:xfrm>
+          <a:prstGeom prst="roundRect">
+            <a:avLst>
+              <a:gd name="adj" fmla="val 4848"/>
+            </a:avLst>
+          </a:prstGeom>
+          <a:solidFill>
+            <a:srgbClr val="F9E3EE"/>
+          </a:solidFill>
+          <a:ln/>
+        </p:spPr>
+      </p:sp>
+      <p:sp>
+        <p:nvSpPr>
+          <p:cNvPr id="11" name="Shape 9"/>
+          <p:cNvSpPr/>
+          <p:nvPr/>
+        </p:nvSpPr>
+        <p:spPr>
+          <a:xfrm>
+            <a:off x="914400" y="3771900"/>
+            <a:ext cx="548640" cy="548640"/>
+          </a:xfrm>
+          <a:prstGeom prst="ellipse">
+            <a:avLst/>
+          </a:prstGeom>
+          <a:solidFill>
+            <a:srgbClr val="9E1B60"/>
+          </a:solidFill>
+          <a:ln/>
+        </p:spPr>
+      </p:sp>
+      <p:sp>
+        <p:nvSpPr>
+          <p:cNvPr id="12" name="Text 10"/>
+          <p:cNvSpPr/>
+          <p:nvPr/>
+        </p:nvSpPr>
+        <p:spPr>
+          <a:xfrm>
+            <a:off x="914400" y="3771900"/>
+            <a:ext cx="548640" cy="548640"/>
+          </a:xfrm>
+          <a:prstGeom prst="rect">
+            <a:avLst/>
+          </a:prstGeom>
+          <a:noFill/>
+          <a:ln/>
+        </p:spPr>
+        <p:txBody>
+          <a:bodyPr wrap="square" lIns="0" tIns="0" rIns="0" bIns="0" rtlCol="0" anchor="ctr"/>
+          <a:lstStyle/>
+          <a:p>
+            <a:pPr algn="ctr" indent="0" marL="0">
+              <a:buNone/>
+            </a:pPr>
+            <a:r>
+              <a:rPr lang="en-US" sz="2100" b="1" dirty="0">
+                <a:solidFill>
+                  <a:srgbClr val="FFFFFF"/>
+                </a:solidFill>
+                <a:latin typeface="Cambria" pitchFamily="34" charset="0"/>
+                <a:ea typeface="Cambria" pitchFamily="34" charset="-122"/>
+                <a:cs typeface="Cambria" pitchFamily="34" charset="-120"/>
+              </a:rPr>
+              <a:t>2</a:t>
+            </a:r>
+            <a:endParaRPr lang="en-US" sz="2100" dirty="0"/>
+          </a:p>
+        </p:txBody>
+      </p:sp>
+      <p:sp>
+        <p:nvSpPr>
+          <p:cNvPr id="13" name="Text 11"/>
+          <p:cNvSpPr/>
+          <p:nvPr/>
+        </p:nvSpPr>
+        <p:spPr>
+          <a:xfrm>
+            <a:off x="1737360" y="3291840"/>
+            <a:ext cx="9555480" cy="1508760"/>
+          </a:xfrm>
+          <a:prstGeom prst="rect">
+            <a:avLst/>
+          </a:prstGeom>
+          <a:noFill/>
+          <a:ln/>
+        </p:spPr>
+        <p:txBody>
+          <a:bodyPr wrap="square" lIns="0" tIns="0" rIns="0" bIns="0" rtlCol="0" anchor="ctr"/>
+          <a:lstStyle/>
+          <a:p>
+            <a:pPr indent="0" marL="0">
+              <a:lnSpc>
+                <a:spcPct val="115000"/>
+              </a:lnSpc>
+              <a:buNone/>
+            </a:pPr>
+            <a:r>
+              <a:rPr lang="en-US" sz="2100" dirty="0">
+                <a:solidFill>
+                  <a:srgbClr val="1B2A41"/>
+                </a:solidFill>
+                <a:latin typeface="Calibri" pitchFamily="34" charset="0"/>
+                <a:ea typeface="Calibri" pitchFamily="34" charset="-122"/>
+                <a:cs typeface="Calibri" pitchFamily="34" charset="-120"/>
+              </a:rPr>
+              <a:t>As part of his rehabilitation he commenced to present his conceptions to other alcoholics, impressing upon them that they must do likewise with still others.</a:t>
+            </a:r>
+            <a:endParaRPr lang="en-US" sz="2100" dirty="0"/>
+          </a:p>
+        </p:txBody>
+      </p:sp>
+      <p:sp>
+        <p:nvSpPr>
+          <p:cNvPr id="14" name="Text 12"/>
+          <p:cNvSpPr/>
+          <p:nvPr/>
+        </p:nvSpPr>
+        <p:spPr>
+          <a:xfrm>
+            <a:off x="548640" y="5074920"/>
+            <a:ext cx="11091672" cy="292608"/>
+          </a:xfrm>
+          <a:prstGeom prst="rect">
+            <a:avLst/>
+          </a:prstGeom>
+          <a:noFill/>
+          <a:ln/>
+        </p:spPr>
+        <p:txBody>
+          <a:bodyPr wrap="square" lIns="0" tIns="0" rIns="0" bIns="0" rtlCol="0" anchor="ctr"/>
+          <a:lstStyle/>
+          <a:p>
+            <a:pPr indent="0" marL="0">
+              <a:buNone/>
+            </a:pPr>
+            <a:r>
+              <a:rPr lang="en-US" sz="1200" i="1" dirty="0">
+                <a:solidFill>
+                  <a:srgbClr val="6B7A8C"/>
+                </a:solidFill>
+                <a:latin typeface="Calibri" pitchFamily="34" charset="0"/>
+                <a:ea typeface="Calibri" pitchFamily="34" charset="-122"/>
+                <a:cs typeface="Calibri" pitchFamily="34" charset="-120"/>
+              </a:rPr>
+              <a:t>Alcoholics Anonymous</a:t>
+            </a:r>
+            <a:pPr indent="0" marL="0">
+              <a:buNone/>
+            </a:pPr>
+            <a:r>
+              <a:rPr lang="en-US" sz="1200" dirty="0">
+                <a:solidFill>
+                  <a:srgbClr val="6B7A8C"/>
+                </a:solidFill>
+                <a:latin typeface="Calibri" pitchFamily="34" charset="0"/>
+                <a:ea typeface="Calibri" pitchFamily="34" charset="-122"/>
+                <a:cs typeface="Calibri" pitchFamily="34" charset="-120"/>
+              </a:rPr>
+              <a:t>, 4th ed., “The Doctor’s Opinion,” p. xxi.</a:t>
+            </a:r>
+            <a:endParaRPr lang="en-US" sz="1200" dirty="0"/>
+          </a:p>
+        </p:txBody>
+      </p:sp>
+      <p:sp>
+        <p:nvSpPr>
+          <p:cNvPr id="15" name="Text 13"/>
+          <p:cNvSpPr/>
+          <p:nvPr/>
+        </p:nvSpPr>
+        <p:spPr>
+          <a:xfrm>
+            <a:off x="548640" y="6355080"/>
+            <a:ext cx="11091672" cy="292608"/>
+          </a:xfrm>
+          <a:prstGeom prst="rect">
+            <a:avLst/>
+          </a:prstGeom>
+          <a:noFill/>
+          <a:ln/>
+        </p:spPr>
+        <p:txBody>
+          <a:bodyPr wrap="square" lIns="0" tIns="0" rIns="0" bIns="0" rtlCol="0" anchor="ctr"/>
+          <a:lstStyle/>
+          <a:p>
+            <a:pPr indent="0" marL="0">
+              <a:buNone/>
+            </a:pPr>
+            <a:r>
+              <a:rPr lang="en-US" sz="950" dirty="0">
+                <a:solidFill>
+                  <a:srgbClr val="6B7A8C"/>
+                </a:solidFill>
+                <a:latin typeface="Calibri" pitchFamily="34" charset="0"/>
+                <a:ea typeface="Calibri" pitchFamily="34" charset="-122"/>
+                <a:cs typeface="Calibri" pitchFamily="34" charset="-120"/>
+              </a:rPr>
+              <a:t>Copyright © Alcoholics Anonymous World Services, Inc. All rights reserved. Intended for personal use only, and not to be reproduced further or distributed for resale.</a:t>
+            </a:r>
+            <a:endParaRPr lang="en-US" sz="950" dirty="0"/>
+          </a:p>
+        </p:txBody>
+      </p:sp>
+    </p:spTree>
+  </p:cSld>
+  <p:clrMapOvr>
+    <a:masterClrMapping/>
+  </p:clrMapOvr>
+</p:sld>
+</file>
+
 <file path=ppt/slides/slide2.xml><?xml version="1.0" encoding="utf-8"?>
 <p:sld xmlns:a="http://schemas.openxmlformats.org/drawingml/2006/main" xmlns:r="http://schemas.openxmlformats.org/officeDocument/2006/relationships" xmlns:p="http://schemas.openxmlformats.org/presentationml/2006/main">
   <p:cSld name="Slide 2">

</xml_diff>

<commit_message>
Add slides 17-20: The Doctor's Opinion, p. xxii
Silkworth's signature and the note that the letter ran as Anonymous in the first
editions; the green paragraph split across two slides so the pink must and the
physical-factor argument each get room; and the allergy paragraph.

Every mark on the page is carried through: the pink stretch in magenta, single
underlines on the two emphasized sentences, and a true double underline on
'control' - u=dbl in the slide XML, which the HTML preview flattens to single but
PowerPoint renders correctly.

Co-Authored-By: Claude Opus 5 <noreply@anthropic.com>
Claude-Session: https://claude.ai/code/session_01NuCgD3Z7aWvkQrsSvAUX4h
</commit_message>
<xml_diff>
--- a/aa-slideshow/aa-big-book-study.pptx
+++ b/aa-slideshow/aa-big-book-study.pptx
@@ -21,9 +21,13 @@
     <p:sldId id="269" r:id="rId15"/>
     <p:sldId id="270" r:id="rId16"/>
     <p:sldId id="271" r:id="rId17"/>
+    <p:sldId id="272" r:id="rId18"/>
+    <p:sldId id="273" r:id="rId19"/>
+    <p:sldId id="274" r:id="rId20"/>
+    <p:sldId id="275" r:id="rId21"/>
   </p:sldIdLst>
   <p:notesMasterIdLst>
-    <p:notesMasterId r:id="rId18"/>
+    <p:notesMasterId r:id="rId22"/>
   </p:notesMasterIdLst>
   <p:sldSz cx="12192000" cy="6858000"/>
   <p:notesSz cx="6858000" cy="12192000"/>
@@ -1216,6 +1220,286 @@
 </p:notes>
 </file>
 
+<file path=ppt/notesSlides/notesSlide17.xml><?xml version="1.0" encoding="utf-8"?>
+<p:notes xmlns:a="http://schemas.openxmlformats.org/drawingml/2006/main" xmlns:r="http://schemas.openxmlformats.org/officeDocument/2006/relationships" xmlns:p="http://schemas.openxmlformats.org/presentationml/2006/main">
+  <p:cSld>
+    <p:spTree>
+      <p:nvGrpSpPr>
+        <p:cNvPr id="1" name=""/>
+        <p:cNvGrpSpPr/>
+        <p:nvPr/>
+      </p:nvGrpSpPr>
+      <p:grpSpPr>
+        <a:xfrm>
+          <a:off x="0" y="0"/>
+          <a:ext cx="0" cy="0"/>
+          <a:chOff x="0" y="0"/>
+          <a:chExt cx="0" cy="0"/>
+        </a:xfrm>
+      </p:grpSpPr>
+      <p:sp>
+        <p:nvSpPr>
+          <p:cNvPr id="2" name="Slide Image Placeholder 1"/>
+          <p:cNvSpPr>
+            <a:spLocks noGrp="1" noRot="1" noChangeAspect="1"/>
+          </p:cNvSpPr>
+          <p:nvPr>
+            <p:ph type="sldImg"/>
+          </p:nvPr>
+        </p:nvSpPr>
+        <p:spPr/>
+      </p:sp>
+      <p:sp>
+        <p:nvSpPr>
+          <p:cNvPr id="3" name="Notes Placeholder 2"/>
+          <p:cNvSpPr>
+            <a:spLocks noGrp="1"/>
+          </p:cNvSpPr>
+          <p:nvPr>
+            <p:ph type="body" idx="1"/>
+          </p:nvPr>
+        </p:nvSpPr>
+        <p:spPr/>
+        <p:txBody>
+          <a:bodyPr/>
+          <a:lstStyle/>
+          <a:p>
+            <a:r>
+              <a:rPr lang="en-US" dirty="0"/>
+              <a:t>The doctor who wrote this letter is the same Silkworth from the Foreword - the one the
+book calls a medical saint, the one who told the broker the grave nature of alcoholism.
+His name is on it now. It was not always. In the first editions the letter was signed
+Anonymous, and the name was added later.
+A doctor put his professional reputation behind a book written by drunks, in 1939, when
+there was nothing to gain by it.</a:t>
+            </a:r>
+            <a:endParaRPr lang="en-US" dirty="0"/>
+          </a:p>
+        </p:txBody>
+      </p:sp>
+      <p:sp>
+        <p:nvSpPr>
+          <p:cNvPr id="4" name="Slide Number Placeholder 3"/>
+          <p:cNvSpPr>
+            <a:spLocks noGrp="1"/>
+          </p:cNvSpPr>
+          <p:nvPr>
+            <p:ph type="sldNum" sz="quarter" idx="10"/>
+          </p:nvPr>
+        </p:nvSpPr>
+        <p:spPr/>
+        <p:txBody>
+          <a:bodyPr/>
+          <a:lstStyle/>
+          <a:p>
+            <a:fld id="{F7021451-1387-4CA6-816F-3879F97B5CBC}" type="slidenum">
+              <a:rPr lang="en-US"/>
+              <a:t>17</a:t>
+            </a:fld>
+            <a:endParaRPr lang="en-US"/>
+          </a:p>
+        </p:txBody>
+      </p:sp>
+    </p:spTree>
+    <p:extLst>
+      <p:ext uri="{BB962C8B-B14F-4D97-AF65-F5344CB8AC3E}">
+        <p14:creationId xmlns:p14="http://schemas.microsoft.com/office/powerpoint/2010/main" val="1024086991"/>
+      </p:ext>
+    </p:extLst>
+  </p:cSld>
+  <p:clrMapOvr>
+    <a:masterClrMapping/>
+  </p:clrMapOvr>
+</p:notes>
+</file>
+
+<file path=ppt/notesSlides/notesSlide18.xml><?xml version="1.0" encoding="utf-8"?>
+<p:notes xmlns:a="http://schemas.openxmlformats.org/drawingml/2006/main" xmlns:r="http://schemas.openxmlformats.org/officeDocument/2006/relationships" xmlns:p="http://schemas.openxmlformats.org/presentationml/2006/main">
+  <p:cSld>
+    <p:spTree>
+      <p:nvGrpSpPr>
+        <p:cNvPr id="1" name=""/>
+        <p:cNvGrpSpPr/>
+        <p:nvPr/>
+      </p:nvGrpSpPr>
+      <p:grpSpPr>
+        <a:xfrm>
+          <a:off x="0" y="0"/>
+          <a:ext cx="0" cy="0"/>
+          <a:chOff x="0" y="0"/>
+          <a:chExt cx="0" cy="0"/>
+        </a:xfrm>
+      </p:grpSpPr>
+      <p:sp>
+        <p:nvSpPr>
+          <p:cNvPr id="2" name="Slide Image Placeholder 1"/>
+          <p:cNvSpPr>
+            <a:spLocks noGrp="1" noRot="1" noChangeAspect="1"/>
+          </p:cNvSpPr>
+          <p:nvPr>
+            <p:ph type="sldImg"/>
+          </p:nvPr>
+        </p:nvSpPr>
+        <p:spPr/>
+      </p:sp>
+      <p:sp>
+        <p:nvSpPr>
+          <p:cNvPr id="3" name="Notes Placeholder 2"/>
+          <p:cNvSpPr>
+            <a:spLocks noGrp="1"/>
+          </p:cNvSpPr>
+          <p:nvPr>
+            <p:ph type="body" idx="1"/>
+          </p:nvPr>
+        </p:nvSpPr>
+        <p:spPr/>
+        <p:txBody>
+          <a:bodyPr/>
+          <a:lstStyle/>
+          <a:p>
+            <a:r>
+              <a:rPr lang="en-US" dirty="0"/>
+              <a:t>Body and mind. Both. That is the whole claim, and it is a must - what we who have
+suffered alcoholic torture must believe.
+Not a weak mind housed in a healthy body. Not a moral failure a person could think his
+way out of. The body is as abnormal as the mind.
+This is Step One territory. If only the mind were the problem, willpower would work.</a:t>
+            </a:r>
+            <a:endParaRPr lang="en-US" dirty="0"/>
+          </a:p>
+        </p:txBody>
+      </p:sp>
+      <p:sp>
+        <p:nvSpPr>
+          <p:cNvPr id="4" name="Slide Number Placeholder 3"/>
+          <p:cNvSpPr>
+            <a:spLocks noGrp="1"/>
+          </p:cNvSpPr>
+          <p:nvPr>
+            <p:ph type="sldNum" sz="quarter" idx="10"/>
+          </p:nvPr>
+        </p:nvSpPr>
+        <p:spPr/>
+        <p:txBody>
+          <a:bodyPr/>
+          <a:lstStyle/>
+          <a:p>
+            <a:fld id="{F7021451-1387-4CA6-816F-3879F97B5CBC}" type="slidenum">
+              <a:rPr lang="en-US"/>
+              <a:t>18</a:t>
+            </a:fld>
+            <a:endParaRPr lang="en-US"/>
+          </a:p>
+        </p:txBody>
+      </p:sp>
+    </p:spTree>
+    <p:extLst>
+      <p:ext uri="{BB962C8B-B14F-4D97-AF65-F5344CB8AC3E}">
+        <p14:creationId xmlns:p14="http://schemas.microsoft.com/office/powerpoint/2010/main" val="1024086991"/>
+      </p:ext>
+    </p:extLst>
+  </p:cSld>
+  <p:clrMapOvr>
+    <a:masterClrMapping/>
+  </p:clrMapOvr>
+</p:notes>
+</file>
+
+<file path=ppt/notesSlides/notesSlide19.xml><?xml version="1.0" encoding="utf-8"?>
+<p:notes xmlns:a="http://schemas.openxmlformats.org/drawingml/2006/main" xmlns:r="http://schemas.openxmlformats.org/officeDocument/2006/relationships" xmlns:p="http://schemas.openxmlformats.org/presentationml/2006/main">
+  <p:cSld>
+    <p:spTree>
+      <p:nvGrpSpPr>
+        <p:cNvPr id="1" name=""/>
+        <p:cNvGrpSpPr/>
+        <p:nvPr/>
+      </p:nvGrpSpPr>
+      <p:grpSpPr>
+        <a:xfrm>
+          <a:off x="0" y="0"/>
+          <a:ext cx="0" cy="0"/>
+          <a:chOff x="0" y="0"/>
+          <a:chExt cx="0" cy="0"/>
+        </a:xfrm>
+      </p:grpSpPr>
+      <p:sp>
+        <p:nvSpPr>
+          <p:cNvPr id="2" name="Slide Image Placeholder 1"/>
+          <p:cNvSpPr>
+            <a:spLocks noGrp="1" noRot="1" noChangeAspect="1"/>
+          </p:cNvSpPr>
+          <p:nvPr>
+            <p:ph type="sldImg"/>
+          </p:nvPr>
+        </p:nvSpPr>
+        <p:spPr/>
+      </p:sp>
+      <p:sp>
+        <p:nvSpPr>
+          <p:cNvPr id="3" name="Notes Placeholder 2"/>
+          <p:cNvSpPr>
+            <a:spLocks noGrp="1"/>
+          </p:cNvSpPr>
+          <p:nvPr>
+            <p:ph type="body" idx="1"/>
+          </p:nvPr>
+        </p:nvSpPr>
+        <p:spPr/>
+        <p:txBody>
+          <a:bodyPr/>
+          <a:lstStyle/>
+          <a:p>
+            <a:r>
+              <a:rPr lang="en-US" dirty="0"/>
+              <a:t>Control is double-underlined in the study copy. Sit on that word.
+They are not arguing that the psychological picture is wrong. Read it again - these things
+were true to some extent, in fact to a considerable extent with some of us. Maladjusted,
+in flight from reality, all of it. They grant it.
+What they will not grant is that it is the whole story. Our bodies were sickened as well.
+Any picture that leaves out the physical factor is incomplete. Incomplete, not wrong -
+and an incomplete picture is what keeps a man trying to solve a physical problem with
+resolutions.</a:t>
+            </a:r>
+            <a:endParaRPr lang="en-US" dirty="0"/>
+          </a:p>
+        </p:txBody>
+      </p:sp>
+      <p:sp>
+        <p:nvSpPr>
+          <p:cNvPr id="4" name="Slide Number Placeholder 3"/>
+          <p:cNvSpPr>
+            <a:spLocks noGrp="1"/>
+          </p:cNvSpPr>
+          <p:nvPr>
+            <p:ph type="sldNum" sz="quarter" idx="10"/>
+          </p:nvPr>
+        </p:nvSpPr>
+        <p:spPr/>
+        <p:txBody>
+          <a:bodyPr/>
+          <a:lstStyle/>
+          <a:p>
+            <a:fld id="{F7021451-1387-4CA6-816F-3879F97B5CBC}" type="slidenum">
+              <a:rPr lang="en-US"/>
+              <a:t>19</a:t>
+            </a:fld>
+            <a:endParaRPr lang="en-US"/>
+          </a:p>
+        </p:txBody>
+      </p:sp>
+    </p:spTree>
+    <p:extLst>
+      <p:ext uri="{BB962C8B-B14F-4D97-AF65-F5344CB8AC3E}">
+        <p14:creationId xmlns:p14="http://schemas.microsoft.com/office/powerpoint/2010/main" val="1024086991"/>
+      </p:ext>
+    </p:extLst>
+  </p:cSld>
+  <p:clrMapOvr>
+    <a:masterClrMapping/>
+  </p:clrMapOvr>
+</p:notes>
+</file>
+
 <file path=ppt/notesSlides/notesSlide2.xml><?xml version="1.0" encoding="utf-8"?>
 <p:notes xmlns:a="http://schemas.openxmlformats.org/drawingml/2006/main" xmlns:r="http://schemas.openxmlformats.org/officeDocument/2006/relationships" xmlns:p="http://schemas.openxmlformats.org/presentationml/2006/main">
   <p:cSld>
@@ -1291,6 +1575,98 @@
             <a:fld id="{F7021451-1387-4CA6-816F-3879F97B5CBC}" type="slidenum">
               <a:rPr lang="en-US"/>
               <a:t>2</a:t>
+            </a:fld>
+            <a:endParaRPr lang="en-US"/>
+          </a:p>
+        </p:txBody>
+      </p:sp>
+    </p:spTree>
+    <p:extLst>
+      <p:ext uri="{BB962C8B-B14F-4D97-AF65-F5344CB8AC3E}">
+        <p14:creationId xmlns:p14="http://schemas.microsoft.com/office/powerpoint/2010/main" val="1024086991"/>
+      </p:ext>
+    </p:extLst>
+  </p:cSld>
+  <p:clrMapOvr>
+    <a:masterClrMapping/>
+  </p:clrMapOvr>
+</p:notes>
+</file>
+
+<file path=ppt/notesSlides/notesSlide20.xml><?xml version="1.0" encoding="utf-8"?>
+<p:notes xmlns:a="http://schemas.openxmlformats.org/drawingml/2006/main" xmlns:r="http://schemas.openxmlformats.org/officeDocument/2006/relationships" xmlns:p="http://schemas.openxmlformats.org/presentationml/2006/main">
+  <p:cSld>
+    <p:spTree>
+      <p:nvGrpSpPr>
+        <p:cNvPr id="1" name=""/>
+        <p:cNvGrpSpPr/>
+        <p:nvPr/>
+      </p:nvGrpSpPr>
+      <p:grpSpPr>
+        <a:xfrm>
+          <a:off x="0" y="0"/>
+          <a:ext cx="0" cy="0"/>
+          <a:chOff x="0" y="0"/>
+          <a:chExt cx="0" cy="0"/>
+        </a:xfrm>
+      </p:grpSpPr>
+      <p:sp>
+        <p:nvSpPr>
+          <p:cNvPr id="2" name="Slide Image Placeholder 1"/>
+          <p:cNvSpPr>
+            <a:spLocks noGrp="1" noRot="1" noChangeAspect="1"/>
+          </p:cNvSpPr>
+          <p:nvPr>
+            <p:ph type="sldImg"/>
+          </p:nvPr>
+        </p:nvSpPr>
+        <p:spPr/>
+      </p:sp>
+      <p:sp>
+        <p:nvSpPr>
+          <p:cNvPr id="3" name="Notes Placeholder 2"/>
+          <p:cNvSpPr>
+            <a:spLocks noGrp="1"/>
+          </p:cNvSpPr>
+          <p:nvPr>
+            <p:ph type="body" idx="1"/>
+          </p:nvPr>
+        </p:nvSpPr>
+        <p:spPr/>
+        <p:txBody>
+          <a:bodyPr/>
+          <a:lstStyle/>
+          <a:p>
+            <a:r>
+              <a:rPr lang="en-US" dirty="0"/>
+              <a:t>Interests us. Not proves, not settles - interests. They are careful here.
+As laymen our opinion means little. They say so themselves. But as ex-problem drinkers -
+and that is the standing that counts in this room - the explanation makes good sense.
+It explains many things for which we cannot otherwise account. That is the test they are
+applying. Not is it proven, but does it account for what happened to me.</a:t>
+            </a:r>
+            <a:endParaRPr lang="en-US" dirty="0"/>
+          </a:p>
+        </p:txBody>
+      </p:sp>
+      <p:sp>
+        <p:nvSpPr>
+          <p:cNvPr id="4" name="Slide Number Placeholder 3"/>
+          <p:cNvSpPr>
+            <a:spLocks noGrp="1"/>
+          </p:cNvSpPr>
+          <p:nvPr>
+            <p:ph type="sldNum" sz="quarter" idx="10"/>
+          </p:nvPr>
+        </p:nvSpPr>
+        <p:spPr/>
+        <p:txBody>
+          <a:bodyPr/>
+          <a:lstStyle/>
+          <a:p>
+            <a:fld id="{F7021451-1387-4CA6-816F-3879F97B5CBC}" type="slidenum">
+              <a:rPr lang="en-US"/>
+              <a:t>20</a:t>
             </a:fld>
             <a:endParaRPr lang="en-US"/>
           </a:p>
@@ -6706,6 +7082,1359 @@
 </p:sld>
 </file>
 
+<file path=ppt/slides/slide17.xml><?xml version="1.0" encoding="utf-8"?>
+<p:sld xmlns:a="http://schemas.openxmlformats.org/drawingml/2006/main" xmlns:r="http://schemas.openxmlformats.org/officeDocument/2006/relationships" xmlns:p="http://schemas.openxmlformats.org/presentationml/2006/main">
+  <p:cSld name="Slide 17">
+    <p:bg>
+      <p:bgPr>
+        <a:solidFill>
+          <a:srgbClr val="FFFFFF"/>
+        </a:solidFill>
+      </p:bgPr>
+    </p:bg>
+    <p:spTree>
+      <p:nvGrpSpPr>
+        <p:cNvPr id="1" name=""/>
+        <p:cNvGrpSpPr/>
+        <p:nvPr/>
+      </p:nvGrpSpPr>
+      <p:grpSpPr>
+        <a:xfrm>
+          <a:off x="0" y="0"/>
+          <a:ext cx="0" cy="0"/>
+          <a:chOff x="0" y="0"/>
+          <a:chExt cx="0" cy="0"/>
+        </a:xfrm>
+      </p:grpSpPr>
+      <p:sp>
+        <p:nvSpPr>
+          <p:cNvPr id="2" name="Text 0"/>
+          <p:cNvSpPr/>
+          <p:nvPr/>
+        </p:nvSpPr>
+        <p:spPr>
+          <a:xfrm>
+            <a:off x="548640" y="320040"/>
+            <a:ext cx="8138160" cy="566928"/>
+          </a:xfrm>
+          <a:prstGeom prst="rect">
+            <a:avLst/>
+          </a:prstGeom>
+          <a:noFill/>
+          <a:ln/>
+        </p:spPr>
+        <p:txBody>
+          <a:bodyPr wrap="square" lIns="0" tIns="0" rIns="0" bIns="0" rtlCol="0" anchor="ctr"/>
+          <a:lstStyle/>
+          <a:p>
+            <a:pPr indent="0" marL="0">
+              <a:buNone/>
+            </a:pPr>
+            <a:r>
+              <a:rPr lang="en-US" sz="3800" b="1" dirty="0">
+                <a:solidFill>
+                  <a:srgbClr val="1B2A41"/>
+                </a:solidFill>
+                <a:latin typeface="Cambria" pitchFamily="34" charset="0"/>
+                <a:ea typeface="Cambria" pitchFamily="34" charset="-122"/>
+                <a:cs typeface="Cambria" pitchFamily="34" charset="-120"/>
+              </a:rPr>
+              <a:t>William D. Silkworth, M.D.</a:t>
+            </a:r>
+            <a:endParaRPr lang="en-US" sz="3800" dirty="0"/>
+          </a:p>
+        </p:txBody>
+      </p:sp>
+      <p:sp>
+        <p:nvSpPr>
+          <p:cNvPr id="3" name="Text 1"/>
+          <p:cNvSpPr/>
+          <p:nvPr/>
+        </p:nvSpPr>
+        <p:spPr>
+          <a:xfrm>
+            <a:off x="548640" y="914400"/>
+            <a:ext cx="8138160" cy="347472"/>
+          </a:xfrm>
+          <a:prstGeom prst="rect">
+            <a:avLst/>
+          </a:prstGeom>
+          <a:noFill/>
+          <a:ln/>
+        </p:spPr>
+        <p:txBody>
+          <a:bodyPr wrap="square" lIns="0" tIns="0" rIns="0" bIns="0" rtlCol="0" anchor="ctr"/>
+          <a:lstStyle/>
+          <a:p>
+            <a:pPr indent="0" marL="0">
+              <a:buNone/>
+            </a:pPr>
+            <a:r>
+              <a:rPr lang="en-US" sz="1700" i="1" dirty="0">
+                <a:solidFill>
+                  <a:srgbClr val="6B7A8C"/>
+                </a:solidFill>
+                <a:latin typeface="Calibri" pitchFamily="34" charset="0"/>
+                <a:ea typeface="Calibri" pitchFamily="34" charset="-122"/>
+                <a:cs typeface="Calibri" pitchFamily="34" charset="-120"/>
+              </a:rPr>
+              <a:t>The letter is signed.</a:t>
+            </a:r>
+            <a:endParaRPr lang="en-US" sz="1700" dirty="0"/>
+          </a:p>
+        </p:txBody>
+      </p:sp>
+      <p:sp>
+        <p:nvSpPr>
+          <p:cNvPr id="4" name="Shape 2"/>
+          <p:cNvSpPr/>
+          <p:nvPr/>
+        </p:nvSpPr>
+        <p:spPr>
+          <a:xfrm>
+            <a:off x="8869680" y="320040"/>
+            <a:ext cx="2770632" cy="960120"/>
+          </a:xfrm>
+          <a:prstGeom prst="roundRect">
+            <a:avLst>
+              <a:gd name="adj" fmla="val 9524"/>
+            </a:avLst>
+          </a:prstGeom>
+          <a:solidFill>
+            <a:srgbClr val="065A82"/>
+          </a:solidFill>
+          <a:ln/>
+        </p:spPr>
+      </p:sp>
+      <p:sp>
+        <p:nvSpPr>
+          <p:cNvPr id="5" name="Text 3"/>
+          <p:cNvSpPr/>
+          <p:nvPr/>
+        </p:nvSpPr>
+        <p:spPr>
+          <a:xfrm>
+            <a:off x="8869680" y="320040"/>
+            <a:ext cx="2770632" cy="960120"/>
+          </a:xfrm>
+          <a:prstGeom prst="rect">
+            <a:avLst/>
+          </a:prstGeom>
+          <a:noFill/>
+          <a:ln/>
+        </p:spPr>
+        <p:txBody>
+          <a:bodyPr wrap="square" lIns="0" tIns="0" rIns="0" bIns="0" rtlCol="0" anchor="ctr"/>
+          <a:lstStyle/>
+          <a:p>
+            <a:pPr algn="ctr" indent="0" marL="0">
+              <a:buNone/>
+            </a:pPr>
+            <a:r>
+              <a:rPr lang="en-US" sz="1700" b="1" spc="100" kern="0" dirty="0">
+                <a:solidFill>
+                  <a:srgbClr val="FFFFFF"/>
+                </a:solidFill>
+                <a:latin typeface="Cambria" pitchFamily="34" charset="0"/>
+                <a:ea typeface="Cambria" pitchFamily="34" charset="-122"/>
+                <a:cs typeface="Cambria" pitchFamily="34" charset="-120"/>
+              </a:rPr>
+              <a:t>THE BIG BOOK</a:t>
+            </a:r>
+            <a:endParaRPr lang="en-US" sz="1700" dirty="0"/>
+          </a:p>
+          <a:p>
+            <a:pPr algn="ctr" indent="0" marL="0">
+              <a:buNone/>
+            </a:pPr>
+            <a:r>
+              <a:rPr lang="en-US" sz="1300" dirty="0">
+                <a:solidFill>
+                  <a:srgbClr val="C7DEEC"/>
+                </a:solidFill>
+                <a:latin typeface="Calibri" pitchFamily="34" charset="0"/>
+                <a:ea typeface="Calibri" pitchFamily="34" charset="-122"/>
+                <a:cs typeface="Calibri" pitchFamily="34" charset="-120"/>
+              </a:rPr>
+              <a:t>p. xxii</a:t>
+            </a:r>
+            <a:endParaRPr lang="en-US" sz="1700" dirty="0"/>
+          </a:p>
+        </p:txBody>
+      </p:sp>
+      <p:sp>
+        <p:nvSpPr>
+          <p:cNvPr id="6" name="Shape 4"/>
+          <p:cNvSpPr/>
+          <p:nvPr/>
+        </p:nvSpPr>
+        <p:spPr>
+          <a:xfrm>
+            <a:off x="548640" y="1645920"/>
+            <a:ext cx="11091672" cy="2103120"/>
+          </a:xfrm>
+          <a:prstGeom prst="roundRect">
+            <a:avLst>
+              <a:gd name="adj" fmla="val 3478"/>
+            </a:avLst>
+          </a:prstGeom>
+          <a:solidFill>
+            <a:srgbClr val="E2EDF4"/>
+          </a:solidFill>
+          <a:ln/>
+        </p:spPr>
+      </p:sp>
+      <p:sp>
+        <p:nvSpPr>
+          <p:cNvPr id="7" name="Text 5"/>
+          <p:cNvSpPr/>
+          <p:nvPr/>
+        </p:nvSpPr>
+        <p:spPr>
+          <a:xfrm>
+            <a:off x="914400" y="2011680"/>
+            <a:ext cx="10360152" cy="457200"/>
+          </a:xfrm>
+          <a:prstGeom prst="rect">
+            <a:avLst/>
+          </a:prstGeom>
+          <a:noFill/>
+          <a:ln/>
+        </p:spPr>
+        <p:txBody>
+          <a:bodyPr wrap="square" lIns="0" tIns="0" rIns="0" bIns="0" rtlCol="0" anchor="ctr"/>
+          <a:lstStyle/>
+          <a:p>
+            <a:pPr algn="r" indent="0" marL="0">
+              <a:buNone/>
+            </a:pPr>
+            <a:r>
+              <a:rPr lang="en-US" sz="2200" i="1" dirty="0">
+                <a:solidFill>
+                  <a:srgbClr val="1B2A41"/>
+                </a:solidFill>
+                <a:latin typeface="Calibri" pitchFamily="34" charset="0"/>
+                <a:ea typeface="Calibri" pitchFamily="34" charset="-122"/>
+                <a:cs typeface="Calibri" pitchFamily="34" charset="-120"/>
+              </a:rPr>
+              <a:t>Very truly yours,</a:t>
+            </a:r>
+            <a:endParaRPr lang="en-US" sz="2200" dirty="0"/>
+          </a:p>
+        </p:txBody>
+      </p:sp>
+      <p:sp>
+        <p:nvSpPr>
+          <p:cNvPr id="8" name="Text 6"/>
+          <p:cNvSpPr/>
+          <p:nvPr/>
+        </p:nvSpPr>
+        <p:spPr>
+          <a:xfrm>
+            <a:off x="914400" y="2560320"/>
+            <a:ext cx="10360152" cy="685800"/>
+          </a:xfrm>
+          <a:prstGeom prst="rect">
+            <a:avLst/>
+          </a:prstGeom>
+          <a:noFill/>
+          <a:ln/>
+        </p:spPr>
+        <p:txBody>
+          <a:bodyPr wrap="square" lIns="0" tIns="0" rIns="0" bIns="0" rtlCol="0" anchor="ctr"/>
+          <a:lstStyle/>
+          <a:p>
+            <a:pPr algn="r" indent="0" marL="0">
+              <a:buNone/>
+            </a:pPr>
+            <a:r>
+              <a:rPr lang="en-US" sz="3400" b="1" dirty="0">
+                <a:solidFill>
+                  <a:srgbClr val="065A82"/>
+                </a:solidFill>
+                <a:latin typeface="Cambria" pitchFamily="34" charset="0"/>
+                <a:ea typeface="Cambria" pitchFamily="34" charset="-122"/>
+                <a:cs typeface="Cambria" pitchFamily="34" charset="-120"/>
+              </a:rPr>
+              <a:t>William D. Silkworth, M.D.</a:t>
+            </a:r>
+            <a:endParaRPr lang="en-US" sz="3400" dirty="0"/>
+          </a:p>
+        </p:txBody>
+      </p:sp>
+      <p:sp>
+        <p:nvSpPr>
+          <p:cNvPr id="9" name="Shape 7"/>
+          <p:cNvSpPr/>
+          <p:nvPr/>
+        </p:nvSpPr>
+        <p:spPr>
+          <a:xfrm>
+            <a:off x="548640" y="4023360"/>
+            <a:ext cx="11091672" cy="1005840"/>
+          </a:xfrm>
+          <a:prstGeom prst="roundRect">
+            <a:avLst>
+              <a:gd name="adj" fmla="val 7273"/>
+            </a:avLst>
+          </a:prstGeom>
+          <a:solidFill>
+            <a:srgbClr val="1B2A41"/>
+          </a:solidFill>
+          <a:ln/>
+        </p:spPr>
+      </p:sp>
+      <p:sp>
+        <p:nvSpPr>
+          <p:cNvPr id="10" name="Text 8"/>
+          <p:cNvSpPr/>
+          <p:nvPr/>
+        </p:nvSpPr>
+        <p:spPr>
+          <a:xfrm>
+            <a:off x="914400" y="4142232"/>
+            <a:ext cx="10360152" cy="256032"/>
+          </a:xfrm>
+          <a:prstGeom prst="rect">
+            <a:avLst/>
+          </a:prstGeom>
+          <a:noFill/>
+          <a:ln/>
+        </p:spPr>
+        <p:txBody>
+          <a:bodyPr wrap="square" lIns="0" tIns="0" rIns="0" bIns="0" rtlCol="0" anchor="ctr"/>
+          <a:lstStyle/>
+          <a:p>
+            <a:pPr indent="0" marL="0">
+              <a:buNone/>
+            </a:pPr>
+            <a:r>
+              <a:rPr lang="en-US" sz="1100" b="1" spc="200" kern="0" dirty="0">
+                <a:solidFill>
+                  <a:srgbClr val="A9B8CC"/>
+                </a:solidFill>
+                <a:latin typeface="Calibri" pitchFamily="34" charset="0"/>
+                <a:ea typeface="Calibri" pitchFamily="34" charset="-122"/>
+                <a:cs typeface="Calibri" pitchFamily="34" charset="-120"/>
+              </a:rPr>
+              <a:t>MARGIN NOTE</a:t>
+            </a:r>
+            <a:endParaRPr lang="en-US" sz="1100" dirty="0"/>
+          </a:p>
+        </p:txBody>
+      </p:sp>
+      <p:sp>
+        <p:nvSpPr>
+          <p:cNvPr id="11" name="Text 9"/>
+          <p:cNvSpPr/>
+          <p:nvPr/>
+        </p:nvSpPr>
+        <p:spPr>
+          <a:xfrm>
+            <a:off x="914400" y="4416552"/>
+            <a:ext cx="10360152" cy="493776"/>
+          </a:xfrm>
+          <a:prstGeom prst="rect">
+            <a:avLst/>
+          </a:prstGeom>
+          <a:noFill/>
+          <a:ln/>
+        </p:spPr>
+        <p:txBody>
+          <a:bodyPr wrap="square" lIns="0" tIns="0" rIns="0" bIns="0" rtlCol="0" anchor="ctr"/>
+          <a:lstStyle/>
+          <a:p>
+            <a:pPr indent="0" marL="0">
+              <a:buNone/>
+            </a:pPr>
+            <a:r>
+              <a:rPr lang="en-US" sz="2200" b="1" dirty="0">
+                <a:solidFill>
+                  <a:srgbClr val="FFFFFF"/>
+                </a:solidFill>
+                <a:latin typeface="Cambria" pitchFamily="34" charset="0"/>
+                <a:ea typeface="Cambria" pitchFamily="34" charset="-122"/>
+                <a:cs typeface="Cambria" pitchFamily="34" charset="-120"/>
+              </a:rPr>
+              <a:t>Signed “Anonymous” in the first editions.</a:t>
+            </a:r>
+            <a:endParaRPr lang="en-US" sz="2200" dirty="0"/>
+          </a:p>
+        </p:txBody>
+      </p:sp>
+      <p:sp>
+        <p:nvSpPr>
+          <p:cNvPr id="12" name="Text 10"/>
+          <p:cNvSpPr/>
+          <p:nvPr/>
+        </p:nvSpPr>
+        <p:spPr>
+          <a:xfrm>
+            <a:off x="548640" y="5212080"/>
+            <a:ext cx="11091672" cy="292608"/>
+          </a:xfrm>
+          <a:prstGeom prst="rect">
+            <a:avLst/>
+          </a:prstGeom>
+          <a:noFill/>
+          <a:ln/>
+        </p:spPr>
+        <p:txBody>
+          <a:bodyPr wrap="square" lIns="0" tIns="0" rIns="0" bIns="0" rtlCol="0" anchor="ctr"/>
+          <a:lstStyle/>
+          <a:p>
+            <a:pPr indent="0" marL="0">
+              <a:buNone/>
+            </a:pPr>
+            <a:r>
+              <a:rPr lang="en-US" sz="1200" i="1" dirty="0">
+                <a:solidFill>
+                  <a:srgbClr val="6B7A8C"/>
+                </a:solidFill>
+                <a:latin typeface="Calibri" pitchFamily="34" charset="0"/>
+                <a:ea typeface="Calibri" pitchFamily="34" charset="-122"/>
+                <a:cs typeface="Calibri" pitchFamily="34" charset="-120"/>
+              </a:rPr>
+              <a:t>Alcoholics Anonymous</a:t>
+            </a:r>
+            <a:pPr indent="0" marL="0">
+              <a:buNone/>
+            </a:pPr>
+            <a:r>
+              <a:rPr lang="en-US" sz="1200" dirty="0">
+                <a:solidFill>
+                  <a:srgbClr val="6B7A8C"/>
+                </a:solidFill>
+                <a:latin typeface="Calibri" pitchFamily="34" charset="0"/>
+                <a:ea typeface="Calibri" pitchFamily="34" charset="-122"/>
+                <a:cs typeface="Calibri" pitchFamily="34" charset="-120"/>
+              </a:rPr>
+              <a:t>, 4th ed., “The Doctor’s Opinion,” p. xxii.</a:t>
+            </a:r>
+            <a:endParaRPr lang="en-US" sz="1200" dirty="0"/>
+          </a:p>
+        </p:txBody>
+      </p:sp>
+      <p:sp>
+        <p:nvSpPr>
+          <p:cNvPr id="13" name="Text 11"/>
+          <p:cNvSpPr/>
+          <p:nvPr/>
+        </p:nvSpPr>
+        <p:spPr>
+          <a:xfrm>
+            <a:off x="548640" y="6355080"/>
+            <a:ext cx="11091672" cy="292608"/>
+          </a:xfrm>
+          <a:prstGeom prst="rect">
+            <a:avLst/>
+          </a:prstGeom>
+          <a:noFill/>
+          <a:ln/>
+        </p:spPr>
+        <p:txBody>
+          <a:bodyPr wrap="square" lIns="0" tIns="0" rIns="0" bIns="0" rtlCol="0" anchor="ctr"/>
+          <a:lstStyle/>
+          <a:p>
+            <a:pPr indent="0" marL="0">
+              <a:buNone/>
+            </a:pPr>
+            <a:r>
+              <a:rPr lang="en-US" sz="950" dirty="0">
+                <a:solidFill>
+                  <a:srgbClr val="6B7A8C"/>
+                </a:solidFill>
+                <a:latin typeface="Calibri" pitchFamily="34" charset="0"/>
+                <a:ea typeface="Calibri" pitchFamily="34" charset="-122"/>
+                <a:cs typeface="Calibri" pitchFamily="34" charset="-120"/>
+              </a:rPr>
+              <a:t>Copyright © Alcoholics Anonymous World Services, Inc. All rights reserved. Intended for personal use only, and not to be reproduced further or distributed for resale.</a:t>
+            </a:r>
+            <a:endParaRPr lang="en-US" sz="950" dirty="0"/>
+          </a:p>
+        </p:txBody>
+      </p:sp>
+    </p:spTree>
+  </p:cSld>
+  <p:clrMapOvr>
+    <a:masterClrMapping/>
+  </p:clrMapOvr>
+</p:sld>
+</file>
+
+<file path=ppt/slides/slide18.xml><?xml version="1.0" encoding="utf-8"?>
+<p:sld xmlns:a="http://schemas.openxmlformats.org/drawingml/2006/main" xmlns:r="http://schemas.openxmlformats.org/officeDocument/2006/relationships" xmlns:p="http://schemas.openxmlformats.org/presentationml/2006/main">
+  <p:cSld name="Slide 18">
+    <p:bg>
+      <p:bgPr>
+        <a:solidFill>
+          <a:srgbClr val="FFFFFF"/>
+        </a:solidFill>
+      </p:bgPr>
+    </p:bg>
+    <p:spTree>
+      <p:nvGrpSpPr>
+        <p:cNvPr id="1" name=""/>
+        <p:cNvGrpSpPr/>
+        <p:nvPr/>
+      </p:nvGrpSpPr>
+      <p:grpSpPr>
+        <a:xfrm>
+          <a:off x="0" y="0"/>
+          <a:ext cx="0" cy="0"/>
+          <a:chOff x="0" y="0"/>
+          <a:chExt cx="0" cy="0"/>
+        </a:xfrm>
+      </p:grpSpPr>
+      <p:sp>
+        <p:nvSpPr>
+          <p:cNvPr id="2" name="Text 0"/>
+          <p:cNvSpPr/>
+          <p:nvPr/>
+        </p:nvSpPr>
+        <p:spPr>
+          <a:xfrm>
+            <a:off x="548640" y="320040"/>
+            <a:ext cx="8138160" cy="566928"/>
+          </a:xfrm>
+          <a:prstGeom prst="rect">
+            <a:avLst/>
+          </a:prstGeom>
+          <a:noFill/>
+          <a:ln/>
+        </p:spPr>
+        <p:txBody>
+          <a:bodyPr wrap="square" lIns="0" tIns="0" rIns="0" bIns="0" rtlCol="0" anchor="ctr"/>
+          <a:lstStyle/>
+          <a:p>
+            <a:pPr indent="0" marL="0">
+              <a:buNone/>
+            </a:pPr>
+            <a:r>
+              <a:rPr lang="en-US" sz="3800" b="1" dirty="0">
+                <a:solidFill>
+                  <a:srgbClr val="1B2A41"/>
+                </a:solidFill>
+                <a:latin typeface="Cambria" pitchFamily="34" charset="0"/>
+                <a:ea typeface="Cambria" pitchFamily="34" charset="-122"/>
+                <a:cs typeface="Cambria" pitchFamily="34" charset="-120"/>
+              </a:rPr>
+              <a:t>As Abnormal as His Mind</a:t>
+            </a:r>
+            <a:endParaRPr lang="en-US" sz="3800" dirty="0"/>
+          </a:p>
+        </p:txBody>
+      </p:sp>
+      <p:sp>
+        <p:nvSpPr>
+          <p:cNvPr id="3" name="Text 1"/>
+          <p:cNvSpPr/>
+          <p:nvPr/>
+        </p:nvSpPr>
+        <p:spPr>
+          <a:xfrm>
+            <a:off x="548640" y="914400"/>
+            <a:ext cx="8138160" cy="347472"/>
+          </a:xfrm>
+          <a:prstGeom prst="rect">
+            <a:avLst/>
+          </a:prstGeom>
+          <a:noFill/>
+          <a:ln/>
+        </p:spPr>
+        <p:txBody>
+          <a:bodyPr wrap="square" lIns="0" tIns="0" rIns="0" bIns="0" rtlCol="0" anchor="ctr"/>
+          <a:lstStyle/>
+          <a:p>
+            <a:pPr indent="0" marL="0">
+              <a:buNone/>
+            </a:pPr>
+            <a:r>
+              <a:rPr lang="en-US" sz="1700" i="1" dirty="0">
+                <a:solidFill>
+                  <a:srgbClr val="6B7A8C"/>
+                </a:solidFill>
+                <a:latin typeface="Calibri" pitchFamily="34" charset="0"/>
+                <a:ea typeface="Calibri" pitchFamily="34" charset="-122"/>
+                <a:cs typeface="Calibri" pitchFamily="34" charset="-120"/>
+              </a:rPr>
+              <a:t>What we who have suffered must believe.</a:t>
+            </a:r>
+            <a:endParaRPr lang="en-US" sz="1700" dirty="0"/>
+          </a:p>
+        </p:txBody>
+      </p:sp>
+      <p:sp>
+        <p:nvSpPr>
+          <p:cNvPr id="4" name="Shape 2"/>
+          <p:cNvSpPr/>
+          <p:nvPr/>
+        </p:nvSpPr>
+        <p:spPr>
+          <a:xfrm>
+            <a:off x="8869680" y="320040"/>
+            <a:ext cx="2770632" cy="960120"/>
+          </a:xfrm>
+          <a:prstGeom prst="roundRect">
+            <a:avLst>
+              <a:gd name="adj" fmla="val 9524"/>
+            </a:avLst>
+          </a:prstGeom>
+          <a:solidFill>
+            <a:srgbClr val="9E1B60"/>
+          </a:solidFill>
+          <a:ln/>
+        </p:spPr>
+      </p:sp>
+      <p:sp>
+        <p:nvSpPr>
+          <p:cNvPr id="5" name="Text 3"/>
+          <p:cNvSpPr/>
+          <p:nvPr/>
+        </p:nvSpPr>
+        <p:spPr>
+          <a:xfrm>
+            <a:off x="8869680" y="320040"/>
+            <a:ext cx="2770632" cy="960120"/>
+          </a:xfrm>
+          <a:prstGeom prst="rect">
+            <a:avLst/>
+          </a:prstGeom>
+          <a:noFill/>
+          <a:ln/>
+        </p:spPr>
+        <p:txBody>
+          <a:bodyPr wrap="square" lIns="0" tIns="0" rIns="0" bIns="0" rtlCol="0" anchor="ctr"/>
+          <a:lstStyle/>
+          <a:p>
+            <a:pPr algn="ctr" indent="0" marL="0">
+              <a:buNone/>
+            </a:pPr>
+            <a:r>
+              <a:rPr lang="en-US" sz="1700" b="1" spc="100" kern="0" dirty="0">
+                <a:solidFill>
+                  <a:srgbClr val="FFFFFF"/>
+                </a:solidFill>
+                <a:latin typeface="Cambria" pitchFamily="34" charset="0"/>
+                <a:ea typeface="Cambria" pitchFamily="34" charset="-122"/>
+                <a:cs typeface="Cambria" pitchFamily="34" charset="-120"/>
+              </a:rPr>
+              <a:t>THE “MUSTS”</a:t>
+            </a:r>
+            <a:endParaRPr lang="en-US" sz="1700" dirty="0"/>
+          </a:p>
+          <a:p>
+            <a:pPr algn="ctr" indent="0" marL="0">
+              <a:buNone/>
+            </a:pPr>
+            <a:r>
+              <a:rPr lang="en-US" sz="1300" dirty="0">
+                <a:solidFill>
+                  <a:srgbClr val="F7D9E8"/>
+                </a:solidFill>
+                <a:latin typeface="Calibri" pitchFamily="34" charset="0"/>
+                <a:ea typeface="Calibri" pitchFamily="34" charset="-122"/>
+                <a:cs typeface="Calibri" pitchFamily="34" charset="-120"/>
+              </a:rPr>
+              <a:t>p. xxii</a:t>
+            </a:r>
+            <a:endParaRPr lang="en-US" sz="1700" dirty="0"/>
+          </a:p>
+        </p:txBody>
+      </p:sp>
+      <p:sp>
+        <p:nvSpPr>
+          <p:cNvPr id="6" name="Shape 4"/>
+          <p:cNvSpPr/>
+          <p:nvPr/>
+        </p:nvSpPr>
+        <p:spPr>
+          <a:xfrm>
+            <a:off x="548640" y="1463040"/>
+            <a:ext cx="11091672" cy="2103120"/>
+          </a:xfrm>
+          <a:prstGeom prst="roundRect">
+            <a:avLst>
+              <a:gd name="adj" fmla="val 3478"/>
+            </a:avLst>
+          </a:prstGeom>
+          <a:solidFill>
+            <a:srgbClr val="EAF1E6"/>
+          </a:solidFill>
+          <a:ln/>
+        </p:spPr>
+      </p:sp>
+      <p:sp>
+        <p:nvSpPr>
+          <p:cNvPr id="7" name="Text 5"/>
+          <p:cNvSpPr/>
+          <p:nvPr/>
+        </p:nvSpPr>
+        <p:spPr>
+          <a:xfrm>
+            <a:off x="914400" y="1463040"/>
+            <a:ext cx="10360152" cy="2103120"/>
+          </a:xfrm>
+          <a:prstGeom prst="rect">
+            <a:avLst/>
+          </a:prstGeom>
+          <a:noFill/>
+          <a:ln/>
+        </p:spPr>
+        <p:txBody>
+          <a:bodyPr wrap="square" lIns="0" tIns="0" rIns="0" bIns="0" rtlCol="0" anchor="ctr"/>
+          <a:lstStyle/>
+          <a:p>
+            <a:pPr indent="0" marL="0">
+              <a:lnSpc>
+                <a:spcPct val="115000"/>
+              </a:lnSpc>
+              <a:buNone/>
+            </a:pPr>
+            <a:r>
+              <a:rPr lang="en-US" sz="1900" dirty="0">
+                <a:solidFill>
+                  <a:srgbClr val="1B2A41"/>
+                </a:solidFill>
+                <a:latin typeface="Calibri" pitchFamily="34" charset="0"/>
+                <a:ea typeface="Calibri" pitchFamily="34" charset="-122"/>
+                <a:cs typeface="Calibri" pitchFamily="34" charset="-120"/>
+              </a:rPr>
+              <a:t>The physician who, at our request, gave us this letter, has been kind enough to enlarge upon his views in another statement which follows. In this statement he </a:t>
+            </a:r>
+            <a:pPr indent="0" marL="0">
+              <a:lnSpc>
+                <a:spcPct val="115000"/>
+              </a:lnSpc>
+              <a:buNone/>
+            </a:pPr>
+            <a:r>
+              <a:rPr lang="en-US" sz="1900" b="1" dirty="0">
+                <a:solidFill>
+                  <a:srgbClr val="9E1B60"/>
+                </a:solidFill>
+                <a:latin typeface="Calibri" pitchFamily="34" charset="0"/>
+                <a:ea typeface="Calibri" pitchFamily="34" charset="-122"/>
+                <a:cs typeface="Calibri" pitchFamily="34" charset="-120"/>
+              </a:rPr>
+              <a:t>confirms what we who have suffered alcoholic torture must believe—</a:t>
+            </a:r>
+            <a:pPr indent="0" marL="0">
+              <a:lnSpc>
+                <a:spcPct val="115000"/>
+              </a:lnSpc>
+              <a:buNone/>
+            </a:pPr>
+            <a:r>
+              <a:rPr lang="en-US" sz="1900" b="1" u="sng" dirty="0">
+                <a:solidFill>
+                  <a:srgbClr val="9E1B60"/>
+                </a:solidFill>
+                <a:latin typeface="Calibri" pitchFamily="34" charset="0"/>
+                <a:ea typeface="Calibri" pitchFamily="34" charset="-122"/>
+                <a:cs typeface="Calibri" pitchFamily="34" charset="-120"/>
+              </a:rPr>
+              <a:t>that the body of the alcoholic is quite as abnormal as his mind.</a:t>
+            </a:r>
+            <a:endParaRPr lang="en-US" sz="1900" dirty="0"/>
+          </a:p>
+        </p:txBody>
+      </p:sp>
+      <p:sp>
+        <p:nvSpPr>
+          <p:cNvPr id="8" name="Shape 6"/>
+          <p:cNvSpPr/>
+          <p:nvPr/>
+        </p:nvSpPr>
+        <p:spPr>
+          <a:xfrm>
+            <a:off x="548640" y="3840480"/>
+            <a:ext cx="11091672" cy="1234440"/>
+          </a:xfrm>
+          <a:prstGeom prst="roundRect">
+            <a:avLst>
+              <a:gd name="adj" fmla="val 5926"/>
+            </a:avLst>
+          </a:prstGeom>
+          <a:solidFill>
+            <a:srgbClr val="9E1B60"/>
+          </a:solidFill>
+          <a:ln/>
+        </p:spPr>
+      </p:sp>
+      <p:sp>
+        <p:nvSpPr>
+          <p:cNvPr id="9" name="Text 7"/>
+          <p:cNvSpPr/>
+          <p:nvPr/>
+        </p:nvSpPr>
+        <p:spPr>
+          <a:xfrm>
+            <a:off x="914400" y="3959352"/>
+            <a:ext cx="10360152" cy="256032"/>
+          </a:xfrm>
+          <a:prstGeom prst="rect">
+            <a:avLst/>
+          </a:prstGeom>
+          <a:noFill/>
+          <a:ln/>
+        </p:spPr>
+        <p:txBody>
+          <a:bodyPr wrap="square" lIns="0" tIns="0" rIns="0" bIns="0" rtlCol="0" anchor="ctr"/>
+          <a:lstStyle/>
+          <a:p>
+            <a:pPr indent="0" marL="0">
+              <a:buNone/>
+            </a:pPr>
+            <a:r>
+              <a:rPr lang="en-US" sz="1100" b="1" spc="200" kern="0" dirty="0">
+                <a:solidFill>
+                  <a:srgbClr val="F7D9E8"/>
+                </a:solidFill>
+                <a:latin typeface="Calibri" pitchFamily="34" charset="0"/>
+                <a:ea typeface="Calibri" pitchFamily="34" charset="-122"/>
+                <a:cs typeface="Calibri" pitchFamily="34" charset="-120"/>
+              </a:rPr>
+              <a:t>A “MUST”</a:t>
+            </a:r>
+            <a:endParaRPr lang="en-US" sz="1100" dirty="0"/>
+          </a:p>
+        </p:txBody>
+      </p:sp>
+      <p:sp>
+        <p:nvSpPr>
+          <p:cNvPr id="10" name="Text 8"/>
+          <p:cNvSpPr/>
+          <p:nvPr/>
+        </p:nvSpPr>
+        <p:spPr>
+          <a:xfrm>
+            <a:off x="914400" y="4233672"/>
+            <a:ext cx="10360152" cy="685800"/>
+          </a:xfrm>
+          <a:prstGeom prst="rect">
+            <a:avLst/>
+          </a:prstGeom>
+          <a:noFill/>
+          <a:ln/>
+        </p:spPr>
+        <p:txBody>
+          <a:bodyPr wrap="square" lIns="0" tIns="0" rIns="0" bIns="0" rtlCol="0" anchor="ctr"/>
+          <a:lstStyle/>
+          <a:p>
+            <a:pPr indent="0" marL="0">
+              <a:buNone/>
+            </a:pPr>
+            <a:r>
+              <a:rPr lang="en-US" sz="2400" b="1" dirty="0">
+                <a:solidFill>
+                  <a:srgbClr val="FFFFFF"/>
+                </a:solidFill>
+                <a:latin typeface="Cambria" pitchFamily="34" charset="0"/>
+                <a:ea typeface="Cambria" pitchFamily="34" charset="-122"/>
+                <a:cs typeface="Cambria" pitchFamily="34" charset="-120"/>
+              </a:rPr>
+              <a:t>…the body of the alcoholic is quite as abnormal as his mind.</a:t>
+            </a:r>
+            <a:endParaRPr lang="en-US" sz="2400" dirty="0"/>
+          </a:p>
+        </p:txBody>
+      </p:sp>
+      <p:sp>
+        <p:nvSpPr>
+          <p:cNvPr id="11" name="Text 9"/>
+          <p:cNvSpPr/>
+          <p:nvPr/>
+        </p:nvSpPr>
+        <p:spPr>
+          <a:xfrm>
+            <a:off x="548640" y="5303520"/>
+            <a:ext cx="11091672" cy="292608"/>
+          </a:xfrm>
+          <a:prstGeom prst="rect">
+            <a:avLst/>
+          </a:prstGeom>
+          <a:noFill/>
+          <a:ln/>
+        </p:spPr>
+        <p:txBody>
+          <a:bodyPr wrap="square" lIns="0" tIns="0" rIns="0" bIns="0" rtlCol="0" anchor="ctr"/>
+          <a:lstStyle/>
+          <a:p>
+            <a:pPr indent="0" marL="0">
+              <a:buNone/>
+            </a:pPr>
+            <a:r>
+              <a:rPr lang="en-US" sz="1200" i="1" dirty="0">
+                <a:solidFill>
+                  <a:srgbClr val="6B7A8C"/>
+                </a:solidFill>
+                <a:latin typeface="Calibri" pitchFamily="34" charset="0"/>
+                <a:ea typeface="Calibri" pitchFamily="34" charset="-122"/>
+                <a:cs typeface="Calibri" pitchFamily="34" charset="-120"/>
+              </a:rPr>
+              <a:t>Alcoholics Anonymous</a:t>
+            </a:r>
+            <a:pPr indent="0" marL="0">
+              <a:buNone/>
+            </a:pPr>
+            <a:r>
+              <a:rPr lang="en-US" sz="1200" dirty="0">
+                <a:solidFill>
+                  <a:srgbClr val="6B7A8C"/>
+                </a:solidFill>
+                <a:latin typeface="Calibri" pitchFamily="34" charset="0"/>
+                <a:ea typeface="Calibri" pitchFamily="34" charset="-122"/>
+                <a:cs typeface="Calibri" pitchFamily="34" charset="-120"/>
+              </a:rPr>
+              <a:t>, 4th ed., “The Doctor’s Opinion,” p. xxii.</a:t>
+            </a:r>
+            <a:endParaRPr lang="en-US" sz="1200" dirty="0"/>
+          </a:p>
+        </p:txBody>
+      </p:sp>
+      <p:sp>
+        <p:nvSpPr>
+          <p:cNvPr id="12" name="Text 10"/>
+          <p:cNvSpPr/>
+          <p:nvPr/>
+        </p:nvSpPr>
+        <p:spPr>
+          <a:xfrm>
+            <a:off x="548640" y="6355080"/>
+            <a:ext cx="11091672" cy="292608"/>
+          </a:xfrm>
+          <a:prstGeom prst="rect">
+            <a:avLst/>
+          </a:prstGeom>
+          <a:noFill/>
+          <a:ln/>
+        </p:spPr>
+        <p:txBody>
+          <a:bodyPr wrap="square" lIns="0" tIns="0" rIns="0" bIns="0" rtlCol="0" anchor="ctr"/>
+          <a:lstStyle/>
+          <a:p>
+            <a:pPr indent="0" marL="0">
+              <a:buNone/>
+            </a:pPr>
+            <a:r>
+              <a:rPr lang="en-US" sz="950" dirty="0">
+                <a:solidFill>
+                  <a:srgbClr val="6B7A8C"/>
+                </a:solidFill>
+                <a:latin typeface="Calibri" pitchFamily="34" charset="0"/>
+                <a:ea typeface="Calibri" pitchFamily="34" charset="-122"/>
+                <a:cs typeface="Calibri" pitchFamily="34" charset="-120"/>
+              </a:rPr>
+              <a:t>Copyright © Alcoholics Anonymous World Services, Inc. All rights reserved. Intended for personal use only, and not to be reproduced further or distributed for resale.</a:t>
+            </a:r>
+            <a:endParaRPr lang="en-US" sz="950" dirty="0"/>
+          </a:p>
+        </p:txBody>
+      </p:sp>
+    </p:spTree>
+  </p:cSld>
+  <p:clrMapOvr>
+    <a:masterClrMapping/>
+  </p:clrMapOvr>
+</p:sld>
+</file>
+
+<file path=ppt/slides/slide19.xml><?xml version="1.0" encoding="utf-8"?>
+<p:sld xmlns:a="http://schemas.openxmlformats.org/drawingml/2006/main" xmlns:r="http://schemas.openxmlformats.org/officeDocument/2006/relationships" xmlns:p="http://schemas.openxmlformats.org/presentationml/2006/main">
+  <p:cSld name="Slide 19">
+    <p:bg>
+      <p:bgPr>
+        <a:solidFill>
+          <a:srgbClr val="FFFFFF"/>
+        </a:solidFill>
+      </p:bgPr>
+    </p:bg>
+    <p:spTree>
+      <p:nvGrpSpPr>
+        <p:cNvPr id="1" name=""/>
+        <p:cNvGrpSpPr/>
+        <p:nvPr/>
+      </p:nvGrpSpPr>
+      <p:grpSpPr>
+        <a:xfrm>
+          <a:off x="0" y="0"/>
+          <a:ext cx="0" cy="0"/>
+          <a:chOff x="0" y="0"/>
+          <a:chExt cx="0" cy="0"/>
+        </a:xfrm>
+      </p:grpSpPr>
+      <p:sp>
+        <p:nvSpPr>
+          <p:cNvPr id="2" name="Text 0"/>
+          <p:cNvSpPr/>
+          <p:nvPr/>
+        </p:nvSpPr>
+        <p:spPr>
+          <a:xfrm>
+            <a:off x="548640" y="320040"/>
+            <a:ext cx="8138160" cy="566928"/>
+          </a:xfrm>
+          <a:prstGeom prst="rect">
+            <a:avLst/>
+          </a:prstGeom>
+          <a:noFill/>
+          <a:ln/>
+        </p:spPr>
+        <p:txBody>
+          <a:bodyPr wrap="square" lIns="0" tIns="0" rIns="0" bIns="0" rtlCol="0" anchor="ctr"/>
+          <a:lstStyle/>
+          <a:p>
+            <a:pPr indent="0" marL="0">
+              <a:buNone/>
+            </a:pPr>
+            <a:r>
+              <a:rPr lang="en-US" sz="3800" b="1" dirty="0">
+                <a:solidFill>
+                  <a:srgbClr val="1B2A41"/>
+                </a:solidFill>
+                <a:latin typeface="Cambria" pitchFamily="34" charset="0"/>
+                <a:ea typeface="Cambria" pitchFamily="34" charset="-122"/>
+                <a:cs typeface="Cambria" pitchFamily="34" charset="-120"/>
+              </a:rPr>
+              <a:t>The Physical Factor</a:t>
+            </a:r>
+            <a:endParaRPr lang="en-US" sz="3800" dirty="0"/>
+          </a:p>
+        </p:txBody>
+      </p:sp>
+      <p:sp>
+        <p:nvSpPr>
+          <p:cNvPr id="3" name="Text 1"/>
+          <p:cNvSpPr/>
+          <p:nvPr/>
+        </p:nvSpPr>
+        <p:spPr>
+          <a:xfrm>
+            <a:off x="548640" y="914400"/>
+            <a:ext cx="8138160" cy="347472"/>
+          </a:xfrm>
+          <a:prstGeom prst="rect">
+            <a:avLst/>
+          </a:prstGeom>
+          <a:noFill/>
+          <a:ln/>
+        </p:spPr>
+        <p:txBody>
+          <a:bodyPr wrap="square" lIns="0" tIns="0" rIns="0" bIns="0" rtlCol="0" anchor="ctr"/>
+          <a:lstStyle/>
+          <a:p>
+            <a:pPr indent="0" marL="0">
+              <a:buNone/>
+            </a:pPr>
+            <a:r>
+              <a:rPr lang="en-US" sz="1700" i="1" dirty="0">
+                <a:solidFill>
+                  <a:srgbClr val="6B7A8C"/>
+                </a:solidFill>
+                <a:latin typeface="Calibri" pitchFamily="34" charset="0"/>
+                <a:ea typeface="Calibri" pitchFamily="34" charset="-122"/>
+                <a:cs typeface="Calibri" pitchFamily="34" charset="-120"/>
+              </a:rPr>
+              <a:t>It did not satisfy us to be told…</a:t>
+            </a:r>
+            <a:endParaRPr lang="en-US" sz="1700" dirty="0"/>
+          </a:p>
+        </p:txBody>
+      </p:sp>
+      <p:sp>
+        <p:nvSpPr>
+          <p:cNvPr id="4" name="Shape 2"/>
+          <p:cNvSpPr/>
+          <p:nvPr/>
+        </p:nvSpPr>
+        <p:spPr>
+          <a:xfrm>
+            <a:off x="8869680" y="320040"/>
+            <a:ext cx="2770632" cy="960120"/>
+          </a:xfrm>
+          <a:prstGeom prst="roundRect">
+            <a:avLst>
+              <a:gd name="adj" fmla="val 9524"/>
+            </a:avLst>
+          </a:prstGeom>
+          <a:solidFill>
+            <a:srgbClr val="2C5F2D"/>
+          </a:solidFill>
+          <a:ln/>
+        </p:spPr>
+      </p:sp>
+      <p:sp>
+        <p:nvSpPr>
+          <p:cNvPr id="5" name="Text 3"/>
+          <p:cNvSpPr/>
+          <p:nvPr/>
+        </p:nvSpPr>
+        <p:spPr>
+          <a:xfrm>
+            <a:off x="8869680" y="320040"/>
+            <a:ext cx="2770632" cy="960120"/>
+          </a:xfrm>
+          <a:prstGeom prst="rect">
+            <a:avLst/>
+          </a:prstGeom>
+          <a:noFill/>
+          <a:ln/>
+        </p:spPr>
+        <p:txBody>
+          <a:bodyPr wrap="square" lIns="0" tIns="0" rIns="0" bIns="0" rtlCol="0" anchor="ctr"/>
+          <a:lstStyle/>
+          <a:p>
+            <a:pPr algn="ctr" indent="0" marL="0">
+              <a:buNone/>
+            </a:pPr>
+            <a:r>
+              <a:rPr lang="en-US" sz="1700" b="1" spc="100" kern="0" dirty="0">
+                <a:solidFill>
+                  <a:srgbClr val="FFFFFF"/>
+                </a:solidFill>
+                <a:latin typeface="Cambria" pitchFamily="34" charset="0"/>
+                <a:ea typeface="Cambria" pitchFamily="34" charset="-122"/>
+                <a:cs typeface="Cambria" pitchFamily="34" charset="-120"/>
+              </a:rPr>
+              <a:t>THE BIG BOOK</a:t>
+            </a:r>
+            <a:endParaRPr lang="en-US" sz="1700" dirty="0"/>
+          </a:p>
+          <a:p>
+            <a:pPr algn="ctr" indent="0" marL="0">
+              <a:buNone/>
+            </a:pPr>
+            <a:r>
+              <a:rPr lang="en-US" sz="1300" dirty="0">
+                <a:solidFill>
+                  <a:srgbClr val="D5E3CE"/>
+                </a:solidFill>
+                <a:latin typeface="Calibri" pitchFamily="34" charset="0"/>
+                <a:ea typeface="Calibri" pitchFamily="34" charset="-122"/>
+                <a:cs typeface="Calibri" pitchFamily="34" charset="-120"/>
+              </a:rPr>
+              <a:t>p. xxii</a:t>
+            </a:r>
+            <a:endParaRPr lang="en-US" sz="1700" dirty="0"/>
+          </a:p>
+        </p:txBody>
+      </p:sp>
+      <p:sp>
+        <p:nvSpPr>
+          <p:cNvPr id="6" name="Shape 4"/>
+          <p:cNvSpPr/>
+          <p:nvPr/>
+        </p:nvSpPr>
+        <p:spPr>
+          <a:xfrm>
+            <a:off x="548640" y="1691640"/>
+            <a:ext cx="11091672" cy="2788920"/>
+          </a:xfrm>
+          <a:prstGeom prst="roundRect">
+            <a:avLst>
+              <a:gd name="adj" fmla="val 2623"/>
+            </a:avLst>
+          </a:prstGeom>
+          <a:solidFill>
+            <a:srgbClr val="EAF1E6"/>
+          </a:solidFill>
+          <a:ln/>
+        </p:spPr>
+      </p:sp>
+      <p:sp>
+        <p:nvSpPr>
+          <p:cNvPr id="7" name="Text 5"/>
+          <p:cNvSpPr/>
+          <p:nvPr/>
+        </p:nvSpPr>
+        <p:spPr>
+          <a:xfrm>
+            <a:off x="914400" y="1691640"/>
+            <a:ext cx="10360152" cy="2788920"/>
+          </a:xfrm>
+          <a:prstGeom prst="rect">
+            <a:avLst/>
+          </a:prstGeom>
+          <a:noFill/>
+          <a:ln/>
+        </p:spPr>
+        <p:txBody>
+          <a:bodyPr wrap="square" lIns="0" tIns="0" rIns="0" bIns="0" rtlCol="0" anchor="ctr"/>
+          <a:lstStyle/>
+          <a:p>
+            <a:pPr indent="0" marL="0">
+              <a:lnSpc>
+                <a:spcPct val="115000"/>
+              </a:lnSpc>
+              <a:buNone/>
+            </a:pPr>
+            <a:r>
+              <a:rPr lang="en-US" sz="1900" dirty="0">
+                <a:solidFill>
+                  <a:srgbClr val="1B2A41"/>
+                </a:solidFill>
+                <a:latin typeface="Calibri" pitchFamily="34" charset="0"/>
+                <a:ea typeface="Calibri" pitchFamily="34" charset="-122"/>
+                <a:cs typeface="Calibri" pitchFamily="34" charset="-120"/>
+              </a:rPr>
+              <a:t>It did not satisfy us to be told that we could not </a:t>
+            </a:r>
+            <a:pPr indent="0" marL="0">
+              <a:lnSpc>
+                <a:spcPct val="115000"/>
+              </a:lnSpc>
+              <a:buNone/>
+            </a:pPr>
+            <a:r>
+              <a:rPr lang="en-US" sz="1900" b="1" u="dbl" dirty="0">
+                <a:solidFill>
+                  <a:srgbClr val="1B2A41"/>
+                </a:solidFill>
+                <a:latin typeface="Calibri" pitchFamily="34" charset="0"/>
+                <a:ea typeface="Calibri" pitchFamily="34" charset="-122"/>
+                <a:cs typeface="Calibri" pitchFamily="34" charset="-120"/>
+              </a:rPr>
+              <a:t>control</a:t>
+            </a:r>
+            <a:pPr indent="0" marL="0">
+              <a:lnSpc>
+                <a:spcPct val="115000"/>
+              </a:lnSpc>
+              <a:buNone/>
+            </a:pPr>
+            <a:r>
+              <a:rPr lang="en-US" sz="1900" dirty="0">
+                <a:solidFill>
+                  <a:srgbClr val="1B2A41"/>
+                </a:solidFill>
+                <a:latin typeface="Calibri" pitchFamily="34" charset="0"/>
+                <a:ea typeface="Calibri" pitchFamily="34" charset="-122"/>
+                <a:cs typeface="Calibri" pitchFamily="34" charset="-120"/>
+              </a:rPr>
+              <a:t> our drinking just because we were maladjusted to life, that we were in full flight from reality, or were outright mental defectives. These things were true to some extent, in fact, to a considerable extent with some of us. But we are sure that our bodies were sickened as well. </a:t>
+            </a:r>
+            <a:pPr indent="0" marL="0">
+              <a:lnSpc>
+                <a:spcPct val="115000"/>
+              </a:lnSpc>
+              <a:buNone/>
+            </a:pPr>
+            <a:r>
+              <a:rPr lang="en-US" sz="1900" b="1" u="sng" dirty="0">
+                <a:solidFill>
+                  <a:srgbClr val="2C5F2D"/>
+                </a:solidFill>
+                <a:latin typeface="Calibri" pitchFamily="34" charset="0"/>
+                <a:ea typeface="Calibri" pitchFamily="34" charset="-122"/>
+                <a:cs typeface="Calibri" pitchFamily="34" charset="-120"/>
+              </a:rPr>
+              <a:t>In our belief, any picture of the alcoholic which leaves out this physical factor is incomplete.</a:t>
+            </a:r>
+            <a:endParaRPr lang="en-US" sz="1900" dirty="0"/>
+          </a:p>
+        </p:txBody>
+      </p:sp>
+      <p:sp>
+        <p:nvSpPr>
+          <p:cNvPr id="8" name="Text 6"/>
+          <p:cNvSpPr/>
+          <p:nvPr/>
+        </p:nvSpPr>
+        <p:spPr>
+          <a:xfrm>
+            <a:off x="548640" y="4754880"/>
+            <a:ext cx="11091672" cy="292608"/>
+          </a:xfrm>
+          <a:prstGeom prst="rect">
+            <a:avLst/>
+          </a:prstGeom>
+          <a:noFill/>
+          <a:ln/>
+        </p:spPr>
+        <p:txBody>
+          <a:bodyPr wrap="square" lIns="0" tIns="0" rIns="0" bIns="0" rtlCol="0" anchor="ctr"/>
+          <a:lstStyle/>
+          <a:p>
+            <a:pPr indent="0" marL="0">
+              <a:buNone/>
+            </a:pPr>
+            <a:r>
+              <a:rPr lang="en-US" sz="1200" i="1" dirty="0">
+                <a:solidFill>
+                  <a:srgbClr val="6B7A8C"/>
+                </a:solidFill>
+                <a:latin typeface="Calibri" pitchFamily="34" charset="0"/>
+                <a:ea typeface="Calibri" pitchFamily="34" charset="-122"/>
+                <a:cs typeface="Calibri" pitchFamily="34" charset="-120"/>
+              </a:rPr>
+              <a:t>Alcoholics Anonymous</a:t>
+            </a:r>
+            <a:pPr indent="0" marL="0">
+              <a:buNone/>
+            </a:pPr>
+            <a:r>
+              <a:rPr lang="en-US" sz="1200" dirty="0">
+                <a:solidFill>
+                  <a:srgbClr val="6B7A8C"/>
+                </a:solidFill>
+                <a:latin typeface="Calibri" pitchFamily="34" charset="0"/>
+                <a:ea typeface="Calibri" pitchFamily="34" charset="-122"/>
+                <a:cs typeface="Calibri" pitchFamily="34" charset="-120"/>
+              </a:rPr>
+              <a:t>, 4th ed., “The Doctor’s Opinion,” p. xxii.</a:t>
+            </a:r>
+            <a:endParaRPr lang="en-US" sz="1200" dirty="0"/>
+          </a:p>
+        </p:txBody>
+      </p:sp>
+      <p:sp>
+        <p:nvSpPr>
+          <p:cNvPr id="9" name="Text 7"/>
+          <p:cNvSpPr/>
+          <p:nvPr/>
+        </p:nvSpPr>
+        <p:spPr>
+          <a:xfrm>
+            <a:off x="548640" y="6355080"/>
+            <a:ext cx="11091672" cy="292608"/>
+          </a:xfrm>
+          <a:prstGeom prst="rect">
+            <a:avLst/>
+          </a:prstGeom>
+          <a:noFill/>
+          <a:ln/>
+        </p:spPr>
+        <p:txBody>
+          <a:bodyPr wrap="square" lIns="0" tIns="0" rIns="0" bIns="0" rtlCol="0" anchor="ctr"/>
+          <a:lstStyle/>
+          <a:p>
+            <a:pPr indent="0" marL="0">
+              <a:buNone/>
+            </a:pPr>
+            <a:r>
+              <a:rPr lang="en-US" sz="950" dirty="0">
+                <a:solidFill>
+                  <a:srgbClr val="6B7A8C"/>
+                </a:solidFill>
+                <a:latin typeface="Calibri" pitchFamily="34" charset="0"/>
+                <a:ea typeface="Calibri" pitchFamily="34" charset="-122"/>
+                <a:cs typeface="Calibri" pitchFamily="34" charset="-120"/>
+              </a:rPr>
+              <a:t>Copyright © Alcoholics Anonymous World Services, Inc. All rights reserved. Intended for personal use only, and not to be reproduced further or distributed for resale.</a:t>
+            </a:r>
+            <a:endParaRPr lang="en-US" sz="950" dirty="0"/>
+          </a:p>
+        </p:txBody>
+      </p:sp>
+    </p:spTree>
+  </p:cSld>
+  <p:clrMapOvr>
+    <a:masterClrMapping/>
+  </p:clrMapOvr>
+</p:sld>
+</file>
+
 <file path=ppt/slides/slide2.xml><?xml version="1.0" encoding="utf-8"?>
 <p:sld xmlns:a="http://schemas.openxmlformats.org/drawingml/2006/main" xmlns:r="http://schemas.openxmlformats.org/officeDocument/2006/relationships" xmlns:p="http://schemas.openxmlformats.org/presentationml/2006/main">
   <p:cSld name="Slide 2">
@@ -8344,6 +10073,367 @@
       <p:sp>
         <p:nvSpPr>
           <p:cNvPr id="42" name="Text 40"/>
+          <p:cNvSpPr/>
+          <p:nvPr/>
+        </p:nvSpPr>
+        <p:spPr>
+          <a:xfrm>
+            <a:off x="548640" y="6355080"/>
+            <a:ext cx="11091672" cy="292608"/>
+          </a:xfrm>
+          <a:prstGeom prst="rect">
+            <a:avLst/>
+          </a:prstGeom>
+          <a:noFill/>
+          <a:ln/>
+        </p:spPr>
+        <p:txBody>
+          <a:bodyPr wrap="square" lIns="0" tIns="0" rIns="0" bIns="0" rtlCol="0" anchor="ctr"/>
+          <a:lstStyle/>
+          <a:p>
+            <a:pPr indent="0" marL="0">
+              <a:buNone/>
+            </a:pPr>
+            <a:r>
+              <a:rPr lang="en-US" sz="950" dirty="0">
+                <a:solidFill>
+                  <a:srgbClr val="6B7A8C"/>
+                </a:solidFill>
+                <a:latin typeface="Calibri" pitchFamily="34" charset="0"/>
+                <a:ea typeface="Calibri" pitchFamily="34" charset="-122"/>
+                <a:cs typeface="Calibri" pitchFamily="34" charset="-120"/>
+              </a:rPr>
+              <a:t>Copyright © Alcoholics Anonymous World Services, Inc. All rights reserved. Intended for personal use only, and not to be reproduced further or distributed for resale.</a:t>
+            </a:r>
+            <a:endParaRPr lang="en-US" sz="950" dirty="0"/>
+          </a:p>
+        </p:txBody>
+      </p:sp>
+    </p:spTree>
+  </p:cSld>
+  <p:clrMapOvr>
+    <a:masterClrMapping/>
+  </p:clrMapOvr>
+</p:sld>
+</file>
+
+<file path=ppt/slides/slide20.xml><?xml version="1.0" encoding="utf-8"?>
+<p:sld xmlns:a="http://schemas.openxmlformats.org/drawingml/2006/main" xmlns:r="http://schemas.openxmlformats.org/officeDocument/2006/relationships" xmlns:p="http://schemas.openxmlformats.org/presentationml/2006/main">
+  <p:cSld name="Slide 20">
+    <p:bg>
+      <p:bgPr>
+        <a:solidFill>
+          <a:srgbClr val="FFFFFF"/>
+        </a:solidFill>
+      </p:bgPr>
+    </p:bg>
+    <p:spTree>
+      <p:nvGrpSpPr>
+        <p:cNvPr id="1" name=""/>
+        <p:cNvGrpSpPr/>
+        <p:nvPr/>
+      </p:nvGrpSpPr>
+      <p:grpSpPr>
+        <a:xfrm>
+          <a:off x="0" y="0"/>
+          <a:ext cx="0" cy="0"/>
+          <a:chOff x="0" y="0"/>
+          <a:chExt cx="0" cy="0"/>
+        </a:xfrm>
+      </p:grpSpPr>
+      <p:sp>
+        <p:nvSpPr>
+          <p:cNvPr id="2" name="Text 0"/>
+          <p:cNvSpPr/>
+          <p:nvPr/>
+        </p:nvSpPr>
+        <p:spPr>
+          <a:xfrm>
+            <a:off x="548640" y="320040"/>
+            <a:ext cx="8138160" cy="566928"/>
+          </a:xfrm>
+          <a:prstGeom prst="rect">
+            <a:avLst/>
+          </a:prstGeom>
+          <a:noFill/>
+          <a:ln/>
+        </p:spPr>
+        <p:txBody>
+          <a:bodyPr wrap="square" lIns="0" tIns="0" rIns="0" bIns="0" rtlCol="0" anchor="ctr"/>
+          <a:lstStyle/>
+          <a:p>
+            <a:pPr indent="0" marL="0">
+              <a:buNone/>
+            </a:pPr>
+            <a:r>
+              <a:rPr lang="en-US" sz="3800" b="1" dirty="0">
+                <a:solidFill>
+                  <a:srgbClr val="1B2A41"/>
+                </a:solidFill>
+                <a:latin typeface="Cambria" pitchFamily="34" charset="0"/>
+                <a:ea typeface="Cambria" pitchFamily="34" charset="-122"/>
+                <a:cs typeface="Cambria" pitchFamily="34" charset="-120"/>
+              </a:rPr>
+              <a:t>An Allergy to Alcohol</a:t>
+            </a:r>
+            <a:endParaRPr lang="en-US" sz="3800" dirty="0"/>
+          </a:p>
+        </p:txBody>
+      </p:sp>
+      <p:sp>
+        <p:nvSpPr>
+          <p:cNvPr id="3" name="Text 1"/>
+          <p:cNvSpPr/>
+          <p:nvPr/>
+        </p:nvSpPr>
+        <p:spPr>
+          <a:xfrm>
+            <a:off x="548640" y="914400"/>
+            <a:ext cx="8138160" cy="347472"/>
+          </a:xfrm>
+          <a:prstGeom prst="rect">
+            <a:avLst/>
+          </a:prstGeom>
+          <a:noFill/>
+          <a:ln/>
+        </p:spPr>
+        <p:txBody>
+          <a:bodyPr wrap="square" lIns="0" tIns="0" rIns="0" bIns="0" rtlCol="0" anchor="ctr"/>
+          <a:lstStyle/>
+          <a:p>
+            <a:pPr indent="0" marL="0">
+              <a:buNone/>
+            </a:pPr>
+            <a:r>
+              <a:rPr lang="en-US" sz="1700" i="1" dirty="0">
+                <a:solidFill>
+                  <a:srgbClr val="6B7A8C"/>
+                </a:solidFill>
+                <a:latin typeface="Calibri" pitchFamily="34" charset="0"/>
+                <a:ea typeface="Calibri" pitchFamily="34" charset="-122"/>
+                <a:cs typeface="Calibri" pitchFamily="34" charset="-120"/>
+              </a:rPr>
+              <a:t>The doctor’s theory.</a:t>
+            </a:r>
+            <a:endParaRPr lang="en-US" sz="1700" dirty="0"/>
+          </a:p>
+        </p:txBody>
+      </p:sp>
+      <p:sp>
+        <p:nvSpPr>
+          <p:cNvPr id="4" name="Shape 2"/>
+          <p:cNvSpPr/>
+          <p:nvPr/>
+        </p:nvSpPr>
+        <p:spPr>
+          <a:xfrm>
+            <a:off x="8869680" y="320040"/>
+            <a:ext cx="2770632" cy="960120"/>
+          </a:xfrm>
+          <a:prstGeom prst="roundRect">
+            <a:avLst>
+              <a:gd name="adj" fmla="val 9524"/>
+            </a:avLst>
+          </a:prstGeom>
+          <a:solidFill>
+            <a:srgbClr val="065A82"/>
+          </a:solidFill>
+          <a:ln/>
+        </p:spPr>
+      </p:sp>
+      <p:sp>
+        <p:nvSpPr>
+          <p:cNvPr id="5" name="Text 3"/>
+          <p:cNvSpPr/>
+          <p:nvPr/>
+        </p:nvSpPr>
+        <p:spPr>
+          <a:xfrm>
+            <a:off x="8869680" y="320040"/>
+            <a:ext cx="2770632" cy="960120"/>
+          </a:xfrm>
+          <a:prstGeom prst="rect">
+            <a:avLst/>
+          </a:prstGeom>
+          <a:noFill/>
+          <a:ln/>
+        </p:spPr>
+        <p:txBody>
+          <a:bodyPr wrap="square" lIns="0" tIns="0" rIns="0" bIns="0" rtlCol="0" anchor="ctr"/>
+          <a:lstStyle/>
+          <a:p>
+            <a:pPr algn="ctr" indent="0" marL="0">
+              <a:buNone/>
+            </a:pPr>
+            <a:r>
+              <a:rPr lang="en-US" sz="1700" b="1" spc="100" kern="0" dirty="0">
+                <a:solidFill>
+                  <a:srgbClr val="FFFFFF"/>
+                </a:solidFill>
+                <a:latin typeface="Cambria" pitchFamily="34" charset="0"/>
+                <a:ea typeface="Cambria" pitchFamily="34" charset="-122"/>
+                <a:cs typeface="Cambria" pitchFamily="34" charset="-120"/>
+              </a:rPr>
+              <a:t>THE BIG BOOK</a:t>
+            </a:r>
+            <a:endParaRPr lang="en-US" sz="1700" dirty="0"/>
+          </a:p>
+          <a:p>
+            <a:pPr algn="ctr" indent="0" marL="0">
+              <a:buNone/>
+            </a:pPr>
+            <a:r>
+              <a:rPr lang="en-US" sz="1300" dirty="0">
+                <a:solidFill>
+                  <a:srgbClr val="C7DEEC"/>
+                </a:solidFill>
+                <a:latin typeface="Calibri" pitchFamily="34" charset="0"/>
+                <a:ea typeface="Calibri" pitchFamily="34" charset="-122"/>
+                <a:cs typeface="Calibri" pitchFamily="34" charset="-120"/>
+              </a:rPr>
+              <a:t>p. xxii</a:t>
+            </a:r>
+            <a:endParaRPr lang="en-US" sz="1700" dirty="0"/>
+          </a:p>
+        </p:txBody>
+      </p:sp>
+      <p:sp>
+        <p:nvSpPr>
+          <p:cNvPr id="6" name="Shape 4"/>
+          <p:cNvSpPr/>
+          <p:nvPr/>
+        </p:nvSpPr>
+        <p:spPr>
+          <a:xfrm>
+            <a:off x="548640" y="1828800"/>
+            <a:ext cx="11091672" cy="2514600"/>
+          </a:xfrm>
+          <a:prstGeom prst="roundRect">
+            <a:avLst>
+              <a:gd name="adj" fmla="val 2909"/>
+            </a:avLst>
+          </a:prstGeom>
+          <a:solidFill>
+            <a:srgbClr val="E2EDF4"/>
+          </a:solidFill>
+          <a:ln/>
+        </p:spPr>
+      </p:sp>
+      <p:sp>
+        <p:nvSpPr>
+          <p:cNvPr id="7" name="Text 5"/>
+          <p:cNvSpPr/>
+          <p:nvPr/>
+        </p:nvSpPr>
+        <p:spPr>
+          <a:xfrm>
+            <a:off x="914400" y="1828800"/>
+            <a:ext cx="10360152" cy="2514600"/>
+          </a:xfrm>
+          <a:prstGeom prst="rect">
+            <a:avLst/>
+          </a:prstGeom>
+          <a:noFill/>
+          <a:ln/>
+        </p:spPr>
+        <p:txBody>
+          <a:bodyPr wrap="square" lIns="0" tIns="0" rIns="0" bIns="0" rtlCol="0" anchor="ctr"/>
+          <a:lstStyle/>
+          <a:p>
+            <a:pPr indent="0" marL="0">
+              <a:lnSpc>
+                <a:spcPct val="115000"/>
+              </a:lnSpc>
+              <a:buNone/>
+            </a:pPr>
+            <a:r>
+              <a:rPr lang="en-US" sz="2100" b="1" u="sng" dirty="0">
+                <a:solidFill>
+                  <a:srgbClr val="065A82"/>
+                </a:solidFill>
+                <a:latin typeface="Calibri" pitchFamily="34" charset="0"/>
+                <a:ea typeface="Calibri" pitchFamily="34" charset="-122"/>
+                <a:cs typeface="Calibri" pitchFamily="34" charset="-120"/>
+              </a:rPr>
+              <a:t>The doctor’s theory that we have an allergy to alcohol interests us.</a:t>
+            </a:r>
+            <a:pPr indent="0" marL="0">
+              <a:lnSpc>
+                <a:spcPct val="115000"/>
+              </a:lnSpc>
+              <a:buNone/>
+            </a:pPr>
+            <a:r>
+              <a:rPr lang="en-US" sz="2100" dirty="0">
+                <a:solidFill>
+                  <a:srgbClr val="1B2A41"/>
+                </a:solidFill>
+                <a:latin typeface="Calibri" pitchFamily="34" charset="0"/>
+                <a:ea typeface="Calibri" pitchFamily="34" charset="-122"/>
+                <a:cs typeface="Calibri" pitchFamily="34" charset="-120"/>
+              </a:rPr>
+              <a:t> As laymen, our opinion as to its soundness may, of course, mean little. But as ex-problem drinkers, we can say that his explanation makes good sense. It explains many things for which we cannot otherwise account.</a:t>
+            </a:r>
+            <a:endParaRPr lang="en-US" sz="2100" dirty="0"/>
+          </a:p>
+        </p:txBody>
+      </p:sp>
+      <p:sp>
+        <p:nvSpPr>
+          <p:cNvPr id="8" name="Text 6"/>
+          <p:cNvSpPr/>
+          <p:nvPr/>
+        </p:nvSpPr>
+        <p:spPr>
+          <a:xfrm>
+            <a:off x="548640" y="4617720"/>
+            <a:ext cx="11091672" cy="292608"/>
+          </a:xfrm>
+          <a:prstGeom prst="rect">
+            <a:avLst/>
+          </a:prstGeom>
+          <a:noFill/>
+          <a:ln/>
+        </p:spPr>
+        <p:txBody>
+          <a:bodyPr wrap="square" lIns="0" tIns="0" rIns="0" bIns="0" rtlCol="0" anchor="ctr"/>
+          <a:lstStyle/>
+          <a:p>
+            <a:pPr indent="0" marL="0">
+              <a:buNone/>
+            </a:pPr>
+            <a:r>
+              <a:rPr lang="en-US" sz="1200" i="1" dirty="0">
+                <a:solidFill>
+                  <a:srgbClr val="6B7A8C"/>
+                </a:solidFill>
+                <a:latin typeface="Calibri" pitchFamily="34" charset="0"/>
+                <a:ea typeface="Calibri" pitchFamily="34" charset="-122"/>
+                <a:cs typeface="Calibri" pitchFamily="34" charset="-120"/>
+              </a:rPr>
+              <a:t>Alcoholics Anonymous</a:t>
+            </a:r>
+            <a:pPr indent="0" marL="0">
+              <a:buNone/>
+            </a:pPr>
+            <a:r>
+              <a:rPr lang="en-US" sz="1200" dirty="0">
+                <a:solidFill>
+                  <a:srgbClr val="6B7A8C"/>
+                </a:solidFill>
+                <a:latin typeface="Calibri" pitchFamily="34" charset="0"/>
+                <a:ea typeface="Calibri" pitchFamily="34" charset="-122"/>
+                <a:cs typeface="Calibri" pitchFamily="34" charset="-120"/>
+              </a:rPr>
+              <a:t>, 4th ed., “The Doctor’s Opinion,” p. xxii.</a:t>
+            </a:r>
+            <a:endParaRPr lang="en-US" sz="1200" dirty="0"/>
+          </a:p>
+        </p:txBody>
+      </p:sp>
+      <p:sp>
+        <p:nvSpPr>
+          <p:cNvPr id="9" name="Text 7"/>
           <p:cNvSpPr/>
           <p:nvPr/>
         </p:nvSpPr>

</xml_diff>

<commit_message>
Add slides 21-23: The Doctor's Opinion, p. xxiii
The full green-arrow run, from 'the subject presented in this book' through
'practical application at once.'

Both circled words are resolved on slide 23 in side-by-side cards: this hospital
is the Charles B. Towns Hospital at 293 Central Park West, where Silkworth was
medical director, and 'he' is Bill W., admitted four times in 1933-34 with his
last drink on 11 December 1934. Verified against published sources; the study
copy spells it Townes, the hospital is Towns.

Slide 20 picks up the 'allergy = abnormal reaction' note, which is written atop
p. xxiii but belongs with the allergy paragraph it defines.

Co-Authored-By: Claude Opus 5 <noreply@anthropic.com>
Claude-Session: https://claude.ai/code/session_01NuCgD3Z7aWvkQrsSvAUX4h
</commit_message>
<xml_diff>
--- a/aa-slideshow/aa-big-book-study.pptx
+++ b/aa-slideshow/aa-big-book-study.pptx
@@ -25,9 +25,12 @@
     <p:sldId id="273" r:id="rId19"/>
     <p:sldId id="274" r:id="rId20"/>
     <p:sldId id="275" r:id="rId21"/>
+    <p:sldId id="276" r:id="rId22"/>
+    <p:sldId id="277" r:id="rId23"/>
+    <p:sldId id="278" r:id="rId24"/>
   </p:sldIdLst>
   <p:notesMasterIdLst>
-    <p:notesMasterId r:id="rId22"/>
+    <p:notesMasterId r:id="rId25"/>
   </p:notesMasterIdLst>
   <p:sldSz cx="12192000" cy="6858000"/>
   <p:notesSz cx="6858000" cy="12192000"/>
@@ -1667,6 +1670,290 @@
             <a:fld id="{F7021451-1387-4CA6-816F-3879F97B5CBC}" type="slidenum">
               <a:rPr lang="en-US"/>
               <a:t>20</a:t>
+            </a:fld>
+            <a:endParaRPr lang="en-US"/>
+          </a:p>
+        </p:txBody>
+      </p:sp>
+    </p:spTree>
+    <p:extLst>
+      <p:ext uri="{BB962C8B-B14F-4D97-AF65-F5344CB8AC3E}">
+        <p14:creationId xmlns:p14="http://schemas.microsoft.com/office/powerpoint/2010/main" val="1024086991"/>
+      </p:ext>
+    </p:extLst>
+  </p:cSld>
+  <p:clrMapOvr>
+    <a:masterClrMapping/>
+  </p:clrMapOvr>
+</p:notes>
+</file>
+
+<file path=ppt/notesSlides/notesSlide21.xml><?xml version="1.0" encoding="utf-8"?>
+<p:notes xmlns:a="http://schemas.openxmlformats.org/drawingml/2006/main" xmlns:r="http://schemas.openxmlformats.org/officeDocument/2006/relationships" xmlns:p="http://schemas.openxmlformats.org/presentationml/2006/main">
+  <p:cSld>
+    <p:spTree>
+      <p:nvGrpSpPr>
+        <p:cNvPr id="1" name=""/>
+        <p:cNvGrpSpPr/>
+        <p:nvPr/>
+      </p:nvGrpSpPr>
+      <p:grpSpPr>
+        <a:xfrm>
+          <a:off x="0" y="0"/>
+          <a:ext cx="0" cy="0"/>
+          <a:chOff x="0" y="0"/>
+          <a:chExt cx="0" cy="0"/>
+        </a:xfrm>
+      </p:grpSpPr>
+      <p:sp>
+        <p:nvSpPr>
+          <p:cNvPr id="2" name="Slide Image Placeholder 1"/>
+          <p:cNvSpPr>
+            <a:spLocks noGrp="1" noRot="1" noChangeAspect="1"/>
+          </p:cNvSpPr>
+          <p:nvPr>
+            <p:ph type="sldImg"/>
+          </p:nvPr>
+        </p:nvSpPr>
+        <p:spPr/>
+      </p:sp>
+      <p:sp>
+        <p:nvSpPr>
+          <p:cNvPr id="3" name="Notes Placeholder 2"/>
+          <p:cNvSpPr>
+            <a:spLocks noGrp="1"/>
+          </p:cNvSpPr>
+          <p:nvPr>
+            <p:ph type="body" idx="1"/>
+          </p:nvPr>
+        </p:nvSpPr>
+        <p:spPr/>
+        <p:txBody>
+          <a:bodyPr/>
+          <a:lstStyle/>
+          <a:p>
+            <a:r>
+              <a:rPr lang="en-US" dirty="0"/>
+              <a:t>The green arrow in the study copy starts here. This is the doctor speaking in his own
+voice, and the first thing he does is establish standing.
+The hospital is the Charles B. Towns Hospital, 293 Central Park West in Manhattan.
+Silkworth was its medical director. That is where he saw thousands of alcoholics come
+through, and it is where he met Bill.
+Note his word for the book - masterly. A physician calling a book written by drunks
+masterly, in 1939.</a:t>
+            </a:r>
+            <a:endParaRPr lang="en-US" dirty="0"/>
+          </a:p>
+        </p:txBody>
+      </p:sp>
+      <p:sp>
+        <p:nvSpPr>
+          <p:cNvPr id="4" name="Slide Number Placeholder 3"/>
+          <p:cNvSpPr>
+            <a:spLocks noGrp="1"/>
+          </p:cNvSpPr>
+          <p:nvPr>
+            <p:ph type="sldNum" sz="quarter" idx="10"/>
+          </p:nvPr>
+        </p:nvSpPr>
+        <p:spPr/>
+        <p:txBody>
+          <a:bodyPr/>
+          <a:lstStyle/>
+          <a:p>
+            <a:fld id="{F7021451-1387-4CA6-816F-3879F97B5CBC}" type="slidenum">
+              <a:rPr lang="en-US"/>
+              <a:t>21</a:t>
+            </a:fld>
+            <a:endParaRPr lang="en-US"/>
+          </a:p>
+        </p:txBody>
+      </p:sp>
+    </p:spTree>
+    <p:extLst>
+      <p:ext uri="{BB962C8B-B14F-4D97-AF65-F5344CB8AC3E}">
+        <p14:creationId xmlns:p14="http://schemas.microsoft.com/office/powerpoint/2010/main" val="1024086991"/>
+      </p:ext>
+    </p:extLst>
+  </p:cSld>
+  <p:clrMapOvr>
+    <a:masterClrMapping/>
+  </p:clrMapOvr>
+</p:notes>
+</file>
+
+<file path=ppt/notesSlides/notesSlide22.xml><?xml version="1.0" encoding="utf-8"?>
+<p:notes xmlns:a="http://schemas.openxmlformats.org/drawingml/2006/main" xmlns:r="http://schemas.openxmlformats.org/officeDocument/2006/relationships" xmlns:p="http://schemas.openxmlformats.org/presentationml/2006/main">
+  <p:cSld>
+    <p:spTree>
+      <p:nvGrpSpPr>
+        <p:cNvPr id="1" name=""/>
+        <p:cNvGrpSpPr/>
+        <p:nvPr/>
+      </p:nvGrpSpPr>
+      <p:grpSpPr>
+        <a:xfrm>
+          <a:off x="0" y="0"/>
+          <a:ext cx="0" cy="0"/>
+          <a:chOff x="0" y="0"/>
+          <a:chExt cx="0" cy="0"/>
+        </a:xfrm>
+      </p:grpSpPr>
+      <p:sp>
+        <p:nvSpPr>
+          <p:cNvPr id="2" name="Slide Image Placeholder 1"/>
+          <p:cNvSpPr>
+            <a:spLocks noGrp="1" noRot="1" noChangeAspect="1"/>
+          </p:cNvSpPr>
+          <p:nvPr>
+            <p:ph type="sldImg"/>
+          </p:nvPr>
+        </p:nvSpPr>
+        <p:spPr/>
+      </p:sp>
+      <p:sp>
+        <p:nvSpPr>
+          <p:cNvPr id="3" name="Notes Placeholder 2"/>
+          <p:cNvSpPr>
+            <a:spLocks noGrp="1"/>
+          </p:cNvSpPr>
+          <p:nvPr>
+            <p:ph type="body" idx="1"/>
+          </p:nvPr>
+        </p:nvSpPr>
+        <p:spPr/>
+        <p:txBody>
+          <a:bodyPr/>
+          <a:lstStyle/>
+          <a:p>
+            <a:r>
+              <a:rPr lang="en-US" dirty="0"/>
+              <a:t>A doctor admitting the limits of medicine. Read that second paragraph slowly.
+They knew some form of moral psychology was urgently needed. They could not deliver it.
+Its application presented difficulties beyond our conception.
+And then he says why - our ultra-modern standards, our scientific approach to everything.
+The training that makes a good physician is the same training that leaves him not well
+equipped to apply powers of good outside his synthetic knowledge.
+He is describing the gap that the Twelve Steps walked into.</a:t>
+            </a:r>
+            <a:endParaRPr lang="en-US" dirty="0"/>
+          </a:p>
+        </p:txBody>
+      </p:sp>
+      <p:sp>
+        <p:nvSpPr>
+          <p:cNvPr id="4" name="Slide Number Placeholder 3"/>
+          <p:cNvSpPr>
+            <a:spLocks noGrp="1"/>
+          </p:cNvSpPr>
+          <p:nvPr>
+            <p:ph type="sldNum" sz="quarter" idx="10"/>
+          </p:nvPr>
+        </p:nvSpPr>
+        <p:spPr/>
+        <p:txBody>
+          <a:bodyPr/>
+          <a:lstStyle/>
+          <a:p>
+            <a:fld id="{F7021451-1387-4CA6-816F-3879F97B5CBC}" type="slidenum">
+              <a:rPr lang="en-US"/>
+              <a:t>22</a:t>
+            </a:fld>
+            <a:endParaRPr lang="en-US"/>
+          </a:p>
+        </p:txBody>
+      </p:sp>
+    </p:spTree>
+    <p:extLst>
+      <p:ext uri="{BB962C8B-B14F-4D97-AF65-F5344CB8AC3E}">
+        <p14:creationId xmlns:p14="http://schemas.microsoft.com/office/powerpoint/2010/main" val="1024086991"/>
+      </p:ext>
+    </p:extLst>
+  </p:cSld>
+  <p:clrMapOvr>
+    <a:masterClrMapping/>
+  </p:clrMapOvr>
+</p:notes>
+</file>
+
+<file path=ppt/notesSlides/notesSlide23.xml><?xml version="1.0" encoding="utf-8"?>
+<p:notes xmlns:a="http://schemas.openxmlformats.org/drawingml/2006/main" xmlns:r="http://schemas.openxmlformats.org/officeDocument/2006/relationships" xmlns:p="http://schemas.openxmlformats.org/presentationml/2006/main">
+  <p:cSld>
+    <p:spTree>
+      <p:nvGrpSpPr>
+        <p:cNvPr id="1" name=""/>
+        <p:cNvGrpSpPr/>
+        <p:nvPr/>
+      </p:nvGrpSpPr>
+      <p:grpSpPr>
+        <a:xfrm>
+          <a:off x="0" y="0"/>
+          <a:ext cx="0" cy="0"/>
+          <a:chOff x="0" y="0"/>
+          <a:chExt cx="0" cy="0"/>
+        </a:xfrm>
+      </p:grpSpPr>
+      <p:sp>
+        <p:nvSpPr>
+          <p:cNvPr id="2" name="Slide Image Placeholder 1"/>
+          <p:cNvSpPr>
+            <a:spLocks noGrp="1" noRot="1" noChangeAspect="1"/>
+          </p:cNvSpPr>
+          <p:nvPr>
+            <p:ph type="sldImg"/>
+          </p:nvPr>
+        </p:nvSpPr>
+        <p:spPr/>
+      </p:sp>
+      <p:sp>
+        <p:nvSpPr>
+          <p:cNvPr id="3" name="Notes Placeholder 2"/>
+          <p:cNvSpPr>
+            <a:spLocks noGrp="1"/>
+          </p:cNvSpPr>
+          <p:nvPr>
+            <p:ph type="body" idx="1"/>
+          </p:nvPr>
+        </p:nvSpPr>
+        <p:spPr/>
+        <p:txBody>
+          <a:bodyPr/>
+          <a:lstStyle/>
+          <a:p>
+            <a:r>
+              <a:rPr lang="en-US" dirty="0"/>
+              <a:t>Silkworth is being discreet. He does not name him. But everyone reading this in 1939 who
+knew anything knew who it was.
+One of the leading contributors to this book is Bill W. This hospital is Towns. Bill was
+admitted four times between 1933 and 1934 - his last drink was 11 December 1934, and
+three days later, still in that hospital, he had the experience he describes in his story.
+The ideas he acquired came from Silkworth: the allergy, and the obsession. And he put them
+into practical application at once - meaning he went out and started talking to other
+alcoholics.
+The doctor who explained the illness to him is the same doctor writing this letter.</a:t>
+            </a:r>
+            <a:endParaRPr lang="en-US" dirty="0"/>
+          </a:p>
+        </p:txBody>
+      </p:sp>
+      <p:sp>
+        <p:nvSpPr>
+          <p:cNvPr id="4" name="Slide Number Placeholder 3"/>
+          <p:cNvSpPr>
+            <a:spLocks noGrp="1"/>
+          </p:cNvSpPr>
+          <p:nvPr>
+            <p:ph type="sldNum" sz="quarter" idx="10"/>
+          </p:nvPr>
+        </p:nvSpPr>
+        <p:spPr/>
+        <p:txBody>
+          <a:bodyPr/>
+          <a:lstStyle/>
+          <a:p>
+            <a:fld id="{F7021451-1387-4CA6-816F-3879F97B5CBC}" type="slidenum">
+              <a:rPr lang="en-US"/>
+              <a:t>23</a:t>
             </a:fld>
             <a:endParaRPr lang="en-US"/>
           </a:p>
@@ -10305,12 +10592,12 @@
         </p:nvSpPr>
         <p:spPr>
           <a:xfrm>
-            <a:off x="548640" y="1828800"/>
-            <a:ext cx="11091672" cy="2514600"/>
+            <a:off x="548640" y="1600200"/>
+            <a:ext cx="11091672" cy="2377440"/>
           </a:xfrm>
           <a:prstGeom prst="roundRect">
             <a:avLst>
-              <a:gd name="adj" fmla="val 2909"/>
+              <a:gd name="adj" fmla="val 3077"/>
             </a:avLst>
           </a:prstGeom>
           <a:solidFill>
@@ -10327,8 +10614,8 @@
         </p:nvSpPr>
         <p:spPr>
           <a:xfrm>
-            <a:off x="914400" y="1828800"/>
-            <a:ext cx="10360152" cy="2514600"/>
+            <a:off x="914400" y="1600200"/>
+            <a:ext cx="10360152" cy="2377440"/>
           </a:xfrm>
           <a:prstGeom prst="rect">
             <a:avLst/>
@@ -10380,13 +10667,113 @@
       </p:sp>
       <p:sp>
         <p:nvSpPr>
-          <p:cNvPr id="8" name="Text 6"/>
-          <p:cNvSpPr/>
-          <p:nvPr/>
-        </p:nvSpPr>
-        <p:spPr>
-          <a:xfrm>
-            <a:off x="548640" y="4617720"/>
+          <p:cNvPr id="8" name="Shape 6"/>
+          <p:cNvSpPr/>
+          <p:nvPr/>
+        </p:nvSpPr>
+        <p:spPr>
+          <a:xfrm>
+            <a:off x="548640" y="4251960"/>
+            <a:ext cx="11091672" cy="960120"/>
+          </a:xfrm>
+          <a:prstGeom prst="roundRect">
+            <a:avLst>
+              <a:gd name="adj" fmla="val 7619"/>
+            </a:avLst>
+          </a:prstGeom>
+          <a:solidFill>
+            <a:srgbClr val="1B2A41"/>
+          </a:solidFill>
+          <a:ln/>
+        </p:spPr>
+      </p:sp>
+      <p:sp>
+        <p:nvSpPr>
+          <p:cNvPr id="9" name="Text 7"/>
+          <p:cNvSpPr/>
+          <p:nvPr/>
+        </p:nvSpPr>
+        <p:spPr>
+          <a:xfrm>
+            <a:off x="914400" y="4370832"/>
+            <a:ext cx="10360152" cy="256032"/>
+          </a:xfrm>
+          <a:prstGeom prst="rect">
+            <a:avLst/>
+          </a:prstGeom>
+          <a:noFill/>
+          <a:ln/>
+        </p:spPr>
+        <p:txBody>
+          <a:bodyPr wrap="square" lIns="0" tIns="0" rIns="0" bIns="0" rtlCol="0" anchor="ctr"/>
+          <a:lstStyle/>
+          <a:p>
+            <a:pPr indent="0" marL="0">
+              <a:buNone/>
+            </a:pPr>
+            <a:r>
+              <a:rPr lang="en-US" sz="1100" b="1" spc="200" kern="0" dirty="0">
+                <a:solidFill>
+                  <a:srgbClr val="A9B8CC"/>
+                </a:solidFill>
+                <a:latin typeface="Calibri" pitchFamily="34" charset="0"/>
+                <a:ea typeface="Calibri" pitchFamily="34" charset="-122"/>
+                <a:cs typeface="Calibri" pitchFamily="34" charset="-120"/>
+              </a:rPr>
+              <a:t>MARGIN NOTE</a:t>
+            </a:r>
+            <a:endParaRPr lang="en-US" sz="1100" dirty="0"/>
+          </a:p>
+        </p:txBody>
+      </p:sp>
+      <p:sp>
+        <p:nvSpPr>
+          <p:cNvPr id="10" name="Text 8"/>
+          <p:cNvSpPr/>
+          <p:nvPr/>
+        </p:nvSpPr>
+        <p:spPr>
+          <a:xfrm>
+            <a:off x="914400" y="4645152"/>
+            <a:ext cx="10360152" cy="448056"/>
+          </a:xfrm>
+          <a:prstGeom prst="rect">
+            <a:avLst/>
+          </a:prstGeom>
+          <a:noFill/>
+          <a:ln/>
+        </p:spPr>
+        <p:txBody>
+          <a:bodyPr wrap="square" lIns="0" tIns="0" rIns="0" bIns="0" rtlCol="0" anchor="ctr"/>
+          <a:lstStyle/>
+          <a:p>
+            <a:pPr indent="0" marL="0">
+              <a:buNone/>
+            </a:pPr>
+            <a:r>
+              <a:rPr lang="en-US" sz="2200" b="1" dirty="0">
+                <a:solidFill>
+                  <a:srgbClr val="FFFFFF"/>
+                </a:solidFill>
+                <a:latin typeface="Cambria" pitchFamily="34" charset="0"/>
+                <a:ea typeface="Cambria" pitchFamily="34" charset="-122"/>
+                <a:cs typeface="Cambria" pitchFamily="34" charset="-120"/>
+              </a:rPr>
+              <a:t>Allergy = abnormal reaction.</a:t>
+            </a:r>
+            <a:endParaRPr lang="en-US" sz="2200" dirty="0"/>
+          </a:p>
+        </p:txBody>
+      </p:sp>
+      <p:sp>
+        <p:nvSpPr>
+          <p:cNvPr id="11" name="Text 9"/>
+          <p:cNvSpPr/>
+          <p:nvPr/>
+        </p:nvSpPr>
+        <p:spPr>
+          <a:xfrm>
+            <a:off x="548640" y="5394960"/>
             <a:ext cx="11091672" cy="292608"/>
           </a:xfrm>
           <a:prstGeom prst="rect">
@@ -10433,7 +10820,1703 @@
       </p:sp>
       <p:sp>
         <p:nvSpPr>
+          <p:cNvPr id="12" name="Text 10"/>
+          <p:cNvSpPr/>
+          <p:nvPr/>
+        </p:nvSpPr>
+        <p:spPr>
+          <a:xfrm>
+            <a:off x="548640" y="6355080"/>
+            <a:ext cx="11091672" cy="292608"/>
+          </a:xfrm>
+          <a:prstGeom prst="rect">
+            <a:avLst/>
+          </a:prstGeom>
+          <a:noFill/>
+          <a:ln/>
+        </p:spPr>
+        <p:txBody>
+          <a:bodyPr wrap="square" lIns="0" tIns="0" rIns="0" bIns="0" rtlCol="0" anchor="ctr"/>
+          <a:lstStyle/>
+          <a:p>
+            <a:pPr indent="0" marL="0">
+              <a:buNone/>
+            </a:pPr>
+            <a:r>
+              <a:rPr lang="en-US" sz="950" dirty="0">
+                <a:solidFill>
+                  <a:srgbClr val="6B7A8C"/>
+                </a:solidFill>
+                <a:latin typeface="Calibri" pitchFamily="34" charset="0"/>
+                <a:ea typeface="Calibri" pitchFamily="34" charset="-122"/>
+                <a:cs typeface="Calibri" pitchFamily="34" charset="-120"/>
+              </a:rPr>
+              <a:t>Copyright © Alcoholics Anonymous World Services, Inc. All rights reserved. Intended for personal use only, and not to be reproduced further or distributed for resale.</a:t>
+            </a:r>
+            <a:endParaRPr lang="en-US" sz="950" dirty="0"/>
+          </a:p>
+        </p:txBody>
+      </p:sp>
+    </p:spTree>
+  </p:cSld>
+  <p:clrMapOvr>
+    <a:masterClrMapping/>
+  </p:clrMapOvr>
+</p:sld>
+</file>
+
+<file path=ppt/slides/slide21.xml><?xml version="1.0" encoding="utf-8"?>
+<p:sld xmlns:a="http://schemas.openxmlformats.org/drawingml/2006/main" xmlns:r="http://schemas.openxmlformats.org/officeDocument/2006/relationships" xmlns:p="http://schemas.openxmlformats.org/presentationml/2006/main">
+  <p:cSld name="Slide 21">
+    <p:bg>
+      <p:bgPr>
+        <a:solidFill>
+          <a:srgbClr val="FFFFFF"/>
+        </a:solidFill>
+      </p:bgPr>
+    </p:bg>
+    <p:spTree>
+      <p:nvGrpSpPr>
+        <p:cNvPr id="1" name=""/>
+        <p:cNvGrpSpPr/>
+        <p:nvPr/>
+      </p:nvGrpSpPr>
+      <p:grpSpPr>
+        <a:xfrm>
+          <a:off x="0" y="0"/>
+          <a:ext cx="0" cy="0"/>
+          <a:chOff x="0" y="0"/>
+          <a:chExt cx="0" cy="0"/>
+        </a:xfrm>
+      </p:grpSpPr>
+      <p:sp>
+        <p:nvSpPr>
+          <p:cNvPr id="2" name="Text 0"/>
+          <p:cNvSpPr/>
+          <p:nvPr/>
+        </p:nvSpPr>
+        <p:spPr>
+          <a:xfrm>
+            <a:off x="548640" y="320040"/>
+            <a:ext cx="8138160" cy="566928"/>
+          </a:xfrm>
+          <a:prstGeom prst="rect">
+            <a:avLst/>
+          </a:prstGeom>
+          <a:noFill/>
+          <a:ln/>
+        </p:spPr>
+        <p:txBody>
+          <a:bodyPr wrap="square" lIns="0" tIns="0" rIns="0" bIns="0" rtlCol="0" anchor="ctr"/>
+          <a:lstStyle/>
+          <a:p>
+            <a:pPr indent="0" marL="0">
+              <a:buNone/>
+            </a:pPr>
+            <a:r>
+              <a:rPr lang="en-US" sz="3800" b="1" dirty="0">
+                <a:solidFill>
+                  <a:srgbClr val="1B2A41"/>
+                </a:solidFill>
+                <a:latin typeface="Cambria" pitchFamily="34" charset="0"/>
+                <a:ea typeface="Cambria" pitchFamily="34" charset="-122"/>
+                <a:cs typeface="Cambria" pitchFamily="34" charset="-120"/>
+              </a:rPr>
+              <a:t>Of Paramount Importance</a:t>
+            </a:r>
+            <a:endParaRPr lang="en-US" sz="3800" dirty="0"/>
+          </a:p>
+        </p:txBody>
+      </p:sp>
+      <p:sp>
+        <p:nvSpPr>
+          <p:cNvPr id="3" name="Text 1"/>
+          <p:cNvSpPr/>
+          <p:nvPr/>
+        </p:nvSpPr>
+        <p:spPr>
+          <a:xfrm>
+            <a:off x="548640" y="914400"/>
+            <a:ext cx="8138160" cy="347472"/>
+          </a:xfrm>
+          <a:prstGeom prst="rect">
+            <a:avLst/>
+          </a:prstGeom>
+          <a:noFill/>
+          <a:ln/>
+        </p:spPr>
+        <p:txBody>
+          <a:bodyPr wrap="square" lIns="0" tIns="0" rIns="0" bIns="0" rtlCol="0" anchor="ctr"/>
+          <a:lstStyle/>
+          <a:p>
+            <a:pPr indent="0" marL="0">
+              <a:buNone/>
+            </a:pPr>
+            <a:r>
+              <a:rPr lang="en-US" sz="1700" i="1" dirty="0">
+                <a:solidFill>
+                  <a:srgbClr val="6B7A8C"/>
+                </a:solidFill>
+                <a:latin typeface="Calibri" pitchFamily="34" charset="0"/>
+                <a:ea typeface="Calibri" pitchFamily="34" charset="-122"/>
+                <a:cs typeface="Calibri" pitchFamily="34" charset="-120"/>
+              </a:rPr>
+              <a:t>The doctor writes:</a:t>
+            </a:r>
+            <a:endParaRPr lang="en-US" sz="1700" dirty="0"/>
+          </a:p>
+        </p:txBody>
+      </p:sp>
+      <p:sp>
+        <p:nvSpPr>
+          <p:cNvPr id="4" name="Shape 2"/>
+          <p:cNvSpPr/>
+          <p:nvPr/>
+        </p:nvSpPr>
+        <p:spPr>
+          <a:xfrm>
+            <a:off x="8869680" y="320040"/>
+            <a:ext cx="2770632" cy="960120"/>
+          </a:xfrm>
+          <a:prstGeom prst="roundRect">
+            <a:avLst>
+              <a:gd name="adj" fmla="val 9524"/>
+            </a:avLst>
+          </a:prstGeom>
+          <a:solidFill>
+            <a:srgbClr val="2C5F2D"/>
+          </a:solidFill>
+          <a:ln/>
+        </p:spPr>
+      </p:sp>
+      <p:sp>
+        <p:nvSpPr>
+          <p:cNvPr id="5" name="Text 3"/>
+          <p:cNvSpPr/>
+          <p:nvPr/>
+        </p:nvSpPr>
+        <p:spPr>
+          <a:xfrm>
+            <a:off x="8869680" y="320040"/>
+            <a:ext cx="2770632" cy="960120"/>
+          </a:xfrm>
+          <a:prstGeom prst="rect">
+            <a:avLst/>
+          </a:prstGeom>
+          <a:noFill/>
+          <a:ln/>
+        </p:spPr>
+        <p:txBody>
+          <a:bodyPr wrap="square" lIns="0" tIns="0" rIns="0" bIns="0" rtlCol="0" anchor="ctr"/>
+          <a:lstStyle/>
+          <a:p>
+            <a:pPr algn="ctr" indent="0" marL="0">
+              <a:buNone/>
+            </a:pPr>
+            <a:r>
+              <a:rPr lang="en-US" sz="1700" b="1" spc="100" kern="0" dirty="0">
+                <a:solidFill>
+                  <a:srgbClr val="FFFFFF"/>
+                </a:solidFill>
+                <a:latin typeface="Cambria" pitchFamily="34" charset="0"/>
+                <a:ea typeface="Cambria" pitchFamily="34" charset="-122"/>
+                <a:cs typeface="Cambria" pitchFamily="34" charset="-120"/>
+              </a:rPr>
+              <a:t>THE BIG BOOK</a:t>
+            </a:r>
+            <a:endParaRPr lang="en-US" sz="1700" dirty="0"/>
+          </a:p>
+          <a:p>
+            <a:pPr algn="ctr" indent="0" marL="0">
+              <a:buNone/>
+            </a:pPr>
+            <a:r>
+              <a:rPr lang="en-US" sz="1300" dirty="0">
+                <a:solidFill>
+                  <a:srgbClr val="D5E3CE"/>
+                </a:solidFill>
+                <a:latin typeface="Calibri" pitchFamily="34" charset="0"/>
+                <a:ea typeface="Calibri" pitchFamily="34" charset="-122"/>
+                <a:cs typeface="Calibri" pitchFamily="34" charset="-120"/>
+              </a:rPr>
+              <a:t>p. xxiii</a:t>
+            </a:r>
+            <a:endParaRPr lang="en-US" sz="1700" dirty="0"/>
+          </a:p>
+        </p:txBody>
+      </p:sp>
+      <p:sp>
+        <p:nvSpPr>
+          <p:cNvPr id="6" name="Shape 4"/>
+          <p:cNvSpPr/>
+          <p:nvPr/>
+        </p:nvSpPr>
+        <p:spPr>
+          <a:xfrm>
+            <a:off x="548640" y="1463040"/>
+            <a:ext cx="11091672" cy="2651760"/>
+          </a:xfrm>
+          <a:prstGeom prst="roundRect">
+            <a:avLst>
+              <a:gd name="adj" fmla="val 2759"/>
+            </a:avLst>
+          </a:prstGeom>
+          <a:solidFill>
+            <a:srgbClr val="EAF1E6"/>
+          </a:solidFill>
+          <a:ln/>
+        </p:spPr>
+      </p:sp>
+      <p:sp>
+        <p:nvSpPr>
+          <p:cNvPr id="7" name="Text 5"/>
+          <p:cNvSpPr/>
+          <p:nvPr/>
+        </p:nvSpPr>
+        <p:spPr>
+          <a:xfrm>
+            <a:off x="914400" y="1463040"/>
+            <a:ext cx="10360152" cy="2651760"/>
+          </a:xfrm>
+          <a:prstGeom prst="rect">
+            <a:avLst/>
+          </a:prstGeom>
+          <a:noFill/>
+          <a:ln/>
+        </p:spPr>
+        <p:txBody>
+          <a:bodyPr wrap="square" lIns="0" tIns="0" rIns="0" bIns="0" rtlCol="0" anchor="ctr"/>
+          <a:lstStyle/>
+          <a:p>
+            <a:pPr indent="0" marL="0">
+              <a:lnSpc>
+                <a:spcPct val="115000"/>
+              </a:lnSpc>
+              <a:spcAft>
+                <a:spcPts val="1000"/>
+              </a:spcAft>
+              <a:buNone/>
+            </a:pPr>
+            <a:r>
+              <a:rPr lang="en-US" sz="1900" dirty="0">
+                <a:solidFill>
+                  <a:srgbClr val="1B2A41"/>
+                </a:solidFill>
+                <a:latin typeface="Calibri" pitchFamily="34" charset="0"/>
+                <a:ea typeface="Calibri" pitchFamily="34" charset="-122"/>
+                <a:cs typeface="Calibri" pitchFamily="34" charset="-120"/>
+              </a:rPr>
+              <a:t>The subject presented in this book seems to me to be of paramount importance to those afflicted with alcoholic addiction.</a:t>
+            </a:r>
+            <a:endParaRPr lang="en-US" sz="1900" dirty="0"/>
+          </a:p>
+          <a:p>
+            <a:pPr indent="0" marL="0">
+              <a:lnSpc>
+                <a:spcPct val="115000"/>
+              </a:lnSpc>
+              <a:buNone/>
+            </a:pPr>
+            <a:r>
+              <a:rPr lang="en-US" sz="1900" dirty="0">
+                <a:solidFill>
+                  <a:srgbClr val="1B2A41"/>
+                </a:solidFill>
+                <a:latin typeface="Calibri" pitchFamily="34" charset="0"/>
+                <a:ea typeface="Calibri" pitchFamily="34" charset="-122"/>
+                <a:cs typeface="Calibri" pitchFamily="34" charset="-120"/>
+              </a:rPr>
+              <a:t>I say this after many years’ experience as Medical Director of </a:t>
+            </a:r>
+            <a:pPr indent="0" marL="0">
+              <a:lnSpc>
+                <a:spcPct val="115000"/>
+              </a:lnSpc>
+              <a:buNone/>
+            </a:pPr>
+            <a:r>
+              <a:rPr lang="en-US" sz="1900" b="1" dirty="0">
+                <a:solidFill>
+                  <a:srgbClr val="2C5F2D"/>
+                </a:solidFill>
+                <a:latin typeface="Calibri" pitchFamily="34" charset="0"/>
+                <a:ea typeface="Calibri" pitchFamily="34" charset="-122"/>
+                <a:cs typeface="Calibri" pitchFamily="34" charset="-120"/>
+              </a:rPr>
+              <a:t>one of the oldest hospitals in the country treating alcoholic and drug addiction</a:t>
+            </a:r>
+            <a:pPr indent="0" marL="0">
+              <a:lnSpc>
+                <a:spcPct val="115000"/>
+              </a:lnSpc>
+              <a:spcAft>
+                <a:spcPts val="1000"/>
+              </a:spcAft>
+              <a:buNone/>
+            </a:pPr>
+            <a:r>
+              <a:rPr lang="en-US" sz="1900" dirty="0">
+                <a:solidFill>
+                  <a:srgbClr val="1B2A41"/>
+                </a:solidFill>
+                <a:latin typeface="Calibri" pitchFamily="34" charset="0"/>
+                <a:ea typeface="Calibri" pitchFamily="34" charset="-122"/>
+                <a:cs typeface="Calibri" pitchFamily="34" charset="-120"/>
+              </a:rPr>
+              <a:t>.</a:t>
+            </a:r>
+            <a:endParaRPr lang="en-US" sz="1900" dirty="0"/>
+          </a:p>
+          <a:p>
+            <a:pPr indent="0" marL="0">
+              <a:lnSpc>
+                <a:spcPct val="115000"/>
+              </a:lnSpc>
+              <a:buNone/>
+            </a:pPr>
+            <a:r>
+              <a:rPr lang="en-US" sz="1900" dirty="0">
+                <a:solidFill>
+                  <a:srgbClr val="1B2A41"/>
+                </a:solidFill>
+                <a:latin typeface="Calibri" pitchFamily="34" charset="0"/>
+                <a:ea typeface="Calibri" pitchFamily="34" charset="-122"/>
+                <a:cs typeface="Calibri" pitchFamily="34" charset="-120"/>
+              </a:rPr>
+              <a:t>There was, therefore, a sense of real satisfaction when I was asked to contribute a few words on a subject which is covered in such masterly detail in these pages.</a:t>
+            </a:r>
+            <a:endParaRPr lang="en-US" sz="1900" dirty="0"/>
+          </a:p>
+        </p:txBody>
+      </p:sp>
+      <p:sp>
+        <p:nvSpPr>
+          <p:cNvPr id="8" name="Shape 6"/>
+          <p:cNvSpPr/>
+          <p:nvPr/>
+        </p:nvSpPr>
+        <p:spPr>
+          <a:xfrm>
+            <a:off x="548640" y="4389120"/>
+            <a:ext cx="11091672" cy="960120"/>
+          </a:xfrm>
+          <a:prstGeom prst="roundRect">
+            <a:avLst>
+              <a:gd name="adj" fmla="val 7619"/>
+            </a:avLst>
+          </a:prstGeom>
+          <a:solidFill>
+            <a:srgbClr val="1B2A41"/>
+          </a:solidFill>
+          <a:ln/>
+        </p:spPr>
+      </p:sp>
+      <p:sp>
+        <p:nvSpPr>
           <p:cNvPr id="9" name="Text 7"/>
+          <p:cNvSpPr/>
+          <p:nvPr/>
+        </p:nvSpPr>
+        <p:spPr>
+          <a:xfrm>
+            <a:off x="914400" y="4507992"/>
+            <a:ext cx="10360152" cy="256032"/>
+          </a:xfrm>
+          <a:prstGeom prst="rect">
+            <a:avLst/>
+          </a:prstGeom>
+          <a:noFill/>
+          <a:ln/>
+        </p:spPr>
+        <p:txBody>
+          <a:bodyPr wrap="square" lIns="0" tIns="0" rIns="0" bIns="0" rtlCol="0" anchor="ctr"/>
+          <a:lstStyle/>
+          <a:p>
+            <a:pPr indent="0" marL="0">
+              <a:buNone/>
+            </a:pPr>
+            <a:r>
+              <a:rPr lang="en-US" sz="1100" b="1" spc="200" kern="0" dirty="0">
+                <a:solidFill>
+                  <a:srgbClr val="A9B8CC"/>
+                </a:solidFill>
+                <a:latin typeface="Calibri" pitchFamily="34" charset="0"/>
+                <a:ea typeface="Calibri" pitchFamily="34" charset="-122"/>
+                <a:cs typeface="Calibri" pitchFamily="34" charset="-120"/>
+              </a:rPr>
+              <a:t>MARGIN NOTE</a:t>
+            </a:r>
+            <a:endParaRPr lang="en-US" sz="1100" dirty="0"/>
+          </a:p>
+        </p:txBody>
+      </p:sp>
+      <p:sp>
+        <p:nvSpPr>
+          <p:cNvPr id="10" name="Text 8"/>
+          <p:cNvSpPr/>
+          <p:nvPr/>
+        </p:nvSpPr>
+        <p:spPr>
+          <a:xfrm>
+            <a:off x="914400" y="4782312"/>
+            <a:ext cx="10360152" cy="448056"/>
+          </a:xfrm>
+          <a:prstGeom prst="rect">
+            <a:avLst/>
+          </a:prstGeom>
+          <a:noFill/>
+          <a:ln/>
+        </p:spPr>
+        <p:txBody>
+          <a:bodyPr wrap="square" lIns="0" tIns="0" rIns="0" bIns="0" rtlCol="0" anchor="ctr"/>
+          <a:lstStyle/>
+          <a:p>
+            <a:pPr indent="0" marL="0">
+              <a:buNone/>
+            </a:pPr>
+            <a:r>
+              <a:rPr lang="en-US" sz="2200" b="1" dirty="0">
+                <a:solidFill>
+                  <a:srgbClr val="FFFFFF"/>
+                </a:solidFill>
+                <a:latin typeface="Cambria" pitchFamily="34" charset="0"/>
+                <a:ea typeface="Cambria" pitchFamily="34" charset="-122"/>
+                <a:cs typeface="Cambria" pitchFamily="34" charset="-120"/>
+              </a:rPr>
+              <a:t>Towns Hospital, New York City.</a:t>
+            </a:r>
+            <a:endParaRPr lang="en-US" sz="2200" dirty="0"/>
+          </a:p>
+        </p:txBody>
+      </p:sp>
+      <p:sp>
+        <p:nvSpPr>
+          <p:cNvPr id="11" name="Text 9"/>
+          <p:cNvSpPr/>
+          <p:nvPr/>
+        </p:nvSpPr>
+        <p:spPr>
+          <a:xfrm>
+            <a:off x="548640" y="5532120"/>
+            <a:ext cx="11091672" cy="292608"/>
+          </a:xfrm>
+          <a:prstGeom prst="rect">
+            <a:avLst/>
+          </a:prstGeom>
+          <a:noFill/>
+          <a:ln/>
+        </p:spPr>
+        <p:txBody>
+          <a:bodyPr wrap="square" lIns="0" tIns="0" rIns="0" bIns="0" rtlCol="0" anchor="ctr"/>
+          <a:lstStyle/>
+          <a:p>
+            <a:pPr indent="0" marL="0">
+              <a:buNone/>
+            </a:pPr>
+            <a:r>
+              <a:rPr lang="en-US" sz="1200" i="1" dirty="0">
+                <a:solidFill>
+                  <a:srgbClr val="6B7A8C"/>
+                </a:solidFill>
+                <a:latin typeface="Calibri" pitchFamily="34" charset="0"/>
+                <a:ea typeface="Calibri" pitchFamily="34" charset="-122"/>
+                <a:cs typeface="Calibri" pitchFamily="34" charset="-120"/>
+              </a:rPr>
+              <a:t>Alcoholics Anonymous</a:t>
+            </a:r>
+            <a:pPr indent="0" marL="0">
+              <a:buNone/>
+            </a:pPr>
+            <a:r>
+              <a:rPr lang="en-US" sz="1200" dirty="0">
+                <a:solidFill>
+                  <a:srgbClr val="6B7A8C"/>
+                </a:solidFill>
+                <a:latin typeface="Calibri" pitchFamily="34" charset="0"/>
+                <a:ea typeface="Calibri" pitchFamily="34" charset="-122"/>
+                <a:cs typeface="Calibri" pitchFamily="34" charset="-120"/>
+              </a:rPr>
+              <a:t>, 4th ed., “The Doctor’s Opinion,” p. xxiii.</a:t>
+            </a:r>
+            <a:endParaRPr lang="en-US" sz="1200" dirty="0"/>
+          </a:p>
+        </p:txBody>
+      </p:sp>
+      <p:sp>
+        <p:nvSpPr>
+          <p:cNvPr id="12" name="Text 10"/>
+          <p:cNvSpPr/>
+          <p:nvPr/>
+        </p:nvSpPr>
+        <p:spPr>
+          <a:xfrm>
+            <a:off x="548640" y="6355080"/>
+            <a:ext cx="11091672" cy="292608"/>
+          </a:xfrm>
+          <a:prstGeom prst="rect">
+            <a:avLst/>
+          </a:prstGeom>
+          <a:noFill/>
+          <a:ln/>
+        </p:spPr>
+        <p:txBody>
+          <a:bodyPr wrap="square" lIns="0" tIns="0" rIns="0" bIns="0" rtlCol="0" anchor="ctr"/>
+          <a:lstStyle/>
+          <a:p>
+            <a:pPr indent="0" marL="0">
+              <a:buNone/>
+            </a:pPr>
+            <a:r>
+              <a:rPr lang="en-US" sz="950" dirty="0">
+                <a:solidFill>
+                  <a:srgbClr val="6B7A8C"/>
+                </a:solidFill>
+                <a:latin typeface="Calibri" pitchFamily="34" charset="0"/>
+                <a:ea typeface="Calibri" pitchFamily="34" charset="-122"/>
+                <a:cs typeface="Calibri" pitchFamily="34" charset="-120"/>
+              </a:rPr>
+              <a:t>Copyright © Alcoholics Anonymous World Services, Inc. All rights reserved. Intended for personal use only, and not to be reproduced further or distributed for resale.</a:t>
+            </a:r>
+            <a:endParaRPr lang="en-US" sz="950" dirty="0"/>
+          </a:p>
+        </p:txBody>
+      </p:sp>
+    </p:spTree>
+  </p:cSld>
+  <p:clrMapOvr>
+    <a:masterClrMapping/>
+  </p:clrMapOvr>
+</p:sld>
+</file>
+
+<file path=ppt/slides/slide22.xml><?xml version="1.0" encoding="utf-8"?>
+<p:sld xmlns:a="http://schemas.openxmlformats.org/drawingml/2006/main" xmlns:r="http://schemas.openxmlformats.org/officeDocument/2006/relationships" xmlns:p="http://schemas.openxmlformats.org/presentationml/2006/main">
+  <p:cSld name="Slide 22">
+    <p:bg>
+      <p:bgPr>
+        <a:solidFill>
+          <a:srgbClr val="FFFFFF"/>
+        </a:solidFill>
+      </p:bgPr>
+    </p:bg>
+    <p:spTree>
+      <p:nvGrpSpPr>
+        <p:cNvPr id="1" name=""/>
+        <p:cNvGrpSpPr/>
+        <p:nvPr/>
+      </p:nvGrpSpPr>
+      <p:grpSpPr>
+        <a:xfrm>
+          <a:off x="0" y="0"/>
+          <a:ext cx="0" cy="0"/>
+          <a:chOff x="0" y="0"/>
+          <a:chExt cx="0" cy="0"/>
+        </a:xfrm>
+      </p:grpSpPr>
+      <p:sp>
+        <p:nvSpPr>
+          <p:cNvPr id="2" name="Text 0"/>
+          <p:cNvSpPr/>
+          <p:nvPr/>
+        </p:nvSpPr>
+        <p:spPr>
+          <a:xfrm>
+            <a:off x="548640" y="320040"/>
+            <a:ext cx="8138160" cy="566928"/>
+          </a:xfrm>
+          <a:prstGeom prst="rect">
+            <a:avLst/>
+          </a:prstGeom>
+          <a:noFill/>
+          <a:ln/>
+        </p:spPr>
+        <p:txBody>
+          <a:bodyPr wrap="square" lIns="0" tIns="0" rIns="0" bIns="0" rtlCol="0" anchor="ctr"/>
+          <a:lstStyle/>
+          <a:p>
+            <a:pPr indent="0" marL="0">
+              <a:buNone/>
+            </a:pPr>
+            <a:r>
+              <a:rPr lang="en-US" sz="3800" b="1" dirty="0">
+                <a:solidFill>
+                  <a:srgbClr val="1B2A41"/>
+                </a:solidFill>
+                <a:latin typeface="Cambria" pitchFamily="34" charset="0"/>
+                <a:ea typeface="Cambria" pitchFamily="34" charset="-122"/>
+                <a:cs typeface="Cambria" pitchFamily="34" charset="-120"/>
+              </a:rPr>
+              <a:t>Beyond Our Conception</a:t>
+            </a:r>
+            <a:endParaRPr lang="en-US" sz="3800" dirty="0"/>
+          </a:p>
+        </p:txBody>
+      </p:sp>
+      <p:sp>
+        <p:nvSpPr>
+          <p:cNvPr id="3" name="Text 1"/>
+          <p:cNvSpPr/>
+          <p:nvPr/>
+        </p:nvSpPr>
+        <p:spPr>
+          <a:xfrm>
+            <a:off x="548640" y="914400"/>
+            <a:ext cx="8138160" cy="347472"/>
+          </a:xfrm>
+          <a:prstGeom prst="rect">
+            <a:avLst/>
+          </a:prstGeom>
+          <a:noFill/>
+          <a:ln/>
+        </p:spPr>
+        <p:txBody>
+          <a:bodyPr wrap="square" lIns="0" tIns="0" rIns="0" bIns="0" rtlCol="0" anchor="ctr"/>
+          <a:lstStyle/>
+          <a:p>
+            <a:pPr indent="0" marL="0">
+              <a:buNone/>
+            </a:pPr>
+            <a:r>
+              <a:rPr lang="en-US" sz="1700" i="1" dirty="0">
+                <a:solidFill>
+                  <a:srgbClr val="6B7A8C"/>
+                </a:solidFill>
+                <a:latin typeface="Calibri" pitchFamily="34" charset="0"/>
+                <a:ea typeface="Calibri" pitchFamily="34" charset="-122"/>
+                <a:cs typeface="Calibri" pitchFamily="34" charset="-120"/>
+              </a:rPr>
+              <a:t>What we doctors have realized.</a:t>
+            </a:r>
+            <a:endParaRPr lang="en-US" sz="1700" dirty="0"/>
+          </a:p>
+        </p:txBody>
+      </p:sp>
+      <p:sp>
+        <p:nvSpPr>
+          <p:cNvPr id="4" name="Shape 2"/>
+          <p:cNvSpPr/>
+          <p:nvPr/>
+        </p:nvSpPr>
+        <p:spPr>
+          <a:xfrm>
+            <a:off x="8869680" y="320040"/>
+            <a:ext cx="2770632" cy="960120"/>
+          </a:xfrm>
+          <a:prstGeom prst="roundRect">
+            <a:avLst>
+              <a:gd name="adj" fmla="val 9524"/>
+            </a:avLst>
+          </a:prstGeom>
+          <a:solidFill>
+            <a:srgbClr val="2C5F2D"/>
+          </a:solidFill>
+          <a:ln/>
+        </p:spPr>
+      </p:sp>
+      <p:sp>
+        <p:nvSpPr>
+          <p:cNvPr id="5" name="Text 3"/>
+          <p:cNvSpPr/>
+          <p:nvPr/>
+        </p:nvSpPr>
+        <p:spPr>
+          <a:xfrm>
+            <a:off x="8869680" y="320040"/>
+            <a:ext cx="2770632" cy="960120"/>
+          </a:xfrm>
+          <a:prstGeom prst="rect">
+            <a:avLst/>
+          </a:prstGeom>
+          <a:noFill/>
+          <a:ln/>
+        </p:spPr>
+        <p:txBody>
+          <a:bodyPr wrap="square" lIns="0" tIns="0" rIns="0" bIns="0" rtlCol="0" anchor="ctr"/>
+          <a:lstStyle/>
+          <a:p>
+            <a:pPr algn="ctr" indent="0" marL="0">
+              <a:buNone/>
+            </a:pPr>
+            <a:r>
+              <a:rPr lang="en-US" sz="1700" b="1" spc="100" kern="0" dirty="0">
+                <a:solidFill>
+                  <a:srgbClr val="FFFFFF"/>
+                </a:solidFill>
+                <a:latin typeface="Cambria" pitchFamily="34" charset="0"/>
+                <a:ea typeface="Cambria" pitchFamily="34" charset="-122"/>
+                <a:cs typeface="Cambria" pitchFamily="34" charset="-120"/>
+              </a:rPr>
+              <a:t>THE BIG BOOK</a:t>
+            </a:r>
+            <a:endParaRPr lang="en-US" sz="1700" dirty="0"/>
+          </a:p>
+          <a:p>
+            <a:pPr algn="ctr" indent="0" marL="0">
+              <a:buNone/>
+            </a:pPr>
+            <a:r>
+              <a:rPr lang="en-US" sz="1300" dirty="0">
+                <a:solidFill>
+                  <a:srgbClr val="D5E3CE"/>
+                </a:solidFill>
+                <a:latin typeface="Calibri" pitchFamily="34" charset="0"/>
+                <a:ea typeface="Calibri" pitchFamily="34" charset="-122"/>
+                <a:cs typeface="Calibri" pitchFamily="34" charset="-120"/>
+              </a:rPr>
+              <a:t>p. xxiii</a:t>
+            </a:r>
+            <a:endParaRPr lang="en-US" sz="1700" dirty="0"/>
+          </a:p>
+        </p:txBody>
+      </p:sp>
+      <p:sp>
+        <p:nvSpPr>
+          <p:cNvPr id="6" name="Shape 4"/>
+          <p:cNvSpPr/>
+          <p:nvPr/>
+        </p:nvSpPr>
+        <p:spPr>
+          <a:xfrm>
+            <a:off x="548640" y="1645920"/>
+            <a:ext cx="11091672" cy="1463040"/>
+          </a:xfrm>
+          <a:prstGeom prst="roundRect">
+            <a:avLst>
+              <a:gd name="adj" fmla="val 5000"/>
+            </a:avLst>
+          </a:prstGeom>
+          <a:solidFill>
+            <a:srgbClr val="EAF1E6"/>
+          </a:solidFill>
+          <a:ln/>
+        </p:spPr>
+      </p:sp>
+      <p:sp>
+        <p:nvSpPr>
+          <p:cNvPr id="7" name="Text 5"/>
+          <p:cNvSpPr/>
+          <p:nvPr/>
+        </p:nvSpPr>
+        <p:spPr>
+          <a:xfrm>
+            <a:off x="914400" y="1645920"/>
+            <a:ext cx="10360152" cy="1463040"/>
+          </a:xfrm>
+          <a:prstGeom prst="rect">
+            <a:avLst/>
+          </a:prstGeom>
+          <a:noFill/>
+          <a:ln/>
+        </p:spPr>
+        <p:txBody>
+          <a:bodyPr wrap="square" lIns="0" tIns="0" rIns="0" bIns="0" rtlCol="0" anchor="ctr"/>
+          <a:lstStyle/>
+          <a:p>
+            <a:pPr indent="0" marL="0">
+              <a:lnSpc>
+                <a:spcPct val="115000"/>
+              </a:lnSpc>
+              <a:buNone/>
+            </a:pPr>
+            <a:r>
+              <a:rPr lang="en-US" sz="2100" dirty="0">
+                <a:solidFill>
+                  <a:srgbClr val="1B2A41"/>
+                </a:solidFill>
+                <a:latin typeface="Calibri" pitchFamily="34" charset="0"/>
+                <a:ea typeface="Calibri" pitchFamily="34" charset="-122"/>
+                <a:cs typeface="Calibri" pitchFamily="34" charset="-120"/>
+              </a:rPr>
+              <a:t>We doctors have realized for a long time that some form of </a:t>
+            </a:r>
+            <a:pPr indent="0" marL="0">
+              <a:lnSpc>
+                <a:spcPct val="115000"/>
+              </a:lnSpc>
+              <a:buNone/>
+            </a:pPr>
+            <a:r>
+              <a:rPr lang="en-US" sz="2100" b="1" dirty="0">
+                <a:solidFill>
+                  <a:srgbClr val="2C5F2D"/>
+                </a:solidFill>
+                <a:latin typeface="Calibri" pitchFamily="34" charset="0"/>
+                <a:ea typeface="Calibri" pitchFamily="34" charset="-122"/>
+                <a:cs typeface="Calibri" pitchFamily="34" charset="-120"/>
+              </a:rPr>
+              <a:t>moral psychology</a:t>
+            </a:r>
+            <a:pPr indent="0" marL="0">
+              <a:lnSpc>
+                <a:spcPct val="115000"/>
+              </a:lnSpc>
+              <a:buNone/>
+            </a:pPr>
+            <a:r>
+              <a:rPr lang="en-US" sz="2100" dirty="0">
+                <a:solidFill>
+                  <a:srgbClr val="1B2A41"/>
+                </a:solidFill>
+                <a:latin typeface="Calibri" pitchFamily="34" charset="0"/>
+                <a:ea typeface="Calibri" pitchFamily="34" charset="-122"/>
+                <a:cs typeface="Calibri" pitchFamily="34" charset="-120"/>
+              </a:rPr>
+              <a:t> was of urgent importance to alcoholics, but its application presented difficulties beyond our conception.</a:t>
+            </a:r>
+            <a:endParaRPr lang="en-US" sz="2100" dirty="0"/>
+          </a:p>
+        </p:txBody>
+      </p:sp>
+      <p:sp>
+        <p:nvSpPr>
+          <p:cNvPr id="8" name="Shape 6"/>
+          <p:cNvSpPr/>
+          <p:nvPr/>
+        </p:nvSpPr>
+        <p:spPr>
+          <a:xfrm>
+            <a:off x="548640" y="3383280"/>
+            <a:ext cx="11091672" cy="1463040"/>
+          </a:xfrm>
+          <a:prstGeom prst="roundRect">
+            <a:avLst>
+              <a:gd name="adj" fmla="val 5000"/>
+            </a:avLst>
+          </a:prstGeom>
+          <a:solidFill>
+            <a:srgbClr val="EAF1E6"/>
+          </a:solidFill>
+          <a:ln/>
+        </p:spPr>
+      </p:sp>
+      <p:sp>
+        <p:nvSpPr>
+          <p:cNvPr id="9" name="Text 7"/>
+          <p:cNvSpPr/>
+          <p:nvPr/>
+        </p:nvSpPr>
+        <p:spPr>
+          <a:xfrm>
+            <a:off x="914400" y="3383280"/>
+            <a:ext cx="10360152" cy="1463040"/>
+          </a:xfrm>
+          <a:prstGeom prst="rect">
+            <a:avLst/>
+          </a:prstGeom>
+          <a:noFill/>
+          <a:ln/>
+        </p:spPr>
+        <p:txBody>
+          <a:bodyPr wrap="square" lIns="0" tIns="0" rIns="0" bIns="0" rtlCol="0" anchor="ctr"/>
+          <a:lstStyle/>
+          <a:p>
+            <a:pPr indent="0" marL="0">
+              <a:lnSpc>
+                <a:spcPct val="115000"/>
+              </a:lnSpc>
+              <a:buNone/>
+            </a:pPr>
+            <a:r>
+              <a:rPr lang="en-US" sz="2100" dirty="0">
+                <a:solidFill>
+                  <a:srgbClr val="1B2A41"/>
+                </a:solidFill>
+                <a:latin typeface="Calibri" pitchFamily="34" charset="0"/>
+                <a:ea typeface="Calibri" pitchFamily="34" charset="-122"/>
+                <a:cs typeface="Calibri" pitchFamily="34" charset="-120"/>
+              </a:rPr>
+              <a:t>What with our ultra-modern standards, our scientific approach to everything, we are perhaps not well equipped to apply the powers of good that lie outside our synthetic knowledge.</a:t>
+            </a:r>
+            <a:endParaRPr lang="en-US" sz="2100" dirty="0"/>
+          </a:p>
+        </p:txBody>
+      </p:sp>
+      <p:sp>
+        <p:nvSpPr>
+          <p:cNvPr id="10" name="Text 8"/>
+          <p:cNvSpPr/>
+          <p:nvPr/>
+        </p:nvSpPr>
+        <p:spPr>
+          <a:xfrm>
+            <a:off x="548640" y="5120640"/>
+            <a:ext cx="11091672" cy="292608"/>
+          </a:xfrm>
+          <a:prstGeom prst="rect">
+            <a:avLst/>
+          </a:prstGeom>
+          <a:noFill/>
+          <a:ln/>
+        </p:spPr>
+        <p:txBody>
+          <a:bodyPr wrap="square" lIns="0" tIns="0" rIns="0" bIns="0" rtlCol="0" anchor="ctr"/>
+          <a:lstStyle/>
+          <a:p>
+            <a:pPr indent="0" marL="0">
+              <a:buNone/>
+            </a:pPr>
+            <a:r>
+              <a:rPr lang="en-US" sz="1200" i="1" dirty="0">
+                <a:solidFill>
+                  <a:srgbClr val="6B7A8C"/>
+                </a:solidFill>
+                <a:latin typeface="Calibri" pitchFamily="34" charset="0"/>
+                <a:ea typeface="Calibri" pitchFamily="34" charset="-122"/>
+                <a:cs typeface="Calibri" pitchFamily="34" charset="-120"/>
+              </a:rPr>
+              <a:t>Alcoholics Anonymous</a:t>
+            </a:r>
+            <a:pPr indent="0" marL="0">
+              <a:buNone/>
+            </a:pPr>
+            <a:r>
+              <a:rPr lang="en-US" sz="1200" dirty="0">
+                <a:solidFill>
+                  <a:srgbClr val="6B7A8C"/>
+                </a:solidFill>
+                <a:latin typeface="Calibri" pitchFamily="34" charset="0"/>
+                <a:ea typeface="Calibri" pitchFamily="34" charset="-122"/>
+                <a:cs typeface="Calibri" pitchFamily="34" charset="-120"/>
+              </a:rPr>
+              <a:t>, 4th ed., “The Doctor’s Opinion,” p. xxiii.</a:t>
+            </a:r>
+            <a:endParaRPr lang="en-US" sz="1200" dirty="0"/>
+          </a:p>
+        </p:txBody>
+      </p:sp>
+      <p:sp>
+        <p:nvSpPr>
+          <p:cNvPr id="11" name="Text 9"/>
+          <p:cNvSpPr/>
+          <p:nvPr/>
+        </p:nvSpPr>
+        <p:spPr>
+          <a:xfrm>
+            <a:off x="548640" y="6355080"/>
+            <a:ext cx="11091672" cy="292608"/>
+          </a:xfrm>
+          <a:prstGeom prst="rect">
+            <a:avLst/>
+          </a:prstGeom>
+          <a:noFill/>
+          <a:ln/>
+        </p:spPr>
+        <p:txBody>
+          <a:bodyPr wrap="square" lIns="0" tIns="0" rIns="0" bIns="0" rtlCol="0" anchor="ctr"/>
+          <a:lstStyle/>
+          <a:p>
+            <a:pPr indent="0" marL="0">
+              <a:buNone/>
+            </a:pPr>
+            <a:r>
+              <a:rPr lang="en-US" sz="950" dirty="0">
+                <a:solidFill>
+                  <a:srgbClr val="6B7A8C"/>
+                </a:solidFill>
+                <a:latin typeface="Calibri" pitchFamily="34" charset="0"/>
+                <a:ea typeface="Calibri" pitchFamily="34" charset="-122"/>
+                <a:cs typeface="Calibri" pitchFamily="34" charset="-120"/>
+              </a:rPr>
+              <a:t>Copyright © Alcoholics Anonymous World Services, Inc. All rights reserved. Intended for personal use only, and not to be reproduced further or distributed for resale.</a:t>
+            </a:r>
+            <a:endParaRPr lang="en-US" sz="950" dirty="0"/>
+          </a:p>
+        </p:txBody>
+      </p:sp>
+    </p:spTree>
+  </p:cSld>
+  <p:clrMapOvr>
+    <a:masterClrMapping/>
+  </p:clrMapOvr>
+</p:sld>
+</file>
+
+<file path=ppt/slides/slide23.xml><?xml version="1.0" encoding="utf-8"?>
+<p:sld xmlns:a="http://schemas.openxmlformats.org/drawingml/2006/main" xmlns:r="http://schemas.openxmlformats.org/officeDocument/2006/relationships" xmlns:p="http://schemas.openxmlformats.org/presentationml/2006/main">
+  <p:cSld name="Slide 23">
+    <p:bg>
+      <p:bgPr>
+        <a:solidFill>
+          <a:srgbClr val="FFFFFF"/>
+        </a:solidFill>
+      </p:bgPr>
+    </p:bg>
+    <p:spTree>
+      <p:nvGrpSpPr>
+        <p:cNvPr id="1" name=""/>
+        <p:cNvGrpSpPr/>
+        <p:nvPr/>
+      </p:nvGrpSpPr>
+      <p:grpSpPr>
+        <a:xfrm>
+          <a:off x="0" y="0"/>
+          <a:ext cx="0" cy="0"/>
+          <a:chOff x="0" y="0"/>
+          <a:chExt cx="0" cy="0"/>
+        </a:xfrm>
+      </p:grpSpPr>
+      <p:sp>
+        <p:nvSpPr>
+          <p:cNvPr id="2" name="Text 0"/>
+          <p:cNvSpPr/>
+          <p:nvPr/>
+        </p:nvSpPr>
+        <p:spPr>
+          <a:xfrm>
+            <a:off x="548640" y="320040"/>
+            <a:ext cx="8138160" cy="566928"/>
+          </a:xfrm>
+          <a:prstGeom prst="rect">
+            <a:avLst/>
+          </a:prstGeom>
+          <a:noFill/>
+          <a:ln/>
+        </p:spPr>
+        <p:txBody>
+          <a:bodyPr wrap="square" lIns="0" tIns="0" rIns="0" bIns="0" rtlCol="0" anchor="ctr"/>
+          <a:lstStyle/>
+          <a:p>
+            <a:pPr indent="0" marL="0">
+              <a:buNone/>
+            </a:pPr>
+            <a:r>
+              <a:rPr lang="en-US" sz="3800" b="1" dirty="0">
+                <a:solidFill>
+                  <a:srgbClr val="1B2A41"/>
+                </a:solidFill>
+                <a:latin typeface="Cambria" pitchFamily="34" charset="0"/>
+                <a:ea typeface="Cambria" pitchFamily="34" charset="-122"/>
+                <a:cs typeface="Cambria" pitchFamily="34" charset="-120"/>
+              </a:rPr>
+              <a:t>One of the Leading Contributors</a:t>
+            </a:r>
+            <a:endParaRPr lang="en-US" sz="3800" dirty="0"/>
+          </a:p>
+        </p:txBody>
+      </p:sp>
+      <p:sp>
+        <p:nvSpPr>
+          <p:cNvPr id="3" name="Text 1"/>
+          <p:cNvSpPr/>
+          <p:nvPr/>
+        </p:nvSpPr>
+        <p:spPr>
+          <a:xfrm>
+            <a:off x="548640" y="914400"/>
+            <a:ext cx="8138160" cy="347472"/>
+          </a:xfrm>
+          <a:prstGeom prst="rect">
+            <a:avLst/>
+          </a:prstGeom>
+          <a:noFill/>
+          <a:ln/>
+        </p:spPr>
+        <p:txBody>
+          <a:bodyPr wrap="square" lIns="0" tIns="0" rIns="0" bIns="0" rtlCol="0" anchor="ctr"/>
+          <a:lstStyle/>
+          <a:p>
+            <a:pPr indent="0" marL="0">
+              <a:buNone/>
+            </a:pPr>
+            <a:r>
+              <a:rPr lang="en-US" sz="1700" i="1" dirty="0">
+                <a:solidFill>
+                  <a:srgbClr val="6B7A8C"/>
+                </a:solidFill>
+                <a:latin typeface="Calibri" pitchFamily="34" charset="0"/>
+                <a:ea typeface="Calibri" pitchFamily="34" charset="-122"/>
+                <a:cs typeface="Calibri" pitchFamily="34" charset="-120"/>
+              </a:rPr>
+              <a:t>Came under our care in this hospital.</a:t>
+            </a:r>
+            <a:endParaRPr lang="en-US" sz="1700" dirty="0"/>
+          </a:p>
+        </p:txBody>
+      </p:sp>
+      <p:sp>
+        <p:nvSpPr>
+          <p:cNvPr id="4" name="Shape 2"/>
+          <p:cNvSpPr/>
+          <p:nvPr/>
+        </p:nvSpPr>
+        <p:spPr>
+          <a:xfrm>
+            <a:off x="8869680" y="320040"/>
+            <a:ext cx="2770632" cy="960120"/>
+          </a:xfrm>
+          <a:prstGeom prst="roundRect">
+            <a:avLst>
+              <a:gd name="adj" fmla="val 9524"/>
+            </a:avLst>
+          </a:prstGeom>
+          <a:solidFill>
+            <a:srgbClr val="2C5F2D"/>
+          </a:solidFill>
+          <a:ln/>
+        </p:spPr>
+      </p:sp>
+      <p:sp>
+        <p:nvSpPr>
+          <p:cNvPr id="5" name="Text 3"/>
+          <p:cNvSpPr/>
+          <p:nvPr/>
+        </p:nvSpPr>
+        <p:spPr>
+          <a:xfrm>
+            <a:off x="8869680" y="320040"/>
+            <a:ext cx="2770632" cy="960120"/>
+          </a:xfrm>
+          <a:prstGeom prst="rect">
+            <a:avLst/>
+          </a:prstGeom>
+          <a:noFill/>
+          <a:ln/>
+        </p:spPr>
+        <p:txBody>
+          <a:bodyPr wrap="square" lIns="0" tIns="0" rIns="0" bIns="0" rtlCol="0" anchor="ctr"/>
+          <a:lstStyle/>
+          <a:p>
+            <a:pPr algn="ctr" indent="0" marL="0">
+              <a:buNone/>
+            </a:pPr>
+            <a:r>
+              <a:rPr lang="en-US" sz="1700" b="1" spc="100" kern="0" dirty="0">
+                <a:solidFill>
+                  <a:srgbClr val="FFFFFF"/>
+                </a:solidFill>
+                <a:latin typeface="Cambria" pitchFamily="34" charset="0"/>
+                <a:ea typeface="Cambria" pitchFamily="34" charset="-122"/>
+                <a:cs typeface="Cambria" pitchFamily="34" charset="-120"/>
+              </a:rPr>
+              <a:t>THE BIG BOOK</a:t>
+            </a:r>
+            <a:endParaRPr lang="en-US" sz="1700" dirty="0"/>
+          </a:p>
+          <a:p>
+            <a:pPr algn="ctr" indent="0" marL="0">
+              <a:buNone/>
+            </a:pPr>
+            <a:r>
+              <a:rPr lang="en-US" sz="1300" dirty="0">
+                <a:solidFill>
+                  <a:srgbClr val="D5E3CE"/>
+                </a:solidFill>
+                <a:latin typeface="Calibri" pitchFamily="34" charset="0"/>
+                <a:ea typeface="Calibri" pitchFamily="34" charset="-122"/>
+                <a:cs typeface="Calibri" pitchFamily="34" charset="-120"/>
+              </a:rPr>
+              <a:t>p. xxiii</a:t>
+            </a:r>
+            <a:endParaRPr lang="en-US" sz="1700" dirty="0"/>
+          </a:p>
+        </p:txBody>
+      </p:sp>
+      <p:sp>
+        <p:nvSpPr>
+          <p:cNvPr id="6" name="Shape 4"/>
+          <p:cNvSpPr/>
+          <p:nvPr/>
+        </p:nvSpPr>
+        <p:spPr>
+          <a:xfrm>
+            <a:off x="548640" y="1554480"/>
+            <a:ext cx="11091672" cy="1737360"/>
+          </a:xfrm>
+          <a:prstGeom prst="roundRect">
+            <a:avLst>
+              <a:gd name="adj" fmla="val 4211"/>
+            </a:avLst>
+          </a:prstGeom>
+          <a:solidFill>
+            <a:srgbClr val="EAF1E6"/>
+          </a:solidFill>
+          <a:ln/>
+        </p:spPr>
+      </p:sp>
+      <p:sp>
+        <p:nvSpPr>
+          <p:cNvPr id="7" name="Text 5"/>
+          <p:cNvSpPr/>
+          <p:nvPr/>
+        </p:nvSpPr>
+        <p:spPr>
+          <a:xfrm>
+            <a:off x="914400" y="1554480"/>
+            <a:ext cx="10360152" cy="1737360"/>
+          </a:xfrm>
+          <a:prstGeom prst="rect">
+            <a:avLst/>
+          </a:prstGeom>
+          <a:noFill/>
+          <a:ln/>
+        </p:spPr>
+        <p:txBody>
+          <a:bodyPr wrap="square" lIns="0" tIns="0" rIns="0" bIns="0" rtlCol="0" anchor="ctr"/>
+          <a:lstStyle/>
+          <a:p>
+            <a:pPr indent="0" marL="0">
+              <a:lnSpc>
+                <a:spcPct val="115000"/>
+              </a:lnSpc>
+              <a:buNone/>
+            </a:pPr>
+            <a:r>
+              <a:rPr lang="en-US" sz="2200" dirty="0">
+                <a:solidFill>
+                  <a:srgbClr val="1B2A41"/>
+                </a:solidFill>
+                <a:latin typeface="Calibri" pitchFamily="34" charset="0"/>
+                <a:ea typeface="Calibri" pitchFamily="34" charset="-122"/>
+                <a:cs typeface="Calibri" pitchFamily="34" charset="-120"/>
+              </a:rPr>
+              <a:t>Many years ago </a:t>
+            </a:r>
+            <a:pPr indent="0" marL="0">
+              <a:lnSpc>
+                <a:spcPct val="115000"/>
+              </a:lnSpc>
+              <a:buNone/>
+            </a:pPr>
+            <a:r>
+              <a:rPr lang="en-US" sz="2200" b="1" dirty="0">
+                <a:solidFill>
+                  <a:srgbClr val="2C5F2D"/>
+                </a:solidFill>
+                <a:latin typeface="Calibri" pitchFamily="34" charset="0"/>
+                <a:ea typeface="Calibri" pitchFamily="34" charset="-122"/>
+                <a:cs typeface="Calibri" pitchFamily="34" charset="-120"/>
+              </a:rPr>
+              <a:t>one of the leading contributors to this book</a:t>
+            </a:r>
+            <a:pPr indent="0" marL="0">
+              <a:lnSpc>
+                <a:spcPct val="115000"/>
+              </a:lnSpc>
+              <a:buNone/>
+            </a:pPr>
+            <a:r>
+              <a:rPr lang="en-US" sz="2200" dirty="0">
+                <a:solidFill>
+                  <a:srgbClr val="1B2A41"/>
+                </a:solidFill>
+                <a:latin typeface="Calibri" pitchFamily="34" charset="0"/>
+                <a:ea typeface="Calibri" pitchFamily="34" charset="-122"/>
+                <a:cs typeface="Calibri" pitchFamily="34" charset="-120"/>
+              </a:rPr>
+              <a:t> came under our care in </a:t>
+            </a:r>
+            <a:pPr indent="0" marL="0">
+              <a:lnSpc>
+                <a:spcPct val="115000"/>
+              </a:lnSpc>
+              <a:buNone/>
+            </a:pPr>
+            <a:r>
+              <a:rPr lang="en-US" sz="2200" b="1" dirty="0">
+                <a:solidFill>
+                  <a:srgbClr val="2C5F2D"/>
+                </a:solidFill>
+                <a:latin typeface="Calibri" pitchFamily="34" charset="0"/>
+                <a:ea typeface="Calibri" pitchFamily="34" charset="-122"/>
+                <a:cs typeface="Calibri" pitchFamily="34" charset="-120"/>
+              </a:rPr>
+              <a:t>this hospital</a:t>
+            </a:r>
+            <a:pPr indent="0" marL="0">
+              <a:lnSpc>
+                <a:spcPct val="115000"/>
+              </a:lnSpc>
+              <a:buNone/>
+            </a:pPr>
+            <a:r>
+              <a:rPr lang="en-US" sz="2200" dirty="0">
+                <a:solidFill>
+                  <a:srgbClr val="1B2A41"/>
+                </a:solidFill>
+                <a:latin typeface="Calibri" pitchFamily="34" charset="0"/>
+                <a:ea typeface="Calibri" pitchFamily="34" charset="-122"/>
+                <a:cs typeface="Calibri" pitchFamily="34" charset="-120"/>
+              </a:rPr>
+              <a:t> and while here </a:t>
+            </a:r>
+            <a:pPr indent="0" marL="0">
+              <a:lnSpc>
+                <a:spcPct val="115000"/>
+              </a:lnSpc>
+              <a:buNone/>
+            </a:pPr>
+            <a:r>
+              <a:rPr lang="en-US" sz="2200" b="1" dirty="0">
+                <a:solidFill>
+                  <a:srgbClr val="2C5F2D"/>
+                </a:solidFill>
+                <a:latin typeface="Calibri" pitchFamily="34" charset="0"/>
+                <a:ea typeface="Calibri" pitchFamily="34" charset="-122"/>
+                <a:cs typeface="Calibri" pitchFamily="34" charset="-120"/>
+              </a:rPr>
+              <a:t>he</a:t>
+            </a:r>
+            <a:pPr indent="0" marL="0">
+              <a:lnSpc>
+                <a:spcPct val="115000"/>
+              </a:lnSpc>
+              <a:buNone/>
+            </a:pPr>
+            <a:r>
+              <a:rPr lang="en-US" sz="2200" dirty="0">
+                <a:solidFill>
+                  <a:srgbClr val="1B2A41"/>
+                </a:solidFill>
+                <a:latin typeface="Calibri" pitchFamily="34" charset="0"/>
+                <a:ea typeface="Calibri" pitchFamily="34" charset="-122"/>
+                <a:cs typeface="Calibri" pitchFamily="34" charset="-120"/>
+              </a:rPr>
+              <a:t> acquired some ideas which he put into practical application at once.</a:t>
+            </a:r>
+            <a:endParaRPr lang="en-US" sz="2200" dirty="0"/>
+          </a:p>
+        </p:txBody>
+      </p:sp>
+      <p:sp>
+        <p:nvSpPr>
+          <p:cNvPr id="8" name="Shape 6"/>
+          <p:cNvSpPr/>
+          <p:nvPr/>
+        </p:nvSpPr>
+        <p:spPr>
+          <a:xfrm>
+            <a:off x="548640" y="3566160"/>
+            <a:ext cx="5440680" cy="1554480"/>
+          </a:xfrm>
+          <a:prstGeom prst="roundRect">
+            <a:avLst>
+              <a:gd name="adj" fmla="val 4706"/>
+            </a:avLst>
+          </a:prstGeom>
+          <a:solidFill>
+            <a:srgbClr val="1B2A41"/>
+          </a:solidFill>
+          <a:ln/>
+        </p:spPr>
+      </p:sp>
+      <p:sp>
+        <p:nvSpPr>
+          <p:cNvPr id="9" name="Text 7"/>
+          <p:cNvSpPr/>
+          <p:nvPr/>
+        </p:nvSpPr>
+        <p:spPr>
+          <a:xfrm>
+            <a:off x="914400" y="3703320"/>
+            <a:ext cx="4709160" cy="256032"/>
+          </a:xfrm>
+          <a:prstGeom prst="rect">
+            <a:avLst/>
+          </a:prstGeom>
+          <a:noFill/>
+          <a:ln/>
+        </p:spPr>
+        <p:txBody>
+          <a:bodyPr wrap="square" lIns="0" tIns="0" rIns="0" bIns="0" rtlCol="0" anchor="ctr"/>
+          <a:lstStyle/>
+          <a:p>
+            <a:pPr indent="0" marL="0">
+              <a:buNone/>
+            </a:pPr>
+            <a:r>
+              <a:rPr lang="en-US" sz="1100" b="1" spc="200" kern="0" dirty="0">
+                <a:solidFill>
+                  <a:srgbClr val="A9B8CC"/>
+                </a:solidFill>
+                <a:latin typeface="Calibri" pitchFamily="34" charset="0"/>
+                <a:ea typeface="Calibri" pitchFamily="34" charset="-122"/>
+                <a:cs typeface="Calibri" pitchFamily="34" charset="-120"/>
+              </a:rPr>
+              <a:t>THIS HOSPITAL</a:t>
+            </a:r>
+            <a:endParaRPr lang="en-US" sz="1100" dirty="0"/>
+          </a:p>
+        </p:txBody>
+      </p:sp>
+      <p:sp>
+        <p:nvSpPr>
+          <p:cNvPr id="10" name="Text 8"/>
+          <p:cNvSpPr/>
+          <p:nvPr/>
+        </p:nvSpPr>
+        <p:spPr>
+          <a:xfrm>
+            <a:off x="914400" y="3977640"/>
+            <a:ext cx="4709160" cy="457200"/>
+          </a:xfrm>
+          <a:prstGeom prst="rect">
+            <a:avLst/>
+          </a:prstGeom>
+          <a:noFill/>
+          <a:ln/>
+        </p:spPr>
+        <p:txBody>
+          <a:bodyPr wrap="square" lIns="0" tIns="0" rIns="0" bIns="0" rtlCol="0" anchor="ctr"/>
+          <a:lstStyle/>
+          <a:p>
+            <a:pPr indent="0" marL="0">
+              <a:buNone/>
+            </a:pPr>
+            <a:r>
+              <a:rPr lang="en-US" sz="2400" b="1" dirty="0">
+                <a:solidFill>
+                  <a:srgbClr val="FFFFFF"/>
+                </a:solidFill>
+                <a:latin typeface="Cambria" pitchFamily="34" charset="0"/>
+                <a:ea typeface="Cambria" pitchFamily="34" charset="-122"/>
+                <a:cs typeface="Cambria" pitchFamily="34" charset="-120"/>
+              </a:rPr>
+              <a:t>Charles B. Towns Hospital</a:t>
+            </a:r>
+            <a:endParaRPr lang="en-US" sz="2400" dirty="0"/>
+          </a:p>
+        </p:txBody>
+      </p:sp>
+      <p:sp>
+        <p:nvSpPr>
+          <p:cNvPr id="11" name="Text 9"/>
+          <p:cNvSpPr/>
+          <p:nvPr/>
+        </p:nvSpPr>
+        <p:spPr>
+          <a:xfrm>
+            <a:off x="914400" y="4480560"/>
+            <a:ext cx="4709160" cy="502920"/>
+          </a:xfrm>
+          <a:prstGeom prst="rect">
+            <a:avLst/>
+          </a:prstGeom>
+          <a:noFill/>
+          <a:ln/>
+        </p:spPr>
+        <p:txBody>
+          <a:bodyPr wrap="square" lIns="0" tIns="0" rIns="0" bIns="0" rtlCol="0" anchor="t"/>
+          <a:lstStyle/>
+          <a:p>
+            <a:pPr indent="0" marL="0">
+              <a:lnSpc>
+                <a:spcPct val="115000"/>
+              </a:lnSpc>
+              <a:buNone/>
+            </a:pPr>
+            <a:r>
+              <a:rPr lang="en-US" sz="1400" dirty="0">
+                <a:solidFill>
+                  <a:srgbClr val="A9B8CC"/>
+                </a:solidFill>
+                <a:latin typeface="Calibri" pitchFamily="34" charset="0"/>
+                <a:ea typeface="Calibri" pitchFamily="34" charset="-122"/>
+                <a:cs typeface="Calibri" pitchFamily="34" charset="-120"/>
+              </a:rPr>
+              <a:t>293 Central Park West, New York City.</a:t>
+            </a:r>
+            <a:endParaRPr lang="en-US" sz="1400" dirty="0"/>
+          </a:p>
+        </p:txBody>
+      </p:sp>
+      <p:sp>
+        <p:nvSpPr>
+          <p:cNvPr id="12" name="Shape 10"/>
+          <p:cNvSpPr/>
+          <p:nvPr/>
+        </p:nvSpPr>
+        <p:spPr>
+          <a:xfrm>
+            <a:off x="6199632" y="3566160"/>
+            <a:ext cx="5440680" cy="1554480"/>
+          </a:xfrm>
+          <a:prstGeom prst="roundRect">
+            <a:avLst>
+              <a:gd name="adj" fmla="val 4706"/>
+            </a:avLst>
+          </a:prstGeom>
+          <a:solidFill>
+            <a:srgbClr val="1B2A41"/>
+          </a:solidFill>
+          <a:ln/>
+        </p:spPr>
+      </p:sp>
+      <p:sp>
+        <p:nvSpPr>
+          <p:cNvPr id="13" name="Text 11"/>
+          <p:cNvSpPr/>
+          <p:nvPr/>
+        </p:nvSpPr>
+        <p:spPr>
+          <a:xfrm>
+            <a:off x="6565392" y="3703320"/>
+            <a:ext cx="4709160" cy="256032"/>
+          </a:xfrm>
+          <a:prstGeom prst="rect">
+            <a:avLst/>
+          </a:prstGeom>
+          <a:noFill/>
+          <a:ln/>
+        </p:spPr>
+        <p:txBody>
+          <a:bodyPr wrap="square" lIns="0" tIns="0" rIns="0" bIns="0" rtlCol="0" anchor="ctr"/>
+          <a:lstStyle/>
+          <a:p>
+            <a:pPr indent="0" marL="0">
+              <a:buNone/>
+            </a:pPr>
+            <a:r>
+              <a:rPr lang="en-US" sz="1100" b="1" spc="200" kern="0" dirty="0">
+                <a:solidFill>
+                  <a:srgbClr val="A9B8CC"/>
+                </a:solidFill>
+                <a:latin typeface="Calibri" pitchFamily="34" charset="0"/>
+                <a:ea typeface="Calibri" pitchFamily="34" charset="-122"/>
+                <a:cs typeface="Calibri" pitchFamily="34" charset="-120"/>
+              </a:rPr>
+              <a:t>HE</a:t>
+            </a:r>
+            <a:endParaRPr lang="en-US" sz="1100" dirty="0"/>
+          </a:p>
+        </p:txBody>
+      </p:sp>
+      <p:sp>
+        <p:nvSpPr>
+          <p:cNvPr id="14" name="Text 12"/>
+          <p:cNvSpPr/>
+          <p:nvPr/>
+        </p:nvSpPr>
+        <p:spPr>
+          <a:xfrm>
+            <a:off x="6565392" y="3977640"/>
+            <a:ext cx="4709160" cy="457200"/>
+          </a:xfrm>
+          <a:prstGeom prst="rect">
+            <a:avLst/>
+          </a:prstGeom>
+          <a:noFill/>
+          <a:ln/>
+        </p:spPr>
+        <p:txBody>
+          <a:bodyPr wrap="square" lIns="0" tIns="0" rIns="0" bIns="0" rtlCol="0" anchor="ctr"/>
+          <a:lstStyle/>
+          <a:p>
+            <a:pPr indent="0" marL="0">
+              <a:buNone/>
+            </a:pPr>
+            <a:r>
+              <a:rPr lang="en-US" sz="2400" b="1" dirty="0">
+                <a:solidFill>
+                  <a:srgbClr val="FFFFFF"/>
+                </a:solidFill>
+                <a:latin typeface="Cambria" pitchFamily="34" charset="0"/>
+                <a:ea typeface="Cambria" pitchFamily="34" charset="-122"/>
+                <a:cs typeface="Cambria" pitchFamily="34" charset="-120"/>
+              </a:rPr>
+              <a:t>Bill W.</a:t>
+            </a:r>
+            <a:endParaRPr lang="en-US" sz="2400" dirty="0"/>
+          </a:p>
+        </p:txBody>
+      </p:sp>
+      <p:sp>
+        <p:nvSpPr>
+          <p:cNvPr id="15" name="Text 13"/>
+          <p:cNvSpPr/>
+          <p:nvPr/>
+        </p:nvSpPr>
+        <p:spPr>
+          <a:xfrm>
+            <a:off x="6565392" y="4480560"/>
+            <a:ext cx="4709160" cy="502920"/>
+          </a:xfrm>
+          <a:prstGeom prst="rect">
+            <a:avLst/>
+          </a:prstGeom>
+          <a:noFill/>
+          <a:ln/>
+        </p:spPr>
+        <p:txBody>
+          <a:bodyPr wrap="square" lIns="0" tIns="0" rIns="0" bIns="0" rtlCol="0" anchor="t"/>
+          <a:lstStyle/>
+          <a:p>
+            <a:pPr indent="0" marL="0">
+              <a:lnSpc>
+                <a:spcPct val="115000"/>
+              </a:lnSpc>
+              <a:buNone/>
+            </a:pPr>
+            <a:r>
+              <a:rPr lang="en-US" sz="1400" dirty="0">
+                <a:solidFill>
+                  <a:srgbClr val="A9B8CC"/>
+                </a:solidFill>
+                <a:latin typeface="Calibri" pitchFamily="34" charset="0"/>
+                <a:ea typeface="Calibri" pitchFamily="34" charset="-122"/>
+                <a:cs typeface="Calibri" pitchFamily="34" charset="-120"/>
+              </a:rPr>
+              <a:t>Admitted four times, 1933–34. Last drink 11 December 1934.</a:t>
+            </a:r>
+            <a:endParaRPr lang="en-US" sz="1400" dirty="0"/>
+          </a:p>
+        </p:txBody>
+      </p:sp>
+      <p:sp>
+        <p:nvSpPr>
+          <p:cNvPr id="16" name="Text 14"/>
+          <p:cNvSpPr/>
+          <p:nvPr/>
+        </p:nvSpPr>
+        <p:spPr>
+          <a:xfrm>
+            <a:off x="548640" y="5303520"/>
+            <a:ext cx="11091672" cy="292608"/>
+          </a:xfrm>
+          <a:prstGeom prst="rect">
+            <a:avLst/>
+          </a:prstGeom>
+          <a:noFill/>
+          <a:ln/>
+        </p:spPr>
+        <p:txBody>
+          <a:bodyPr wrap="square" lIns="0" tIns="0" rIns="0" bIns="0" rtlCol="0" anchor="ctr"/>
+          <a:lstStyle/>
+          <a:p>
+            <a:pPr indent="0" marL="0">
+              <a:buNone/>
+            </a:pPr>
+            <a:r>
+              <a:rPr lang="en-US" sz="1200" i="1" dirty="0">
+                <a:solidFill>
+                  <a:srgbClr val="6B7A8C"/>
+                </a:solidFill>
+                <a:latin typeface="Calibri" pitchFamily="34" charset="0"/>
+                <a:ea typeface="Calibri" pitchFamily="34" charset="-122"/>
+                <a:cs typeface="Calibri" pitchFamily="34" charset="-120"/>
+              </a:rPr>
+              <a:t>Alcoholics Anonymous</a:t>
+            </a:r>
+            <a:pPr indent="0" marL="0">
+              <a:buNone/>
+            </a:pPr>
+            <a:r>
+              <a:rPr lang="en-US" sz="1200" dirty="0">
+                <a:solidFill>
+                  <a:srgbClr val="6B7A8C"/>
+                </a:solidFill>
+                <a:latin typeface="Calibri" pitchFamily="34" charset="0"/>
+                <a:ea typeface="Calibri" pitchFamily="34" charset="-122"/>
+                <a:cs typeface="Calibri" pitchFamily="34" charset="-120"/>
+              </a:rPr>
+              <a:t>, 4th ed., “The Doctor’s Opinion,” p. xxiii.</a:t>
+            </a:r>
+            <a:endParaRPr lang="en-US" sz="1200" dirty="0"/>
+          </a:p>
+        </p:txBody>
+      </p:sp>
+      <p:sp>
+        <p:nvSpPr>
+          <p:cNvPr id="17" name="Text 15"/>
           <p:cNvSpPr/>
           <p:nvPr/>
         </p:nvSpPr>

</xml_diff>

<commit_message>
Add slides 24-28: The Doctor's Opinion, pp. xxiv-xxv
Craving as a physical phenomenon, the frothy-emotional-appeal must, the effect
produced by alcohol running across the page break, the psychic change, and the
three pink stretches where the doctor concedes medicine cannot do it.

'Psychic = thinking' rides with slide 27 - the word is circled three times across
the spread and glossed the same way each time. The 'Show Sheet' star is a
presenter cue rather than content, so it lives in slide 27's speaker notes until
we know what sheet it means.

Co-Authored-By: Claude Opus 5 <noreply@anthropic.com>
Claude-Session: https://claude.ai/code/session_01NuCgD3Z7aWvkQrsSvAUX4h
</commit_message>
<xml_diff>
--- a/aa-slideshow/aa-big-book-study.pptx
+++ b/aa-slideshow/aa-big-book-study.pptx
@@ -28,9 +28,14 @@
     <p:sldId id="276" r:id="rId22"/>
     <p:sldId id="277" r:id="rId23"/>
     <p:sldId id="278" r:id="rId24"/>
+    <p:sldId id="279" r:id="rId25"/>
+    <p:sldId id="280" r:id="rId26"/>
+    <p:sldId id="281" r:id="rId27"/>
+    <p:sldId id="282" r:id="rId28"/>
+    <p:sldId id="283" r:id="rId29"/>
   </p:sldIdLst>
   <p:notesMasterIdLst>
-    <p:notesMasterId r:id="rId25"/>
+    <p:notesMasterId r:id="rId30"/>
   </p:notesMasterIdLst>
   <p:sldSz cx="12192000" cy="6858000"/>
   <p:notesSz cx="6858000" cy="12192000"/>
@@ -1954,6 +1959,476 @@
             <a:fld id="{F7021451-1387-4CA6-816F-3879F97B5CBC}" type="slidenum">
               <a:rPr lang="en-US"/>
               <a:t>23</a:t>
+            </a:fld>
+            <a:endParaRPr lang="en-US"/>
+          </a:p>
+        </p:txBody>
+      </p:sp>
+    </p:spTree>
+    <p:extLst>
+      <p:ext uri="{BB962C8B-B14F-4D97-AF65-F5344CB8AC3E}">
+        <p14:creationId xmlns:p14="http://schemas.microsoft.com/office/powerpoint/2010/main" val="1024086991"/>
+      </p:ext>
+    </p:extLst>
+  </p:cSld>
+  <p:clrMapOvr>
+    <a:masterClrMapping/>
+  </p:clrMapOvr>
+</p:notes>
+</file>
+
+<file path=ppt/notesSlides/notesSlide24.xml><?xml version="1.0" encoding="utf-8"?>
+<p:notes xmlns:a="http://schemas.openxmlformats.org/drawingml/2006/main" xmlns:r="http://schemas.openxmlformats.org/officeDocument/2006/relationships" xmlns:p="http://schemas.openxmlformats.org/presentationml/2006/main">
+  <p:cSld>
+    <p:spTree>
+      <p:nvGrpSpPr>
+        <p:cNvPr id="1" name=""/>
+        <p:cNvGrpSpPr/>
+        <p:nvPr/>
+      </p:nvGrpSpPr>
+      <p:grpSpPr>
+        <a:xfrm>
+          <a:off x="0" y="0"/>
+          <a:ext cx="0" cy="0"/>
+          <a:chOff x="0" y="0"/>
+          <a:chExt cx="0" cy="0"/>
+        </a:xfrm>
+      </p:grpSpPr>
+      <p:sp>
+        <p:nvSpPr>
+          <p:cNvPr id="2" name="Slide Image Placeholder 1"/>
+          <p:cNvSpPr>
+            <a:spLocks noGrp="1" noRot="1" noChangeAspect="1"/>
+          </p:cNvSpPr>
+          <p:nvPr>
+            <p:ph type="sldImg"/>
+          </p:nvPr>
+        </p:nvSpPr>
+        <p:spPr/>
+      </p:sp>
+      <p:sp>
+        <p:nvSpPr>
+          <p:cNvPr id="3" name="Notes Placeholder 2"/>
+          <p:cNvSpPr>
+            <a:spLocks noGrp="1"/>
+          </p:cNvSpPr>
+          <p:nvPr>
+            <p:ph type="body" idx="1"/>
+          </p:nvPr>
+        </p:nvSpPr>
+        <p:spPr/>
+        <p:txBody>
+          <a:bodyPr/>
+          <a:lstStyle/>
+          <a:p>
+            <a:r>
+              <a:rPr lang="en-US" dirty="0"/>
+              <a:t>Craving in this book means the physical thing. Not wanting a drink - the body's reaction
+once alcohol is in it.
+And it is limited to this class. It never occurs in the average temperate drinker. That is
+why the normal drinker cannot understand us and why his advice never helps.
+Never safely use alcohol in any form at all. Not less. Not carefully. Not at all.
+Then watch the order of the collapse: form the habit, cannot break it, lose self-confidence,
+lose reliance upon things human. The problems pile up after that, not before.</a:t>
+            </a:r>
+            <a:endParaRPr lang="en-US" dirty="0"/>
+          </a:p>
+        </p:txBody>
+      </p:sp>
+      <p:sp>
+        <p:nvSpPr>
+          <p:cNvPr id="4" name="Slide Number Placeholder 3"/>
+          <p:cNvSpPr>
+            <a:spLocks noGrp="1"/>
+          </p:cNvSpPr>
+          <p:nvPr>
+            <p:ph type="sldNum" sz="quarter" idx="10"/>
+          </p:nvPr>
+        </p:nvSpPr>
+        <p:spPr/>
+        <p:txBody>
+          <a:bodyPr/>
+          <a:lstStyle/>
+          <a:p>
+            <a:fld id="{F7021451-1387-4CA6-816F-3879F97B5CBC}" type="slidenum">
+              <a:rPr lang="en-US"/>
+              <a:t>24</a:t>
+            </a:fld>
+            <a:endParaRPr lang="en-US"/>
+          </a:p>
+        </p:txBody>
+      </p:sp>
+    </p:spTree>
+    <p:extLst>
+      <p:ext uri="{BB962C8B-B14F-4D97-AF65-F5344CB8AC3E}">
+        <p14:creationId xmlns:p14="http://schemas.microsoft.com/office/powerpoint/2010/main" val="1024086991"/>
+      </p:ext>
+    </p:extLst>
+  </p:cSld>
+  <p:clrMapOvr>
+    <a:masterClrMapping/>
+  </p:clrMapOvr>
+</p:notes>
+</file>
+
+<file path=ppt/notesSlides/notesSlide25.xml><?xml version="1.0" encoding="utf-8"?>
+<p:notes xmlns:a="http://schemas.openxmlformats.org/drawingml/2006/main" xmlns:r="http://schemas.openxmlformats.org/officeDocument/2006/relationships" xmlns:p="http://schemas.openxmlformats.org/presentationml/2006/main">
+  <p:cSld>
+    <p:spTree>
+      <p:nvGrpSpPr>
+        <p:cNvPr id="1" name=""/>
+        <p:cNvGrpSpPr/>
+        <p:nvPr/>
+      </p:nvGrpSpPr>
+      <p:grpSpPr>
+        <a:xfrm>
+          <a:off x="0" y="0"/>
+          <a:ext cx="0" cy="0"/>
+          <a:chOff x="0" y="0"/>
+          <a:chExt cx="0" cy="0"/>
+        </a:xfrm>
+      </p:grpSpPr>
+      <p:sp>
+        <p:nvSpPr>
+          <p:cNvPr id="2" name="Slide Image Placeholder 1"/>
+          <p:cNvSpPr>
+            <a:spLocks noGrp="1" noRot="1" noChangeAspect="1"/>
+          </p:cNvSpPr>
+          <p:nvPr>
+            <p:ph type="sldImg"/>
+          </p:nvPr>
+        </p:nvSpPr>
+        <p:spPr/>
+      </p:sp>
+      <p:sp>
+        <p:nvSpPr>
+          <p:cNvPr id="3" name="Notes Placeholder 2"/>
+          <p:cNvSpPr>
+            <a:spLocks noGrp="1"/>
+          </p:cNvSpPr>
+          <p:nvPr>
+            <p:ph type="body" idx="1"/>
+          </p:nvPr>
+        </p:nvSpPr>
+        <p:spPr/>
+        <p:txBody>
+          <a:bodyPr/>
+          <a:lstStyle/>
+          <a:p>
+            <a:r>
+              <a:rPr lang="en-US" dirty="0"/>
+              <a:t>Frothy emotional appeal seldom suffices. A doctor wrote that, about pep talks and
+sentiment and getting people fired up. It does not hold.
+Depth and weight. That is what he says the message needs, and it is why this book reads
+the way it does rather than like a motivational pamphlet.
+And there is Step Two, stated by a physician in the front matter: a power greater than
+themselves. Re-create their lives - not improve, not manage. Re-create.</a:t>
+            </a:r>
+            <a:endParaRPr lang="en-US" dirty="0"/>
+          </a:p>
+        </p:txBody>
+      </p:sp>
+      <p:sp>
+        <p:nvSpPr>
+          <p:cNvPr id="4" name="Slide Number Placeholder 3"/>
+          <p:cNvSpPr>
+            <a:spLocks noGrp="1"/>
+          </p:cNvSpPr>
+          <p:nvPr>
+            <p:ph type="sldNum" sz="quarter" idx="10"/>
+          </p:nvPr>
+        </p:nvSpPr>
+        <p:spPr/>
+        <p:txBody>
+          <a:bodyPr/>
+          <a:lstStyle/>
+          <a:p>
+            <a:fld id="{F7021451-1387-4CA6-816F-3879F97B5CBC}" type="slidenum">
+              <a:rPr lang="en-US"/>
+              <a:t>25</a:t>
+            </a:fld>
+            <a:endParaRPr lang="en-US"/>
+          </a:p>
+        </p:txBody>
+      </p:sp>
+    </p:spTree>
+    <p:extLst>
+      <p:ext uri="{BB962C8B-B14F-4D97-AF65-F5344CB8AC3E}">
+        <p14:creationId xmlns:p14="http://schemas.microsoft.com/office/powerpoint/2010/main" val="1024086991"/>
+      </p:ext>
+    </p:extLst>
+  </p:cSld>
+  <p:clrMapOvr>
+    <a:masterClrMapping/>
+  </p:clrMapOvr>
+</p:notes>
+</file>
+
+<file path=ppt/notesSlides/notesSlide26.xml><?xml version="1.0" encoding="utf-8"?>
+<p:notes xmlns:a="http://schemas.openxmlformats.org/drawingml/2006/main" xmlns:r="http://schemas.openxmlformats.org/officeDocument/2006/relationships" xmlns:p="http://schemas.openxmlformats.org/presentationml/2006/main">
+  <p:cSld>
+    <p:spTree>
+      <p:nvGrpSpPr>
+        <p:cNvPr id="1" name=""/>
+        <p:cNvGrpSpPr/>
+        <p:nvPr/>
+      </p:nvGrpSpPr>
+      <p:grpSpPr>
+        <a:xfrm>
+          <a:off x="0" y="0"/>
+          <a:ext cx="0" cy="0"/>
+          <a:chOff x="0" y="0"/>
+          <a:chExt cx="0" cy="0"/>
+        </a:xfrm>
+      </p:grpSpPr>
+      <p:sp>
+        <p:nvSpPr>
+          <p:cNvPr id="2" name="Slide Image Placeholder 1"/>
+          <p:cNvSpPr>
+            <a:spLocks noGrp="1" noRot="1" noChangeAspect="1"/>
+          </p:cNvSpPr>
+          <p:nvPr>
+            <p:ph type="sldImg"/>
+          </p:nvPr>
+        </p:nvSpPr>
+        <p:spPr/>
+      </p:sp>
+      <p:sp>
+        <p:nvSpPr>
+          <p:cNvPr id="3" name="Notes Placeholder 2"/>
+          <p:cNvSpPr>
+            <a:spLocks noGrp="1"/>
+          </p:cNvSpPr>
+          <p:nvPr>
+            <p:ph type="body" idx="1"/>
+          </p:nvPr>
+        </p:nvSpPr>
+        <p:spPr/>
+        <p:txBody>
+          <a:bodyPr/>
+          <a:lstStyle/>
+          <a:p>
+            <a:r>
+              <a:rPr lang="en-US" dirty="0"/>
+              <a:t>Not because of the wife, the job, the childhood. Because they like the effect. Start there.
+Cannot differentiate the true from the false - he is describing a man who no longer knows
+which of his own thoughts to trust.
+Restless, irritable and discontented. Anyone who has been around a while can say that line
+from memory, and it is in a doctor's letter before page 1.
+And the last clause is the whole trouble: drinks which they see others taking with impunity.</a:t>
+            </a:r>
+            <a:endParaRPr lang="en-US" dirty="0"/>
+          </a:p>
+        </p:txBody>
+      </p:sp>
+      <p:sp>
+        <p:nvSpPr>
+          <p:cNvPr id="4" name="Slide Number Placeholder 3"/>
+          <p:cNvSpPr>
+            <a:spLocks noGrp="1"/>
+          </p:cNvSpPr>
+          <p:nvPr>
+            <p:ph type="sldNum" sz="quarter" idx="10"/>
+          </p:nvPr>
+        </p:nvSpPr>
+        <p:spPr/>
+        <p:txBody>
+          <a:bodyPr/>
+          <a:lstStyle/>
+          <a:p>
+            <a:fld id="{F7021451-1387-4CA6-816F-3879F97B5CBC}" type="slidenum">
+              <a:rPr lang="en-US"/>
+              <a:t>26</a:t>
+            </a:fld>
+            <a:endParaRPr lang="en-US"/>
+          </a:p>
+        </p:txBody>
+      </p:sp>
+    </p:spTree>
+    <p:extLst>
+      <p:ext uri="{BB962C8B-B14F-4D97-AF65-F5344CB8AC3E}">
+        <p14:creationId xmlns:p14="http://schemas.microsoft.com/office/powerpoint/2010/main" val="1024086991"/>
+      </p:ext>
+    </p:extLst>
+  </p:cSld>
+  <p:clrMapOvr>
+    <a:masterClrMapping/>
+  </p:clrMapOvr>
+</p:notes>
+</file>
+
+<file path=ppt/notesSlides/notesSlide27.xml><?xml version="1.0" encoding="utf-8"?>
+<p:notes xmlns:a="http://schemas.openxmlformats.org/drawingml/2006/main" xmlns:r="http://schemas.openxmlformats.org/officeDocument/2006/relationships" xmlns:p="http://schemas.openxmlformats.org/presentationml/2006/main">
+  <p:cSld>
+    <p:spTree>
+      <p:nvGrpSpPr>
+        <p:cNvPr id="1" name=""/>
+        <p:cNvGrpSpPr/>
+        <p:nvPr/>
+      </p:nvGrpSpPr>
+      <p:grpSpPr>
+        <a:xfrm>
+          <a:off x="0" y="0"/>
+          <a:ext cx="0" cy="0"/>
+          <a:chOff x="0" y="0"/>
+          <a:chExt cx="0" cy="0"/>
+        </a:xfrm>
+      </p:grpSpPr>
+      <p:sp>
+        <p:nvSpPr>
+          <p:cNvPr id="2" name="Slide Image Placeholder 1"/>
+          <p:cNvSpPr>
+            <a:spLocks noGrp="1" noRot="1" noChangeAspect="1"/>
+          </p:cNvSpPr>
+          <p:nvPr>
+            <p:ph type="sldImg"/>
+          </p:nvPr>
+        </p:nvSpPr>
+        <p:spPr/>
+      </p:sp>
+      <p:sp>
+        <p:nvSpPr>
+          <p:cNvPr id="3" name="Notes Placeholder 2"/>
+          <p:cNvSpPr>
+            <a:spLocks noGrp="1"/>
+          </p:cNvSpPr>
+          <p:nvPr>
+            <p:ph type="body" idx="1"/>
+          </p:nvPr>
+        </p:nvSpPr>
+        <p:spPr/>
+        <p:txBody>
+          <a:bodyPr/>
+          <a:lstStyle/>
+          <a:p>
+            <a:r>
+              <a:rPr lang="en-US" dirty="0"/>
+              <a:t>SHOW SHEET here - that is the star in the margin.
+Psychic change means a change in thinking. Circled three times on this page in the study
+copy, so it is worth saying out loud: not mystical, not spooky. Thinking.
+The cycle first: succumb, craving develops, the spree runs its stages, remorse, firm
+resolution. Repeated over and over. Everyone in this room has run that lap.
+The resolution is not the way out. An entire change in thinking is. And on the next page
+Silkworth says that once it happens, the man who seemed doomed finds he can follow a few
+simple rules.</a:t>
+            </a:r>
+            <a:endParaRPr lang="en-US" dirty="0"/>
+          </a:p>
+        </p:txBody>
+      </p:sp>
+      <p:sp>
+        <p:nvSpPr>
+          <p:cNvPr id="4" name="Slide Number Placeholder 3"/>
+          <p:cNvSpPr>
+            <a:spLocks noGrp="1"/>
+          </p:cNvSpPr>
+          <p:nvPr>
+            <p:ph type="sldNum" sz="quarter" idx="10"/>
+          </p:nvPr>
+        </p:nvSpPr>
+        <p:spPr/>
+        <p:txBody>
+          <a:bodyPr/>
+          <a:lstStyle/>
+          <a:p>
+            <a:fld id="{F7021451-1387-4CA6-816F-3879F97B5CBC}" type="slidenum">
+              <a:rPr lang="en-US"/>
+              <a:t>27</a:t>
+            </a:fld>
+            <a:endParaRPr lang="en-US"/>
+          </a:p>
+        </p:txBody>
+      </p:sp>
+    </p:spTree>
+    <p:extLst>
+      <p:ext uri="{BB962C8B-B14F-4D97-AF65-F5344CB8AC3E}">
+        <p14:creationId xmlns:p14="http://schemas.microsoft.com/office/powerpoint/2010/main" val="1024086991"/>
+      </p:ext>
+    </p:extLst>
+  </p:cSld>
+  <p:clrMapOvr>
+    <a:masterClrMapping/>
+  </p:clrMapOvr>
+</p:notes>
+</file>
+
+<file path=ppt/notesSlides/notesSlide28.xml><?xml version="1.0" encoding="utf-8"?>
+<p:notes xmlns:a="http://schemas.openxmlformats.org/drawingml/2006/main" xmlns:r="http://schemas.openxmlformats.org/officeDocument/2006/relationships" xmlns:p="http://schemas.openxmlformats.org/presentationml/2006/main">
+  <p:cSld>
+    <p:spTree>
+      <p:nvGrpSpPr>
+        <p:cNvPr id="1" name=""/>
+        <p:cNvGrpSpPr/>
+        <p:nvPr/>
+      </p:nvGrpSpPr>
+      <p:grpSpPr>
+        <a:xfrm>
+          <a:off x="0" y="0"/>
+          <a:ext cx="0" cy="0"/>
+          <a:chOff x="0" y="0"/>
+          <a:chExt cx="0" cy="0"/>
+        </a:xfrm>
+      </p:grpSpPr>
+      <p:sp>
+        <p:nvSpPr>
+          <p:cNvPr id="2" name="Slide Image Placeholder 1"/>
+          <p:cNvSpPr>
+            <a:spLocks noGrp="1" noRot="1" noChangeAspect="1"/>
+          </p:cNvSpPr>
+          <p:nvPr>
+            <p:ph type="sldImg"/>
+          </p:nvPr>
+        </p:nvSpPr>
+        <p:spPr/>
+      </p:sp>
+      <p:sp>
+        <p:nvSpPr>
+          <p:cNvPr id="3" name="Notes Placeholder 2"/>
+          <p:cNvSpPr>
+            <a:spLocks noGrp="1"/>
+          </p:cNvSpPr>
+          <p:nvPr>
+            <p:ph type="body" idx="1"/>
+          </p:nvPr>
+        </p:nvSpPr>
+        <p:spPr/>
+        <p:txBody>
+          <a:bodyPr/>
+          <a:lstStyle/>
+          <a:p>
+            <a:r>
+              <a:rPr lang="en-US" dirty="0"/>
+              <a:t>Three musts, and all three are the doctor admitting he is beaten.
+First, the patient: I must stop, but I cannot. That sentence is Step One in a man's own
+words, said to a doctor, years before there were Steps.
+Second, the physician: if he is honest with himself, he must sometimes feel his own
+inadequacy. He gives all that is in him and it often is not enough.
+Third: we physicians must admit we have made little impression upon the problem as a whole.
+That is the man who signed this letter, with a hospital and thousands of cases behind him,
+saying medicine could not do it. Something more than human power is needed.</a:t>
+            </a:r>
+            <a:endParaRPr lang="en-US" dirty="0"/>
+          </a:p>
+        </p:txBody>
+      </p:sp>
+      <p:sp>
+        <p:nvSpPr>
+          <p:cNvPr id="4" name="Slide Number Placeholder 3"/>
+          <p:cNvSpPr>
+            <a:spLocks noGrp="1"/>
+          </p:cNvSpPr>
+          <p:nvPr>
+            <p:ph type="sldNum" sz="quarter" idx="10"/>
+          </p:nvPr>
+        </p:nvSpPr>
+        <p:spPr/>
+        <p:txBody>
+          <a:bodyPr/>
+          <a:lstStyle/>
+          <a:p>
+            <a:fld id="{F7021451-1387-4CA6-816F-3879F97B5CBC}" type="slidenum">
+              <a:rPr lang="en-US"/>
+              <a:t>28</a:t>
             </a:fld>
             <a:endParaRPr lang="en-US"/>
           </a:p>
@@ -12561,6 +13036,2799 @@
 </p:sld>
 </file>
 
+<file path=ppt/slides/slide24.xml><?xml version="1.0" encoding="utf-8"?>
+<p:sld xmlns:a="http://schemas.openxmlformats.org/drawingml/2006/main" xmlns:r="http://schemas.openxmlformats.org/officeDocument/2006/relationships" xmlns:p="http://schemas.openxmlformats.org/presentationml/2006/main">
+  <p:cSld name="Slide 24">
+    <p:bg>
+      <p:bgPr>
+        <a:solidFill>
+          <a:srgbClr val="FFFFFF"/>
+        </a:solidFill>
+      </p:bgPr>
+    </p:bg>
+    <p:spTree>
+      <p:nvGrpSpPr>
+        <p:cNvPr id="1" name=""/>
+        <p:cNvGrpSpPr/>
+        <p:nvPr/>
+      </p:nvGrpSpPr>
+      <p:grpSpPr>
+        <a:xfrm>
+          <a:off x="0" y="0"/>
+          <a:ext cx="0" cy="0"/>
+          <a:chOff x="0" y="0"/>
+          <a:chExt cx="0" cy="0"/>
+        </a:xfrm>
+      </p:grpSpPr>
+      <p:sp>
+        <p:nvSpPr>
+          <p:cNvPr id="2" name="Text 0"/>
+          <p:cNvSpPr/>
+          <p:nvPr/>
+        </p:nvSpPr>
+        <p:spPr>
+          <a:xfrm>
+            <a:off x="548640" y="320040"/>
+            <a:ext cx="8138160" cy="566928"/>
+          </a:xfrm>
+          <a:prstGeom prst="rect">
+            <a:avLst/>
+          </a:prstGeom>
+          <a:noFill/>
+          <a:ln/>
+        </p:spPr>
+        <p:txBody>
+          <a:bodyPr wrap="square" lIns="0" tIns="0" rIns="0" bIns="0" rtlCol="0" anchor="ctr"/>
+          <a:lstStyle/>
+          <a:p>
+            <a:pPr indent="0" marL="0">
+              <a:buNone/>
+            </a:pPr>
+            <a:r>
+              <a:rPr lang="en-US" sz="3800" b="1" dirty="0">
+                <a:solidFill>
+                  <a:srgbClr val="1B2A41"/>
+                </a:solidFill>
+                <a:latin typeface="Cambria" pitchFamily="34" charset="0"/>
+                <a:ea typeface="Cambria" pitchFamily="34" charset="-122"/>
+                <a:cs typeface="Cambria" pitchFamily="34" charset="-120"/>
+              </a:rPr>
+              <a:t>The Phenomenon of Craving</a:t>
+            </a:r>
+            <a:endParaRPr lang="en-US" sz="3800" dirty="0"/>
+          </a:p>
+        </p:txBody>
+      </p:sp>
+      <p:sp>
+        <p:nvSpPr>
+          <p:cNvPr id="3" name="Text 1"/>
+          <p:cNvSpPr/>
+          <p:nvPr/>
+        </p:nvSpPr>
+        <p:spPr>
+          <a:xfrm>
+            <a:off x="548640" y="914400"/>
+            <a:ext cx="8138160" cy="347472"/>
+          </a:xfrm>
+          <a:prstGeom prst="rect">
+            <a:avLst/>
+          </a:prstGeom>
+          <a:noFill/>
+          <a:ln/>
+        </p:spPr>
+        <p:txBody>
+          <a:bodyPr wrap="square" lIns="0" tIns="0" rIns="0" bIns="0" rtlCol="0" anchor="ctr"/>
+          <a:lstStyle/>
+          <a:p>
+            <a:pPr indent="0" marL="0">
+              <a:buNone/>
+            </a:pPr>
+            <a:r>
+              <a:rPr lang="en-US" sz="1700" i="1" dirty="0">
+                <a:solidFill>
+                  <a:srgbClr val="6B7A8C"/>
+                </a:solidFill>
+                <a:latin typeface="Calibri" pitchFamily="34" charset="0"/>
+                <a:ea typeface="Calibri" pitchFamily="34" charset="-122"/>
+                <a:cs typeface="Calibri" pitchFamily="34" charset="-120"/>
+              </a:rPr>
+              <a:t>A manifestation of an allergy.</a:t>
+            </a:r>
+            <a:endParaRPr lang="en-US" sz="1700" dirty="0"/>
+          </a:p>
+        </p:txBody>
+      </p:sp>
+      <p:sp>
+        <p:nvSpPr>
+          <p:cNvPr id="4" name="Shape 2"/>
+          <p:cNvSpPr/>
+          <p:nvPr/>
+        </p:nvSpPr>
+        <p:spPr>
+          <a:xfrm>
+            <a:off x="8869680" y="320040"/>
+            <a:ext cx="2770632" cy="960120"/>
+          </a:xfrm>
+          <a:prstGeom prst="roundRect">
+            <a:avLst>
+              <a:gd name="adj" fmla="val 9524"/>
+            </a:avLst>
+          </a:prstGeom>
+          <a:solidFill>
+            <a:srgbClr val="2C5F2D"/>
+          </a:solidFill>
+          <a:ln/>
+        </p:spPr>
+      </p:sp>
+      <p:sp>
+        <p:nvSpPr>
+          <p:cNvPr id="5" name="Text 3"/>
+          <p:cNvSpPr/>
+          <p:nvPr/>
+        </p:nvSpPr>
+        <p:spPr>
+          <a:xfrm>
+            <a:off x="8869680" y="320040"/>
+            <a:ext cx="2770632" cy="960120"/>
+          </a:xfrm>
+          <a:prstGeom prst="rect">
+            <a:avLst/>
+          </a:prstGeom>
+          <a:noFill/>
+          <a:ln/>
+        </p:spPr>
+        <p:txBody>
+          <a:bodyPr wrap="square" lIns="0" tIns="0" rIns="0" bIns="0" rtlCol="0" anchor="ctr"/>
+          <a:lstStyle/>
+          <a:p>
+            <a:pPr algn="ctr" indent="0" marL="0">
+              <a:buNone/>
+            </a:pPr>
+            <a:r>
+              <a:rPr lang="en-US" sz="1700" b="1" spc="100" kern="0" dirty="0">
+                <a:solidFill>
+                  <a:srgbClr val="FFFFFF"/>
+                </a:solidFill>
+                <a:latin typeface="Cambria" pitchFamily="34" charset="0"/>
+                <a:ea typeface="Cambria" pitchFamily="34" charset="-122"/>
+                <a:cs typeface="Cambria" pitchFamily="34" charset="-120"/>
+              </a:rPr>
+              <a:t>THE BIG BOOK</a:t>
+            </a:r>
+            <a:endParaRPr lang="en-US" sz="1700" dirty="0"/>
+          </a:p>
+          <a:p>
+            <a:pPr algn="ctr" indent="0" marL="0">
+              <a:buNone/>
+            </a:pPr>
+            <a:r>
+              <a:rPr lang="en-US" sz="1300" dirty="0">
+                <a:solidFill>
+                  <a:srgbClr val="D5E3CE"/>
+                </a:solidFill>
+                <a:latin typeface="Calibri" pitchFamily="34" charset="0"/>
+                <a:ea typeface="Calibri" pitchFamily="34" charset="-122"/>
+                <a:cs typeface="Calibri" pitchFamily="34" charset="-120"/>
+              </a:rPr>
+              <a:t>p. xxiv</a:t>
+            </a:r>
+            <a:endParaRPr lang="en-US" sz="1700" dirty="0"/>
+          </a:p>
+        </p:txBody>
+      </p:sp>
+      <p:sp>
+        <p:nvSpPr>
+          <p:cNvPr id="6" name="Shape 4"/>
+          <p:cNvSpPr/>
+          <p:nvPr/>
+        </p:nvSpPr>
+        <p:spPr>
+          <a:xfrm>
+            <a:off x="548640" y="1417320"/>
+            <a:ext cx="11091672" cy="1371600"/>
+          </a:xfrm>
+          <a:prstGeom prst="roundRect">
+            <a:avLst>
+              <a:gd name="adj" fmla="val 5333"/>
+            </a:avLst>
+          </a:prstGeom>
+          <a:solidFill>
+            <a:srgbClr val="EAF1E6"/>
+          </a:solidFill>
+          <a:ln/>
+        </p:spPr>
+      </p:sp>
+      <p:sp>
+        <p:nvSpPr>
+          <p:cNvPr id="7" name="Text 5"/>
+          <p:cNvSpPr/>
+          <p:nvPr/>
+        </p:nvSpPr>
+        <p:spPr>
+          <a:xfrm>
+            <a:off x="914400" y="1417320"/>
+            <a:ext cx="10360152" cy="1371600"/>
+          </a:xfrm>
+          <a:prstGeom prst="rect">
+            <a:avLst/>
+          </a:prstGeom>
+          <a:noFill/>
+          <a:ln/>
+        </p:spPr>
+        <p:txBody>
+          <a:bodyPr wrap="square" lIns="0" tIns="0" rIns="0" bIns="0" rtlCol="0" anchor="ctr"/>
+          <a:lstStyle/>
+          <a:p>
+            <a:pPr indent="0" marL="0">
+              <a:lnSpc>
+                <a:spcPct val="115000"/>
+              </a:lnSpc>
+              <a:buNone/>
+            </a:pPr>
+            <a:r>
+              <a:rPr lang="en-US" sz="1900" dirty="0">
+                <a:solidFill>
+                  <a:srgbClr val="1B2A41"/>
+                </a:solidFill>
+                <a:latin typeface="Calibri" pitchFamily="34" charset="0"/>
+                <a:ea typeface="Calibri" pitchFamily="34" charset="-122"/>
+                <a:cs typeface="Calibri" pitchFamily="34" charset="-120"/>
+              </a:rPr>
+              <a:t>We believe, and so suggested a few years ago, that the action of alcohol on these chronic alcoholics is a manifestation of an allergy; that the </a:t>
+            </a:r>
+            <a:pPr indent="0" marL="0">
+              <a:lnSpc>
+                <a:spcPct val="115000"/>
+              </a:lnSpc>
+              <a:buNone/>
+            </a:pPr>
+            <a:r>
+              <a:rPr lang="en-US" sz="1900" b="1" dirty="0">
+                <a:solidFill>
+                  <a:srgbClr val="2C5F2D"/>
+                </a:solidFill>
+                <a:latin typeface="Calibri" pitchFamily="34" charset="0"/>
+                <a:ea typeface="Calibri" pitchFamily="34" charset="-122"/>
+                <a:cs typeface="Calibri" pitchFamily="34" charset="-120"/>
+              </a:rPr>
+              <a:t>phenomenon of craving is limited to this class</a:t>
+            </a:r>
+            <a:pPr indent="0" marL="0">
+              <a:lnSpc>
+                <a:spcPct val="115000"/>
+              </a:lnSpc>
+              <a:buNone/>
+            </a:pPr>
+            <a:r>
+              <a:rPr lang="en-US" sz="1900" dirty="0">
+                <a:solidFill>
+                  <a:srgbClr val="1B2A41"/>
+                </a:solidFill>
+                <a:latin typeface="Calibri" pitchFamily="34" charset="0"/>
+                <a:ea typeface="Calibri" pitchFamily="34" charset="-122"/>
+                <a:cs typeface="Calibri" pitchFamily="34" charset="-120"/>
+              </a:rPr>
+              <a:t> and never occurs in the average temperate drinker.</a:t>
+            </a:r>
+            <a:endParaRPr lang="en-US" sz="1900" dirty="0"/>
+          </a:p>
+        </p:txBody>
+      </p:sp>
+      <p:sp>
+        <p:nvSpPr>
+          <p:cNvPr id="8" name="Shape 6"/>
+          <p:cNvSpPr/>
+          <p:nvPr/>
+        </p:nvSpPr>
+        <p:spPr>
+          <a:xfrm>
+            <a:off x="548640" y="2971800"/>
+            <a:ext cx="11091672" cy="1554480"/>
+          </a:xfrm>
+          <a:prstGeom prst="roundRect">
+            <a:avLst>
+              <a:gd name="adj" fmla="val 4706"/>
+            </a:avLst>
+          </a:prstGeom>
+          <a:solidFill>
+            <a:srgbClr val="E2EDF4"/>
+          </a:solidFill>
+          <a:ln/>
+        </p:spPr>
+      </p:sp>
+      <p:sp>
+        <p:nvSpPr>
+          <p:cNvPr id="9" name="Text 7"/>
+          <p:cNvSpPr/>
+          <p:nvPr/>
+        </p:nvSpPr>
+        <p:spPr>
+          <a:xfrm>
+            <a:off x="914400" y="2971800"/>
+            <a:ext cx="10360152" cy="1554480"/>
+          </a:xfrm>
+          <a:prstGeom prst="rect">
+            <a:avLst/>
+          </a:prstGeom>
+          <a:noFill/>
+          <a:ln/>
+        </p:spPr>
+        <p:txBody>
+          <a:bodyPr wrap="square" lIns="0" tIns="0" rIns="0" bIns="0" rtlCol="0" anchor="ctr"/>
+          <a:lstStyle/>
+          <a:p>
+            <a:pPr indent="0" marL="0">
+              <a:lnSpc>
+                <a:spcPct val="115000"/>
+              </a:lnSpc>
+              <a:buNone/>
+            </a:pPr>
+            <a:r>
+              <a:rPr lang="en-US" sz="1900" dirty="0">
+                <a:solidFill>
+                  <a:srgbClr val="1B2A41"/>
+                </a:solidFill>
+                <a:latin typeface="Calibri" pitchFamily="34" charset="0"/>
+                <a:ea typeface="Calibri" pitchFamily="34" charset="-122"/>
+                <a:cs typeface="Calibri" pitchFamily="34" charset="-120"/>
+              </a:rPr>
+              <a:t>These allergic types can </a:t>
+            </a:r>
+            <a:pPr indent="0" marL="0">
+              <a:lnSpc>
+                <a:spcPct val="115000"/>
+              </a:lnSpc>
+              <a:buNone/>
+            </a:pPr>
+            <a:r>
+              <a:rPr lang="en-US" sz="1900" b="1" dirty="0">
+                <a:solidFill>
+                  <a:srgbClr val="065A82"/>
+                </a:solidFill>
+                <a:latin typeface="Calibri" pitchFamily="34" charset="0"/>
+                <a:ea typeface="Calibri" pitchFamily="34" charset="-122"/>
+                <a:cs typeface="Calibri" pitchFamily="34" charset="-120"/>
+              </a:rPr>
+              <a:t>never safely use alcohol in any form at all</a:t>
+            </a:r>
+            <a:pPr indent="0" marL="0">
+              <a:lnSpc>
+                <a:spcPct val="115000"/>
+              </a:lnSpc>
+              <a:buNone/>
+            </a:pPr>
+            <a:r>
+              <a:rPr lang="en-US" sz="1900" dirty="0">
+                <a:solidFill>
+                  <a:srgbClr val="1B2A41"/>
+                </a:solidFill>
+                <a:latin typeface="Calibri" pitchFamily="34" charset="0"/>
+                <a:ea typeface="Calibri" pitchFamily="34" charset="-122"/>
+                <a:cs typeface="Calibri" pitchFamily="34" charset="-120"/>
+              </a:rPr>
+              <a:t>; and once having formed the habit and found they cannot break it, once having lost their self-confidence, their reliance upon things human, their problems pile up on them and become astonishingly difficult to solve.</a:t>
+            </a:r>
+            <a:endParaRPr lang="en-US" sz="1900" dirty="0"/>
+          </a:p>
+        </p:txBody>
+      </p:sp>
+      <p:sp>
+        <p:nvSpPr>
+          <p:cNvPr id="10" name="Shape 8"/>
+          <p:cNvSpPr/>
+          <p:nvPr/>
+        </p:nvSpPr>
+        <p:spPr>
+          <a:xfrm>
+            <a:off x="548640" y="4754880"/>
+            <a:ext cx="11091672" cy="868680"/>
+          </a:xfrm>
+          <a:prstGeom prst="roundRect">
+            <a:avLst>
+              <a:gd name="adj" fmla="val 8421"/>
+            </a:avLst>
+          </a:prstGeom>
+          <a:solidFill>
+            <a:srgbClr val="1B2A41"/>
+          </a:solidFill>
+          <a:ln/>
+        </p:spPr>
+      </p:sp>
+      <p:sp>
+        <p:nvSpPr>
+          <p:cNvPr id="11" name="Text 9"/>
+          <p:cNvSpPr/>
+          <p:nvPr/>
+        </p:nvSpPr>
+        <p:spPr>
+          <a:xfrm>
+            <a:off x="914400" y="4873752"/>
+            <a:ext cx="10360152" cy="256032"/>
+          </a:xfrm>
+          <a:prstGeom prst="rect">
+            <a:avLst/>
+          </a:prstGeom>
+          <a:noFill/>
+          <a:ln/>
+        </p:spPr>
+        <p:txBody>
+          <a:bodyPr wrap="square" lIns="0" tIns="0" rIns="0" bIns="0" rtlCol="0" anchor="ctr"/>
+          <a:lstStyle/>
+          <a:p>
+            <a:pPr indent="0" marL="0">
+              <a:buNone/>
+            </a:pPr>
+            <a:r>
+              <a:rPr lang="en-US" sz="1100" b="1" spc="200" kern="0" dirty="0">
+                <a:solidFill>
+                  <a:srgbClr val="A9B8CC"/>
+                </a:solidFill>
+                <a:latin typeface="Calibri" pitchFamily="34" charset="0"/>
+                <a:ea typeface="Calibri" pitchFamily="34" charset="-122"/>
+                <a:cs typeface="Calibri" pitchFamily="34" charset="-120"/>
+              </a:rPr>
+              <a:t>MARGIN NOTE</a:t>
+            </a:r>
+            <a:endParaRPr lang="en-US" sz="1100" dirty="0"/>
+          </a:p>
+        </p:txBody>
+      </p:sp>
+      <p:sp>
+        <p:nvSpPr>
+          <p:cNvPr id="12" name="Text 10"/>
+          <p:cNvSpPr/>
+          <p:nvPr/>
+        </p:nvSpPr>
+        <p:spPr>
+          <a:xfrm>
+            <a:off x="914400" y="5148072"/>
+            <a:ext cx="10360152" cy="356616"/>
+          </a:xfrm>
+          <a:prstGeom prst="rect">
+            <a:avLst/>
+          </a:prstGeom>
+          <a:noFill/>
+          <a:ln/>
+        </p:spPr>
+        <p:txBody>
+          <a:bodyPr wrap="square" lIns="0" tIns="0" rIns="0" bIns="0" rtlCol="0" anchor="ctr"/>
+          <a:lstStyle/>
+          <a:p>
+            <a:pPr indent="0" marL="0">
+              <a:buNone/>
+            </a:pPr>
+            <a:r>
+              <a:rPr lang="en-US" sz="2200" b="1" dirty="0">
+                <a:solidFill>
+                  <a:srgbClr val="FFFFFF"/>
+                </a:solidFill>
+                <a:latin typeface="Cambria" pitchFamily="34" charset="0"/>
+                <a:ea typeface="Cambria" pitchFamily="34" charset="-122"/>
+                <a:cs typeface="Cambria" pitchFamily="34" charset="-120"/>
+              </a:rPr>
+              <a:t>Crave = physical, in this book.</a:t>
+            </a:r>
+            <a:endParaRPr lang="en-US" sz="2200" dirty="0"/>
+          </a:p>
+        </p:txBody>
+      </p:sp>
+      <p:sp>
+        <p:nvSpPr>
+          <p:cNvPr id="13" name="Text 11"/>
+          <p:cNvSpPr/>
+          <p:nvPr/>
+        </p:nvSpPr>
+        <p:spPr>
+          <a:xfrm>
+            <a:off x="548640" y="5806440"/>
+            <a:ext cx="11091672" cy="292608"/>
+          </a:xfrm>
+          <a:prstGeom prst="rect">
+            <a:avLst/>
+          </a:prstGeom>
+          <a:noFill/>
+          <a:ln/>
+        </p:spPr>
+        <p:txBody>
+          <a:bodyPr wrap="square" lIns="0" tIns="0" rIns="0" bIns="0" rtlCol="0" anchor="ctr"/>
+          <a:lstStyle/>
+          <a:p>
+            <a:pPr indent="0" marL="0">
+              <a:buNone/>
+            </a:pPr>
+            <a:r>
+              <a:rPr lang="en-US" sz="1200" i="1" dirty="0">
+                <a:solidFill>
+                  <a:srgbClr val="6B7A8C"/>
+                </a:solidFill>
+                <a:latin typeface="Calibri" pitchFamily="34" charset="0"/>
+                <a:ea typeface="Calibri" pitchFamily="34" charset="-122"/>
+                <a:cs typeface="Calibri" pitchFamily="34" charset="-120"/>
+              </a:rPr>
+              <a:t>Alcoholics Anonymous</a:t>
+            </a:r>
+            <a:pPr indent="0" marL="0">
+              <a:buNone/>
+            </a:pPr>
+            <a:r>
+              <a:rPr lang="en-US" sz="1200" dirty="0">
+                <a:solidFill>
+                  <a:srgbClr val="6B7A8C"/>
+                </a:solidFill>
+                <a:latin typeface="Calibri" pitchFamily="34" charset="0"/>
+                <a:ea typeface="Calibri" pitchFamily="34" charset="-122"/>
+                <a:cs typeface="Calibri" pitchFamily="34" charset="-120"/>
+              </a:rPr>
+              <a:t>, 4th ed., “The Doctor’s Opinion,” p. xxiv.</a:t>
+            </a:r>
+            <a:endParaRPr lang="en-US" sz="1200" dirty="0"/>
+          </a:p>
+        </p:txBody>
+      </p:sp>
+      <p:sp>
+        <p:nvSpPr>
+          <p:cNvPr id="14" name="Text 12"/>
+          <p:cNvSpPr/>
+          <p:nvPr/>
+        </p:nvSpPr>
+        <p:spPr>
+          <a:xfrm>
+            <a:off x="548640" y="6355080"/>
+            <a:ext cx="11091672" cy="292608"/>
+          </a:xfrm>
+          <a:prstGeom prst="rect">
+            <a:avLst/>
+          </a:prstGeom>
+          <a:noFill/>
+          <a:ln/>
+        </p:spPr>
+        <p:txBody>
+          <a:bodyPr wrap="square" lIns="0" tIns="0" rIns="0" bIns="0" rtlCol="0" anchor="ctr"/>
+          <a:lstStyle/>
+          <a:p>
+            <a:pPr indent="0" marL="0">
+              <a:buNone/>
+            </a:pPr>
+            <a:r>
+              <a:rPr lang="en-US" sz="950" dirty="0">
+                <a:solidFill>
+                  <a:srgbClr val="6B7A8C"/>
+                </a:solidFill>
+                <a:latin typeface="Calibri" pitchFamily="34" charset="0"/>
+                <a:ea typeface="Calibri" pitchFamily="34" charset="-122"/>
+                <a:cs typeface="Calibri" pitchFamily="34" charset="-120"/>
+              </a:rPr>
+              <a:t>Copyright © Alcoholics Anonymous World Services, Inc. All rights reserved. Intended for personal use only, and not to be reproduced further or distributed for resale.</a:t>
+            </a:r>
+            <a:endParaRPr lang="en-US" sz="950" dirty="0"/>
+          </a:p>
+        </p:txBody>
+      </p:sp>
+    </p:spTree>
+  </p:cSld>
+  <p:clrMapOvr>
+    <a:masterClrMapping/>
+  </p:clrMapOvr>
+</p:sld>
+</file>
+
+<file path=ppt/slides/slide25.xml><?xml version="1.0" encoding="utf-8"?>
+<p:sld xmlns:a="http://schemas.openxmlformats.org/drawingml/2006/main" xmlns:r="http://schemas.openxmlformats.org/officeDocument/2006/relationships" xmlns:p="http://schemas.openxmlformats.org/presentationml/2006/main">
+  <p:cSld name="Slide 25">
+    <p:bg>
+      <p:bgPr>
+        <a:solidFill>
+          <a:srgbClr val="FFFFFF"/>
+        </a:solidFill>
+      </p:bgPr>
+    </p:bg>
+    <p:spTree>
+      <p:nvGrpSpPr>
+        <p:cNvPr id="1" name=""/>
+        <p:cNvGrpSpPr/>
+        <p:nvPr/>
+      </p:nvGrpSpPr>
+      <p:grpSpPr>
+        <a:xfrm>
+          <a:off x="0" y="0"/>
+          <a:ext cx="0" cy="0"/>
+          <a:chOff x="0" y="0"/>
+          <a:chExt cx="0" cy="0"/>
+        </a:xfrm>
+      </p:grpSpPr>
+      <p:sp>
+        <p:nvSpPr>
+          <p:cNvPr id="2" name="Text 0"/>
+          <p:cNvSpPr/>
+          <p:nvPr/>
+        </p:nvSpPr>
+        <p:spPr>
+          <a:xfrm>
+            <a:off x="548640" y="320040"/>
+            <a:ext cx="8138160" cy="566928"/>
+          </a:xfrm>
+          <a:prstGeom prst="rect">
+            <a:avLst/>
+          </a:prstGeom>
+          <a:noFill/>
+          <a:ln/>
+        </p:spPr>
+        <p:txBody>
+          <a:bodyPr wrap="square" lIns="0" tIns="0" rIns="0" bIns="0" rtlCol="0" anchor="ctr"/>
+          <a:lstStyle/>
+          <a:p>
+            <a:pPr indent="0" marL="0">
+              <a:buNone/>
+            </a:pPr>
+            <a:r>
+              <a:rPr lang="en-US" sz="3800" b="1" dirty="0">
+                <a:solidFill>
+                  <a:srgbClr val="1B2A41"/>
+                </a:solidFill>
+                <a:latin typeface="Cambria" pitchFamily="34" charset="0"/>
+                <a:ea typeface="Cambria" pitchFamily="34" charset="-122"/>
+                <a:cs typeface="Cambria" pitchFamily="34" charset="-120"/>
+              </a:rPr>
+              <a:t>Frothy Emotional Appeal</a:t>
+            </a:r>
+            <a:endParaRPr lang="en-US" sz="3800" dirty="0"/>
+          </a:p>
+        </p:txBody>
+      </p:sp>
+      <p:sp>
+        <p:nvSpPr>
+          <p:cNvPr id="3" name="Text 1"/>
+          <p:cNvSpPr/>
+          <p:nvPr/>
+        </p:nvSpPr>
+        <p:spPr>
+          <a:xfrm>
+            <a:off x="548640" y="914400"/>
+            <a:ext cx="8138160" cy="347472"/>
+          </a:xfrm>
+          <a:prstGeom prst="rect">
+            <a:avLst/>
+          </a:prstGeom>
+          <a:noFill/>
+          <a:ln/>
+        </p:spPr>
+        <p:txBody>
+          <a:bodyPr wrap="square" lIns="0" tIns="0" rIns="0" bIns="0" rtlCol="0" anchor="ctr"/>
+          <a:lstStyle/>
+          <a:p>
+            <a:pPr indent="0" marL="0">
+              <a:buNone/>
+            </a:pPr>
+            <a:r>
+              <a:rPr lang="en-US" sz="1700" i="1" dirty="0">
+                <a:solidFill>
+                  <a:srgbClr val="6B7A8C"/>
+                </a:solidFill>
+                <a:latin typeface="Calibri" pitchFamily="34" charset="0"/>
+                <a:ea typeface="Calibri" pitchFamily="34" charset="-122"/>
+                <a:cs typeface="Calibri" pitchFamily="34" charset="-120"/>
+              </a:rPr>
+              <a:t>Seldom suffices.</a:t>
+            </a:r>
+            <a:endParaRPr lang="en-US" sz="1700" dirty="0"/>
+          </a:p>
+        </p:txBody>
+      </p:sp>
+      <p:sp>
+        <p:nvSpPr>
+          <p:cNvPr id="4" name="Shape 2"/>
+          <p:cNvSpPr/>
+          <p:nvPr/>
+        </p:nvSpPr>
+        <p:spPr>
+          <a:xfrm>
+            <a:off x="8869680" y="320040"/>
+            <a:ext cx="2770632" cy="960120"/>
+          </a:xfrm>
+          <a:prstGeom prst="roundRect">
+            <a:avLst>
+              <a:gd name="adj" fmla="val 9524"/>
+            </a:avLst>
+          </a:prstGeom>
+          <a:solidFill>
+            <a:srgbClr val="9E1B60"/>
+          </a:solidFill>
+          <a:ln/>
+        </p:spPr>
+      </p:sp>
+      <p:sp>
+        <p:nvSpPr>
+          <p:cNvPr id="5" name="Text 3"/>
+          <p:cNvSpPr/>
+          <p:nvPr/>
+        </p:nvSpPr>
+        <p:spPr>
+          <a:xfrm>
+            <a:off x="8869680" y="320040"/>
+            <a:ext cx="2770632" cy="960120"/>
+          </a:xfrm>
+          <a:prstGeom prst="rect">
+            <a:avLst/>
+          </a:prstGeom>
+          <a:noFill/>
+          <a:ln/>
+        </p:spPr>
+        <p:txBody>
+          <a:bodyPr wrap="square" lIns="0" tIns="0" rIns="0" bIns="0" rtlCol="0" anchor="ctr"/>
+          <a:lstStyle/>
+          <a:p>
+            <a:pPr algn="ctr" indent="0" marL="0">
+              <a:buNone/>
+            </a:pPr>
+            <a:r>
+              <a:rPr lang="en-US" sz="1700" b="1" spc="100" kern="0" dirty="0">
+                <a:solidFill>
+                  <a:srgbClr val="FFFFFF"/>
+                </a:solidFill>
+                <a:latin typeface="Cambria" pitchFamily="34" charset="0"/>
+                <a:ea typeface="Cambria" pitchFamily="34" charset="-122"/>
+                <a:cs typeface="Cambria" pitchFamily="34" charset="-120"/>
+              </a:rPr>
+              <a:t>THE “MUSTS”</a:t>
+            </a:r>
+            <a:endParaRPr lang="en-US" sz="1700" dirty="0"/>
+          </a:p>
+          <a:p>
+            <a:pPr algn="ctr" indent="0" marL="0">
+              <a:buNone/>
+            </a:pPr>
+            <a:r>
+              <a:rPr lang="en-US" sz="1300" dirty="0">
+                <a:solidFill>
+                  <a:srgbClr val="F7D9E8"/>
+                </a:solidFill>
+                <a:latin typeface="Calibri" pitchFamily="34" charset="0"/>
+                <a:ea typeface="Calibri" pitchFamily="34" charset="-122"/>
+                <a:cs typeface="Calibri" pitchFamily="34" charset="-120"/>
+              </a:rPr>
+              <a:t>p. xxiv</a:t>
+            </a:r>
+            <a:endParaRPr lang="en-US" sz="1700" dirty="0"/>
+          </a:p>
+        </p:txBody>
+      </p:sp>
+      <p:sp>
+        <p:nvSpPr>
+          <p:cNvPr id="6" name="Shape 4"/>
+          <p:cNvSpPr/>
+          <p:nvPr/>
+        </p:nvSpPr>
+        <p:spPr>
+          <a:xfrm>
+            <a:off x="548640" y="1463040"/>
+            <a:ext cx="11091672" cy="1737360"/>
+          </a:xfrm>
+          <a:prstGeom prst="roundRect">
+            <a:avLst>
+              <a:gd name="adj" fmla="val 4211"/>
+            </a:avLst>
+          </a:prstGeom>
+          <a:solidFill>
+            <a:srgbClr val="F9E3EE"/>
+          </a:solidFill>
+          <a:ln/>
+        </p:spPr>
+      </p:sp>
+      <p:sp>
+        <p:nvSpPr>
+          <p:cNvPr id="7" name="Text 5"/>
+          <p:cNvSpPr/>
+          <p:nvPr/>
+        </p:nvSpPr>
+        <p:spPr>
+          <a:xfrm>
+            <a:off x="914400" y="1463040"/>
+            <a:ext cx="10360152" cy="1737360"/>
+          </a:xfrm>
+          <a:prstGeom prst="rect">
+            <a:avLst/>
+          </a:prstGeom>
+          <a:noFill/>
+          <a:ln/>
+        </p:spPr>
+        <p:txBody>
+          <a:bodyPr wrap="square" lIns="0" tIns="0" rIns="0" bIns="0" rtlCol="0" anchor="ctr"/>
+          <a:lstStyle/>
+          <a:p>
+            <a:pPr indent="0" marL="0">
+              <a:lnSpc>
+                <a:spcPct val="115000"/>
+              </a:lnSpc>
+              <a:buNone/>
+            </a:pPr>
+            <a:r>
+              <a:rPr lang="en-US" sz="2000" dirty="0">
+                <a:solidFill>
+                  <a:srgbClr val="1B2A41"/>
+                </a:solidFill>
+                <a:latin typeface="Calibri" pitchFamily="34" charset="0"/>
+                <a:ea typeface="Calibri" pitchFamily="34" charset="-122"/>
+                <a:cs typeface="Calibri" pitchFamily="34" charset="-120"/>
+              </a:rPr>
+              <a:t>Frothy emotional appeal seldom suffices. The message which can interest and hold these alcoholic people </a:t>
+            </a:r>
+            <a:pPr indent="0" marL="0">
+              <a:lnSpc>
+                <a:spcPct val="115000"/>
+              </a:lnSpc>
+              <a:buNone/>
+            </a:pPr>
+            <a:r>
+              <a:rPr lang="en-US" sz="2000" b="1" dirty="0">
+                <a:solidFill>
+                  <a:srgbClr val="9E1B60"/>
+                </a:solidFill>
+                <a:latin typeface="Calibri" pitchFamily="34" charset="0"/>
+                <a:ea typeface="Calibri" pitchFamily="34" charset="-122"/>
+                <a:cs typeface="Calibri" pitchFamily="34" charset="-120"/>
+              </a:rPr>
+              <a:t>must have depth and weight</a:t>
+            </a:r>
+            <a:pPr indent="0" marL="0">
+              <a:lnSpc>
+                <a:spcPct val="115000"/>
+              </a:lnSpc>
+              <a:buNone/>
+            </a:pPr>
+            <a:r>
+              <a:rPr lang="en-US" sz="2000" dirty="0">
+                <a:solidFill>
+                  <a:srgbClr val="1B2A41"/>
+                </a:solidFill>
+                <a:latin typeface="Calibri" pitchFamily="34" charset="0"/>
+                <a:ea typeface="Calibri" pitchFamily="34" charset="-122"/>
+                <a:cs typeface="Calibri" pitchFamily="34" charset="-120"/>
+              </a:rPr>
+              <a:t>. In nearly all cases, their ideals </a:t>
+            </a:r>
+            <a:pPr indent="0" marL="0">
+              <a:lnSpc>
+                <a:spcPct val="115000"/>
+              </a:lnSpc>
+              <a:buNone/>
+            </a:pPr>
+            <a:r>
+              <a:rPr lang="en-US" sz="2000" b="1" dirty="0">
+                <a:solidFill>
+                  <a:srgbClr val="9E1B60"/>
+                </a:solidFill>
+                <a:latin typeface="Calibri" pitchFamily="34" charset="0"/>
+                <a:ea typeface="Calibri" pitchFamily="34" charset="-122"/>
+                <a:cs typeface="Calibri" pitchFamily="34" charset="-120"/>
+              </a:rPr>
+              <a:t>must be grounded in a power greater than themselves</a:t>
+            </a:r>
+            <a:pPr indent="0" marL="0">
+              <a:lnSpc>
+                <a:spcPct val="115000"/>
+              </a:lnSpc>
+              <a:buNone/>
+            </a:pPr>
+            <a:r>
+              <a:rPr lang="en-US" sz="2000" dirty="0">
+                <a:solidFill>
+                  <a:srgbClr val="1B2A41"/>
+                </a:solidFill>
+                <a:latin typeface="Calibri" pitchFamily="34" charset="0"/>
+                <a:ea typeface="Calibri" pitchFamily="34" charset="-122"/>
+                <a:cs typeface="Calibri" pitchFamily="34" charset="-120"/>
+              </a:rPr>
+              <a:t>, if they are to re-create their lives.</a:t>
+            </a:r>
+            <a:endParaRPr lang="en-US" sz="2000" dirty="0"/>
+          </a:p>
+        </p:txBody>
+      </p:sp>
+      <p:sp>
+        <p:nvSpPr>
+          <p:cNvPr id="8" name="Shape 6"/>
+          <p:cNvSpPr/>
+          <p:nvPr/>
+        </p:nvSpPr>
+        <p:spPr>
+          <a:xfrm>
+            <a:off x="548640" y="3474720"/>
+            <a:ext cx="11091672" cy="1371600"/>
+          </a:xfrm>
+          <a:prstGeom prst="roundRect">
+            <a:avLst>
+              <a:gd name="adj" fmla="val 5333"/>
+            </a:avLst>
+          </a:prstGeom>
+          <a:solidFill>
+            <a:srgbClr val="9E1B60"/>
+          </a:solidFill>
+          <a:ln/>
+        </p:spPr>
+      </p:sp>
+      <p:sp>
+        <p:nvSpPr>
+          <p:cNvPr id="9" name="Text 7"/>
+          <p:cNvSpPr/>
+          <p:nvPr/>
+        </p:nvSpPr>
+        <p:spPr>
+          <a:xfrm>
+            <a:off x="914400" y="3611880"/>
+            <a:ext cx="10360152" cy="256032"/>
+          </a:xfrm>
+          <a:prstGeom prst="rect">
+            <a:avLst/>
+          </a:prstGeom>
+          <a:noFill/>
+          <a:ln/>
+        </p:spPr>
+        <p:txBody>
+          <a:bodyPr wrap="square" lIns="0" tIns="0" rIns="0" bIns="0" rtlCol="0" anchor="ctr"/>
+          <a:lstStyle/>
+          <a:p>
+            <a:pPr indent="0" marL="0">
+              <a:buNone/>
+            </a:pPr>
+            <a:r>
+              <a:rPr lang="en-US" sz="1100" b="1" spc="200" kern="0" dirty="0">
+                <a:solidFill>
+                  <a:srgbClr val="F7D9E8"/>
+                </a:solidFill>
+                <a:latin typeface="Calibri" pitchFamily="34" charset="0"/>
+                <a:ea typeface="Calibri" pitchFamily="34" charset="-122"/>
+                <a:cs typeface="Calibri" pitchFamily="34" charset="-120"/>
+              </a:rPr>
+              <a:t>A “MUST”</a:t>
+            </a:r>
+            <a:endParaRPr lang="en-US" sz="1100" dirty="0"/>
+          </a:p>
+        </p:txBody>
+      </p:sp>
+      <p:sp>
+        <p:nvSpPr>
+          <p:cNvPr id="10" name="Text 8"/>
+          <p:cNvSpPr/>
+          <p:nvPr/>
+        </p:nvSpPr>
+        <p:spPr>
+          <a:xfrm>
+            <a:off x="914400" y="3886200"/>
+            <a:ext cx="10360152" cy="777240"/>
+          </a:xfrm>
+          <a:prstGeom prst="rect">
+            <a:avLst/>
+          </a:prstGeom>
+          <a:noFill/>
+          <a:ln/>
+        </p:spPr>
+        <p:txBody>
+          <a:bodyPr wrap="square" lIns="0" tIns="0" rIns="0" bIns="0" rtlCol="0" anchor="ctr"/>
+          <a:lstStyle/>
+          <a:p>
+            <a:pPr indent="0" marL="0">
+              <a:buNone/>
+            </a:pPr>
+            <a:r>
+              <a:rPr lang="en-US" sz="2400" b="1" dirty="0">
+                <a:solidFill>
+                  <a:srgbClr val="FFFFFF"/>
+                </a:solidFill>
+                <a:latin typeface="Cambria" pitchFamily="34" charset="0"/>
+                <a:ea typeface="Cambria" pitchFamily="34" charset="-122"/>
+                <a:cs typeface="Cambria" pitchFamily="34" charset="-120"/>
+              </a:rPr>
+              <a:t>…their ideals must be grounded in a power greater than themselves.</a:t>
+            </a:r>
+            <a:endParaRPr lang="en-US" sz="2400" dirty="0"/>
+          </a:p>
+        </p:txBody>
+      </p:sp>
+      <p:sp>
+        <p:nvSpPr>
+          <p:cNvPr id="11" name="Text 9"/>
+          <p:cNvSpPr/>
+          <p:nvPr/>
+        </p:nvSpPr>
+        <p:spPr>
+          <a:xfrm>
+            <a:off x="548640" y="5074920"/>
+            <a:ext cx="11091672" cy="292608"/>
+          </a:xfrm>
+          <a:prstGeom prst="rect">
+            <a:avLst/>
+          </a:prstGeom>
+          <a:noFill/>
+          <a:ln/>
+        </p:spPr>
+        <p:txBody>
+          <a:bodyPr wrap="square" lIns="0" tIns="0" rIns="0" bIns="0" rtlCol="0" anchor="ctr"/>
+          <a:lstStyle/>
+          <a:p>
+            <a:pPr indent="0" marL="0">
+              <a:buNone/>
+            </a:pPr>
+            <a:r>
+              <a:rPr lang="en-US" sz="1200" i="1" dirty="0">
+                <a:solidFill>
+                  <a:srgbClr val="6B7A8C"/>
+                </a:solidFill>
+                <a:latin typeface="Calibri" pitchFamily="34" charset="0"/>
+                <a:ea typeface="Calibri" pitchFamily="34" charset="-122"/>
+                <a:cs typeface="Calibri" pitchFamily="34" charset="-120"/>
+              </a:rPr>
+              <a:t>Alcoholics Anonymous</a:t>
+            </a:r>
+            <a:pPr indent="0" marL="0">
+              <a:buNone/>
+            </a:pPr>
+            <a:r>
+              <a:rPr lang="en-US" sz="1200" dirty="0">
+                <a:solidFill>
+                  <a:srgbClr val="6B7A8C"/>
+                </a:solidFill>
+                <a:latin typeface="Calibri" pitchFamily="34" charset="0"/>
+                <a:ea typeface="Calibri" pitchFamily="34" charset="-122"/>
+                <a:cs typeface="Calibri" pitchFamily="34" charset="-120"/>
+              </a:rPr>
+              <a:t>, 4th ed., “The Doctor’s Opinion,” p. xxiv.</a:t>
+            </a:r>
+            <a:endParaRPr lang="en-US" sz="1200" dirty="0"/>
+          </a:p>
+        </p:txBody>
+      </p:sp>
+      <p:sp>
+        <p:nvSpPr>
+          <p:cNvPr id="12" name="Text 10"/>
+          <p:cNvSpPr/>
+          <p:nvPr/>
+        </p:nvSpPr>
+        <p:spPr>
+          <a:xfrm>
+            <a:off x="548640" y="6355080"/>
+            <a:ext cx="11091672" cy="292608"/>
+          </a:xfrm>
+          <a:prstGeom prst="rect">
+            <a:avLst/>
+          </a:prstGeom>
+          <a:noFill/>
+          <a:ln/>
+        </p:spPr>
+        <p:txBody>
+          <a:bodyPr wrap="square" lIns="0" tIns="0" rIns="0" bIns="0" rtlCol="0" anchor="ctr"/>
+          <a:lstStyle/>
+          <a:p>
+            <a:pPr indent="0" marL="0">
+              <a:buNone/>
+            </a:pPr>
+            <a:r>
+              <a:rPr lang="en-US" sz="950" dirty="0">
+                <a:solidFill>
+                  <a:srgbClr val="6B7A8C"/>
+                </a:solidFill>
+                <a:latin typeface="Calibri" pitchFamily="34" charset="0"/>
+                <a:ea typeface="Calibri" pitchFamily="34" charset="-122"/>
+                <a:cs typeface="Calibri" pitchFamily="34" charset="-120"/>
+              </a:rPr>
+              <a:t>Copyright © Alcoholics Anonymous World Services, Inc. All rights reserved. Intended for personal use only, and not to be reproduced further or distributed for resale.</a:t>
+            </a:r>
+            <a:endParaRPr lang="en-US" sz="950" dirty="0"/>
+          </a:p>
+        </p:txBody>
+      </p:sp>
+    </p:spTree>
+  </p:cSld>
+  <p:clrMapOvr>
+    <a:masterClrMapping/>
+  </p:clrMapOvr>
+</p:sld>
+</file>
+
+<file path=ppt/slides/slide26.xml><?xml version="1.0" encoding="utf-8"?>
+<p:sld xmlns:a="http://schemas.openxmlformats.org/drawingml/2006/main" xmlns:r="http://schemas.openxmlformats.org/officeDocument/2006/relationships" xmlns:p="http://schemas.openxmlformats.org/presentationml/2006/main">
+  <p:cSld name="Slide 26">
+    <p:bg>
+      <p:bgPr>
+        <a:solidFill>
+          <a:srgbClr val="FFFFFF"/>
+        </a:solidFill>
+      </p:bgPr>
+    </p:bg>
+    <p:spTree>
+      <p:nvGrpSpPr>
+        <p:cNvPr id="1" name=""/>
+        <p:cNvGrpSpPr/>
+        <p:nvPr/>
+      </p:nvGrpSpPr>
+      <p:grpSpPr>
+        <a:xfrm>
+          <a:off x="0" y="0"/>
+          <a:ext cx="0" cy="0"/>
+          <a:chOff x="0" y="0"/>
+          <a:chExt cx="0" cy="0"/>
+        </a:xfrm>
+      </p:grpSpPr>
+      <p:sp>
+        <p:nvSpPr>
+          <p:cNvPr id="2" name="Text 0"/>
+          <p:cNvSpPr/>
+          <p:nvPr/>
+        </p:nvSpPr>
+        <p:spPr>
+          <a:xfrm>
+            <a:off x="548640" y="320040"/>
+            <a:ext cx="8138160" cy="566928"/>
+          </a:xfrm>
+          <a:prstGeom prst="rect">
+            <a:avLst/>
+          </a:prstGeom>
+          <a:noFill/>
+          <a:ln/>
+        </p:spPr>
+        <p:txBody>
+          <a:bodyPr wrap="square" lIns="0" tIns="0" rIns="0" bIns="0" rtlCol="0" anchor="ctr"/>
+          <a:lstStyle/>
+          <a:p>
+            <a:pPr indent="0" marL="0">
+              <a:buNone/>
+            </a:pPr>
+            <a:r>
+              <a:rPr lang="en-US" sz="3800" b="1" dirty="0">
+                <a:solidFill>
+                  <a:srgbClr val="1B2A41"/>
+                </a:solidFill>
+                <a:latin typeface="Cambria" pitchFamily="34" charset="0"/>
+                <a:ea typeface="Cambria" pitchFamily="34" charset="-122"/>
+                <a:cs typeface="Cambria" pitchFamily="34" charset="-120"/>
+              </a:rPr>
+              <a:t>The Effect Produced by Alcohol</a:t>
+            </a:r>
+            <a:endParaRPr lang="en-US" sz="3800" dirty="0"/>
+          </a:p>
+        </p:txBody>
+      </p:sp>
+      <p:sp>
+        <p:nvSpPr>
+          <p:cNvPr id="3" name="Text 1"/>
+          <p:cNvSpPr/>
+          <p:nvPr/>
+        </p:nvSpPr>
+        <p:spPr>
+          <a:xfrm>
+            <a:off x="548640" y="914400"/>
+            <a:ext cx="8138160" cy="347472"/>
+          </a:xfrm>
+          <a:prstGeom prst="rect">
+            <a:avLst/>
+          </a:prstGeom>
+          <a:noFill/>
+          <a:ln/>
+        </p:spPr>
+        <p:txBody>
+          <a:bodyPr wrap="square" lIns="0" tIns="0" rIns="0" bIns="0" rtlCol="0" anchor="ctr"/>
+          <a:lstStyle/>
+          <a:p>
+            <a:pPr indent="0" marL="0">
+              <a:buNone/>
+            </a:pPr>
+            <a:r>
+              <a:rPr lang="en-US" sz="1700" i="1" dirty="0">
+                <a:solidFill>
+                  <a:srgbClr val="6B7A8C"/>
+                </a:solidFill>
+                <a:latin typeface="Calibri" pitchFamily="34" charset="0"/>
+                <a:ea typeface="Calibri" pitchFamily="34" charset="-122"/>
+                <a:cs typeface="Calibri" pitchFamily="34" charset="-120"/>
+              </a:rPr>
+              <a:t>Restless, irritable and discontented.</a:t>
+            </a:r>
+            <a:endParaRPr lang="en-US" sz="1700" dirty="0"/>
+          </a:p>
+        </p:txBody>
+      </p:sp>
+      <p:sp>
+        <p:nvSpPr>
+          <p:cNvPr id="4" name="Shape 2"/>
+          <p:cNvSpPr/>
+          <p:nvPr/>
+        </p:nvSpPr>
+        <p:spPr>
+          <a:xfrm>
+            <a:off x="8869680" y="320040"/>
+            <a:ext cx="2770632" cy="960120"/>
+          </a:xfrm>
+          <a:prstGeom prst="roundRect">
+            <a:avLst>
+              <a:gd name="adj" fmla="val 9524"/>
+            </a:avLst>
+          </a:prstGeom>
+          <a:solidFill>
+            <a:srgbClr val="2C5F2D"/>
+          </a:solidFill>
+          <a:ln/>
+        </p:spPr>
+      </p:sp>
+      <p:sp>
+        <p:nvSpPr>
+          <p:cNvPr id="5" name="Text 3"/>
+          <p:cNvSpPr/>
+          <p:nvPr/>
+        </p:nvSpPr>
+        <p:spPr>
+          <a:xfrm>
+            <a:off x="8869680" y="320040"/>
+            <a:ext cx="2770632" cy="960120"/>
+          </a:xfrm>
+          <a:prstGeom prst="rect">
+            <a:avLst/>
+          </a:prstGeom>
+          <a:noFill/>
+          <a:ln/>
+        </p:spPr>
+        <p:txBody>
+          <a:bodyPr wrap="square" lIns="0" tIns="0" rIns="0" bIns="0" rtlCol="0" anchor="ctr"/>
+          <a:lstStyle/>
+          <a:p>
+            <a:pPr algn="ctr" indent="0" marL="0">
+              <a:buNone/>
+            </a:pPr>
+            <a:r>
+              <a:rPr lang="en-US" sz="1700" b="1" spc="100" kern="0" dirty="0">
+                <a:solidFill>
+                  <a:srgbClr val="FFFFFF"/>
+                </a:solidFill>
+                <a:latin typeface="Cambria" pitchFamily="34" charset="0"/>
+                <a:ea typeface="Cambria" pitchFamily="34" charset="-122"/>
+                <a:cs typeface="Cambria" pitchFamily="34" charset="-120"/>
+              </a:rPr>
+              <a:t>THE BIG BOOK</a:t>
+            </a:r>
+            <a:endParaRPr lang="en-US" sz="1700" dirty="0"/>
+          </a:p>
+          <a:p>
+            <a:pPr algn="ctr" indent="0" marL="0">
+              <a:buNone/>
+            </a:pPr>
+            <a:r>
+              <a:rPr lang="en-US" sz="1300" dirty="0">
+                <a:solidFill>
+                  <a:srgbClr val="D5E3CE"/>
+                </a:solidFill>
+                <a:latin typeface="Calibri" pitchFamily="34" charset="0"/>
+                <a:ea typeface="Calibri" pitchFamily="34" charset="-122"/>
+                <a:cs typeface="Calibri" pitchFamily="34" charset="-120"/>
+              </a:rPr>
+              <a:t>pp. xxiv–xxv</a:t>
+            </a:r>
+            <a:endParaRPr lang="en-US" sz="1700" dirty="0"/>
+          </a:p>
+        </p:txBody>
+      </p:sp>
+      <p:sp>
+        <p:nvSpPr>
+          <p:cNvPr id="6" name="Shape 4"/>
+          <p:cNvSpPr/>
+          <p:nvPr/>
+        </p:nvSpPr>
+        <p:spPr>
+          <a:xfrm>
+            <a:off x="548640" y="1463040"/>
+            <a:ext cx="11091672" cy="1417320"/>
+          </a:xfrm>
+          <a:prstGeom prst="roundRect">
+            <a:avLst>
+              <a:gd name="adj" fmla="val 5161"/>
+            </a:avLst>
+          </a:prstGeom>
+          <a:solidFill>
+            <a:srgbClr val="EAF1E6"/>
+          </a:solidFill>
+          <a:ln/>
+        </p:spPr>
+      </p:sp>
+      <p:sp>
+        <p:nvSpPr>
+          <p:cNvPr id="7" name="Text 5"/>
+          <p:cNvSpPr/>
+          <p:nvPr/>
+        </p:nvSpPr>
+        <p:spPr>
+          <a:xfrm>
+            <a:off x="914400" y="1463040"/>
+            <a:ext cx="10360152" cy="1417320"/>
+          </a:xfrm>
+          <a:prstGeom prst="rect">
+            <a:avLst/>
+          </a:prstGeom>
+          <a:noFill/>
+          <a:ln/>
+        </p:spPr>
+        <p:txBody>
+          <a:bodyPr wrap="square" lIns="0" tIns="0" rIns="0" bIns="0" rtlCol="0" anchor="ctr"/>
+          <a:lstStyle/>
+          <a:p>
+            <a:pPr indent="0" marL="0">
+              <a:lnSpc>
+                <a:spcPct val="115000"/>
+              </a:lnSpc>
+              <a:buNone/>
+            </a:pPr>
+            <a:r>
+              <a:rPr lang="en-US" sz="2000" dirty="0">
+                <a:solidFill>
+                  <a:srgbClr val="1B2A41"/>
+                </a:solidFill>
+                <a:latin typeface="Calibri" pitchFamily="34" charset="0"/>
+                <a:ea typeface="Calibri" pitchFamily="34" charset="-122"/>
+                <a:cs typeface="Calibri" pitchFamily="34" charset="-120"/>
+              </a:rPr>
+              <a:t>Men and women drink essentially because they </a:t>
+            </a:r>
+            <a:pPr indent="0" marL="0">
+              <a:lnSpc>
+                <a:spcPct val="115000"/>
+              </a:lnSpc>
+              <a:buNone/>
+            </a:pPr>
+            <a:r>
+              <a:rPr lang="en-US" sz="2000" b="1" dirty="0">
+                <a:solidFill>
+                  <a:srgbClr val="2C5F2D"/>
+                </a:solidFill>
+                <a:latin typeface="Calibri" pitchFamily="34" charset="0"/>
+                <a:ea typeface="Calibri" pitchFamily="34" charset="-122"/>
+                <a:cs typeface="Calibri" pitchFamily="34" charset="-120"/>
+              </a:rPr>
+              <a:t>like the effect produced by alcohol</a:t>
+            </a:r>
+            <a:pPr indent="0" marL="0">
+              <a:lnSpc>
+                <a:spcPct val="115000"/>
+              </a:lnSpc>
+              <a:buNone/>
+            </a:pPr>
+            <a:r>
+              <a:rPr lang="en-US" sz="2000" dirty="0">
+                <a:solidFill>
+                  <a:srgbClr val="1B2A41"/>
+                </a:solidFill>
+                <a:latin typeface="Calibri" pitchFamily="34" charset="0"/>
+                <a:ea typeface="Calibri" pitchFamily="34" charset="-122"/>
+                <a:cs typeface="Calibri" pitchFamily="34" charset="-120"/>
+              </a:rPr>
+              <a:t>. The sensation is so elusive that, while they admit it is injurious, they cannot after a time differentiate the true from the false.</a:t>
+            </a:r>
+            <a:endParaRPr lang="en-US" sz="2000" dirty="0"/>
+          </a:p>
+        </p:txBody>
+      </p:sp>
+      <p:sp>
+        <p:nvSpPr>
+          <p:cNvPr id="8" name="Shape 6"/>
+          <p:cNvSpPr/>
+          <p:nvPr/>
+        </p:nvSpPr>
+        <p:spPr>
+          <a:xfrm>
+            <a:off x="548640" y="3063240"/>
+            <a:ext cx="11091672" cy="1783080"/>
+          </a:xfrm>
+          <a:prstGeom prst="roundRect">
+            <a:avLst>
+              <a:gd name="adj" fmla="val 4103"/>
+            </a:avLst>
+          </a:prstGeom>
+          <a:solidFill>
+            <a:srgbClr val="E2EDF4"/>
+          </a:solidFill>
+          <a:ln/>
+        </p:spPr>
+      </p:sp>
+      <p:sp>
+        <p:nvSpPr>
+          <p:cNvPr id="9" name="Text 7"/>
+          <p:cNvSpPr/>
+          <p:nvPr/>
+        </p:nvSpPr>
+        <p:spPr>
+          <a:xfrm>
+            <a:off x="914400" y="3063240"/>
+            <a:ext cx="10360152" cy="1783080"/>
+          </a:xfrm>
+          <a:prstGeom prst="rect">
+            <a:avLst/>
+          </a:prstGeom>
+          <a:noFill/>
+          <a:ln/>
+        </p:spPr>
+        <p:txBody>
+          <a:bodyPr wrap="square" lIns="0" tIns="0" rIns="0" bIns="0" rtlCol="0" anchor="ctr"/>
+          <a:lstStyle/>
+          <a:p>
+            <a:pPr indent="0" marL="0">
+              <a:lnSpc>
+                <a:spcPct val="115000"/>
+              </a:lnSpc>
+              <a:buNone/>
+            </a:pPr>
+            <a:r>
+              <a:rPr lang="en-US" sz="2000" dirty="0">
+                <a:solidFill>
+                  <a:srgbClr val="1B2A41"/>
+                </a:solidFill>
+                <a:latin typeface="Calibri" pitchFamily="34" charset="0"/>
+                <a:ea typeface="Calibri" pitchFamily="34" charset="-122"/>
+                <a:cs typeface="Calibri" pitchFamily="34" charset="-120"/>
+              </a:rPr>
+              <a:t>To them, their alcoholic life seems the only normal one. They are </a:t>
+            </a:r>
+            <a:pPr indent="0" marL="0">
+              <a:lnSpc>
+                <a:spcPct val="115000"/>
+              </a:lnSpc>
+              <a:buNone/>
+            </a:pPr>
+            <a:r>
+              <a:rPr lang="en-US" sz="2000" b="1" dirty="0">
+                <a:solidFill>
+                  <a:srgbClr val="065A82"/>
+                </a:solidFill>
+                <a:latin typeface="Calibri" pitchFamily="34" charset="0"/>
+                <a:ea typeface="Calibri" pitchFamily="34" charset="-122"/>
+                <a:cs typeface="Calibri" pitchFamily="34" charset="-120"/>
+              </a:rPr>
+              <a:t>restless, irritable and discontented</a:t>
+            </a:r>
+            <a:pPr indent="0" marL="0">
+              <a:lnSpc>
+                <a:spcPct val="115000"/>
+              </a:lnSpc>
+              <a:buNone/>
+            </a:pPr>
+            <a:r>
+              <a:rPr lang="en-US" sz="2000" dirty="0">
+                <a:solidFill>
+                  <a:srgbClr val="1B2A41"/>
+                </a:solidFill>
+                <a:latin typeface="Calibri" pitchFamily="34" charset="0"/>
+                <a:ea typeface="Calibri" pitchFamily="34" charset="-122"/>
+                <a:cs typeface="Calibri" pitchFamily="34" charset="-120"/>
+              </a:rPr>
+              <a:t>, unless they can again experience the sense of ease and comfort which comes at once by taking a few drinks—drinks which they see others taking with impunity.</a:t>
+            </a:r>
+            <a:endParaRPr lang="en-US" sz="2000" dirty="0"/>
+          </a:p>
+        </p:txBody>
+      </p:sp>
+      <p:sp>
+        <p:nvSpPr>
+          <p:cNvPr id="10" name="Text 8"/>
+          <p:cNvSpPr/>
+          <p:nvPr/>
+        </p:nvSpPr>
+        <p:spPr>
+          <a:xfrm>
+            <a:off x="548640" y="5120640"/>
+            <a:ext cx="11091672" cy="292608"/>
+          </a:xfrm>
+          <a:prstGeom prst="rect">
+            <a:avLst/>
+          </a:prstGeom>
+          <a:noFill/>
+          <a:ln/>
+        </p:spPr>
+        <p:txBody>
+          <a:bodyPr wrap="square" lIns="0" tIns="0" rIns="0" bIns="0" rtlCol="0" anchor="ctr"/>
+          <a:lstStyle/>
+          <a:p>
+            <a:pPr indent="0" marL="0">
+              <a:buNone/>
+            </a:pPr>
+            <a:r>
+              <a:rPr lang="en-US" sz="1200" i="1" dirty="0">
+                <a:solidFill>
+                  <a:srgbClr val="6B7A8C"/>
+                </a:solidFill>
+                <a:latin typeface="Calibri" pitchFamily="34" charset="0"/>
+                <a:ea typeface="Calibri" pitchFamily="34" charset="-122"/>
+                <a:cs typeface="Calibri" pitchFamily="34" charset="-120"/>
+              </a:rPr>
+              <a:t>Alcoholics Anonymous</a:t>
+            </a:r>
+            <a:pPr indent="0" marL="0">
+              <a:buNone/>
+            </a:pPr>
+            <a:r>
+              <a:rPr lang="en-US" sz="1200" dirty="0">
+                <a:solidFill>
+                  <a:srgbClr val="6B7A8C"/>
+                </a:solidFill>
+                <a:latin typeface="Calibri" pitchFamily="34" charset="0"/>
+                <a:ea typeface="Calibri" pitchFamily="34" charset="-122"/>
+                <a:cs typeface="Calibri" pitchFamily="34" charset="-120"/>
+              </a:rPr>
+              <a:t>, 4th ed., “The Doctor’s Opinion,” pp. xxiv–xxv.</a:t>
+            </a:r>
+            <a:endParaRPr lang="en-US" sz="1200" dirty="0"/>
+          </a:p>
+        </p:txBody>
+      </p:sp>
+      <p:sp>
+        <p:nvSpPr>
+          <p:cNvPr id="11" name="Text 9"/>
+          <p:cNvSpPr/>
+          <p:nvPr/>
+        </p:nvSpPr>
+        <p:spPr>
+          <a:xfrm>
+            <a:off x="548640" y="6355080"/>
+            <a:ext cx="11091672" cy="292608"/>
+          </a:xfrm>
+          <a:prstGeom prst="rect">
+            <a:avLst/>
+          </a:prstGeom>
+          <a:noFill/>
+          <a:ln/>
+        </p:spPr>
+        <p:txBody>
+          <a:bodyPr wrap="square" lIns="0" tIns="0" rIns="0" bIns="0" rtlCol="0" anchor="ctr"/>
+          <a:lstStyle/>
+          <a:p>
+            <a:pPr indent="0" marL="0">
+              <a:buNone/>
+            </a:pPr>
+            <a:r>
+              <a:rPr lang="en-US" sz="950" dirty="0">
+                <a:solidFill>
+                  <a:srgbClr val="6B7A8C"/>
+                </a:solidFill>
+                <a:latin typeface="Calibri" pitchFamily="34" charset="0"/>
+                <a:ea typeface="Calibri" pitchFamily="34" charset="-122"/>
+                <a:cs typeface="Calibri" pitchFamily="34" charset="-120"/>
+              </a:rPr>
+              <a:t>Copyright © Alcoholics Anonymous World Services, Inc. All rights reserved. Intended for personal use only, and not to be reproduced further or distributed for resale.</a:t>
+            </a:r>
+            <a:endParaRPr lang="en-US" sz="950" dirty="0"/>
+          </a:p>
+        </p:txBody>
+      </p:sp>
+    </p:spTree>
+  </p:cSld>
+  <p:clrMapOvr>
+    <a:masterClrMapping/>
+  </p:clrMapOvr>
+</p:sld>
+</file>
+
+<file path=ppt/slides/slide27.xml><?xml version="1.0" encoding="utf-8"?>
+<p:sld xmlns:a="http://schemas.openxmlformats.org/drawingml/2006/main" xmlns:r="http://schemas.openxmlformats.org/officeDocument/2006/relationships" xmlns:p="http://schemas.openxmlformats.org/presentationml/2006/main">
+  <p:cSld name="Slide 27">
+    <p:bg>
+      <p:bgPr>
+        <a:solidFill>
+          <a:srgbClr val="FFFFFF"/>
+        </a:solidFill>
+      </p:bgPr>
+    </p:bg>
+    <p:spTree>
+      <p:nvGrpSpPr>
+        <p:cNvPr id="1" name=""/>
+        <p:cNvGrpSpPr/>
+        <p:nvPr/>
+      </p:nvGrpSpPr>
+      <p:grpSpPr>
+        <a:xfrm>
+          <a:off x="0" y="0"/>
+          <a:ext cx="0" cy="0"/>
+          <a:chOff x="0" y="0"/>
+          <a:chExt cx="0" cy="0"/>
+        </a:xfrm>
+      </p:grpSpPr>
+      <p:sp>
+        <p:nvSpPr>
+          <p:cNvPr id="2" name="Text 0"/>
+          <p:cNvSpPr/>
+          <p:nvPr/>
+        </p:nvSpPr>
+        <p:spPr>
+          <a:xfrm>
+            <a:off x="548640" y="320040"/>
+            <a:ext cx="8138160" cy="566928"/>
+          </a:xfrm>
+          <a:prstGeom prst="rect">
+            <a:avLst/>
+          </a:prstGeom>
+          <a:noFill/>
+          <a:ln/>
+        </p:spPr>
+        <p:txBody>
+          <a:bodyPr wrap="square" lIns="0" tIns="0" rIns="0" bIns="0" rtlCol="0" anchor="ctr"/>
+          <a:lstStyle/>
+          <a:p>
+            <a:pPr indent="0" marL="0">
+              <a:buNone/>
+            </a:pPr>
+            <a:r>
+              <a:rPr lang="en-US" sz="3800" b="1" dirty="0">
+                <a:solidFill>
+                  <a:srgbClr val="1B2A41"/>
+                </a:solidFill>
+                <a:latin typeface="Cambria" pitchFamily="34" charset="0"/>
+                <a:ea typeface="Cambria" pitchFamily="34" charset="-122"/>
+                <a:cs typeface="Cambria" pitchFamily="34" charset="-120"/>
+              </a:rPr>
+              <a:t>An Entire Psychic Change</a:t>
+            </a:r>
+            <a:endParaRPr lang="en-US" sz="3800" dirty="0"/>
+          </a:p>
+        </p:txBody>
+      </p:sp>
+      <p:sp>
+        <p:nvSpPr>
+          <p:cNvPr id="3" name="Text 1"/>
+          <p:cNvSpPr/>
+          <p:nvPr/>
+        </p:nvSpPr>
+        <p:spPr>
+          <a:xfrm>
+            <a:off x="548640" y="914400"/>
+            <a:ext cx="8138160" cy="347472"/>
+          </a:xfrm>
+          <a:prstGeom prst="rect">
+            <a:avLst/>
+          </a:prstGeom>
+          <a:noFill/>
+          <a:ln/>
+        </p:spPr>
+        <p:txBody>
+          <a:bodyPr wrap="square" lIns="0" tIns="0" rIns="0" bIns="0" rtlCol="0" anchor="ctr"/>
+          <a:lstStyle/>
+          <a:p>
+            <a:pPr indent="0" marL="0">
+              <a:buNone/>
+            </a:pPr>
+            <a:r>
+              <a:rPr lang="en-US" sz="1700" i="1" dirty="0">
+                <a:solidFill>
+                  <a:srgbClr val="6B7A8C"/>
+                </a:solidFill>
+                <a:latin typeface="Calibri" pitchFamily="34" charset="0"/>
+                <a:ea typeface="Calibri" pitchFamily="34" charset="-122"/>
+                <a:cs typeface="Calibri" pitchFamily="34" charset="-120"/>
+              </a:rPr>
+              <a:t>Or very little hope of recovery.</a:t>
+            </a:r>
+            <a:endParaRPr lang="en-US" sz="1700" dirty="0"/>
+          </a:p>
+        </p:txBody>
+      </p:sp>
+      <p:sp>
+        <p:nvSpPr>
+          <p:cNvPr id="4" name="Shape 2"/>
+          <p:cNvSpPr/>
+          <p:nvPr/>
+        </p:nvSpPr>
+        <p:spPr>
+          <a:xfrm>
+            <a:off x="8869680" y="320040"/>
+            <a:ext cx="2770632" cy="960120"/>
+          </a:xfrm>
+          <a:prstGeom prst="roundRect">
+            <a:avLst>
+              <a:gd name="adj" fmla="val 9524"/>
+            </a:avLst>
+          </a:prstGeom>
+          <a:solidFill>
+            <a:srgbClr val="065A82"/>
+          </a:solidFill>
+          <a:ln/>
+        </p:spPr>
+      </p:sp>
+      <p:sp>
+        <p:nvSpPr>
+          <p:cNvPr id="5" name="Text 3"/>
+          <p:cNvSpPr/>
+          <p:nvPr/>
+        </p:nvSpPr>
+        <p:spPr>
+          <a:xfrm>
+            <a:off x="8869680" y="320040"/>
+            <a:ext cx="2770632" cy="960120"/>
+          </a:xfrm>
+          <a:prstGeom prst="rect">
+            <a:avLst/>
+          </a:prstGeom>
+          <a:noFill/>
+          <a:ln/>
+        </p:spPr>
+        <p:txBody>
+          <a:bodyPr wrap="square" lIns="0" tIns="0" rIns="0" bIns="0" rtlCol="0" anchor="ctr"/>
+          <a:lstStyle/>
+          <a:p>
+            <a:pPr algn="ctr" indent="0" marL="0">
+              <a:buNone/>
+            </a:pPr>
+            <a:r>
+              <a:rPr lang="en-US" sz="1700" b="1" spc="100" kern="0" dirty="0">
+                <a:solidFill>
+                  <a:srgbClr val="FFFFFF"/>
+                </a:solidFill>
+                <a:latin typeface="Cambria" pitchFamily="34" charset="0"/>
+                <a:ea typeface="Cambria" pitchFamily="34" charset="-122"/>
+                <a:cs typeface="Cambria" pitchFamily="34" charset="-120"/>
+              </a:rPr>
+              <a:t>THE BIG BOOK</a:t>
+            </a:r>
+            <a:endParaRPr lang="en-US" sz="1700" dirty="0"/>
+          </a:p>
+          <a:p>
+            <a:pPr algn="ctr" indent="0" marL="0">
+              <a:buNone/>
+            </a:pPr>
+            <a:r>
+              <a:rPr lang="en-US" sz="1300" dirty="0">
+                <a:solidFill>
+                  <a:srgbClr val="C7DEEC"/>
+                </a:solidFill>
+                <a:latin typeface="Calibri" pitchFamily="34" charset="0"/>
+                <a:ea typeface="Calibri" pitchFamily="34" charset="-122"/>
+                <a:cs typeface="Calibri" pitchFamily="34" charset="-120"/>
+              </a:rPr>
+              <a:t>p. xxv</a:t>
+            </a:r>
+            <a:endParaRPr lang="en-US" sz="1700" dirty="0"/>
+          </a:p>
+        </p:txBody>
+      </p:sp>
+      <p:sp>
+        <p:nvSpPr>
+          <p:cNvPr id="6" name="Shape 4"/>
+          <p:cNvSpPr/>
+          <p:nvPr/>
+        </p:nvSpPr>
+        <p:spPr>
+          <a:xfrm>
+            <a:off x="548640" y="1554480"/>
+            <a:ext cx="11091672" cy="2057400"/>
+          </a:xfrm>
+          <a:prstGeom prst="roundRect">
+            <a:avLst>
+              <a:gd name="adj" fmla="val 3556"/>
+            </a:avLst>
+          </a:prstGeom>
+          <a:solidFill>
+            <a:srgbClr val="E2EDF4"/>
+          </a:solidFill>
+          <a:ln/>
+        </p:spPr>
+      </p:sp>
+      <p:sp>
+        <p:nvSpPr>
+          <p:cNvPr id="7" name="Text 5"/>
+          <p:cNvSpPr/>
+          <p:nvPr/>
+        </p:nvSpPr>
+        <p:spPr>
+          <a:xfrm>
+            <a:off x="914400" y="1554480"/>
+            <a:ext cx="10360152" cy="2057400"/>
+          </a:xfrm>
+          <a:prstGeom prst="rect">
+            <a:avLst/>
+          </a:prstGeom>
+          <a:noFill/>
+          <a:ln/>
+        </p:spPr>
+        <p:txBody>
+          <a:bodyPr wrap="square" lIns="0" tIns="0" rIns="0" bIns="0" rtlCol="0" anchor="ctr"/>
+          <a:lstStyle/>
+          <a:p>
+            <a:pPr indent="0" marL="0">
+              <a:lnSpc>
+                <a:spcPct val="115000"/>
+              </a:lnSpc>
+              <a:buNone/>
+            </a:pPr>
+            <a:r>
+              <a:rPr lang="en-US" sz="2000" dirty="0">
+                <a:solidFill>
+                  <a:srgbClr val="1B2A41"/>
+                </a:solidFill>
+                <a:latin typeface="Calibri" pitchFamily="34" charset="0"/>
+                <a:ea typeface="Calibri" pitchFamily="34" charset="-122"/>
+                <a:cs typeface="Calibri" pitchFamily="34" charset="-120"/>
+              </a:rPr>
+              <a:t>After they have succumbed to the desire again, as so many do, and the phenomenon of craving develops, they pass through the well-known stages of a spree, emerging remorseful, with a firm resolution not to drink again. This is repeated over and over, and unless this person can experience </a:t>
+            </a:r>
+            <a:pPr indent="0" marL="0">
+              <a:lnSpc>
+                <a:spcPct val="115000"/>
+              </a:lnSpc>
+              <a:buNone/>
+            </a:pPr>
+            <a:r>
+              <a:rPr lang="en-US" sz="2000" b="1" dirty="0">
+                <a:solidFill>
+                  <a:srgbClr val="065A82"/>
+                </a:solidFill>
+                <a:latin typeface="Calibri" pitchFamily="34" charset="0"/>
+                <a:ea typeface="Calibri" pitchFamily="34" charset="-122"/>
+                <a:cs typeface="Calibri" pitchFamily="34" charset="-120"/>
+              </a:rPr>
+              <a:t>an entire psychic change</a:t>
+            </a:r>
+            <a:pPr indent="0" marL="0">
+              <a:lnSpc>
+                <a:spcPct val="115000"/>
+              </a:lnSpc>
+              <a:buNone/>
+            </a:pPr>
+            <a:r>
+              <a:rPr lang="en-US" sz="2000" dirty="0">
+                <a:solidFill>
+                  <a:srgbClr val="1B2A41"/>
+                </a:solidFill>
+                <a:latin typeface="Calibri" pitchFamily="34" charset="0"/>
+                <a:ea typeface="Calibri" pitchFamily="34" charset="-122"/>
+                <a:cs typeface="Calibri" pitchFamily="34" charset="-120"/>
+              </a:rPr>
+              <a:t> there is very little hope of his recovery.</a:t>
+            </a:r>
+            <a:endParaRPr lang="en-US" sz="2000" dirty="0"/>
+          </a:p>
+        </p:txBody>
+      </p:sp>
+      <p:sp>
+        <p:nvSpPr>
+          <p:cNvPr id="8" name="Shape 6"/>
+          <p:cNvSpPr/>
+          <p:nvPr/>
+        </p:nvSpPr>
+        <p:spPr>
+          <a:xfrm>
+            <a:off x="548640" y="3886200"/>
+            <a:ext cx="11091672" cy="960120"/>
+          </a:xfrm>
+          <a:prstGeom prst="roundRect">
+            <a:avLst>
+              <a:gd name="adj" fmla="val 7619"/>
+            </a:avLst>
+          </a:prstGeom>
+          <a:solidFill>
+            <a:srgbClr val="1B2A41"/>
+          </a:solidFill>
+          <a:ln/>
+        </p:spPr>
+      </p:sp>
+      <p:sp>
+        <p:nvSpPr>
+          <p:cNvPr id="9" name="Text 7"/>
+          <p:cNvSpPr/>
+          <p:nvPr/>
+        </p:nvSpPr>
+        <p:spPr>
+          <a:xfrm>
+            <a:off x="914400" y="4005072"/>
+            <a:ext cx="10360152" cy="256032"/>
+          </a:xfrm>
+          <a:prstGeom prst="rect">
+            <a:avLst/>
+          </a:prstGeom>
+          <a:noFill/>
+          <a:ln/>
+        </p:spPr>
+        <p:txBody>
+          <a:bodyPr wrap="square" lIns="0" tIns="0" rIns="0" bIns="0" rtlCol="0" anchor="ctr"/>
+          <a:lstStyle/>
+          <a:p>
+            <a:pPr indent="0" marL="0">
+              <a:buNone/>
+            </a:pPr>
+            <a:r>
+              <a:rPr lang="en-US" sz="1100" b="1" spc="200" kern="0" dirty="0">
+                <a:solidFill>
+                  <a:srgbClr val="A9B8CC"/>
+                </a:solidFill>
+                <a:latin typeface="Calibri" pitchFamily="34" charset="0"/>
+                <a:ea typeface="Calibri" pitchFamily="34" charset="-122"/>
+                <a:cs typeface="Calibri" pitchFamily="34" charset="-120"/>
+              </a:rPr>
+              <a:t>MARGIN NOTE</a:t>
+            </a:r>
+            <a:endParaRPr lang="en-US" sz="1100" dirty="0"/>
+          </a:p>
+        </p:txBody>
+      </p:sp>
+      <p:sp>
+        <p:nvSpPr>
+          <p:cNvPr id="10" name="Text 8"/>
+          <p:cNvSpPr/>
+          <p:nvPr/>
+        </p:nvSpPr>
+        <p:spPr>
+          <a:xfrm>
+            <a:off x="914400" y="4279392"/>
+            <a:ext cx="10360152" cy="448056"/>
+          </a:xfrm>
+          <a:prstGeom prst="rect">
+            <a:avLst/>
+          </a:prstGeom>
+          <a:noFill/>
+          <a:ln/>
+        </p:spPr>
+        <p:txBody>
+          <a:bodyPr wrap="square" lIns="0" tIns="0" rIns="0" bIns="0" rtlCol="0" anchor="ctr"/>
+          <a:lstStyle/>
+          <a:p>
+            <a:pPr indent="0" marL="0">
+              <a:buNone/>
+            </a:pPr>
+            <a:r>
+              <a:rPr lang="en-US" sz="2200" b="1" dirty="0">
+                <a:solidFill>
+                  <a:srgbClr val="FFFFFF"/>
+                </a:solidFill>
+                <a:latin typeface="Cambria" pitchFamily="34" charset="0"/>
+                <a:ea typeface="Cambria" pitchFamily="34" charset="-122"/>
+                <a:cs typeface="Cambria" pitchFamily="34" charset="-120"/>
+              </a:rPr>
+              <a:t>Psychic = thinking.</a:t>
+            </a:r>
+            <a:endParaRPr lang="en-US" sz="2200" dirty="0"/>
+          </a:p>
+        </p:txBody>
+      </p:sp>
+      <p:sp>
+        <p:nvSpPr>
+          <p:cNvPr id="11" name="Text 9"/>
+          <p:cNvSpPr/>
+          <p:nvPr/>
+        </p:nvSpPr>
+        <p:spPr>
+          <a:xfrm>
+            <a:off x="548640" y="5029200"/>
+            <a:ext cx="11091672" cy="292608"/>
+          </a:xfrm>
+          <a:prstGeom prst="rect">
+            <a:avLst/>
+          </a:prstGeom>
+          <a:noFill/>
+          <a:ln/>
+        </p:spPr>
+        <p:txBody>
+          <a:bodyPr wrap="square" lIns="0" tIns="0" rIns="0" bIns="0" rtlCol="0" anchor="ctr"/>
+          <a:lstStyle/>
+          <a:p>
+            <a:pPr indent="0" marL="0">
+              <a:buNone/>
+            </a:pPr>
+            <a:r>
+              <a:rPr lang="en-US" sz="1200" i="1" dirty="0">
+                <a:solidFill>
+                  <a:srgbClr val="6B7A8C"/>
+                </a:solidFill>
+                <a:latin typeface="Calibri" pitchFamily="34" charset="0"/>
+                <a:ea typeface="Calibri" pitchFamily="34" charset="-122"/>
+                <a:cs typeface="Calibri" pitchFamily="34" charset="-120"/>
+              </a:rPr>
+              <a:t>Alcoholics Anonymous</a:t>
+            </a:r>
+            <a:pPr indent="0" marL="0">
+              <a:buNone/>
+            </a:pPr>
+            <a:r>
+              <a:rPr lang="en-US" sz="1200" dirty="0">
+                <a:solidFill>
+                  <a:srgbClr val="6B7A8C"/>
+                </a:solidFill>
+                <a:latin typeface="Calibri" pitchFamily="34" charset="0"/>
+                <a:ea typeface="Calibri" pitchFamily="34" charset="-122"/>
+                <a:cs typeface="Calibri" pitchFamily="34" charset="-120"/>
+              </a:rPr>
+              <a:t>, 4th ed., “The Doctor’s Opinion,” p. xxv.</a:t>
+            </a:r>
+            <a:endParaRPr lang="en-US" sz="1200" dirty="0"/>
+          </a:p>
+        </p:txBody>
+      </p:sp>
+      <p:sp>
+        <p:nvSpPr>
+          <p:cNvPr id="12" name="Text 10"/>
+          <p:cNvSpPr/>
+          <p:nvPr/>
+        </p:nvSpPr>
+        <p:spPr>
+          <a:xfrm>
+            <a:off x="548640" y="6355080"/>
+            <a:ext cx="11091672" cy="292608"/>
+          </a:xfrm>
+          <a:prstGeom prst="rect">
+            <a:avLst/>
+          </a:prstGeom>
+          <a:noFill/>
+          <a:ln/>
+        </p:spPr>
+        <p:txBody>
+          <a:bodyPr wrap="square" lIns="0" tIns="0" rIns="0" bIns="0" rtlCol="0" anchor="ctr"/>
+          <a:lstStyle/>
+          <a:p>
+            <a:pPr indent="0" marL="0">
+              <a:buNone/>
+            </a:pPr>
+            <a:r>
+              <a:rPr lang="en-US" sz="950" dirty="0">
+                <a:solidFill>
+                  <a:srgbClr val="6B7A8C"/>
+                </a:solidFill>
+                <a:latin typeface="Calibri" pitchFamily="34" charset="0"/>
+                <a:ea typeface="Calibri" pitchFamily="34" charset="-122"/>
+                <a:cs typeface="Calibri" pitchFamily="34" charset="-120"/>
+              </a:rPr>
+              <a:t>Copyright © Alcoholics Anonymous World Services, Inc. All rights reserved. Intended for personal use only, and not to be reproduced further or distributed for resale.</a:t>
+            </a:r>
+            <a:endParaRPr lang="en-US" sz="950" dirty="0"/>
+          </a:p>
+        </p:txBody>
+      </p:sp>
+    </p:spTree>
+  </p:cSld>
+  <p:clrMapOvr>
+    <a:masterClrMapping/>
+  </p:clrMapOvr>
+</p:sld>
+</file>
+
+<file path=ppt/slides/slide28.xml><?xml version="1.0" encoding="utf-8"?>
+<p:sld xmlns:a="http://schemas.openxmlformats.org/drawingml/2006/main" xmlns:r="http://schemas.openxmlformats.org/officeDocument/2006/relationships" xmlns:p="http://schemas.openxmlformats.org/presentationml/2006/main">
+  <p:cSld name="Slide 28">
+    <p:bg>
+      <p:bgPr>
+        <a:solidFill>
+          <a:srgbClr val="FFFFFF"/>
+        </a:solidFill>
+      </p:bgPr>
+    </p:bg>
+    <p:spTree>
+      <p:nvGrpSpPr>
+        <p:cNvPr id="1" name=""/>
+        <p:cNvGrpSpPr/>
+        <p:nvPr/>
+      </p:nvGrpSpPr>
+      <p:grpSpPr>
+        <a:xfrm>
+          <a:off x="0" y="0"/>
+          <a:ext cx="0" cy="0"/>
+          <a:chOff x="0" y="0"/>
+          <a:chExt cx="0" cy="0"/>
+        </a:xfrm>
+      </p:grpSpPr>
+      <p:sp>
+        <p:nvSpPr>
+          <p:cNvPr id="2" name="Text 0"/>
+          <p:cNvSpPr/>
+          <p:nvPr/>
+        </p:nvSpPr>
+        <p:spPr>
+          <a:xfrm>
+            <a:off x="548640" y="320040"/>
+            <a:ext cx="8138160" cy="566928"/>
+          </a:xfrm>
+          <a:prstGeom prst="rect">
+            <a:avLst/>
+          </a:prstGeom>
+          <a:noFill/>
+          <a:ln/>
+        </p:spPr>
+        <p:txBody>
+          <a:bodyPr wrap="square" lIns="0" tIns="0" rIns="0" bIns="0" rtlCol="0" anchor="ctr"/>
+          <a:lstStyle/>
+          <a:p>
+            <a:pPr indent="0" marL="0">
+              <a:buNone/>
+            </a:pPr>
+            <a:r>
+              <a:rPr lang="en-US" sz="3800" b="1" dirty="0">
+                <a:solidFill>
+                  <a:srgbClr val="1B2A41"/>
+                </a:solidFill>
+                <a:latin typeface="Cambria" pitchFamily="34" charset="0"/>
+                <a:ea typeface="Cambria" pitchFamily="34" charset="-122"/>
+                <a:cs typeface="Cambria" pitchFamily="34" charset="-120"/>
+              </a:rPr>
+              <a:t>Doctor, I Cannot Go On Like This</a:t>
+            </a:r>
+            <a:endParaRPr lang="en-US" sz="3800" dirty="0"/>
+          </a:p>
+        </p:txBody>
+      </p:sp>
+      <p:sp>
+        <p:nvSpPr>
+          <p:cNvPr id="3" name="Text 1"/>
+          <p:cNvSpPr/>
+          <p:nvPr/>
+        </p:nvSpPr>
+        <p:spPr>
+          <a:xfrm>
+            <a:off x="548640" y="914400"/>
+            <a:ext cx="8138160" cy="347472"/>
+          </a:xfrm>
+          <a:prstGeom prst="rect">
+            <a:avLst/>
+          </a:prstGeom>
+          <a:noFill/>
+          <a:ln/>
+        </p:spPr>
+        <p:txBody>
+          <a:bodyPr wrap="square" lIns="0" tIns="0" rIns="0" bIns="0" rtlCol="0" anchor="ctr"/>
+          <a:lstStyle/>
+          <a:p>
+            <a:pPr indent="0" marL="0">
+              <a:buNone/>
+            </a:pPr>
+            <a:r>
+              <a:rPr lang="en-US" sz="1700" i="1" dirty="0">
+                <a:solidFill>
+                  <a:srgbClr val="6B7A8C"/>
+                </a:solidFill>
+                <a:latin typeface="Calibri" pitchFamily="34" charset="0"/>
+                <a:ea typeface="Calibri" pitchFamily="34" charset="-122"/>
+                <a:cs typeface="Calibri" pitchFamily="34" charset="-120"/>
+              </a:rPr>
+              <a:t>Where medicine runs out.</a:t>
+            </a:r>
+            <a:endParaRPr lang="en-US" sz="1700" dirty="0"/>
+          </a:p>
+        </p:txBody>
+      </p:sp>
+      <p:sp>
+        <p:nvSpPr>
+          <p:cNvPr id="4" name="Shape 2"/>
+          <p:cNvSpPr/>
+          <p:nvPr/>
+        </p:nvSpPr>
+        <p:spPr>
+          <a:xfrm>
+            <a:off x="8869680" y="320040"/>
+            <a:ext cx="2770632" cy="960120"/>
+          </a:xfrm>
+          <a:prstGeom prst="roundRect">
+            <a:avLst>
+              <a:gd name="adj" fmla="val 9524"/>
+            </a:avLst>
+          </a:prstGeom>
+          <a:solidFill>
+            <a:srgbClr val="9E1B60"/>
+          </a:solidFill>
+          <a:ln/>
+        </p:spPr>
+      </p:sp>
+      <p:sp>
+        <p:nvSpPr>
+          <p:cNvPr id="5" name="Text 3"/>
+          <p:cNvSpPr/>
+          <p:nvPr/>
+        </p:nvSpPr>
+        <p:spPr>
+          <a:xfrm>
+            <a:off x="8869680" y="320040"/>
+            <a:ext cx="2770632" cy="960120"/>
+          </a:xfrm>
+          <a:prstGeom prst="rect">
+            <a:avLst/>
+          </a:prstGeom>
+          <a:noFill/>
+          <a:ln/>
+        </p:spPr>
+        <p:txBody>
+          <a:bodyPr wrap="square" lIns="0" tIns="0" rIns="0" bIns="0" rtlCol="0" anchor="ctr"/>
+          <a:lstStyle/>
+          <a:p>
+            <a:pPr algn="ctr" indent="0" marL="0">
+              <a:buNone/>
+            </a:pPr>
+            <a:r>
+              <a:rPr lang="en-US" sz="1700" b="1" spc="100" kern="0" dirty="0">
+                <a:solidFill>
+                  <a:srgbClr val="FFFFFF"/>
+                </a:solidFill>
+                <a:latin typeface="Cambria" pitchFamily="34" charset="0"/>
+                <a:ea typeface="Cambria" pitchFamily="34" charset="-122"/>
+                <a:cs typeface="Cambria" pitchFamily="34" charset="-120"/>
+              </a:rPr>
+              <a:t>THE “MUSTS”</a:t>
+            </a:r>
+            <a:endParaRPr lang="en-US" sz="1700" dirty="0"/>
+          </a:p>
+          <a:p>
+            <a:pPr algn="ctr" indent="0" marL="0">
+              <a:buNone/>
+            </a:pPr>
+            <a:r>
+              <a:rPr lang="en-US" sz="1300" dirty="0">
+                <a:solidFill>
+                  <a:srgbClr val="F7D9E8"/>
+                </a:solidFill>
+                <a:latin typeface="Calibri" pitchFamily="34" charset="0"/>
+                <a:ea typeface="Calibri" pitchFamily="34" charset="-122"/>
+                <a:cs typeface="Calibri" pitchFamily="34" charset="-120"/>
+              </a:rPr>
+              <a:t>p. xxv</a:t>
+            </a:r>
+            <a:endParaRPr lang="en-US" sz="1700" dirty="0"/>
+          </a:p>
+        </p:txBody>
+      </p:sp>
+      <p:sp>
+        <p:nvSpPr>
+          <p:cNvPr id="6" name="Shape 4"/>
+          <p:cNvSpPr/>
+          <p:nvPr/>
+        </p:nvSpPr>
+        <p:spPr>
+          <a:xfrm>
+            <a:off x="548640" y="1463040"/>
+            <a:ext cx="11091672" cy="1280160"/>
+          </a:xfrm>
+          <a:prstGeom prst="roundRect">
+            <a:avLst>
+              <a:gd name="adj" fmla="val 5714"/>
+            </a:avLst>
+          </a:prstGeom>
+          <a:solidFill>
+            <a:srgbClr val="F9E3EE"/>
+          </a:solidFill>
+          <a:ln/>
+        </p:spPr>
+      </p:sp>
+      <p:sp>
+        <p:nvSpPr>
+          <p:cNvPr id="7" name="Shape 5"/>
+          <p:cNvSpPr/>
+          <p:nvPr/>
+        </p:nvSpPr>
+        <p:spPr>
+          <a:xfrm>
+            <a:off x="914400" y="1847088"/>
+            <a:ext cx="512064" cy="512064"/>
+          </a:xfrm>
+          <a:prstGeom prst="ellipse">
+            <a:avLst/>
+          </a:prstGeom>
+          <a:solidFill>
+            <a:srgbClr val="9E1B60"/>
+          </a:solidFill>
+          <a:ln/>
+        </p:spPr>
+      </p:sp>
+      <p:sp>
+        <p:nvSpPr>
+          <p:cNvPr id="8" name="Text 6"/>
+          <p:cNvSpPr/>
+          <p:nvPr/>
+        </p:nvSpPr>
+        <p:spPr>
+          <a:xfrm>
+            <a:off x="914400" y="1847088"/>
+            <a:ext cx="512064" cy="512064"/>
+          </a:xfrm>
+          <a:prstGeom prst="rect">
+            <a:avLst/>
+          </a:prstGeom>
+          <a:noFill/>
+          <a:ln/>
+        </p:spPr>
+        <p:txBody>
+          <a:bodyPr wrap="square" lIns="0" tIns="0" rIns="0" bIns="0" rtlCol="0" anchor="ctr"/>
+          <a:lstStyle/>
+          <a:p>
+            <a:pPr algn="ctr" indent="0" marL="0">
+              <a:buNone/>
+            </a:pPr>
+            <a:r>
+              <a:rPr lang="en-US" sz="2000" b="1" dirty="0">
+                <a:solidFill>
+                  <a:srgbClr val="FFFFFF"/>
+                </a:solidFill>
+                <a:latin typeface="Cambria" pitchFamily="34" charset="0"/>
+                <a:ea typeface="Cambria" pitchFamily="34" charset="-122"/>
+                <a:cs typeface="Cambria" pitchFamily="34" charset="-120"/>
+              </a:rPr>
+              <a:t>1</a:t>
+            </a:r>
+            <a:endParaRPr lang="en-US" sz="2000" dirty="0"/>
+          </a:p>
+        </p:txBody>
+      </p:sp>
+      <p:sp>
+        <p:nvSpPr>
+          <p:cNvPr id="9" name="Text 7"/>
+          <p:cNvSpPr/>
+          <p:nvPr/>
+        </p:nvSpPr>
+        <p:spPr>
+          <a:xfrm>
+            <a:off x="1691640" y="1463040"/>
+            <a:ext cx="9601200" cy="1280160"/>
+          </a:xfrm>
+          <a:prstGeom prst="rect">
+            <a:avLst/>
+          </a:prstGeom>
+          <a:noFill/>
+          <a:ln/>
+        </p:spPr>
+        <p:txBody>
+          <a:bodyPr wrap="square" lIns="0" tIns="0" rIns="0" bIns="0" rtlCol="0" anchor="ctr"/>
+          <a:lstStyle/>
+          <a:p>
+            <a:pPr indent="0" marL="0">
+              <a:lnSpc>
+                <a:spcPct val="115000"/>
+              </a:lnSpc>
+              <a:buNone/>
+            </a:pPr>
+            <a:r>
+              <a:rPr lang="en-US" sz="1900" dirty="0">
+                <a:solidFill>
+                  <a:srgbClr val="1B2A41"/>
+                </a:solidFill>
+                <a:latin typeface="Calibri" pitchFamily="34" charset="0"/>
+                <a:ea typeface="Calibri" pitchFamily="34" charset="-122"/>
+                <a:cs typeface="Calibri" pitchFamily="34" charset="-120"/>
+              </a:rPr>
+              <a:t>Men have cried out to me in sincere and despairing appeal: “Doctor, I cannot go on like this! I have everything to live for! </a:t>
+            </a:r>
+            <a:pPr indent="0" marL="0">
+              <a:lnSpc>
+                <a:spcPct val="115000"/>
+              </a:lnSpc>
+              <a:buNone/>
+            </a:pPr>
+            <a:r>
+              <a:rPr lang="en-US" sz="1900" b="1" dirty="0">
+                <a:solidFill>
+                  <a:srgbClr val="9E1B60"/>
+                </a:solidFill>
+                <a:latin typeface="Calibri" pitchFamily="34" charset="0"/>
+                <a:ea typeface="Calibri" pitchFamily="34" charset="-122"/>
+                <a:cs typeface="Calibri" pitchFamily="34" charset="-120"/>
+              </a:rPr>
+              <a:t>I must stop, but I cannot!</a:t>
+            </a:r>
+            <a:pPr indent="0" marL="0">
+              <a:lnSpc>
+                <a:spcPct val="115000"/>
+              </a:lnSpc>
+              <a:buNone/>
+            </a:pPr>
+            <a:r>
+              <a:rPr lang="en-US" sz="1900" dirty="0">
+                <a:solidFill>
+                  <a:srgbClr val="1B2A41"/>
+                </a:solidFill>
+                <a:latin typeface="Calibri" pitchFamily="34" charset="0"/>
+                <a:ea typeface="Calibri" pitchFamily="34" charset="-122"/>
+                <a:cs typeface="Calibri" pitchFamily="34" charset="-120"/>
+              </a:rPr>
+              <a:t> You must help me!”</a:t>
+            </a:r>
+            <a:endParaRPr lang="en-US" sz="1900" dirty="0"/>
+          </a:p>
+        </p:txBody>
+      </p:sp>
+      <p:sp>
+        <p:nvSpPr>
+          <p:cNvPr id="10" name="Shape 8"/>
+          <p:cNvSpPr/>
+          <p:nvPr/>
+        </p:nvSpPr>
+        <p:spPr>
+          <a:xfrm>
+            <a:off x="548640" y="2926080"/>
+            <a:ext cx="11091672" cy="1097280"/>
+          </a:xfrm>
+          <a:prstGeom prst="roundRect">
+            <a:avLst>
+              <a:gd name="adj" fmla="val 6667"/>
+            </a:avLst>
+          </a:prstGeom>
+          <a:solidFill>
+            <a:srgbClr val="F9E3EE"/>
+          </a:solidFill>
+          <a:ln/>
+        </p:spPr>
+      </p:sp>
+      <p:sp>
+        <p:nvSpPr>
+          <p:cNvPr id="11" name="Shape 9"/>
+          <p:cNvSpPr/>
+          <p:nvPr/>
+        </p:nvSpPr>
+        <p:spPr>
+          <a:xfrm>
+            <a:off x="914400" y="3218688"/>
+            <a:ext cx="512064" cy="512064"/>
+          </a:xfrm>
+          <a:prstGeom prst="ellipse">
+            <a:avLst/>
+          </a:prstGeom>
+          <a:solidFill>
+            <a:srgbClr val="9E1B60"/>
+          </a:solidFill>
+          <a:ln/>
+        </p:spPr>
+      </p:sp>
+      <p:sp>
+        <p:nvSpPr>
+          <p:cNvPr id="12" name="Text 10"/>
+          <p:cNvSpPr/>
+          <p:nvPr/>
+        </p:nvSpPr>
+        <p:spPr>
+          <a:xfrm>
+            <a:off x="914400" y="3218688"/>
+            <a:ext cx="512064" cy="512064"/>
+          </a:xfrm>
+          <a:prstGeom prst="rect">
+            <a:avLst/>
+          </a:prstGeom>
+          <a:noFill/>
+          <a:ln/>
+        </p:spPr>
+        <p:txBody>
+          <a:bodyPr wrap="square" lIns="0" tIns="0" rIns="0" bIns="0" rtlCol="0" anchor="ctr"/>
+          <a:lstStyle/>
+          <a:p>
+            <a:pPr algn="ctr" indent="0" marL="0">
+              <a:buNone/>
+            </a:pPr>
+            <a:r>
+              <a:rPr lang="en-US" sz="2000" b="1" dirty="0">
+                <a:solidFill>
+                  <a:srgbClr val="FFFFFF"/>
+                </a:solidFill>
+                <a:latin typeface="Cambria" pitchFamily="34" charset="0"/>
+                <a:ea typeface="Cambria" pitchFamily="34" charset="-122"/>
+                <a:cs typeface="Cambria" pitchFamily="34" charset="-120"/>
+              </a:rPr>
+              <a:t>2</a:t>
+            </a:r>
+            <a:endParaRPr lang="en-US" sz="2000" dirty="0"/>
+          </a:p>
+        </p:txBody>
+      </p:sp>
+      <p:sp>
+        <p:nvSpPr>
+          <p:cNvPr id="13" name="Text 11"/>
+          <p:cNvSpPr/>
+          <p:nvPr/>
+        </p:nvSpPr>
+        <p:spPr>
+          <a:xfrm>
+            <a:off x="1691640" y="2926080"/>
+            <a:ext cx="9601200" cy="1097280"/>
+          </a:xfrm>
+          <a:prstGeom prst="rect">
+            <a:avLst/>
+          </a:prstGeom>
+          <a:noFill/>
+          <a:ln/>
+        </p:spPr>
+        <p:txBody>
+          <a:bodyPr wrap="square" lIns="0" tIns="0" rIns="0" bIns="0" rtlCol="0" anchor="ctr"/>
+          <a:lstStyle/>
+          <a:p>
+            <a:pPr indent="0" marL="0">
+              <a:lnSpc>
+                <a:spcPct val="115000"/>
+              </a:lnSpc>
+              <a:buNone/>
+            </a:pPr>
+            <a:r>
+              <a:rPr lang="en-US" sz="1900" dirty="0">
+                <a:solidFill>
+                  <a:srgbClr val="1B2A41"/>
+                </a:solidFill>
+                <a:latin typeface="Calibri" pitchFamily="34" charset="0"/>
+                <a:ea typeface="Calibri" pitchFamily="34" charset="-122"/>
+                <a:cs typeface="Calibri" pitchFamily="34" charset="-120"/>
+              </a:rPr>
+              <a:t>Faced with this problem, if a doctor is honest with himself, </a:t>
+            </a:r>
+            <a:pPr indent="0" marL="0">
+              <a:lnSpc>
+                <a:spcPct val="115000"/>
+              </a:lnSpc>
+              <a:buNone/>
+            </a:pPr>
+            <a:r>
+              <a:rPr lang="en-US" sz="1900" b="1" dirty="0">
+                <a:solidFill>
+                  <a:srgbClr val="9E1B60"/>
+                </a:solidFill>
+                <a:latin typeface="Calibri" pitchFamily="34" charset="0"/>
+                <a:ea typeface="Calibri" pitchFamily="34" charset="-122"/>
+                <a:cs typeface="Calibri" pitchFamily="34" charset="-120"/>
+              </a:rPr>
+              <a:t>he must sometimes feel his own inadequacy</a:t>
+            </a:r>
+            <a:pPr indent="0" marL="0">
+              <a:lnSpc>
+                <a:spcPct val="115000"/>
+              </a:lnSpc>
+              <a:buNone/>
+            </a:pPr>
+            <a:r>
+              <a:rPr lang="en-US" sz="1900" dirty="0">
+                <a:solidFill>
+                  <a:srgbClr val="1B2A41"/>
+                </a:solidFill>
+                <a:latin typeface="Calibri" pitchFamily="34" charset="0"/>
+                <a:ea typeface="Calibri" pitchFamily="34" charset="-122"/>
+                <a:cs typeface="Calibri" pitchFamily="34" charset="-120"/>
+              </a:rPr>
+              <a:t>.</a:t>
+            </a:r>
+            <a:endParaRPr lang="en-US" sz="1900" dirty="0"/>
+          </a:p>
+        </p:txBody>
+      </p:sp>
+      <p:sp>
+        <p:nvSpPr>
+          <p:cNvPr id="14" name="Shape 12"/>
+          <p:cNvSpPr/>
+          <p:nvPr/>
+        </p:nvSpPr>
+        <p:spPr>
+          <a:xfrm>
+            <a:off x="548640" y="4206240"/>
+            <a:ext cx="11091672" cy="1097280"/>
+          </a:xfrm>
+          <a:prstGeom prst="roundRect">
+            <a:avLst>
+              <a:gd name="adj" fmla="val 6667"/>
+            </a:avLst>
+          </a:prstGeom>
+          <a:solidFill>
+            <a:srgbClr val="F9E3EE"/>
+          </a:solidFill>
+          <a:ln/>
+        </p:spPr>
+      </p:sp>
+      <p:sp>
+        <p:nvSpPr>
+          <p:cNvPr id="15" name="Shape 13"/>
+          <p:cNvSpPr/>
+          <p:nvPr/>
+        </p:nvSpPr>
+        <p:spPr>
+          <a:xfrm>
+            <a:off x="914400" y="4498848"/>
+            <a:ext cx="512064" cy="512064"/>
+          </a:xfrm>
+          <a:prstGeom prst="ellipse">
+            <a:avLst/>
+          </a:prstGeom>
+          <a:solidFill>
+            <a:srgbClr val="9E1B60"/>
+          </a:solidFill>
+          <a:ln/>
+        </p:spPr>
+      </p:sp>
+      <p:sp>
+        <p:nvSpPr>
+          <p:cNvPr id="16" name="Text 14"/>
+          <p:cNvSpPr/>
+          <p:nvPr/>
+        </p:nvSpPr>
+        <p:spPr>
+          <a:xfrm>
+            <a:off x="914400" y="4498848"/>
+            <a:ext cx="512064" cy="512064"/>
+          </a:xfrm>
+          <a:prstGeom prst="rect">
+            <a:avLst/>
+          </a:prstGeom>
+          <a:noFill/>
+          <a:ln/>
+        </p:spPr>
+        <p:txBody>
+          <a:bodyPr wrap="square" lIns="0" tIns="0" rIns="0" bIns="0" rtlCol="0" anchor="ctr"/>
+          <a:lstStyle/>
+          <a:p>
+            <a:pPr algn="ctr" indent="0" marL="0">
+              <a:buNone/>
+            </a:pPr>
+            <a:r>
+              <a:rPr lang="en-US" sz="2000" b="1" dirty="0">
+                <a:solidFill>
+                  <a:srgbClr val="FFFFFF"/>
+                </a:solidFill>
+                <a:latin typeface="Cambria" pitchFamily="34" charset="0"/>
+                <a:ea typeface="Cambria" pitchFamily="34" charset="-122"/>
+                <a:cs typeface="Cambria" pitchFamily="34" charset="-120"/>
+              </a:rPr>
+              <a:t>3</a:t>
+            </a:r>
+            <a:endParaRPr lang="en-US" sz="2000" dirty="0"/>
+          </a:p>
+        </p:txBody>
+      </p:sp>
+      <p:sp>
+        <p:nvSpPr>
+          <p:cNvPr id="17" name="Text 15"/>
+          <p:cNvSpPr/>
+          <p:nvPr/>
+        </p:nvSpPr>
+        <p:spPr>
+          <a:xfrm>
+            <a:off x="1691640" y="4206240"/>
+            <a:ext cx="9601200" cy="1097280"/>
+          </a:xfrm>
+          <a:prstGeom prst="rect">
+            <a:avLst/>
+          </a:prstGeom>
+          <a:noFill/>
+          <a:ln/>
+        </p:spPr>
+        <p:txBody>
+          <a:bodyPr wrap="square" lIns="0" tIns="0" rIns="0" bIns="0" rtlCol="0" anchor="ctr"/>
+          <a:lstStyle/>
+          <a:p>
+            <a:pPr indent="0" marL="0">
+              <a:lnSpc>
+                <a:spcPct val="115000"/>
+              </a:lnSpc>
+              <a:buNone/>
+            </a:pPr>
+            <a:r>
+              <a:rPr lang="en-US" sz="1900" dirty="0">
+                <a:solidFill>
+                  <a:srgbClr val="1B2A41"/>
+                </a:solidFill>
+                <a:latin typeface="Calibri" pitchFamily="34" charset="0"/>
+                <a:ea typeface="Calibri" pitchFamily="34" charset="-122"/>
+                <a:cs typeface="Calibri" pitchFamily="34" charset="-120"/>
+              </a:rPr>
+              <a:t>…</a:t>
+            </a:r>
+            <a:pPr indent="0" marL="0">
+              <a:lnSpc>
+                <a:spcPct val="115000"/>
+              </a:lnSpc>
+              <a:buNone/>
+            </a:pPr>
+            <a:r>
+              <a:rPr lang="en-US" sz="1900" b="1" dirty="0">
+                <a:solidFill>
+                  <a:srgbClr val="9E1B60"/>
+                </a:solidFill>
+                <a:latin typeface="Calibri" pitchFamily="34" charset="0"/>
+                <a:ea typeface="Calibri" pitchFamily="34" charset="-122"/>
+                <a:cs typeface="Calibri" pitchFamily="34" charset="-120"/>
+              </a:rPr>
+              <a:t>we physicians must admit we have made little impression upon the problem as a whole</a:t>
+            </a:r>
+            <a:pPr indent="0" marL="0">
+              <a:lnSpc>
+                <a:spcPct val="115000"/>
+              </a:lnSpc>
+              <a:buNone/>
+            </a:pPr>
+            <a:r>
+              <a:rPr lang="en-US" sz="1900" dirty="0">
+                <a:solidFill>
+                  <a:srgbClr val="1B2A41"/>
+                </a:solidFill>
+                <a:latin typeface="Calibri" pitchFamily="34" charset="0"/>
+                <a:ea typeface="Calibri" pitchFamily="34" charset="-122"/>
+                <a:cs typeface="Calibri" pitchFamily="34" charset="-120"/>
+              </a:rPr>
+              <a:t>.</a:t>
+            </a:r>
+            <a:endParaRPr lang="en-US" sz="1900" dirty="0"/>
+          </a:p>
+        </p:txBody>
+      </p:sp>
+      <p:sp>
+        <p:nvSpPr>
+          <p:cNvPr id="18" name="Text 16"/>
+          <p:cNvSpPr/>
+          <p:nvPr/>
+        </p:nvSpPr>
+        <p:spPr>
+          <a:xfrm>
+            <a:off x="548640" y="5440680"/>
+            <a:ext cx="11091672" cy="292608"/>
+          </a:xfrm>
+          <a:prstGeom prst="rect">
+            <a:avLst/>
+          </a:prstGeom>
+          <a:noFill/>
+          <a:ln/>
+        </p:spPr>
+        <p:txBody>
+          <a:bodyPr wrap="square" lIns="0" tIns="0" rIns="0" bIns="0" rtlCol="0" anchor="ctr"/>
+          <a:lstStyle/>
+          <a:p>
+            <a:pPr indent="0" marL="0">
+              <a:buNone/>
+            </a:pPr>
+            <a:r>
+              <a:rPr lang="en-US" sz="1200" i="1" dirty="0">
+                <a:solidFill>
+                  <a:srgbClr val="6B7A8C"/>
+                </a:solidFill>
+                <a:latin typeface="Calibri" pitchFamily="34" charset="0"/>
+                <a:ea typeface="Calibri" pitchFamily="34" charset="-122"/>
+                <a:cs typeface="Calibri" pitchFamily="34" charset="-120"/>
+              </a:rPr>
+              <a:t>Alcoholics Anonymous</a:t>
+            </a:r>
+            <a:pPr indent="0" marL="0">
+              <a:buNone/>
+            </a:pPr>
+            <a:r>
+              <a:rPr lang="en-US" sz="1200" dirty="0">
+                <a:solidFill>
+                  <a:srgbClr val="6B7A8C"/>
+                </a:solidFill>
+                <a:latin typeface="Calibri" pitchFamily="34" charset="0"/>
+                <a:ea typeface="Calibri" pitchFamily="34" charset="-122"/>
+                <a:cs typeface="Calibri" pitchFamily="34" charset="-120"/>
+              </a:rPr>
+              <a:t>, 4th ed., “The Doctor’s Opinion,” p. xxv.</a:t>
+            </a:r>
+            <a:endParaRPr lang="en-US" sz="1200" dirty="0"/>
+          </a:p>
+        </p:txBody>
+      </p:sp>
+      <p:sp>
+        <p:nvSpPr>
+          <p:cNvPr id="19" name="Text 17"/>
+          <p:cNvSpPr/>
+          <p:nvPr/>
+        </p:nvSpPr>
+        <p:spPr>
+          <a:xfrm>
+            <a:off x="548640" y="6355080"/>
+            <a:ext cx="11091672" cy="292608"/>
+          </a:xfrm>
+          <a:prstGeom prst="rect">
+            <a:avLst/>
+          </a:prstGeom>
+          <a:noFill/>
+          <a:ln/>
+        </p:spPr>
+        <p:txBody>
+          <a:bodyPr wrap="square" lIns="0" tIns="0" rIns="0" bIns="0" rtlCol="0" anchor="ctr"/>
+          <a:lstStyle/>
+          <a:p>
+            <a:pPr indent="0" marL="0">
+              <a:buNone/>
+            </a:pPr>
+            <a:r>
+              <a:rPr lang="en-US" sz="950" dirty="0">
+                <a:solidFill>
+                  <a:srgbClr val="6B7A8C"/>
+                </a:solidFill>
+                <a:latin typeface="Calibri" pitchFamily="34" charset="0"/>
+                <a:ea typeface="Calibri" pitchFamily="34" charset="-122"/>
+                <a:cs typeface="Calibri" pitchFamily="34" charset="-120"/>
+              </a:rPr>
+              <a:t>Copyright © Alcoholics Anonymous World Services, Inc. All rights reserved. Intended for personal use only, and not to be reproduced further or distributed for resale.</a:t>
+            </a:r>
+            <a:endParaRPr lang="en-US" sz="950" dirty="0"/>
+          </a:p>
+        </p:txBody>
+      </p:sp>
+    </p:spTree>
+  </p:cSld>
+  <p:clrMapOvr>
+    <a:masterClrMapping/>
+  </p:clrMapOvr>
+</p:sld>
+</file>
+
 <file path=ppt/slides/slide3.xml><?xml version="1.0" encoding="utf-8"?>
 <p:sld xmlns:a="http://schemas.openxmlformats.org/drawingml/2006/main" xmlns:r="http://schemas.openxmlformats.org/officeDocument/2006/relationships" xmlns:p="http://schemas.openxmlformats.org/presentationml/2006/main">
   <p:cSld name="Slide 3">

</xml_diff>

<commit_message>
Add slides 29-30: the five types and the one symptom (p. xxvi)
Five labeled rows alternating green and blue as the highlighting does, then the
paragraph the margin brace marks IMPORTANT - which becomes the label on a solid
blue bar carrying 'the only relief we have to suggest is entire abstinence.'

'entire abstinence' is double-underlined; the page was enlarged to confirm two
distinct pen strokes before committing to u=dbl.

Co-Authored-By: Claude Opus 5 <noreply@anthropic.com>
Claude-Session: https://claude.ai/code/session_01NuCgD3Z7aWvkQrsSvAUX4h
</commit_message>
<xml_diff>
--- a/aa-slideshow/aa-big-book-study.pptx
+++ b/aa-slideshow/aa-big-book-study.pptx
@@ -33,9 +33,11 @@
     <p:sldId id="281" r:id="rId27"/>
     <p:sldId id="282" r:id="rId28"/>
     <p:sldId id="283" r:id="rId29"/>
+    <p:sldId id="284" r:id="rId30"/>
+    <p:sldId id="285" r:id="rId31"/>
   </p:sldIdLst>
   <p:notesMasterIdLst>
-    <p:notesMasterId r:id="rId30"/>
+    <p:notesMasterId r:id="rId32"/>
   </p:notesMasterIdLst>
   <p:sldSz cx="12192000" cy="6858000"/>
   <p:notesSz cx="6858000" cy="12192000"/>
@@ -2447,6 +2449,103 @@
 </p:notes>
 </file>
 
+<file path=ppt/notesSlides/notesSlide29.xml><?xml version="1.0" encoding="utf-8"?>
+<p:notes xmlns:a="http://schemas.openxmlformats.org/drawingml/2006/main" xmlns:r="http://schemas.openxmlformats.org/officeDocument/2006/relationships" xmlns:p="http://schemas.openxmlformats.org/presentationml/2006/main">
+  <p:cSld>
+    <p:spTree>
+      <p:nvGrpSpPr>
+        <p:cNvPr id="1" name=""/>
+        <p:cNvGrpSpPr/>
+        <p:nvPr/>
+      </p:nvGrpSpPr>
+      <p:grpSpPr>
+        <a:xfrm>
+          <a:off x="0" y="0"/>
+          <a:ext cx="0" cy="0"/>
+          <a:chOff x="0" y="0"/>
+          <a:chExt cx="0" cy="0"/>
+        </a:xfrm>
+      </p:grpSpPr>
+      <p:sp>
+        <p:nvSpPr>
+          <p:cNvPr id="2" name="Slide Image Placeholder 1"/>
+          <p:cNvSpPr>
+            <a:spLocks noGrp="1" noRot="1" noChangeAspect="1"/>
+          </p:cNvSpPr>
+          <p:nvPr>
+            <p:ph type="sldImg"/>
+          </p:nvPr>
+        </p:nvSpPr>
+        <p:spPr/>
+      </p:sp>
+      <p:sp>
+        <p:nvSpPr>
+          <p:cNvPr id="3" name="Notes Placeholder 2"/>
+          <p:cNvSpPr>
+            <a:spLocks noGrp="1"/>
+          </p:cNvSpPr>
+          <p:nvPr>
+            <p:ph type="body" idx="1"/>
+          </p:nvPr>
+        </p:nvSpPr>
+        <p:spPr/>
+        <p:txBody>
+          <a:bodyPr/>
+          <a:lstStyle/>
+          <a:p>
+            <a:r>
+              <a:rPr lang="en-US" dirty="0"/>
+              <a:t>Five types, and the doctor is not being unkind about any of them. He is showing that the
+illness does not care what sort of person you are.
+Type I - over-remorseful, always going on the wagon for keeps. Many resolutions, but never
+a decision. Sit on that difference.
+Type II - unwilling to admit he cannot take a drink. Changes his brand, changes his
+environment. Anything but the one admission.
+Type III - believes that after enough time off he can drink safely again.
+Type IV - the manic-depressive, least understood by his friends.
+Type V - entirely normal in every respect except one. Able, intelligent, friendly people.
+That one is on the list so nobody in the room gets to disqualify himself for looking fine.</a:t>
+            </a:r>
+            <a:endParaRPr lang="en-US" dirty="0"/>
+          </a:p>
+        </p:txBody>
+      </p:sp>
+      <p:sp>
+        <p:nvSpPr>
+          <p:cNvPr id="4" name="Slide Number Placeholder 3"/>
+          <p:cNvSpPr>
+            <a:spLocks noGrp="1"/>
+          </p:cNvSpPr>
+          <p:nvPr>
+            <p:ph type="sldNum" sz="quarter" idx="10"/>
+          </p:nvPr>
+        </p:nvSpPr>
+        <p:spPr/>
+        <p:txBody>
+          <a:bodyPr/>
+          <a:lstStyle/>
+          <a:p>
+            <a:fld id="{F7021451-1387-4CA6-816F-3879F97B5CBC}" type="slidenum">
+              <a:rPr lang="en-US"/>
+              <a:t>29</a:t>
+            </a:fld>
+            <a:endParaRPr lang="en-US"/>
+          </a:p>
+        </p:txBody>
+      </p:sp>
+    </p:spTree>
+    <p:extLst>
+      <p:ext uri="{BB962C8B-B14F-4D97-AF65-F5344CB8AC3E}">
+        <p14:creationId xmlns:p14="http://schemas.microsoft.com/office/powerpoint/2010/main" val="1024086991"/>
+      </p:ext>
+    </p:extLst>
+  </p:cSld>
+  <p:clrMapOvr>
+    <a:masterClrMapping/>
+  </p:clrMapOvr>
+</p:notes>
+</file>
+
 <file path=ppt/notesSlides/notesSlide3.xml><?xml version="1.0" encoding="utf-8"?>
 <p:notes xmlns:a="http://schemas.openxmlformats.org/drawingml/2006/main" xmlns:r="http://schemas.openxmlformats.org/officeDocument/2006/relationships" xmlns:p="http://schemas.openxmlformats.org/presentationml/2006/main">
   <p:cSld>
@@ -2523,6 +2622,102 @@
             <a:fld id="{F7021451-1387-4CA6-816F-3879F97B5CBC}" type="slidenum">
               <a:rPr lang="en-US"/>
               <a:t>3</a:t>
+            </a:fld>
+            <a:endParaRPr lang="en-US"/>
+          </a:p>
+        </p:txBody>
+      </p:sp>
+    </p:spTree>
+    <p:extLst>
+      <p:ext uri="{BB962C8B-B14F-4D97-AF65-F5344CB8AC3E}">
+        <p14:creationId xmlns:p14="http://schemas.microsoft.com/office/powerpoint/2010/main" val="1024086991"/>
+      </p:ext>
+    </p:extLst>
+  </p:cSld>
+  <p:clrMapOvr>
+    <a:masterClrMapping/>
+  </p:clrMapOvr>
+</p:notes>
+</file>
+
+<file path=ppt/notesSlides/notesSlide30.xml><?xml version="1.0" encoding="utf-8"?>
+<p:notes xmlns:a="http://schemas.openxmlformats.org/drawingml/2006/main" xmlns:r="http://schemas.openxmlformats.org/officeDocument/2006/relationships" xmlns:p="http://schemas.openxmlformats.org/presentationml/2006/main">
+  <p:cSld>
+    <p:spTree>
+      <p:nvGrpSpPr>
+        <p:cNvPr id="1" name=""/>
+        <p:cNvGrpSpPr/>
+        <p:nvPr/>
+      </p:nvGrpSpPr>
+      <p:grpSpPr>
+        <a:xfrm>
+          <a:off x="0" y="0"/>
+          <a:ext cx="0" cy="0"/>
+          <a:chOff x="0" y="0"/>
+          <a:chExt cx="0" cy="0"/>
+        </a:xfrm>
+      </p:grpSpPr>
+      <p:sp>
+        <p:nvSpPr>
+          <p:cNvPr id="2" name="Slide Image Placeholder 1"/>
+          <p:cNvSpPr>
+            <a:spLocks noGrp="1" noRot="1" noChangeAspect="1"/>
+          </p:cNvSpPr>
+          <p:nvPr>
+            <p:ph type="sldImg"/>
+          </p:nvPr>
+        </p:nvSpPr>
+        <p:spPr/>
+      </p:sp>
+      <p:sp>
+        <p:nvSpPr>
+          <p:cNvPr id="3" name="Notes Placeholder 2"/>
+          <p:cNvSpPr>
+            <a:spLocks noGrp="1"/>
+          </p:cNvSpPr>
+          <p:nvPr>
+            <p:ph type="body" idx="1"/>
+          </p:nvPr>
+        </p:nvSpPr>
+        <p:spPr/>
+        <p:txBody>
+          <a:bodyPr/>
+          <a:lstStyle/>
+          <a:p>
+            <a:r>
+              <a:rPr lang="en-US" dirty="0"/>
+              <a:t>This is the paragraph the margin marks IMPORTANT, and it is the one that ties the five
+types together.
+Whatever type a man is, one symptom is common to all of them: he cannot start drinking
+without developing the phenomenon of craving. Cannot start.
+Sets them apart as a distinct entity - not worse people, a different category.
+Never permanently eradicated, by any treatment he knows of. That word is doing a lot of
+work. Not cured. Arrested, at best.
+So the only relief he has to suggest is entire abstinence - double underlined in the study
+copy. Entire. Not moderation, not management. And relief, not cure.</a:t>
+            </a:r>
+            <a:endParaRPr lang="en-US" dirty="0"/>
+          </a:p>
+        </p:txBody>
+      </p:sp>
+      <p:sp>
+        <p:nvSpPr>
+          <p:cNvPr id="4" name="Slide Number Placeholder 3"/>
+          <p:cNvSpPr>
+            <a:spLocks noGrp="1"/>
+          </p:cNvSpPr>
+          <p:nvPr>
+            <p:ph type="sldNum" sz="quarter" idx="10"/>
+          </p:nvPr>
+        </p:nvSpPr>
+        <p:spPr/>
+        <p:txBody>
+          <a:bodyPr/>
+          <a:lstStyle/>
+          <a:p>
+            <a:fld id="{F7021451-1387-4CA6-816F-3879F97B5CBC}" type="slidenum">
+              <a:rPr lang="en-US"/>
+              <a:t>30</a:t>
             </a:fld>
             <a:endParaRPr lang="en-US"/>
           </a:p>
@@ -15829,6 +16024,911 @@
 </p:sld>
 </file>
 
+<file path=ppt/slides/slide29.xml><?xml version="1.0" encoding="utf-8"?>
+<p:sld xmlns:a="http://schemas.openxmlformats.org/drawingml/2006/main" xmlns:r="http://schemas.openxmlformats.org/officeDocument/2006/relationships" xmlns:p="http://schemas.openxmlformats.org/presentationml/2006/main">
+  <p:cSld name="Slide 29">
+    <p:bg>
+      <p:bgPr>
+        <a:solidFill>
+          <a:srgbClr val="FFFFFF"/>
+        </a:solidFill>
+      </p:bgPr>
+    </p:bg>
+    <p:spTree>
+      <p:nvGrpSpPr>
+        <p:cNvPr id="1" name=""/>
+        <p:cNvGrpSpPr/>
+        <p:nvPr/>
+      </p:nvGrpSpPr>
+      <p:grpSpPr>
+        <a:xfrm>
+          <a:off x="0" y="0"/>
+          <a:ext cx="0" cy="0"/>
+          <a:chOff x="0" y="0"/>
+          <a:chExt cx="0" cy="0"/>
+        </a:xfrm>
+      </p:grpSpPr>
+      <p:sp>
+        <p:nvSpPr>
+          <p:cNvPr id="2" name="Text 0"/>
+          <p:cNvSpPr/>
+          <p:nvPr/>
+        </p:nvSpPr>
+        <p:spPr>
+          <a:xfrm>
+            <a:off x="548640" y="320040"/>
+            <a:ext cx="8138160" cy="566928"/>
+          </a:xfrm>
+          <a:prstGeom prst="rect">
+            <a:avLst/>
+          </a:prstGeom>
+          <a:noFill/>
+          <a:ln/>
+        </p:spPr>
+        <p:txBody>
+          <a:bodyPr wrap="square" lIns="0" tIns="0" rIns="0" bIns="0" rtlCol="0" anchor="ctr"/>
+          <a:lstStyle/>
+          <a:p>
+            <a:pPr indent="0" marL="0">
+              <a:buNone/>
+            </a:pPr>
+            <a:r>
+              <a:rPr lang="en-US" sz="3800" b="1" dirty="0">
+                <a:solidFill>
+                  <a:srgbClr val="1B2A41"/>
+                </a:solidFill>
+                <a:latin typeface="Cambria" pitchFamily="34" charset="0"/>
+                <a:ea typeface="Cambria" pitchFamily="34" charset="-122"/>
+                <a:cs typeface="Cambria" pitchFamily="34" charset="-120"/>
+              </a:rPr>
+              <a:t>The Classification of Alcoholics</a:t>
+            </a:r>
+            <a:endParaRPr lang="en-US" sz="3800" dirty="0"/>
+          </a:p>
+        </p:txBody>
+      </p:sp>
+      <p:sp>
+        <p:nvSpPr>
+          <p:cNvPr id="3" name="Text 1"/>
+          <p:cNvSpPr/>
+          <p:nvPr/>
+        </p:nvSpPr>
+        <p:spPr>
+          <a:xfrm>
+            <a:off x="548640" y="914400"/>
+            <a:ext cx="8138160" cy="347472"/>
+          </a:xfrm>
+          <a:prstGeom prst="rect">
+            <a:avLst/>
+          </a:prstGeom>
+          <a:noFill/>
+          <a:ln/>
+        </p:spPr>
+        <p:txBody>
+          <a:bodyPr wrap="square" lIns="0" tIns="0" rIns="0" bIns="0" rtlCol="0" anchor="ctr"/>
+          <a:lstStyle/>
+          <a:p>
+            <a:pPr indent="0" marL="0">
+              <a:buNone/>
+            </a:pPr>
+            <a:r>
+              <a:rPr lang="en-US" sz="1700" i="1" dirty="0">
+                <a:solidFill>
+                  <a:srgbClr val="6B7A8C"/>
+                </a:solidFill>
+                <a:latin typeface="Calibri" pitchFamily="34" charset="0"/>
+                <a:ea typeface="Calibri" pitchFamily="34" charset="-122"/>
+                <a:cs typeface="Calibri" pitchFamily="34" charset="-120"/>
+              </a:rPr>
+              <a:t>…seems most difficult, and in much detail is outside the scope of this book.</a:t>
+            </a:r>
+            <a:endParaRPr lang="en-US" sz="1700" dirty="0"/>
+          </a:p>
+        </p:txBody>
+      </p:sp>
+      <p:sp>
+        <p:nvSpPr>
+          <p:cNvPr id="4" name="Shape 2"/>
+          <p:cNvSpPr/>
+          <p:nvPr/>
+        </p:nvSpPr>
+        <p:spPr>
+          <a:xfrm>
+            <a:off x="8869680" y="320040"/>
+            <a:ext cx="2770632" cy="960120"/>
+          </a:xfrm>
+          <a:prstGeom prst="roundRect">
+            <a:avLst>
+              <a:gd name="adj" fmla="val 9524"/>
+            </a:avLst>
+          </a:prstGeom>
+          <a:solidFill>
+            <a:srgbClr val="1B2A41"/>
+          </a:solidFill>
+          <a:ln/>
+        </p:spPr>
+      </p:sp>
+      <p:sp>
+        <p:nvSpPr>
+          <p:cNvPr id="5" name="Text 3"/>
+          <p:cNvSpPr/>
+          <p:nvPr/>
+        </p:nvSpPr>
+        <p:spPr>
+          <a:xfrm>
+            <a:off x="8869680" y="320040"/>
+            <a:ext cx="2770632" cy="960120"/>
+          </a:xfrm>
+          <a:prstGeom prst="rect">
+            <a:avLst/>
+          </a:prstGeom>
+          <a:noFill/>
+          <a:ln/>
+        </p:spPr>
+        <p:txBody>
+          <a:bodyPr wrap="square" lIns="0" tIns="0" rIns="0" bIns="0" rtlCol="0" anchor="ctr"/>
+          <a:lstStyle/>
+          <a:p>
+            <a:pPr algn="ctr" indent="0" marL="0">
+              <a:buNone/>
+            </a:pPr>
+            <a:r>
+              <a:rPr lang="en-US" sz="1700" b="1" spc="100" kern="0" dirty="0">
+                <a:solidFill>
+                  <a:srgbClr val="FFFFFF"/>
+                </a:solidFill>
+                <a:latin typeface="Cambria" pitchFamily="34" charset="0"/>
+                <a:ea typeface="Cambria" pitchFamily="34" charset="-122"/>
+                <a:cs typeface="Cambria" pitchFamily="34" charset="-120"/>
+              </a:rPr>
+              <a:t>THE BIG BOOK</a:t>
+            </a:r>
+            <a:endParaRPr lang="en-US" sz="1700" dirty="0"/>
+          </a:p>
+          <a:p>
+            <a:pPr algn="ctr" indent="0" marL="0">
+              <a:buNone/>
+            </a:pPr>
+            <a:r>
+              <a:rPr lang="en-US" sz="1300" dirty="0">
+                <a:solidFill>
+                  <a:srgbClr val="A9B8CC"/>
+                </a:solidFill>
+                <a:latin typeface="Calibri" pitchFamily="34" charset="0"/>
+                <a:ea typeface="Calibri" pitchFamily="34" charset="-122"/>
+                <a:cs typeface="Calibri" pitchFamily="34" charset="-120"/>
+              </a:rPr>
+              <a:t>p. xxvi</a:t>
+            </a:r>
+            <a:endParaRPr lang="en-US" sz="1700" dirty="0"/>
+          </a:p>
+        </p:txBody>
+      </p:sp>
+      <p:sp>
+        <p:nvSpPr>
+          <p:cNvPr id="6" name="Shape 4"/>
+          <p:cNvSpPr/>
+          <p:nvPr/>
+        </p:nvSpPr>
+        <p:spPr>
+          <a:xfrm>
+            <a:off x="548640" y="1325880"/>
+            <a:ext cx="11091672" cy="914400"/>
+          </a:xfrm>
+          <a:prstGeom prst="roundRect">
+            <a:avLst>
+              <a:gd name="adj" fmla="val 8000"/>
+            </a:avLst>
+          </a:prstGeom>
+          <a:solidFill>
+            <a:srgbClr val="EAF1E6"/>
+          </a:solidFill>
+          <a:ln/>
+        </p:spPr>
+      </p:sp>
+      <p:sp>
+        <p:nvSpPr>
+          <p:cNvPr id="7" name="Shape 5"/>
+          <p:cNvSpPr/>
+          <p:nvPr/>
+        </p:nvSpPr>
+        <p:spPr>
+          <a:xfrm>
+            <a:off x="548640" y="1325880"/>
+            <a:ext cx="1691640" cy="914400"/>
+          </a:xfrm>
+          <a:prstGeom prst="roundRect">
+            <a:avLst>
+              <a:gd name="adj" fmla="val 8000"/>
+            </a:avLst>
+          </a:prstGeom>
+          <a:solidFill>
+            <a:srgbClr val="2C5F2D"/>
+          </a:solidFill>
+          <a:ln/>
+        </p:spPr>
+      </p:sp>
+      <p:sp>
+        <p:nvSpPr>
+          <p:cNvPr id="8" name="Text 6"/>
+          <p:cNvSpPr/>
+          <p:nvPr/>
+        </p:nvSpPr>
+        <p:spPr>
+          <a:xfrm>
+            <a:off x="548640" y="1325880"/>
+            <a:ext cx="1691640" cy="914400"/>
+          </a:xfrm>
+          <a:prstGeom prst="rect">
+            <a:avLst/>
+          </a:prstGeom>
+          <a:noFill/>
+          <a:ln/>
+        </p:spPr>
+        <p:txBody>
+          <a:bodyPr wrap="square" lIns="0" tIns="0" rIns="0" bIns="0" rtlCol="0" anchor="ctr"/>
+          <a:lstStyle/>
+          <a:p>
+            <a:pPr algn="ctr" indent="0" marL="0">
+              <a:buNone/>
+            </a:pPr>
+            <a:r>
+              <a:rPr lang="en-US" sz="1600" b="1" dirty="0">
+                <a:solidFill>
+                  <a:srgbClr val="FFFFFF"/>
+                </a:solidFill>
+                <a:latin typeface="Cambria" pitchFamily="34" charset="0"/>
+                <a:ea typeface="Cambria" pitchFamily="34" charset="-122"/>
+                <a:cs typeface="Cambria" pitchFamily="34" charset="-120"/>
+              </a:rPr>
+              <a:t>TYPE I</a:t>
+            </a:r>
+            <a:endParaRPr lang="en-US" sz="1600" dirty="0"/>
+          </a:p>
+        </p:txBody>
+      </p:sp>
+      <p:sp>
+        <p:nvSpPr>
+          <p:cNvPr id="9" name="Text 7"/>
+          <p:cNvSpPr/>
+          <p:nvPr/>
+        </p:nvSpPr>
+        <p:spPr>
+          <a:xfrm>
+            <a:off x="2450592" y="1325880"/>
+            <a:ext cx="9189720" cy="914400"/>
+          </a:xfrm>
+          <a:prstGeom prst="rect">
+            <a:avLst/>
+          </a:prstGeom>
+          <a:noFill/>
+          <a:ln/>
+        </p:spPr>
+        <p:txBody>
+          <a:bodyPr wrap="square" lIns="0" tIns="0" rIns="0" bIns="0" rtlCol="0" anchor="ctr"/>
+          <a:lstStyle/>
+          <a:p>
+            <a:pPr indent="0" marL="0">
+              <a:lnSpc>
+                <a:spcPct val="115000"/>
+              </a:lnSpc>
+              <a:buNone/>
+            </a:pPr>
+            <a:r>
+              <a:rPr lang="en-US" sz="1600" dirty="0">
+                <a:solidFill>
+                  <a:srgbClr val="1B2A41"/>
+                </a:solidFill>
+                <a:latin typeface="Calibri" pitchFamily="34" charset="0"/>
+                <a:ea typeface="Calibri" pitchFamily="34" charset="-122"/>
+                <a:cs typeface="Calibri" pitchFamily="34" charset="-120"/>
+              </a:rPr>
+              <a:t>There are, of course, the psychopaths who are emotionally unstable. We are all familiar with this type. They are always “going on the wagon for keeps.” They are over-remorseful and make many resolutions, but never a decision.</a:t>
+            </a:r>
+            <a:endParaRPr lang="en-US" sz="1600" dirty="0"/>
+          </a:p>
+        </p:txBody>
+      </p:sp>
+      <p:sp>
+        <p:nvSpPr>
+          <p:cNvPr id="10" name="Shape 8"/>
+          <p:cNvSpPr/>
+          <p:nvPr/>
+        </p:nvSpPr>
+        <p:spPr>
+          <a:xfrm>
+            <a:off x="548640" y="2304288"/>
+            <a:ext cx="11091672" cy="786384"/>
+          </a:xfrm>
+          <a:prstGeom prst="roundRect">
+            <a:avLst>
+              <a:gd name="adj" fmla="val 9302"/>
+            </a:avLst>
+          </a:prstGeom>
+          <a:solidFill>
+            <a:srgbClr val="E2EDF4"/>
+          </a:solidFill>
+          <a:ln/>
+        </p:spPr>
+      </p:sp>
+      <p:sp>
+        <p:nvSpPr>
+          <p:cNvPr id="11" name="Shape 9"/>
+          <p:cNvSpPr/>
+          <p:nvPr/>
+        </p:nvSpPr>
+        <p:spPr>
+          <a:xfrm>
+            <a:off x="548640" y="2304288"/>
+            <a:ext cx="1691640" cy="786384"/>
+          </a:xfrm>
+          <a:prstGeom prst="roundRect">
+            <a:avLst>
+              <a:gd name="adj" fmla="val 9302"/>
+            </a:avLst>
+          </a:prstGeom>
+          <a:solidFill>
+            <a:srgbClr val="065A82"/>
+          </a:solidFill>
+          <a:ln/>
+        </p:spPr>
+      </p:sp>
+      <p:sp>
+        <p:nvSpPr>
+          <p:cNvPr id="12" name="Text 10"/>
+          <p:cNvSpPr/>
+          <p:nvPr/>
+        </p:nvSpPr>
+        <p:spPr>
+          <a:xfrm>
+            <a:off x="548640" y="2304288"/>
+            <a:ext cx="1691640" cy="786384"/>
+          </a:xfrm>
+          <a:prstGeom prst="rect">
+            <a:avLst/>
+          </a:prstGeom>
+          <a:noFill/>
+          <a:ln/>
+        </p:spPr>
+        <p:txBody>
+          <a:bodyPr wrap="square" lIns="0" tIns="0" rIns="0" bIns="0" rtlCol="0" anchor="ctr"/>
+          <a:lstStyle/>
+          <a:p>
+            <a:pPr algn="ctr" indent="0" marL="0">
+              <a:buNone/>
+            </a:pPr>
+            <a:r>
+              <a:rPr lang="en-US" sz="1600" b="1" dirty="0">
+                <a:solidFill>
+                  <a:srgbClr val="FFFFFF"/>
+                </a:solidFill>
+                <a:latin typeface="Cambria" pitchFamily="34" charset="0"/>
+                <a:ea typeface="Cambria" pitchFamily="34" charset="-122"/>
+                <a:cs typeface="Cambria" pitchFamily="34" charset="-120"/>
+              </a:rPr>
+              <a:t>TYPE II</a:t>
+            </a:r>
+            <a:endParaRPr lang="en-US" sz="1600" dirty="0"/>
+          </a:p>
+        </p:txBody>
+      </p:sp>
+      <p:sp>
+        <p:nvSpPr>
+          <p:cNvPr id="13" name="Text 11"/>
+          <p:cNvSpPr/>
+          <p:nvPr/>
+        </p:nvSpPr>
+        <p:spPr>
+          <a:xfrm>
+            <a:off x="2450592" y="2304288"/>
+            <a:ext cx="9189720" cy="786384"/>
+          </a:xfrm>
+          <a:prstGeom prst="rect">
+            <a:avLst/>
+          </a:prstGeom>
+          <a:noFill/>
+          <a:ln/>
+        </p:spPr>
+        <p:txBody>
+          <a:bodyPr wrap="square" lIns="0" tIns="0" rIns="0" bIns="0" rtlCol="0" anchor="ctr"/>
+          <a:lstStyle/>
+          <a:p>
+            <a:pPr indent="0" marL="0">
+              <a:lnSpc>
+                <a:spcPct val="115000"/>
+              </a:lnSpc>
+              <a:buNone/>
+            </a:pPr>
+            <a:r>
+              <a:rPr lang="en-US" sz="1600" dirty="0">
+                <a:solidFill>
+                  <a:srgbClr val="1B2A41"/>
+                </a:solidFill>
+                <a:latin typeface="Calibri" pitchFamily="34" charset="0"/>
+                <a:ea typeface="Calibri" pitchFamily="34" charset="-122"/>
+                <a:cs typeface="Calibri" pitchFamily="34" charset="-120"/>
+              </a:rPr>
+              <a:t>There is the type of man who is unwilling to admit that he cannot take a drink. He plans various ways of drinking. He changes his brand or his environment.</a:t>
+            </a:r>
+            <a:endParaRPr lang="en-US" sz="1600" dirty="0"/>
+          </a:p>
+        </p:txBody>
+      </p:sp>
+      <p:sp>
+        <p:nvSpPr>
+          <p:cNvPr id="14" name="Shape 12"/>
+          <p:cNvSpPr/>
+          <p:nvPr/>
+        </p:nvSpPr>
+        <p:spPr>
+          <a:xfrm>
+            <a:off x="548640" y="3154680"/>
+            <a:ext cx="11091672" cy="786384"/>
+          </a:xfrm>
+          <a:prstGeom prst="roundRect">
+            <a:avLst>
+              <a:gd name="adj" fmla="val 9302"/>
+            </a:avLst>
+          </a:prstGeom>
+          <a:solidFill>
+            <a:srgbClr val="EAF1E6"/>
+          </a:solidFill>
+          <a:ln/>
+        </p:spPr>
+      </p:sp>
+      <p:sp>
+        <p:nvSpPr>
+          <p:cNvPr id="15" name="Shape 13"/>
+          <p:cNvSpPr/>
+          <p:nvPr/>
+        </p:nvSpPr>
+        <p:spPr>
+          <a:xfrm>
+            <a:off x="548640" y="3154680"/>
+            <a:ext cx="1691640" cy="786384"/>
+          </a:xfrm>
+          <a:prstGeom prst="roundRect">
+            <a:avLst>
+              <a:gd name="adj" fmla="val 9302"/>
+            </a:avLst>
+          </a:prstGeom>
+          <a:solidFill>
+            <a:srgbClr val="2C5F2D"/>
+          </a:solidFill>
+          <a:ln/>
+        </p:spPr>
+      </p:sp>
+      <p:sp>
+        <p:nvSpPr>
+          <p:cNvPr id="16" name="Text 14"/>
+          <p:cNvSpPr/>
+          <p:nvPr/>
+        </p:nvSpPr>
+        <p:spPr>
+          <a:xfrm>
+            <a:off x="548640" y="3154680"/>
+            <a:ext cx="1691640" cy="786384"/>
+          </a:xfrm>
+          <a:prstGeom prst="rect">
+            <a:avLst/>
+          </a:prstGeom>
+          <a:noFill/>
+          <a:ln/>
+        </p:spPr>
+        <p:txBody>
+          <a:bodyPr wrap="square" lIns="0" tIns="0" rIns="0" bIns="0" rtlCol="0" anchor="ctr"/>
+          <a:lstStyle/>
+          <a:p>
+            <a:pPr algn="ctr" indent="0" marL="0">
+              <a:buNone/>
+            </a:pPr>
+            <a:r>
+              <a:rPr lang="en-US" sz="1600" b="1" dirty="0">
+                <a:solidFill>
+                  <a:srgbClr val="FFFFFF"/>
+                </a:solidFill>
+                <a:latin typeface="Cambria" pitchFamily="34" charset="0"/>
+                <a:ea typeface="Cambria" pitchFamily="34" charset="-122"/>
+                <a:cs typeface="Cambria" pitchFamily="34" charset="-120"/>
+              </a:rPr>
+              <a:t>TYPE III</a:t>
+            </a:r>
+            <a:endParaRPr lang="en-US" sz="1600" dirty="0"/>
+          </a:p>
+        </p:txBody>
+      </p:sp>
+      <p:sp>
+        <p:nvSpPr>
+          <p:cNvPr id="17" name="Text 15"/>
+          <p:cNvSpPr/>
+          <p:nvPr/>
+        </p:nvSpPr>
+        <p:spPr>
+          <a:xfrm>
+            <a:off x="2450592" y="3154680"/>
+            <a:ext cx="9189720" cy="786384"/>
+          </a:xfrm>
+          <a:prstGeom prst="rect">
+            <a:avLst/>
+          </a:prstGeom>
+          <a:noFill/>
+          <a:ln/>
+        </p:spPr>
+        <p:txBody>
+          <a:bodyPr wrap="square" lIns="0" tIns="0" rIns="0" bIns="0" rtlCol="0" anchor="ctr"/>
+          <a:lstStyle/>
+          <a:p>
+            <a:pPr indent="0" marL="0">
+              <a:lnSpc>
+                <a:spcPct val="115000"/>
+              </a:lnSpc>
+              <a:buNone/>
+            </a:pPr>
+            <a:r>
+              <a:rPr lang="en-US" sz="1600" dirty="0">
+                <a:solidFill>
+                  <a:srgbClr val="1B2A41"/>
+                </a:solidFill>
+                <a:latin typeface="Calibri" pitchFamily="34" charset="0"/>
+                <a:ea typeface="Calibri" pitchFamily="34" charset="-122"/>
+                <a:cs typeface="Calibri" pitchFamily="34" charset="-120"/>
+              </a:rPr>
+              <a:t>There is the type who always believes that after being entirely free from alcohol for a period of time he can take a drink without danger.</a:t>
+            </a:r>
+            <a:endParaRPr lang="en-US" sz="1600" dirty="0"/>
+          </a:p>
+        </p:txBody>
+      </p:sp>
+      <p:sp>
+        <p:nvSpPr>
+          <p:cNvPr id="18" name="Shape 16"/>
+          <p:cNvSpPr/>
+          <p:nvPr/>
+        </p:nvSpPr>
+        <p:spPr>
+          <a:xfrm>
+            <a:off x="548640" y="4005072"/>
+            <a:ext cx="11091672" cy="786384"/>
+          </a:xfrm>
+          <a:prstGeom prst="roundRect">
+            <a:avLst>
+              <a:gd name="adj" fmla="val 9302"/>
+            </a:avLst>
+          </a:prstGeom>
+          <a:solidFill>
+            <a:srgbClr val="E2EDF4"/>
+          </a:solidFill>
+          <a:ln/>
+        </p:spPr>
+      </p:sp>
+      <p:sp>
+        <p:nvSpPr>
+          <p:cNvPr id="19" name="Shape 17"/>
+          <p:cNvSpPr/>
+          <p:nvPr/>
+        </p:nvSpPr>
+        <p:spPr>
+          <a:xfrm>
+            <a:off x="548640" y="4005072"/>
+            <a:ext cx="1691640" cy="786384"/>
+          </a:xfrm>
+          <a:prstGeom prst="roundRect">
+            <a:avLst>
+              <a:gd name="adj" fmla="val 9302"/>
+            </a:avLst>
+          </a:prstGeom>
+          <a:solidFill>
+            <a:srgbClr val="065A82"/>
+          </a:solidFill>
+          <a:ln/>
+        </p:spPr>
+      </p:sp>
+      <p:sp>
+        <p:nvSpPr>
+          <p:cNvPr id="20" name="Text 18"/>
+          <p:cNvSpPr/>
+          <p:nvPr/>
+        </p:nvSpPr>
+        <p:spPr>
+          <a:xfrm>
+            <a:off x="548640" y="4005072"/>
+            <a:ext cx="1691640" cy="786384"/>
+          </a:xfrm>
+          <a:prstGeom prst="rect">
+            <a:avLst/>
+          </a:prstGeom>
+          <a:noFill/>
+          <a:ln/>
+        </p:spPr>
+        <p:txBody>
+          <a:bodyPr wrap="square" lIns="0" tIns="0" rIns="0" bIns="0" rtlCol="0" anchor="ctr"/>
+          <a:lstStyle/>
+          <a:p>
+            <a:pPr algn="ctr" indent="0" marL="0">
+              <a:buNone/>
+            </a:pPr>
+            <a:r>
+              <a:rPr lang="en-US" sz="1600" b="1" dirty="0">
+                <a:solidFill>
+                  <a:srgbClr val="FFFFFF"/>
+                </a:solidFill>
+                <a:latin typeface="Cambria" pitchFamily="34" charset="0"/>
+                <a:ea typeface="Cambria" pitchFamily="34" charset="-122"/>
+                <a:cs typeface="Cambria" pitchFamily="34" charset="-120"/>
+              </a:rPr>
+              <a:t>TYPE IV</a:t>
+            </a:r>
+            <a:endParaRPr lang="en-US" sz="1600" dirty="0"/>
+          </a:p>
+        </p:txBody>
+      </p:sp>
+      <p:sp>
+        <p:nvSpPr>
+          <p:cNvPr id="21" name="Text 19"/>
+          <p:cNvSpPr/>
+          <p:nvPr/>
+        </p:nvSpPr>
+        <p:spPr>
+          <a:xfrm>
+            <a:off x="2450592" y="4005072"/>
+            <a:ext cx="9189720" cy="786384"/>
+          </a:xfrm>
+          <a:prstGeom prst="rect">
+            <a:avLst/>
+          </a:prstGeom>
+          <a:noFill/>
+          <a:ln/>
+        </p:spPr>
+        <p:txBody>
+          <a:bodyPr wrap="square" lIns="0" tIns="0" rIns="0" bIns="0" rtlCol="0" anchor="ctr"/>
+          <a:lstStyle/>
+          <a:p>
+            <a:pPr indent="0" marL="0">
+              <a:lnSpc>
+                <a:spcPct val="115000"/>
+              </a:lnSpc>
+              <a:buNone/>
+            </a:pPr>
+            <a:r>
+              <a:rPr lang="en-US" sz="1600" dirty="0">
+                <a:solidFill>
+                  <a:srgbClr val="1B2A41"/>
+                </a:solidFill>
+                <a:latin typeface="Calibri" pitchFamily="34" charset="0"/>
+                <a:ea typeface="Calibri" pitchFamily="34" charset="-122"/>
+                <a:cs typeface="Calibri" pitchFamily="34" charset="-120"/>
+              </a:rPr>
+              <a:t>There is the manic-depressive type, who is, perhaps, the least understood by his friends, and about whom a whole chapter could be written.</a:t>
+            </a:r>
+            <a:endParaRPr lang="en-US" sz="1600" dirty="0"/>
+          </a:p>
+        </p:txBody>
+      </p:sp>
+      <p:sp>
+        <p:nvSpPr>
+          <p:cNvPr id="22" name="Shape 20"/>
+          <p:cNvSpPr/>
+          <p:nvPr/>
+        </p:nvSpPr>
+        <p:spPr>
+          <a:xfrm>
+            <a:off x="548640" y="4855464"/>
+            <a:ext cx="11091672" cy="786384"/>
+          </a:xfrm>
+          <a:prstGeom prst="roundRect">
+            <a:avLst>
+              <a:gd name="adj" fmla="val 9302"/>
+            </a:avLst>
+          </a:prstGeom>
+          <a:solidFill>
+            <a:srgbClr val="EAF1E6"/>
+          </a:solidFill>
+          <a:ln/>
+        </p:spPr>
+      </p:sp>
+      <p:sp>
+        <p:nvSpPr>
+          <p:cNvPr id="23" name="Shape 21"/>
+          <p:cNvSpPr/>
+          <p:nvPr/>
+        </p:nvSpPr>
+        <p:spPr>
+          <a:xfrm>
+            <a:off x="548640" y="4855464"/>
+            <a:ext cx="1691640" cy="786384"/>
+          </a:xfrm>
+          <a:prstGeom prst="roundRect">
+            <a:avLst>
+              <a:gd name="adj" fmla="val 9302"/>
+            </a:avLst>
+          </a:prstGeom>
+          <a:solidFill>
+            <a:srgbClr val="2C5F2D"/>
+          </a:solidFill>
+          <a:ln/>
+        </p:spPr>
+      </p:sp>
+      <p:sp>
+        <p:nvSpPr>
+          <p:cNvPr id="24" name="Text 22"/>
+          <p:cNvSpPr/>
+          <p:nvPr/>
+        </p:nvSpPr>
+        <p:spPr>
+          <a:xfrm>
+            <a:off x="548640" y="4855464"/>
+            <a:ext cx="1691640" cy="786384"/>
+          </a:xfrm>
+          <a:prstGeom prst="rect">
+            <a:avLst/>
+          </a:prstGeom>
+          <a:noFill/>
+          <a:ln/>
+        </p:spPr>
+        <p:txBody>
+          <a:bodyPr wrap="square" lIns="0" tIns="0" rIns="0" bIns="0" rtlCol="0" anchor="ctr"/>
+          <a:lstStyle/>
+          <a:p>
+            <a:pPr algn="ctr" indent="0" marL="0">
+              <a:buNone/>
+            </a:pPr>
+            <a:r>
+              <a:rPr lang="en-US" sz="1600" b="1" dirty="0">
+                <a:solidFill>
+                  <a:srgbClr val="FFFFFF"/>
+                </a:solidFill>
+                <a:latin typeface="Cambria" pitchFamily="34" charset="0"/>
+                <a:ea typeface="Cambria" pitchFamily="34" charset="-122"/>
+                <a:cs typeface="Cambria" pitchFamily="34" charset="-120"/>
+              </a:rPr>
+              <a:t>TYPE V</a:t>
+            </a:r>
+            <a:endParaRPr lang="en-US" sz="1600" dirty="0"/>
+          </a:p>
+        </p:txBody>
+      </p:sp>
+      <p:sp>
+        <p:nvSpPr>
+          <p:cNvPr id="25" name="Text 23"/>
+          <p:cNvSpPr/>
+          <p:nvPr/>
+        </p:nvSpPr>
+        <p:spPr>
+          <a:xfrm>
+            <a:off x="2450592" y="4855464"/>
+            <a:ext cx="9189720" cy="786384"/>
+          </a:xfrm>
+          <a:prstGeom prst="rect">
+            <a:avLst/>
+          </a:prstGeom>
+          <a:noFill/>
+          <a:ln/>
+        </p:spPr>
+        <p:txBody>
+          <a:bodyPr wrap="square" lIns="0" tIns="0" rIns="0" bIns="0" rtlCol="0" anchor="ctr"/>
+          <a:lstStyle/>
+          <a:p>
+            <a:pPr indent="0" marL="0">
+              <a:lnSpc>
+                <a:spcPct val="115000"/>
+              </a:lnSpc>
+              <a:buNone/>
+            </a:pPr>
+            <a:r>
+              <a:rPr lang="en-US" sz="1600" dirty="0">
+                <a:solidFill>
+                  <a:srgbClr val="1B2A41"/>
+                </a:solidFill>
+                <a:latin typeface="Calibri" pitchFamily="34" charset="0"/>
+                <a:ea typeface="Calibri" pitchFamily="34" charset="-122"/>
+                <a:cs typeface="Calibri" pitchFamily="34" charset="-120"/>
+              </a:rPr>
+              <a:t>Then there are types entirely normal in every respect except in the effect alcohol has upon them. They are often able, intelligent, friendly people.</a:t>
+            </a:r>
+            <a:endParaRPr lang="en-US" sz="1600" dirty="0"/>
+          </a:p>
+        </p:txBody>
+      </p:sp>
+      <p:sp>
+        <p:nvSpPr>
+          <p:cNvPr id="26" name="Text 24"/>
+          <p:cNvSpPr/>
+          <p:nvPr/>
+        </p:nvSpPr>
+        <p:spPr>
+          <a:xfrm>
+            <a:off x="548640" y="5760720"/>
+            <a:ext cx="11091672" cy="292608"/>
+          </a:xfrm>
+          <a:prstGeom prst="rect">
+            <a:avLst/>
+          </a:prstGeom>
+          <a:noFill/>
+          <a:ln/>
+        </p:spPr>
+        <p:txBody>
+          <a:bodyPr wrap="square" lIns="0" tIns="0" rIns="0" bIns="0" rtlCol="0" anchor="ctr"/>
+          <a:lstStyle/>
+          <a:p>
+            <a:pPr indent="0" marL="0">
+              <a:buNone/>
+            </a:pPr>
+            <a:r>
+              <a:rPr lang="en-US" sz="1200" i="1" dirty="0">
+                <a:solidFill>
+                  <a:srgbClr val="6B7A8C"/>
+                </a:solidFill>
+                <a:latin typeface="Calibri" pitchFamily="34" charset="0"/>
+                <a:ea typeface="Calibri" pitchFamily="34" charset="-122"/>
+                <a:cs typeface="Calibri" pitchFamily="34" charset="-120"/>
+              </a:rPr>
+              <a:t>Alcoholics Anonymous</a:t>
+            </a:r>
+            <a:pPr indent="0" marL="0">
+              <a:buNone/>
+            </a:pPr>
+            <a:r>
+              <a:rPr lang="en-US" sz="1200" dirty="0">
+                <a:solidFill>
+                  <a:srgbClr val="6B7A8C"/>
+                </a:solidFill>
+                <a:latin typeface="Calibri" pitchFamily="34" charset="0"/>
+                <a:ea typeface="Calibri" pitchFamily="34" charset="-122"/>
+                <a:cs typeface="Calibri" pitchFamily="34" charset="-120"/>
+              </a:rPr>
+              <a:t>, 4th ed., “The Doctor’s Opinion,” p. xxvi.</a:t>
+            </a:r>
+            <a:endParaRPr lang="en-US" sz="1200" dirty="0"/>
+          </a:p>
+        </p:txBody>
+      </p:sp>
+      <p:sp>
+        <p:nvSpPr>
+          <p:cNvPr id="27" name="Text 25"/>
+          <p:cNvSpPr/>
+          <p:nvPr/>
+        </p:nvSpPr>
+        <p:spPr>
+          <a:xfrm>
+            <a:off x="548640" y="6355080"/>
+            <a:ext cx="11091672" cy="292608"/>
+          </a:xfrm>
+          <a:prstGeom prst="rect">
+            <a:avLst/>
+          </a:prstGeom>
+          <a:noFill/>
+          <a:ln/>
+        </p:spPr>
+        <p:txBody>
+          <a:bodyPr wrap="square" lIns="0" tIns="0" rIns="0" bIns="0" rtlCol="0" anchor="ctr"/>
+          <a:lstStyle/>
+          <a:p>
+            <a:pPr indent="0" marL="0">
+              <a:buNone/>
+            </a:pPr>
+            <a:r>
+              <a:rPr lang="en-US" sz="950" dirty="0">
+                <a:solidFill>
+                  <a:srgbClr val="6B7A8C"/>
+                </a:solidFill>
+                <a:latin typeface="Calibri" pitchFamily="34" charset="0"/>
+                <a:ea typeface="Calibri" pitchFamily="34" charset="-122"/>
+                <a:cs typeface="Calibri" pitchFamily="34" charset="-120"/>
+              </a:rPr>
+              <a:t>Copyright © Alcoholics Anonymous World Services, Inc. All rights reserved. Intended for personal use only, and not to be reproduced further or distributed for resale.</a:t>
+            </a:r>
+            <a:endParaRPr lang="en-US" sz="950" dirty="0"/>
+          </a:p>
+        </p:txBody>
+      </p:sp>
+    </p:spTree>
+  </p:cSld>
+  <p:clrMapOvr>
+    <a:masterClrMapping/>
+  </p:clrMapOvr>
+</p:sld>
+</file>
+
 <file path=ppt/slides/slide3.xml><?xml version="1.0" encoding="utf-8"?>
 <p:sld xmlns:a="http://schemas.openxmlformats.org/drawingml/2006/main" xmlns:r="http://schemas.openxmlformats.org/officeDocument/2006/relationships" xmlns:p="http://schemas.openxmlformats.org/presentationml/2006/main">
   <p:cSld name="Slide 3">
@@ -16434,6 +17534,580 @@
       <p:sp>
         <p:nvSpPr>
           <p:cNvPr id="19" name="Text 17"/>
+          <p:cNvSpPr/>
+          <p:nvPr/>
+        </p:nvSpPr>
+        <p:spPr>
+          <a:xfrm>
+            <a:off x="548640" y="6355080"/>
+            <a:ext cx="11091672" cy="292608"/>
+          </a:xfrm>
+          <a:prstGeom prst="rect">
+            <a:avLst/>
+          </a:prstGeom>
+          <a:noFill/>
+          <a:ln/>
+        </p:spPr>
+        <p:txBody>
+          <a:bodyPr wrap="square" lIns="0" tIns="0" rIns="0" bIns="0" rtlCol="0" anchor="ctr"/>
+          <a:lstStyle/>
+          <a:p>
+            <a:pPr indent="0" marL="0">
+              <a:buNone/>
+            </a:pPr>
+            <a:r>
+              <a:rPr lang="en-US" sz="950" dirty="0">
+                <a:solidFill>
+                  <a:srgbClr val="6B7A8C"/>
+                </a:solidFill>
+                <a:latin typeface="Calibri" pitchFamily="34" charset="0"/>
+                <a:ea typeface="Calibri" pitchFamily="34" charset="-122"/>
+                <a:cs typeface="Calibri" pitchFamily="34" charset="-120"/>
+              </a:rPr>
+              <a:t>Copyright © Alcoholics Anonymous World Services, Inc. All rights reserved. Intended for personal use only, and not to be reproduced further or distributed for resale.</a:t>
+            </a:r>
+            <a:endParaRPr lang="en-US" sz="950" dirty="0"/>
+          </a:p>
+        </p:txBody>
+      </p:sp>
+    </p:spTree>
+  </p:cSld>
+  <p:clrMapOvr>
+    <a:masterClrMapping/>
+  </p:clrMapOvr>
+</p:sld>
+</file>
+
+<file path=ppt/slides/slide30.xml><?xml version="1.0" encoding="utf-8"?>
+<p:sld xmlns:a="http://schemas.openxmlformats.org/drawingml/2006/main" xmlns:r="http://schemas.openxmlformats.org/officeDocument/2006/relationships" xmlns:p="http://schemas.openxmlformats.org/presentationml/2006/main">
+  <p:cSld name="Slide 30">
+    <p:bg>
+      <p:bgPr>
+        <a:solidFill>
+          <a:srgbClr val="FFFFFF"/>
+        </a:solidFill>
+      </p:bgPr>
+    </p:bg>
+    <p:spTree>
+      <p:nvGrpSpPr>
+        <p:cNvPr id="1" name=""/>
+        <p:cNvGrpSpPr/>
+        <p:nvPr/>
+      </p:nvGrpSpPr>
+      <p:grpSpPr>
+        <a:xfrm>
+          <a:off x="0" y="0"/>
+          <a:ext cx="0" cy="0"/>
+          <a:chOff x="0" y="0"/>
+          <a:chExt cx="0" cy="0"/>
+        </a:xfrm>
+      </p:grpSpPr>
+      <p:sp>
+        <p:nvSpPr>
+          <p:cNvPr id="2" name="Text 0"/>
+          <p:cNvSpPr/>
+          <p:nvPr/>
+        </p:nvSpPr>
+        <p:spPr>
+          <a:xfrm>
+            <a:off x="548640" y="320040"/>
+            <a:ext cx="8138160" cy="566928"/>
+          </a:xfrm>
+          <a:prstGeom prst="rect">
+            <a:avLst/>
+          </a:prstGeom>
+          <a:noFill/>
+          <a:ln/>
+        </p:spPr>
+        <p:txBody>
+          <a:bodyPr wrap="square" lIns="0" tIns="0" rIns="0" bIns="0" rtlCol="0" anchor="ctr"/>
+          <a:lstStyle/>
+          <a:p>
+            <a:pPr indent="0" marL="0">
+              <a:buNone/>
+            </a:pPr>
+            <a:r>
+              <a:rPr lang="en-US" sz="3800" b="1" dirty="0">
+                <a:solidFill>
+                  <a:srgbClr val="1B2A41"/>
+                </a:solidFill>
+                <a:latin typeface="Cambria" pitchFamily="34" charset="0"/>
+                <a:ea typeface="Cambria" pitchFamily="34" charset="-122"/>
+                <a:cs typeface="Cambria" pitchFamily="34" charset="-120"/>
+              </a:rPr>
+              <a:t>One Symptom in Common</a:t>
+            </a:r>
+            <a:endParaRPr lang="en-US" sz="3800" dirty="0"/>
+          </a:p>
+        </p:txBody>
+      </p:sp>
+      <p:sp>
+        <p:nvSpPr>
+          <p:cNvPr id="3" name="Text 1"/>
+          <p:cNvSpPr/>
+          <p:nvPr/>
+        </p:nvSpPr>
+        <p:spPr>
+          <a:xfrm>
+            <a:off x="548640" y="914400"/>
+            <a:ext cx="8138160" cy="347472"/>
+          </a:xfrm>
+          <a:prstGeom prst="rect">
+            <a:avLst/>
+          </a:prstGeom>
+          <a:noFill/>
+          <a:ln/>
+        </p:spPr>
+        <p:txBody>
+          <a:bodyPr wrap="square" lIns="0" tIns="0" rIns="0" bIns="0" rtlCol="0" anchor="ctr"/>
+          <a:lstStyle/>
+          <a:p>
+            <a:pPr indent="0" marL="0">
+              <a:buNone/>
+            </a:pPr>
+            <a:r>
+              <a:rPr lang="en-US" sz="1700" i="1" dirty="0">
+                <a:solidFill>
+                  <a:srgbClr val="6B7A8C"/>
+                </a:solidFill>
+                <a:latin typeface="Calibri" pitchFamily="34" charset="0"/>
+                <a:ea typeface="Calibri" pitchFamily="34" charset="-122"/>
+                <a:cs typeface="Calibri" pitchFamily="34" charset="-120"/>
+              </a:rPr>
+              <a:t>What every type shares.</a:t>
+            </a:r>
+            <a:endParaRPr lang="en-US" sz="1700" dirty="0"/>
+          </a:p>
+        </p:txBody>
+      </p:sp>
+      <p:sp>
+        <p:nvSpPr>
+          <p:cNvPr id="4" name="Shape 2"/>
+          <p:cNvSpPr/>
+          <p:nvPr/>
+        </p:nvSpPr>
+        <p:spPr>
+          <a:xfrm>
+            <a:off x="8869680" y="320040"/>
+            <a:ext cx="2770632" cy="960120"/>
+          </a:xfrm>
+          <a:prstGeom prst="roundRect">
+            <a:avLst>
+              <a:gd name="adj" fmla="val 9524"/>
+            </a:avLst>
+          </a:prstGeom>
+          <a:solidFill>
+            <a:srgbClr val="065A82"/>
+          </a:solidFill>
+          <a:ln/>
+        </p:spPr>
+      </p:sp>
+      <p:sp>
+        <p:nvSpPr>
+          <p:cNvPr id="5" name="Text 3"/>
+          <p:cNvSpPr/>
+          <p:nvPr/>
+        </p:nvSpPr>
+        <p:spPr>
+          <a:xfrm>
+            <a:off x="8869680" y="320040"/>
+            <a:ext cx="2770632" cy="960120"/>
+          </a:xfrm>
+          <a:prstGeom prst="rect">
+            <a:avLst/>
+          </a:prstGeom>
+          <a:noFill/>
+          <a:ln/>
+        </p:spPr>
+        <p:txBody>
+          <a:bodyPr wrap="square" lIns="0" tIns="0" rIns="0" bIns="0" rtlCol="0" anchor="ctr"/>
+          <a:lstStyle/>
+          <a:p>
+            <a:pPr algn="ctr" indent="0" marL="0">
+              <a:buNone/>
+            </a:pPr>
+            <a:r>
+              <a:rPr lang="en-US" sz="1700" b="1" spc="100" kern="0" dirty="0">
+                <a:solidFill>
+                  <a:srgbClr val="FFFFFF"/>
+                </a:solidFill>
+                <a:latin typeface="Cambria" pitchFamily="34" charset="0"/>
+                <a:ea typeface="Cambria" pitchFamily="34" charset="-122"/>
+                <a:cs typeface="Cambria" pitchFamily="34" charset="-120"/>
+              </a:rPr>
+              <a:t>THE BIG BOOK</a:t>
+            </a:r>
+            <a:endParaRPr lang="en-US" sz="1700" dirty="0"/>
+          </a:p>
+          <a:p>
+            <a:pPr algn="ctr" indent="0" marL="0">
+              <a:buNone/>
+            </a:pPr>
+            <a:r>
+              <a:rPr lang="en-US" sz="1300" dirty="0">
+                <a:solidFill>
+                  <a:srgbClr val="C7DEEC"/>
+                </a:solidFill>
+                <a:latin typeface="Calibri" pitchFamily="34" charset="0"/>
+                <a:ea typeface="Calibri" pitchFamily="34" charset="-122"/>
+                <a:cs typeface="Calibri" pitchFamily="34" charset="-120"/>
+              </a:rPr>
+              <a:t>p. xxvi</a:t>
+            </a:r>
+            <a:endParaRPr lang="en-US" sz="1700" dirty="0"/>
+          </a:p>
+        </p:txBody>
+      </p:sp>
+      <p:sp>
+        <p:nvSpPr>
+          <p:cNvPr id="6" name="Shape 4"/>
+          <p:cNvSpPr/>
+          <p:nvPr/>
+        </p:nvSpPr>
+        <p:spPr>
+          <a:xfrm>
+            <a:off x="548640" y="1554480"/>
+            <a:ext cx="11091672" cy="2011680"/>
+          </a:xfrm>
+          <a:prstGeom prst="roundRect">
+            <a:avLst>
+              <a:gd name="adj" fmla="val 3636"/>
+            </a:avLst>
+          </a:prstGeom>
+          <a:solidFill>
+            <a:srgbClr val="E2EDF4"/>
+          </a:solidFill>
+          <a:ln/>
+        </p:spPr>
+      </p:sp>
+      <p:sp>
+        <p:nvSpPr>
+          <p:cNvPr id="7" name="Text 5"/>
+          <p:cNvSpPr/>
+          <p:nvPr/>
+        </p:nvSpPr>
+        <p:spPr>
+          <a:xfrm>
+            <a:off x="914400" y="1554480"/>
+            <a:ext cx="10360152" cy="2011680"/>
+          </a:xfrm>
+          <a:prstGeom prst="rect">
+            <a:avLst/>
+          </a:prstGeom>
+          <a:noFill/>
+          <a:ln/>
+        </p:spPr>
+        <p:txBody>
+          <a:bodyPr wrap="square" lIns="0" tIns="0" rIns="0" bIns="0" rtlCol="0" anchor="ctr"/>
+          <a:lstStyle/>
+          <a:p>
+            <a:pPr indent="0" marL="0">
+              <a:lnSpc>
+                <a:spcPct val="115000"/>
+              </a:lnSpc>
+              <a:buNone/>
+            </a:pPr>
+            <a:r>
+              <a:rPr lang="en-US" sz="2000" dirty="0">
+                <a:solidFill>
+                  <a:srgbClr val="1B2A41"/>
+                </a:solidFill>
+                <a:latin typeface="Calibri" pitchFamily="34" charset="0"/>
+                <a:ea typeface="Calibri" pitchFamily="34" charset="-122"/>
+                <a:cs typeface="Calibri" pitchFamily="34" charset="-120"/>
+              </a:rPr>
+              <a:t>All these, and many others, have </a:t>
+            </a:r>
+            <a:pPr indent="0" marL="0">
+              <a:lnSpc>
+                <a:spcPct val="115000"/>
+              </a:lnSpc>
+              <a:buNone/>
+            </a:pPr>
+            <a:r>
+              <a:rPr lang="en-US" sz="2000" b="1" dirty="0">
+                <a:solidFill>
+                  <a:srgbClr val="065A82"/>
+                </a:solidFill>
+                <a:latin typeface="Calibri" pitchFamily="34" charset="0"/>
+                <a:ea typeface="Calibri" pitchFamily="34" charset="-122"/>
+                <a:cs typeface="Calibri" pitchFamily="34" charset="-120"/>
+              </a:rPr>
+              <a:t>one symptom in common</a:t>
+            </a:r>
+            <a:pPr indent="0" marL="0">
+              <a:lnSpc>
+                <a:spcPct val="115000"/>
+              </a:lnSpc>
+              <a:buNone/>
+            </a:pPr>
+            <a:r>
+              <a:rPr lang="en-US" sz="2000" dirty="0">
+                <a:solidFill>
+                  <a:srgbClr val="1B2A41"/>
+                </a:solidFill>
+                <a:latin typeface="Calibri" pitchFamily="34" charset="0"/>
+                <a:ea typeface="Calibri" pitchFamily="34" charset="-122"/>
+                <a:cs typeface="Calibri" pitchFamily="34" charset="-120"/>
+              </a:rPr>
+              <a:t>: they cannot start drinking without developing the phenomenon of craving. This phenomenon, as we have suggested, may be the manifestation of an allergy which differentiates these people, and </a:t>
+            </a:r>
+            <a:pPr indent="0" marL="0">
+              <a:lnSpc>
+                <a:spcPct val="115000"/>
+              </a:lnSpc>
+              <a:buNone/>
+            </a:pPr>
+            <a:r>
+              <a:rPr lang="en-US" sz="2000" b="1" dirty="0">
+                <a:solidFill>
+                  <a:srgbClr val="065A82"/>
+                </a:solidFill>
+                <a:latin typeface="Calibri" pitchFamily="34" charset="0"/>
+                <a:ea typeface="Calibri" pitchFamily="34" charset="-122"/>
+                <a:cs typeface="Calibri" pitchFamily="34" charset="-120"/>
+              </a:rPr>
+              <a:t>sets them apart as a distinct entity</a:t>
+            </a:r>
+            <a:pPr indent="0" marL="0">
+              <a:lnSpc>
+                <a:spcPct val="115000"/>
+              </a:lnSpc>
+              <a:buNone/>
+            </a:pPr>
+            <a:r>
+              <a:rPr lang="en-US" sz="2000" dirty="0">
+                <a:solidFill>
+                  <a:srgbClr val="1B2A41"/>
+                </a:solidFill>
+                <a:latin typeface="Calibri" pitchFamily="34" charset="0"/>
+                <a:ea typeface="Calibri" pitchFamily="34" charset="-122"/>
+                <a:cs typeface="Calibri" pitchFamily="34" charset="-120"/>
+              </a:rPr>
+              <a:t>. It has never been, by any treatment with which we are familiar, </a:t>
+            </a:r>
+            <a:pPr indent="0" marL="0">
+              <a:lnSpc>
+                <a:spcPct val="115000"/>
+              </a:lnSpc>
+              <a:buNone/>
+            </a:pPr>
+            <a:r>
+              <a:rPr lang="en-US" sz="2000" b="1" dirty="0">
+                <a:solidFill>
+                  <a:srgbClr val="065A82"/>
+                </a:solidFill>
+                <a:latin typeface="Calibri" pitchFamily="34" charset="0"/>
+                <a:ea typeface="Calibri" pitchFamily="34" charset="-122"/>
+                <a:cs typeface="Calibri" pitchFamily="34" charset="-120"/>
+              </a:rPr>
+              <a:t>permanently eradicated</a:t>
+            </a:r>
+            <a:pPr indent="0" marL="0">
+              <a:lnSpc>
+                <a:spcPct val="115000"/>
+              </a:lnSpc>
+              <a:buNone/>
+            </a:pPr>
+            <a:r>
+              <a:rPr lang="en-US" sz="2000" dirty="0">
+                <a:solidFill>
+                  <a:srgbClr val="1B2A41"/>
+                </a:solidFill>
+                <a:latin typeface="Calibri" pitchFamily="34" charset="0"/>
+                <a:ea typeface="Calibri" pitchFamily="34" charset="-122"/>
+                <a:cs typeface="Calibri" pitchFamily="34" charset="-120"/>
+              </a:rPr>
+              <a:t>.</a:t>
+            </a:r>
+            <a:endParaRPr lang="en-US" sz="2000" dirty="0"/>
+          </a:p>
+        </p:txBody>
+      </p:sp>
+      <p:sp>
+        <p:nvSpPr>
+          <p:cNvPr id="8" name="Shape 6"/>
+          <p:cNvSpPr/>
+          <p:nvPr/>
+        </p:nvSpPr>
+        <p:spPr>
+          <a:xfrm>
+            <a:off x="548640" y="3840480"/>
+            <a:ext cx="11091672" cy="1280160"/>
+          </a:xfrm>
+          <a:prstGeom prst="roundRect">
+            <a:avLst>
+              <a:gd name="adj" fmla="val 5714"/>
+            </a:avLst>
+          </a:prstGeom>
+          <a:solidFill>
+            <a:srgbClr val="065A82"/>
+          </a:solidFill>
+          <a:ln/>
+        </p:spPr>
+      </p:sp>
+      <p:sp>
+        <p:nvSpPr>
+          <p:cNvPr id="9" name="Text 7"/>
+          <p:cNvSpPr/>
+          <p:nvPr/>
+        </p:nvSpPr>
+        <p:spPr>
+          <a:xfrm>
+            <a:off x="914400" y="3977640"/>
+            <a:ext cx="10360152" cy="256032"/>
+          </a:xfrm>
+          <a:prstGeom prst="rect">
+            <a:avLst/>
+          </a:prstGeom>
+          <a:noFill/>
+          <a:ln/>
+        </p:spPr>
+        <p:txBody>
+          <a:bodyPr wrap="square" lIns="0" tIns="0" rIns="0" bIns="0" rtlCol="0" anchor="ctr"/>
+          <a:lstStyle/>
+          <a:p>
+            <a:pPr indent="0" marL="0">
+              <a:buNone/>
+            </a:pPr>
+            <a:r>
+              <a:rPr lang="en-US" sz="1100" b="1" spc="200" kern="0" dirty="0">
+                <a:solidFill>
+                  <a:srgbClr val="C7DEEC"/>
+                </a:solidFill>
+                <a:latin typeface="Calibri" pitchFamily="34" charset="0"/>
+                <a:ea typeface="Calibri" pitchFamily="34" charset="-122"/>
+                <a:cs typeface="Calibri" pitchFamily="34" charset="-120"/>
+              </a:rPr>
+              <a:t>IMPORTANT</a:t>
+            </a:r>
+            <a:endParaRPr lang="en-US" sz="1100" dirty="0"/>
+          </a:p>
+        </p:txBody>
+      </p:sp>
+      <p:sp>
+        <p:nvSpPr>
+          <p:cNvPr id="10" name="Text 8"/>
+          <p:cNvSpPr/>
+          <p:nvPr/>
+        </p:nvSpPr>
+        <p:spPr>
+          <a:xfrm>
+            <a:off x="914400" y="4270248"/>
+            <a:ext cx="10360152" cy="685800"/>
+          </a:xfrm>
+          <a:prstGeom prst="rect">
+            <a:avLst/>
+          </a:prstGeom>
+          <a:noFill/>
+          <a:ln/>
+        </p:spPr>
+        <p:txBody>
+          <a:bodyPr wrap="square" lIns="0" tIns="0" rIns="0" bIns="0" rtlCol="0" anchor="ctr"/>
+          <a:lstStyle/>
+          <a:p>
+            <a:pPr indent="0" marL="0">
+              <a:buNone/>
+            </a:pPr>
+            <a:r>
+              <a:rPr lang="en-US" sz="2400" b="1" dirty="0">
+                <a:solidFill>
+                  <a:srgbClr val="FFFFFF"/>
+                </a:solidFill>
+                <a:latin typeface="Cambria" pitchFamily="34" charset="0"/>
+                <a:ea typeface="Cambria" pitchFamily="34" charset="-122"/>
+                <a:cs typeface="Cambria" pitchFamily="34" charset="-120"/>
+              </a:rPr>
+              <a:t>The only relief we have to suggest is </a:t>
+            </a:r>
+            <a:pPr indent="0" marL="0">
+              <a:buNone/>
+            </a:pPr>
+            <a:r>
+              <a:rPr lang="en-US" sz="2400" b="1" u="dbl" dirty="0">
+                <a:solidFill>
+                  <a:srgbClr val="FFFFFF"/>
+                </a:solidFill>
+                <a:latin typeface="Cambria" pitchFamily="34" charset="0"/>
+                <a:ea typeface="Cambria" pitchFamily="34" charset="-122"/>
+                <a:cs typeface="Cambria" pitchFamily="34" charset="-120"/>
+              </a:rPr>
+              <a:t>entire abstinence</a:t>
+            </a:r>
+            <a:pPr indent="0" marL="0">
+              <a:buNone/>
+            </a:pPr>
+            <a:r>
+              <a:rPr lang="en-US" sz="2400" b="1" dirty="0">
+                <a:solidFill>
+                  <a:srgbClr val="FFFFFF"/>
+                </a:solidFill>
+                <a:latin typeface="Cambria" pitchFamily="34" charset="0"/>
+                <a:ea typeface="Cambria" pitchFamily="34" charset="-122"/>
+                <a:cs typeface="Cambria" pitchFamily="34" charset="-120"/>
+              </a:rPr>
+              <a:t>.</a:t>
+            </a:r>
+            <a:endParaRPr lang="en-US" sz="2400" dirty="0"/>
+          </a:p>
+        </p:txBody>
+      </p:sp>
+      <p:sp>
+        <p:nvSpPr>
+          <p:cNvPr id="11" name="Text 9"/>
+          <p:cNvSpPr/>
+          <p:nvPr/>
+        </p:nvSpPr>
+        <p:spPr>
+          <a:xfrm>
+            <a:off x="548640" y="5349240"/>
+            <a:ext cx="11091672" cy="292608"/>
+          </a:xfrm>
+          <a:prstGeom prst="rect">
+            <a:avLst/>
+          </a:prstGeom>
+          <a:noFill/>
+          <a:ln/>
+        </p:spPr>
+        <p:txBody>
+          <a:bodyPr wrap="square" lIns="0" tIns="0" rIns="0" bIns="0" rtlCol="0" anchor="ctr"/>
+          <a:lstStyle/>
+          <a:p>
+            <a:pPr indent="0" marL="0">
+              <a:buNone/>
+            </a:pPr>
+            <a:r>
+              <a:rPr lang="en-US" sz="1200" i="1" dirty="0">
+                <a:solidFill>
+                  <a:srgbClr val="6B7A8C"/>
+                </a:solidFill>
+                <a:latin typeface="Calibri" pitchFamily="34" charset="0"/>
+                <a:ea typeface="Calibri" pitchFamily="34" charset="-122"/>
+                <a:cs typeface="Calibri" pitchFamily="34" charset="-120"/>
+              </a:rPr>
+              <a:t>Alcoholics Anonymous</a:t>
+            </a:r>
+            <a:pPr indent="0" marL="0">
+              <a:buNone/>
+            </a:pPr>
+            <a:r>
+              <a:rPr lang="en-US" sz="1200" dirty="0">
+                <a:solidFill>
+                  <a:srgbClr val="6B7A8C"/>
+                </a:solidFill>
+                <a:latin typeface="Calibri" pitchFamily="34" charset="0"/>
+                <a:ea typeface="Calibri" pitchFamily="34" charset="-122"/>
+                <a:cs typeface="Calibri" pitchFamily="34" charset="-120"/>
+              </a:rPr>
+              <a:t>, 4th ed., “The Doctor’s Opinion,” p. xxvi.</a:t>
+            </a:r>
+            <a:endParaRPr lang="en-US" sz="1200" dirty="0"/>
+          </a:p>
+        </p:txBody>
+      </p:sp>
+      <p:sp>
+        <p:nvSpPr>
+          <p:cNvPr id="12" name="Text 10"/>
           <p:cNvSpPr/>
           <p:nvPr/>
         </p:nvSpPr>

</xml_diff>